<commit_message>
Tactic 4: restructure deck to follow the template slide for slide
19 slides in the template's exact order and titles; chapter dividers,
brief and closing slide removed.

Co-Authored-By: Claude Opus 5.5 <noreply@anthropic.com>
Claude-Session: https://claude.ai/code/session_014DwxjU8rHfrSVBV6irvX7Y
</commit_message>
<xml_diff>
--- a/weekly-tactics/04-sales/NBC_Sales_Tactic.pptx
+++ b/weekly-tactics/04-sales/NBC_Sales_Tactic.pptx
@@ -24,23 +24,9 @@
     <p:sldId id="272" r:id="rId18"/>
     <p:sldId id="273" r:id="rId19"/>
     <p:sldId id="274" r:id="rId20"/>
-    <p:sldId id="275" r:id="rId21"/>
-    <p:sldId id="276" r:id="rId22"/>
-    <p:sldId id="277" r:id="rId23"/>
-    <p:sldId id="278" r:id="rId24"/>
-    <p:sldId id="279" r:id="rId25"/>
-    <p:sldId id="280" r:id="rId26"/>
-    <p:sldId id="281" r:id="rId27"/>
-    <p:sldId id="282" r:id="rId28"/>
-    <p:sldId id="283" r:id="rId29"/>
-    <p:sldId id="284" r:id="rId30"/>
-    <p:sldId id="285" r:id="rId31"/>
-    <p:sldId id="286" r:id="rId32"/>
-    <p:sldId id="287" r:id="rId33"/>
-    <p:sldId id="288" r:id="rId34"/>
   </p:sldIdLst>
   <p:notesMasterIdLst>
-    <p:notesMasterId r:id="rId35"/>
+    <p:notesMasterId r:id="rId21"/>
   </p:notesMasterIdLst>
   <p:sldSz cx="9144000" cy="5143500"/>
   <p:notesSz cx="5143500" cy="9144000"/>
@@ -1544,886 +1530,6 @@
 </p:notes>
 </file>
 
-<file path=ppt/notesSlides/notesSlide20.xml><?xml version="1.0" encoding="utf-8"?>
-<p:notes xmlns:a="http://schemas.openxmlformats.org/drawingml/2006/main" xmlns:r="http://schemas.openxmlformats.org/officeDocument/2006/relationships" xmlns:p="http://schemas.openxmlformats.org/presentationml/2006/main">
-  <p:cSld>
-    <p:spTree>
-      <p:nvGrpSpPr>
-        <p:cNvPr id="1" name=""/>
-        <p:cNvGrpSpPr/>
-        <p:nvPr/>
-      </p:nvGrpSpPr>
-      <p:grpSpPr>
-        <a:xfrm>
-          <a:off x="0" y="0"/>
-          <a:ext cx="0" cy="0"/>
-          <a:chOff x="0" y="0"/>
-          <a:chExt cx="0" cy="0"/>
-        </a:xfrm>
-      </p:grpSpPr>
-      <p:sp>
-        <p:nvSpPr>
-          <p:cNvPr id="2" name="Slide Image Placeholder 1"/>
-          <p:cNvSpPr>
-            <a:spLocks noGrp="1" noRot="1" noChangeAspect="1"/>
-          </p:cNvSpPr>
-          <p:nvPr>
-            <p:ph type="sldImg"/>
-          </p:nvPr>
-        </p:nvSpPr>
-        <p:spPr/>
-      </p:sp>
-      <p:sp>
-        <p:nvSpPr>
-          <p:cNvPr id="3" name="Notes Placeholder 2"/>
-          <p:cNvSpPr>
-            <a:spLocks noGrp="1"/>
-          </p:cNvSpPr>
-          <p:nvPr>
-            <p:ph type="body" idx="1"/>
-          </p:nvPr>
-        </p:nvSpPr>
-        <p:spPr/>
-        <p:txBody>
-          <a:bodyPr/>
-          <a:lstStyle/>
-          <a:p>
-            <a:r>
-              <a:rPr lang="en-US" dirty="0"/>
-              <a:t/>
-            </a:r>
-            <a:endParaRPr lang="en-US" dirty="0"/>
-          </a:p>
-        </p:txBody>
-      </p:sp>
-      <p:sp>
-        <p:nvSpPr>
-          <p:cNvPr id="4" name="Slide Number Placeholder 3"/>
-          <p:cNvSpPr>
-            <a:spLocks noGrp="1"/>
-          </p:cNvSpPr>
-          <p:nvPr>
-            <p:ph type="sldNum" sz="quarter" idx="10"/>
-          </p:nvPr>
-        </p:nvSpPr>
-        <p:spPr/>
-        <p:txBody>
-          <a:bodyPr/>
-          <a:lstStyle/>
-          <a:p>
-            <a:fld id="{F7021451-1387-4CA6-816F-3879F97B5CBC}" type="slidenum">
-              <a:rPr lang="en-US"/>
-              <a:t>20</a:t>
-            </a:fld>
-            <a:endParaRPr lang="en-US"/>
-          </a:p>
-        </p:txBody>
-      </p:sp>
-    </p:spTree>
-    <p:extLst>
-      <p:ext uri="{BB962C8B-B14F-4D97-AF65-F5344CB8AC3E}">
-        <p14:creationId xmlns:p14="http://schemas.microsoft.com/office/powerpoint/2010/main" val="1024086991"/>
-      </p:ext>
-    </p:extLst>
-  </p:cSld>
-  <p:clrMapOvr>
-    <a:masterClrMapping/>
-  </p:clrMapOvr>
-</p:notes>
-</file>
-
-<file path=ppt/notesSlides/notesSlide21.xml><?xml version="1.0" encoding="utf-8"?>
-<p:notes xmlns:a="http://schemas.openxmlformats.org/drawingml/2006/main" xmlns:r="http://schemas.openxmlformats.org/officeDocument/2006/relationships" xmlns:p="http://schemas.openxmlformats.org/presentationml/2006/main">
-  <p:cSld>
-    <p:spTree>
-      <p:nvGrpSpPr>
-        <p:cNvPr id="1" name=""/>
-        <p:cNvGrpSpPr/>
-        <p:nvPr/>
-      </p:nvGrpSpPr>
-      <p:grpSpPr>
-        <a:xfrm>
-          <a:off x="0" y="0"/>
-          <a:ext cx="0" cy="0"/>
-          <a:chOff x="0" y="0"/>
-          <a:chExt cx="0" cy="0"/>
-        </a:xfrm>
-      </p:grpSpPr>
-      <p:sp>
-        <p:nvSpPr>
-          <p:cNvPr id="2" name="Slide Image Placeholder 1"/>
-          <p:cNvSpPr>
-            <a:spLocks noGrp="1" noRot="1" noChangeAspect="1"/>
-          </p:cNvSpPr>
-          <p:nvPr>
-            <p:ph type="sldImg"/>
-          </p:nvPr>
-        </p:nvSpPr>
-        <p:spPr/>
-      </p:sp>
-      <p:sp>
-        <p:nvSpPr>
-          <p:cNvPr id="3" name="Notes Placeholder 2"/>
-          <p:cNvSpPr>
-            <a:spLocks noGrp="1"/>
-          </p:cNvSpPr>
-          <p:nvPr>
-            <p:ph type="body" idx="1"/>
-          </p:nvPr>
-        </p:nvSpPr>
-        <p:spPr/>
-        <p:txBody>
-          <a:bodyPr/>
-          <a:lstStyle/>
-          <a:p>
-            <a:r>
-              <a:rPr lang="en-US" dirty="0"/>
-              <a:t/>
-            </a:r>
-            <a:endParaRPr lang="en-US" dirty="0"/>
-          </a:p>
-        </p:txBody>
-      </p:sp>
-      <p:sp>
-        <p:nvSpPr>
-          <p:cNvPr id="4" name="Slide Number Placeholder 3"/>
-          <p:cNvSpPr>
-            <a:spLocks noGrp="1"/>
-          </p:cNvSpPr>
-          <p:nvPr>
-            <p:ph type="sldNum" sz="quarter" idx="10"/>
-          </p:nvPr>
-        </p:nvSpPr>
-        <p:spPr/>
-        <p:txBody>
-          <a:bodyPr/>
-          <a:lstStyle/>
-          <a:p>
-            <a:fld id="{F7021451-1387-4CA6-816F-3879F97B5CBC}" type="slidenum">
-              <a:rPr lang="en-US"/>
-              <a:t>21</a:t>
-            </a:fld>
-            <a:endParaRPr lang="en-US"/>
-          </a:p>
-        </p:txBody>
-      </p:sp>
-    </p:spTree>
-    <p:extLst>
-      <p:ext uri="{BB962C8B-B14F-4D97-AF65-F5344CB8AC3E}">
-        <p14:creationId xmlns:p14="http://schemas.microsoft.com/office/powerpoint/2010/main" val="1024086991"/>
-      </p:ext>
-    </p:extLst>
-  </p:cSld>
-  <p:clrMapOvr>
-    <a:masterClrMapping/>
-  </p:clrMapOvr>
-</p:notes>
-</file>
-
-<file path=ppt/notesSlides/notesSlide22.xml><?xml version="1.0" encoding="utf-8"?>
-<p:notes xmlns:a="http://schemas.openxmlformats.org/drawingml/2006/main" xmlns:r="http://schemas.openxmlformats.org/officeDocument/2006/relationships" xmlns:p="http://schemas.openxmlformats.org/presentationml/2006/main">
-  <p:cSld>
-    <p:spTree>
-      <p:nvGrpSpPr>
-        <p:cNvPr id="1" name=""/>
-        <p:cNvGrpSpPr/>
-        <p:nvPr/>
-      </p:nvGrpSpPr>
-      <p:grpSpPr>
-        <a:xfrm>
-          <a:off x="0" y="0"/>
-          <a:ext cx="0" cy="0"/>
-          <a:chOff x="0" y="0"/>
-          <a:chExt cx="0" cy="0"/>
-        </a:xfrm>
-      </p:grpSpPr>
-      <p:sp>
-        <p:nvSpPr>
-          <p:cNvPr id="2" name="Slide Image Placeholder 1"/>
-          <p:cNvSpPr>
-            <a:spLocks noGrp="1" noRot="1" noChangeAspect="1"/>
-          </p:cNvSpPr>
-          <p:nvPr>
-            <p:ph type="sldImg"/>
-          </p:nvPr>
-        </p:nvSpPr>
-        <p:spPr/>
-      </p:sp>
-      <p:sp>
-        <p:nvSpPr>
-          <p:cNvPr id="3" name="Notes Placeholder 2"/>
-          <p:cNvSpPr>
-            <a:spLocks noGrp="1"/>
-          </p:cNvSpPr>
-          <p:nvPr>
-            <p:ph type="body" idx="1"/>
-          </p:nvPr>
-        </p:nvSpPr>
-        <p:spPr/>
-        <p:txBody>
-          <a:bodyPr/>
-          <a:lstStyle/>
-          <a:p>
-            <a:r>
-              <a:rPr lang="en-US" dirty="0"/>
-              <a:t/>
-            </a:r>
-            <a:endParaRPr lang="en-US" dirty="0"/>
-          </a:p>
-        </p:txBody>
-      </p:sp>
-      <p:sp>
-        <p:nvSpPr>
-          <p:cNvPr id="4" name="Slide Number Placeholder 3"/>
-          <p:cNvSpPr>
-            <a:spLocks noGrp="1"/>
-          </p:cNvSpPr>
-          <p:nvPr>
-            <p:ph type="sldNum" sz="quarter" idx="10"/>
-          </p:nvPr>
-        </p:nvSpPr>
-        <p:spPr/>
-        <p:txBody>
-          <a:bodyPr/>
-          <a:lstStyle/>
-          <a:p>
-            <a:fld id="{F7021451-1387-4CA6-816F-3879F97B5CBC}" type="slidenum">
-              <a:rPr lang="en-US"/>
-              <a:t>22</a:t>
-            </a:fld>
-            <a:endParaRPr lang="en-US"/>
-          </a:p>
-        </p:txBody>
-      </p:sp>
-    </p:spTree>
-    <p:extLst>
-      <p:ext uri="{BB962C8B-B14F-4D97-AF65-F5344CB8AC3E}">
-        <p14:creationId xmlns:p14="http://schemas.microsoft.com/office/powerpoint/2010/main" val="1024086991"/>
-      </p:ext>
-    </p:extLst>
-  </p:cSld>
-  <p:clrMapOvr>
-    <a:masterClrMapping/>
-  </p:clrMapOvr>
-</p:notes>
-</file>
-
-<file path=ppt/notesSlides/notesSlide23.xml><?xml version="1.0" encoding="utf-8"?>
-<p:notes xmlns:a="http://schemas.openxmlformats.org/drawingml/2006/main" xmlns:r="http://schemas.openxmlformats.org/officeDocument/2006/relationships" xmlns:p="http://schemas.openxmlformats.org/presentationml/2006/main">
-  <p:cSld>
-    <p:spTree>
-      <p:nvGrpSpPr>
-        <p:cNvPr id="1" name=""/>
-        <p:cNvGrpSpPr/>
-        <p:nvPr/>
-      </p:nvGrpSpPr>
-      <p:grpSpPr>
-        <a:xfrm>
-          <a:off x="0" y="0"/>
-          <a:ext cx="0" cy="0"/>
-          <a:chOff x="0" y="0"/>
-          <a:chExt cx="0" cy="0"/>
-        </a:xfrm>
-      </p:grpSpPr>
-      <p:sp>
-        <p:nvSpPr>
-          <p:cNvPr id="2" name="Slide Image Placeholder 1"/>
-          <p:cNvSpPr>
-            <a:spLocks noGrp="1" noRot="1" noChangeAspect="1"/>
-          </p:cNvSpPr>
-          <p:nvPr>
-            <p:ph type="sldImg"/>
-          </p:nvPr>
-        </p:nvSpPr>
-        <p:spPr/>
-      </p:sp>
-      <p:sp>
-        <p:nvSpPr>
-          <p:cNvPr id="3" name="Notes Placeholder 2"/>
-          <p:cNvSpPr>
-            <a:spLocks noGrp="1"/>
-          </p:cNvSpPr>
-          <p:nvPr>
-            <p:ph type="body" idx="1"/>
-          </p:nvPr>
-        </p:nvSpPr>
-        <p:spPr/>
-        <p:txBody>
-          <a:bodyPr/>
-          <a:lstStyle/>
-          <a:p>
-            <a:r>
-              <a:rPr lang="en-US" dirty="0"/>
-              <a:t/>
-            </a:r>
-            <a:endParaRPr lang="en-US" dirty="0"/>
-          </a:p>
-        </p:txBody>
-      </p:sp>
-      <p:sp>
-        <p:nvSpPr>
-          <p:cNvPr id="4" name="Slide Number Placeholder 3"/>
-          <p:cNvSpPr>
-            <a:spLocks noGrp="1"/>
-          </p:cNvSpPr>
-          <p:nvPr>
-            <p:ph type="sldNum" sz="quarter" idx="10"/>
-          </p:nvPr>
-        </p:nvSpPr>
-        <p:spPr/>
-        <p:txBody>
-          <a:bodyPr/>
-          <a:lstStyle/>
-          <a:p>
-            <a:fld id="{F7021451-1387-4CA6-816F-3879F97B5CBC}" type="slidenum">
-              <a:rPr lang="en-US"/>
-              <a:t>23</a:t>
-            </a:fld>
-            <a:endParaRPr lang="en-US"/>
-          </a:p>
-        </p:txBody>
-      </p:sp>
-    </p:spTree>
-    <p:extLst>
-      <p:ext uri="{BB962C8B-B14F-4D97-AF65-F5344CB8AC3E}">
-        <p14:creationId xmlns:p14="http://schemas.microsoft.com/office/powerpoint/2010/main" val="1024086991"/>
-      </p:ext>
-    </p:extLst>
-  </p:cSld>
-  <p:clrMapOvr>
-    <a:masterClrMapping/>
-  </p:clrMapOvr>
-</p:notes>
-</file>
-
-<file path=ppt/notesSlides/notesSlide24.xml><?xml version="1.0" encoding="utf-8"?>
-<p:notes xmlns:a="http://schemas.openxmlformats.org/drawingml/2006/main" xmlns:r="http://schemas.openxmlformats.org/officeDocument/2006/relationships" xmlns:p="http://schemas.openxmlformats.org/presentationml/2006/main">
-  <p:cSld>
-    <p:spTree>
-      <p:nvGrpSpPr>
-        <p:cNvPr id="1" name=""/>
-        <p:cNvGrpSpPr/>
-        <p:nvPr/>
-      </p:nvGrpSpPr>
-      <p:grpSpPr>
-        <a:xfrm>
-          <a:off x="0" y="0"/>
-          <a:ext cx="0" cy="0"/>
-          <a:chOff x="0" y="0"/>
-          <a:chExt cx="0" cy="0"/>
-        </a:xfrm>
-      </p:grpSpPr>
-      <p:sp>
-        <p:nvSpPr>
-          <p:cNvPr id="2" name="Slide Image Placeholder 1"/>
-          <p:cNvSpPr>
-            <a:spLocks noGrp="1" noRot="1" noChangeAspect="1"/>
-          </p:cNvSpPr>
-          <p:nvPr>
-            <p:ph type="sldImg"/>
-          </p:nvPr>
-        </p:nvSpPr>
-        <p:spPr/>
-      </p:sp>
-      <p:sp>
-        <p:nvSpPr>
-          <p:cNvPr id="3" name="Notes Placeholder 2"/>
-          <p:cNvSpPr>
-            <a:spLocks noGrp="1"/>
-          </p:cNvSpPr>
-          <p:nvPr>
-            <p:ph type="body" idx="1"/>
-          </p:nvPr>
-        </p:nvSpPr>
-        <p:spPr/>
-        <p:txBody>
-          <a:bodyPr/>
-          <a:lstStyle/>
-          <a:p>
-            <a:r>
-              <a:rPr lang="en-US" dirty="0"/>
-              <a:t/>
-            </a:r>
-            <a:endParaRPr lang="en-US" dirty="0"/>
-          </a:p>
-        </p:txBody>
-      </p:sp>
-      <p:sp>
-        <p:nvSpPr>
-          <p:cNvPr id="4" name="Slide Number Placeholder 3"/>
-          <p:cNvSpPr>
-            <a:spLocks noGrp="1"/>
-          </p:cNvSpPr>
-          <p:nvPr>
-            <p:ph type="sldNum" sz="quarter" idx="10"/>
-          </p:nvPr>
-        </p:nvSpPr>
-        <p:spPr/>
-        <p:txBody>
-          <a:bodyPr/>
-          <a:lstStyle/>
-          <a:p>
-            <a:fld id="{F7021451-1387-4CA6-816F-3879F97B5CBC}" type="slidenum">
-              <a:rPr lang="en-US"/>
-              <a:t>24</a:t>
-            </a:fld>
-            <a:endParaRPr lang="en-US"/>
-          </a:p>
-        </p:txBody>
-      </p:sp>
-    </p:spTree>
-    <p:extLst>
-      <p:ext uri="{BB962C8B-B14F-4D97-AF65-F5344CB8AC3E}">
-        <p14:creationId xmlns:p14="http://schemas.microsoft.com/office/powerpoint/2010/main" val="1024086991"/>
-      </p:ext>
-    </p:extLst>
-  </p:cSld>
-  <p:clrMapOvr>
-    <a:masterClrMapping/>
-  </p:clrMapOvr>
-</p:notes>
-</file>
-
-<file path=ppt/notesSlides/notesSlide25.xml><?xml version="1.0" encoding="utf-8"?>
-<p:notes xmlns:a="http://schemas.openxmlformats.org/drawingml/2006/main" xmlns:r="http://schemas.openxmlformats.org/officeDocument/2006/relationships" xmlns:p="http://schemas.openxmlformats.org/presentationml/2006/main">
-  <p:cSld>
-    <p:spTree>
-      <p:nvGrpSpPr>
-        <p:cNvPr id="1" name=""/>
-        <p:cNvGrpSpPr/>
-        <p:nvPr/>
-      </p:nvGrpSpPr>
-      <p:grpSpPr>
-        <a:xfrm>
-          <a:off x="0" y="0"/>
-          <a:ext cx="0" cy="0"/>
-          <a:chOff x="0" y="0"/>
-          <a:chExt cx="0" cy="0"/>
-        </a:xfrm>
-      </p:grpSpPr>
-      <p:sp>
-        <p:nvSpPr>
-          <p:cNvPr id="2" name="Slide Image Placeholder 1"/>
-          <p:cNvSpPr>
-            <a:spLocks noGrp="1" noRot="1" noChangeAspect="1"/>
-          </p:cNvSpPr>
-          <p:nvPr>
-            <p:ph type="sldImg"/>
-          </p:nvPr>
-        </p:nvSpPr>
-        <p:spPr/>
-      </p:sp>
-      <p:sp>
-        <p:nvSpPr>
-          <p:cNvPr id="3" name="Notes Placeholder 2"/>
-          <p:cNvSpPr>
-            <a:spLocks noGrp="1"/>
-          </p:cNvSpPr>
-          <p:nvPr>
-            <p:ph type="body" idx="1"/>
-          </p:nvPr>
-        </p:nvSpPr>
-        <p:spPr/>
-        <p:txBody>
-          <a:bodyPr/>
-          <a:lstStyle/>
-          <a:p>
-            <a:r>
-              <a:rPr lang="en-US" dirty="0"/>
-              <a:t/>
-            </a:r>
-            <a:endParaRPr lang="en-US" dirty="0"/>
-          </a:p>
-        </p:txBody>
-      </p:sp>
-      <p:sp>
-        <p:nvSpPr>
-          <p:cNvPr id="4" name="Slide Number Placeholder 3"/>
-          <p:cNvSpPr>
-            <a:spLocks noGrp="1"/>
-          </p:cNvSpPr>
-          <p:nvPr>
-            <p:ph type="sldNum" sz="quarter" idx="10"/>
-          </p:nvPr>
-        </p:nvSpPr>
-        <p:spPr/>
-        <p:txBody>
-          <a:bodyPr/>
-          <a:lstStyle/>
-          <a:p>
-            <a:fld id="{F7021451-1387-4CA6-816F-3879F97B5CBC}" type="slidenum">
-              <a:rPr lang="en-US"/>
-              <a:t>25</a:t>
-            </a:fld>
-            <a:endParaRPr lang="en-US"/>
-          </a:p>
-        </p:txBody>
-      </p:sp>
-    </p:spTree>
-    <p:extLst>
-      <p:ext uri="{BB962C8B-B14F-4D97-AF65-F5344CB8AC3E}">
-        <p14:creationId xmlns:p14="http://schemas.microsoft.com/office/powerpoint/2010/main" val="1024086991"/>
-      </p:ext>
-    </p:extLst>
-  </p:cSld>
-  <p:clrMapOvr>
-    <a:masterClrMapping/>
-  </p:clrMapOvr>
-</p:notes>
-</file>
-
-<file path=ppt/notesSlides/notesSlide26.xml><?xml version="1.0" encoding="utf-8"?>
-<p:notes xmlns:a="http://schemas.openxmlformats.org/drawingml/2006/main" xmlns:r="http://schemas.openxmlformats.org/officeDocument/2006/relationships" xmlns:p="http://schemas.openxmlformats.org/presentationml/2006/main">
-  <p:cSld>
-    <p:spTree>
-      <p:nvGrpSpPr>
-        <p:cNvPr id="1" name=""/>
-        <p:cNvGrpSpPr/>
-        <p:nvPr/>
-      </p:nvGrpSpPr>
-      <p:grpSpPr>
-        <a:xfrm>
-          <a:off x="0" y="0"/>
-          <a:ext cx="0" cy="0"/>
-          <a:chOff x="0" y="0"/>
-          <a:chExt cx="0" cy="0"/>
-        </a:xfrm>
-      </p:grpSpPr>
-      <p:sp>
-        <p:nvSpPr>
-          <p:cNvPr id="2" name="Slide Image Placeholder 1"/>
-          <p:cNvSpPr>
-            <a:spLocks noGrp="1" noRot="1" noChangeAspect="1"/>
-          </p:cNvSpPr>
-          <p:nvPr>
-            <p:ph type="sldImg"/>
-          </p:nvPr>
-        </p:nvSpPr>
-        <p:spPr/>
-      </p:sp>
-      <p:sp>
-        <p:nvSpPr>
-          <p:cNvPr id="3" name="Notes Placeholder 2"/>
-          <p:cNvSpPr>
-            <a:spLocks noGrp="1"/>
-          </p:cNvSpPr>
-          <p:nvPr>
-            <p:ph type="body" idx="1"/>
-          </p:nvPr>
-        </p:nvSpPr>
-        <p:spPr/>
-        <p:txBody>
-          <a:bodyPr/>
-          <a:lstStyle/>
-          <a:p>
-            <a:r>
-              <a:rPr lang="en-US" dirty="0"/>
-              <a:t/>
-            </a:r>
-            <a:endParaRPr lang="en-US" dirty="0"/>
-          </a:p>
-        </p:txBody>
-      </p:sp>
-      <p:sp>
-        <p:nvSpPr>
-          <p:cNvPr id="4" name="Slide Number Placeholder 3"/>
-          <p:cNvSpPr>
-            <a:spLocks noGrp="1"/>
-          </p:cNvSpPr>
-          <p:nvPr>
-            <p:ph type="sldNum" sz="quarter" idx="10"/>
-          </p:nvPr>
-        </p:nvSpPr>
-        <p:spPr/>
-        <p:txBody>
-          <a:bodyPr/>
-          <a:lstStyle/>
-          <a:p>
-            <a:fld id="{F7021451-1387-4CA6-816F-3879F97B5CBC}" type="slidenum">
-              <a:rPr lang="en-US"/>
-              <a:t>26</a:t>
-            </a:fld>
-            <a:endParaRPr lang="en-US"/>
-          </a:p>
-        </p:txBody>
-      </p:sp>
-    </p:spTree>
-    <p:extLst>
-      <p:ext uri="{BB962C8B-B14F-4D97-AF65-F5344CB8AC3E}">
-        <p14:creationId xmlns:p14="http://schemas.microsoft.com/office/powerpoint/2010/main" val="1024086991"/>
-      </p:ext>
-    </p:extLst>
-  </p:cSld>
-  <p:clrMapOvr>
-    <a:masterClrMapping/>
-  </p:clrMapOvr>
-</p:notes>
-</file>
-
-<file path=ppt/notesSlides/notesSlide27.xml><?xml version="1.0" encoding="utf-8"?>
-<p:notes xmlns:a="http://schemas.openxmlformats.org/drawingml/2006/main" xmlns:r="http://schemas.openxmlformats.org/officeDocument/2006/relationships" xmlns:p="http://schemas.openxmlformats.org/presentationml/2006/main">
-  <p:cSld>
-    <p:spTree>
-      <p:nvGrpSpPr>
-        <p:cNvPr id="1" name=""/>
-        <p:cNvGrpSpPr/>
-        <p:nvPr/>
-      </p:nvGrpSpPr>
-      <p:grpSpPr>
-        <a:xfrm>
-          <a:off x="0" y="0"/>
-          <a:ext cx="0" cy="0"/>
-          <a:chOff x="0" y="0"/>
-          <a:chExt cx="0" cy="0"/>
-        </a:xfrm>
-      </p:grpSpPr>
-      <p:sp>
-        <p:nvSpPr>
-          <p:cNvPr id="2" name="Slide Image Placeholder 1"/>
-          <p:cNvSpPr>
-            <a:spLocks noGrp="1" noRot="1" noChangeAspect="1"/>
-          </p:cNvSpPr>
-          <p:nvPr>
-            <p:ph type="sldImg"/>
-          </p:nvPr>
-        </p:nvSpPr>
-        <p:spPr/>
-      </p:sp>
-      <p:sp>
-        <p:nvSpPr>
-          <p:cNvPr id="3" name="Notes Placeholder 2"/>
-          <p:cNvSpPr>
-            <a:spLocks noGrp="1"/>
-          </p:cNvSpPr>
-          <p:nvPr>
-            <p:ph type="body" idx="1"/>
-          </p:nvPr>
-        </p:nvSpPr>
-        <p:spPr/>
-        <p:txBody>
-          <a:bodyPr/>
-          <a:lstStyle/>
-          <a:p>
-            <a:r>
-              <a:rPr lang="en-US" dirty="0"/>
-              <a:t/>
-            </a:r>
-            <a:endParaRPr lang="en-US" dirty="0"/>
-          </a:p>
-        </p:txBody>
-      </p:sp>
-      <p:sp>
-        <p:nvSpPr>
-          <p:cNvPr id="4" name="Slide Number Placeholder 3"/>
-          <p:cNvSpPr>
-            <a:spLocks noGrp="1"/>
-          </p:cNvSpPr>
-          <p:nvPr>
-            <p:ph type="sldNum" sz="quarter" idx="10"/>
-          </p:nvPr>
-        </p:nvSpPr>
-        <p:spPr/>
-        <p:txBody>
-          <a:bodyPr/>
-          <a:lstStyle/>
-          <a:p>
-            <a:fld id="{F7021451-1387-4CA6-816F-3879F97B5CBC}" type="slidenum">
-              <a:rPr lang="en-US"/>
-              <a:t>27</a:t>
-            </a:fld>
-            <a:endParaRPr lang="en-US"/>
-          </a:p>
-        </p:txBody>
-      </p:sp>
-    </p:spTree>
-    <p:extLst>
-      <p:ext uri="{BB962C8B-B14F-4D97-AF65-F5344CB8AC3E}">
-        <p14:creationId xmlns:p14="http://schemas.microsoft.com/office/powerpoint/2010/main" val="1024086991"/>
-      </p:ext>
-    </p:extLst>
-  </p:cSld>
-  <p:clrMapOvr>
-    <a:masterClrMapping/>
-  </p:clrMapOvr>
-</p:notes>
-</file>
-
-<file path=ppt/notesSlides/notesSlide28.xml><?xml version="1.0" encoding="utf-8"?>
-<p:notes xmlns:a="http://schemas.openxmlformats.org/drawingml/2006/main" xmlns:r="http://schemas.openxmlformats.org/officeDocument/2006/relationships" xmlns:p="http://schemas.openxmlformats.org/presentationml/2006/main">
-  <p:cSld>
-    <p:spTree>
-      <p:nvGrpSpPr>
-        <p:cNvPr id="1" name=""/>
-        <p:cNvGrpSpPr/>
-        <p:nvPr/>
-      </p:nvGrpSpPr>
-      <p:grpSpPr>
-        <a:xfrm>
-          <a:off x="0" y="0"/>
-          <a:ext cx="0" cy="0"/>
-          <a:chOff x="0" y="0"/>
-          <a:chExt cx="0" cy="0"/>
-        </a:xfrm>
-      </p:grpSpPr>
-      <p:sp>
-        <p:nvSpPr>
-          <p:cNvPr id="2" name="Slide Image Placeholder 1"/>
-          <p:cNvSpPr>
-            <a:spLocks noGrp="1" noRot="1" noChangeAspect="1"/>
-          </p:cNvSpPr>
-          <p:nvPr>
-            <p:ph type="sldImg"/>
-          </p:nvPr>
-        </p:nvSpPr>
-        <p:spPr/>
-      </p:sp>
-      <p:sp>
-        <p:nvSpPr>
-          <p:cNvPr id="3" name="Notes Placeholder 2"/>
-          <p:cNvSpPr>
-            <a:spLocks noGrp="1"/>
-          </p:cNvSpPr>
-          <p:nvPr>
-            <p:ph type="body" idx="1"/>
-          </p:nvPr>
-        </p:nvSpPr>
-        <p:spPr/>
-        <p:txBody>
-          <a:bodyPr/>
-          <a:lstStyle/>
-          <a:p>
-            <a:r>
-              <a:rPr lang="en-US" dirty="0"/>
-              <a:t/>
-            </a:r>
-            <a:endParaRPr lang="en-US" dirty="0"/>
-          </a:p>
-        </p:txBody>
-      </p:sp>
-      <p:sp>
-        <p:nvSpPr>
-          <p:cNvPr id="4" name="Slide Number Placeholder 3"/>
-          <p:cNvSpPr>
-            <a:spLocks noGrp="1"/>
-          </p:cNvSpPr>
-          <p:nvPr>
-            <p:ph type="sldNum" sz="quarter" idx="10"/>
-          </p:nvPr>
-        </p:nvSpPr>
-        <p:spPr/>
-        <p:txBody>
-          <a:bodyPr/>
-          <a:lstStyle/>
-          <a:p>
-            <a:fld id="{F7021451-1387-4CA6-816F-3879F97B5CBC}" type="slidenum">
-              <a:rPr lang="en-US"/>
-              <a:t>28</a:t>
-            </a:fld>
-            <a:endParaRPr lang="en-US"/>
-          </a:p>
-        </p:txBody>
-      </p:sp>
-    </p:spTree>
-    <p:extLst>
-      <p:ext uri="{BB962C8B-B14F-4D97-AF65-F5344CB8AC3E}">
-        <p14:creationId xmlns:p14="http://schemas.microsoft.com/office/powerpoint/2010/main" val="1024086991"/>
-      </p:ext>
-    </p:extLst>
-  </p:cSld>
-  <p:clrMapOvr>
-    <a:masterClrMapping/>
-  </p:clrMapOvr>
-</p:notes>
-</file>
-
-<file path=ppt/notesSlides/notesSlide29.xml><?xml version="1.0" encoding="utf-8"?>
-<p:notes xmlns:a="http://schemas.openxmlformats.org/drawingml/2006/main" xmlns:r="http://schemas.openxmlformats.org/officeDocument/2006/relationships" xmlns:p="http://schemas.openxmlformats.org/presentationml/2006/main">
-  <p:cSld>
-    <p:spTree>
-      <p:nvGrpSpPr>
-        <p:cNvPr id="1" name=""/>
-        <p:cNvGrpSpPr/>
-        <p:nvPr/>
-      </p:nvGrpSpPr>
-      <p:grpSpPr>
-        <a:xfrm>
-          <a:off x="0" y="0"/>
-          <a:ext cx="0" cy="0"/>
-          <a:chOff x="0" y="0"/>
-          <a:chExt cx="0" cy="0"/>
-        </a:xfrm>
-      </p:grpSpPr>
-      <p:sp>
-        <p:nvSpPr>
-          <p:cNvPr id="2" name="Slide Image Placeholder 1"/>
-          <p:cNvSpPr>
-            <a:spLocks noGrp="1" noRot="1" noChangeAspect="1"/>
-          </p:cNvSpPr>
-          <p:nvPr>
-            <p:ph type="sldImg"/>
-          </p:nvPr>
-        </p:nvSpPr>
-        <p:spPr/>
-      </p:sp>
-      <p:sp>
-        <p:nvSpPr>
-          <p:cNvPr id="3" name="Notes Placeholder 2"/>
-          <p:cNvSpPr>
-            <a:spLocks noGrp="1"/>
-          </p:cNvSpPr>
-          <p:nvPr>
-            <p:ph type="body" idx="1"/>
-          </p:nvPr>
-        </p:nvSpPr>
-        <p:spPr/>
-        <p:txBody>
-          <a:bodyPr/>
-          <a:lstStyle/>
-          <a:p>
-            <a:r>
-              <a:rPr lang="en-US" dirty="0"/>
-              <a:t/>
-            </a:r>
-            <a:endParaRPr lang="en-US" dirty="0"/>
-          </a:p>
-        </p:txBody>
-      </p:sp>
-      <p:sp>
-        <p:nvSpPr>
-          <p:cNvPr id="4" name="Slide Number Placeholder 3"/>
-          <p:cNvSpPr>
-            <a:spLocks noGrp="1"/>
-          </p:cNvSpPr>
-          <p:nvPr>
-            <p:ph type="sldNum" sz="quarter" idx="10"/>
-          </p:nvPr>
-        </p:nvSpPr>
-        <p:spPr/>
-        <p:txBody>
-          <a:bodyPr/>
-          <a:lstStyle/>
-          <a:p>
-            <a:fld id="{F7021451-1387-4CA6-816F-3879F97B5CBC}" type="slidenum">
-              <a:rPr lang="en-US"/>
-              <a:t>29</a:t>
-            </a:fld>
-            <a:endParaRPr lang="en-US"/>
-          </a:p>
-        </p:txBody>
-      </p:sp>
-    </p:spTree>
-    <p:extLst>
-      <p:ext uri="{BB962C8B-B14F-4D97-AF65-F5344CB8AC3E}">
-        <p14:creationId xmlns:p14="http://schemas.microsoft.com/office/powerpoint/2010/main" val="1024086991"/>
-      </p:ext>
-    </p:extLst>
-  </p:cSld>
-  <p:clrMapOvr>
-    <a:masterClrMapping/>
-  </p:clrMapOvr>
-</p:notes>
-</file>
-
 <file path=ppt/notesSlides/notesSlide3.xml><?xml version="1.0" encoding="utf-8"?>
 <p:notes xmlns:a="http://schemas.openxmlformats.org/drawingml/2006/main" xmlns:r="http://schemas.openxmlformats.org/officeDocument/2006/relationships" xmlns:p="http://schemas.openxmlformats.org/presentationml/2006/main">
   <p:cSld>
@@ -2494,358 +1600,6 @@
             <a:fld id="{F7021451-1387-4CA6-816F-3879F97B5CBC}" type="slidenum">
               <a:rPr lang="en-US"/>
               <a:t>3</a:t>
-            </a:fld>
-            <a:endParaRPr lang="en-US"/>
-          </a:p>
-        </p:txBody>
-      </p:sp>
-    </p:spTree>
-    <p:extLst>
-      <p:ext uri="{BB962C8B-B14F-4D97-AF65-F5344CB8AC3E}">
-        <p14:creationId xmlns:p14="http://schemas.microsoft.com/office/powerpoint/2010/main" val="1024086991"/>
-      </p:ext>
-    </p:extLst>
-  </p:cSld>
-  <p:clrMapOvr>
-    <a:masterClrMapping/>
-  </p:clrMapOvr>
-</p:notes>
-</file>
-
-<file path=ppt/notesSlides/notesSlide30.xml><?xml version="1.0" encoding="utf-8"?>
-<p:notes xmlns:a="http://schemas.openxmlformats.org/drawingml/2006/main" xmlns:r="http://schemas.openxmlformats.org/officeDocument/2006/relationships" xmlns:p="http://schemas.openxmlformats.org/presentationml/2006/main">
-  <p:cSld>
-    <p:spTree>
-      <p:nvGrpSpPr>
-        <p:cNvPr id="1" name=""/>
-        <p:cNvGrpSpPr/>
-        <p:nvPr/>
-      </p:nvGrpSpPr>
-      <p:grpSpPr>
-        <a:xfrm>
-          <a:off x="0" y="0"/>
-          <a:ext cx="0" cy="0"/>
-          <a:chOff x="0" y="0"/>
-          <a:chExt cx="0" cy="0"/>
-        </a:xfrm>
-      </p:grpSpPr>
-      <p:sp>
-        <p:nvSpPr>
-          <p:cNvPr id="2" name="Slide Image Placeholder 1"/>
-          <p:cNvSpPr>
-            <a:spLocks noGrp="1" noRot="1" noChangeAspect="1"/>
-          </p:cNvSpPr>
-          <p:nvPr>
-            <p:ph type="sldImg"/>
-          </p:nvPr>
-        </p:nvSpPr>
-        <p:spPr/>
-      </p:sp>
-      <p:sp>
-        <p:nvSpPr>
-          <p:cNvPr id="3" name="Notes Placeholder 2"/>
-          <p:cNvSpPr>
-            <a:spLocks noGrp="1"/>
-          </p:cNvSpPr>
-          <p:nvPr>
-            <p:ph type="body" idx="1"/>
-          </p:nvPr>
-        </p:nvSpPr>
-        <p:spPr/>
-        <p:txBody>
-          <a:bodyPr/>
-          <a:lstStyle/>
-          <a:p>
-            <a:r>
-              <a:rPr lang="en-US" dirty="0"/>
-              <a:t/>
-            </a:r>
-            <a:endParaRPr lang="en-US" dirty="0"/>
-          </a:p>
-        </p:txBody>
-      </p:sp>
-      <p:sp>
-        <p:nvSpPr>
-          <p:cNvPr id="4" name="Slide Number Placeholder 3"/>
-          <p:cNvSpPr>
-            <a:spLocks noGrp="1"/>
-          </p:cNvSpPr>
-          <p:nvPr>
-            <p:ph type="sldNum" sz="quarter" idx="10"/>
-          </p:nvPr>
-        </p:nvSpPr>
-        <p:spPr/>
-        <p:txBody>
-          <a:bodyPr/>
-          <a:lstStyle/>
-          <a:p>
-            <a:fld id="{F7021451-1387-4CA6-816F-3879F97B5CBC}" type="slidenum">
-              <a:rPr lang="en-US"/>
-              <a:t>30</a:t>
-            </a:fld>
-            <a:endParaRPr lang="en-US"/>
-          </a:p>
-        </p:txBody>
-      </p:sp>
-    </p:spTree>
-    <p:extLst>
-      <p:ext uri="{BB962C8B-B14F-4D97-AF65-F5344CB8AC3E}">
-        <p14:creationId xmlns:p14="http://schemas.microsoft.com/office/powerpoint/2010/main" val="1024086991"/>
-      </p:ext>
-    </p:extLst>
-  </p:cSld>
-  <p:clrMapOvr>
-    <a:masterClrMapping/>
-  </p:clrMapOvr>
-</p:notes>
-</file>
-
-<file path=ppt/notesSlides/notesSlide31.xml><?xml version="1.0" encoding="utf-8"?>
-<p:notes xmlns:a="http://schemas.openxmlformats.org/drawingml/2006/main" xmlns:r="http://schemas.openxmlformats.org/officeDocument/2006/relationships" xmlns:p="http://schemas.openxmlformats.org/presentationml/2006/main">
-  <p:cSld>
-    <p:spTree>
-      <p:nvGrpSpPr>
-        <p:cNvPr id="1" name=""/>
-        <p:cNvGrpSpPr/>
-        <p:nvPr/>
-      </p:nvGrpSpPr>
-      <p:grpSpPr>
-        <a:xfrm>
-          <a:off x="0" y="0"/>
-          <a:ext cx="0" cy="0"/>
-          <a:chOff x="0" y="0"/>
-          <a:chExt cx="0" cy="0"/>
-        </a:xfrm>
-      </p:grpSpPr>
-      <p:sp>
-        <p:nvSpPr>
-          <p:cNvPr id="2" name="Slide Image Placeholder 1"/>
-          <p:cNvSpPr>
-            <a:spLocks noGrp="1" noRot="1" noChangeAspect="1"/>
-          </p:cNvSpPr>
-          <p:nvPr>
-            <p:ph type="sldImg"/>
-          </p:nvPr>
-        </p:nvSpPr>
-        <p:spPr/>
-      </p:sp>
-      <p:sp>
-        <p:nvSpPr>
-          <p:cNvPr id="3" name="Notes Placeholder 2"/>
-          <p:cNvSpPr>
-            <a:spLocks noGrp="1"/>
-          </p:cNvSpPr>
-          <p:nvPr>
-            <p:ph type="body" idx="1"/>
-          </p:nvPr>
-        </p:nvSpPr>
-        <p:spPr/>
-        <p:txBody>
-          <a:bodyPr/>
-          <a:lstStyle/>
-          <a:p>
-            <a:r>
-              <a:rPr lang="en-US" dirty="0"/>
-              <a:t/>
-            </a:r>
-            <a:endParaRPr lang="en-US" dirty="0"/>
-          </a:p>
-        </p:txBody>
-      </p:sp>
-      <p:sp>
-        <p:nvSpPr>
-          <p:cNvPr id="4" name="Slide Number Placeholder 3"/>
-          <p:cNvSpPr>
-            <a:spLocks noGrp="1"/>
-          </p:cNvSpPr>
-          <p:nvPr>
-            <p:ph type="sldNum" sz="quarter" idx="10"/>
-          </p:nvPr>
-        </p:nvSpPr>
-        <p:spPr/>
-        <p:txBody>
-          <a:bodyPr/>
-          <a:lstStyle/>
-          <a:p>
-            <a:fld id="{F7021451-1387-4CA6-816F-3879F97B5CBC}" type="slidenum">
-              <a:rPr lang="en-US"/>
-              <a:t>31</a:t>
-            </a:fld>
-            <a:endParaRPr lang="en-US"/>
-          </a:p>
-        </p:txBody>
-      </p:sp>
-    </p:spTree>
-    <p:extLst>
-      <p:ext uri="{BB962C8B-B14F-4D97-AF65-F5344CB8AC3E}">
-        <p14:creationId xmlns:p14="http://schemas.microsoft.com/office/powerpoint/2010/main" val="1024086991"/>
-      </p:ext>
-    </p:extLst>
-  </p:cSld>
-  <p:clrMapOvr>
-    <a:masterClrMapping/>
-  </p:clrMapOvr>
-</p:notes>
-</file>
-
-<file path=ppt/notesSlides/notesSlide32.xml><?xml version="1.0" encoding="utf-8"?>
-<p:notes xmlns:a="http://schemas.openxmlformats.org/drawingml/2006/main" xmlns:r="http://schemas.openxmlformats.org/officeDocument/2006/relationships" xmlns:p="http://schemas.openxmlformats.org/presentationml/2006/main">
-  <p:cSld>
-    <p:spTree>
-      <p:nvGrpSpPr>
-        <p:cNvPr id="1" name=""/>
-        <p:cNvGrpSpPr/>
-        <p:nvPr/>
-      </p:nvGrpSpPr>
-      <p:grpSpPr>
-        <a:xfrm>
-          <a:off x="0" y="0"/>
-          <a:ext cx="0" cy="0"/>
-          <a:chOff x="0" y="0"/>
-          <a:chExt cx="0" cy="0"/>
-        </a:xfrm>
-      </p:grpSpPr>
-      <p:sp>
-        <p:nvSpPr>
-          <p:cNvPr id="2" name="Slide Image Placeholder 1"/>
-          <p:cNvSpPr>
-            <a:spLocks noGrp="1" noRot="1" noChangeAspect="1"/>
-          </p:cNvSpPr>
-          <p:nvPr>
-            <p:ph type="sldImg"/>
-          </p:nvPr>
-        </p:nvSpPr>
-        <p:spPr/>
-      </p:sp>
-      <p:sp>
-        <p:nvSpPr>
-          <p:cNvPr id="3" name="Notes Placeholder 2"/>
-          <p:cNvSpPr>
-            <a:spLocks noGrp="1"/>
-          </p:cNvSpPr>
-          <p:nvPr>
-            <p:ph type="body" idx="1"/>
-          </p:nvPr>
-        </p:nvSpPr>
-        <p:spPr/>
-        <p:txBody>
-          <a:bodyPr/>
-          <a:lstStyle/>
-          <a:p>
-            <a:r>
-              <a:rPr lang="en-US" dirty="0"/>
-              <a:t/>
-            </a:r>
-            <a:endParaRPr lang="en-US" dirty="0"/>
-          </a:p>
-        </p:txBody>
-      </p:sp>
-      <p:sp>
-        <p:nvSpPr>
-          <p:cNvPr id="4" name="Slide Number Placeholder 3"/>
-          <p:cNvSpPr>
-            <a:spLocks noGrp="1"/>
-          </p:cNvSpPr>
-          <p:nvPr>
-            <p:ph type="sldNum" sz="quarter" idx="10"/>
-          </p:nvPr>
-        </p:nvSpPr>
-        <p:spPr/>
-        <p:txBody>
-          <a:bodyPr/>
-          <a:lstStyle/>
-          <a:p>
-            <a:fld id="{F7021451-1387-4CA6-816F-3879F97B5CBC}" type="slidenum">
-              <a:rPr lang="en-US"/>
-              <a:t>32</a:t>
-            </a:fld>
-            <a:endParaRPr lang="en-US"/>
-          </a:p>
-        </p:txBody>
-      </p:sp>
-    </p:spTree>
-    <p:extLst>
-      <p:ext uri="{BB962C8B-B14F-4D97-AF65-F5344CB8AC3E}">
-        <p14:creationId xmlns:p14="http://schemas.microsoft.com/office/powerpoint/2010/main" val="1024086991"/>
-      </p:ext>
-    </p:extLst>
-  </p:cSld>
-  <p:clrMapOvr>
-    <a:masterClrMapping/>
-  </p:clrMapOvr>
-</p:notes>
-</file>
-
-<file path=ppt/notesSlides/notesSlide33.xml><?xml version="1.0" encoding="utf-8"?>
-<p:notes xmlns:a="http://schemas.openxmlformats.org/drawingml/2006/main" xmlns:r="http://schemas.openxmlformats.org/officeDocument/2006/relationships" xmlns:p="http://schemas.openxmlformats.org/presentationml/2006/main">
-  <p:cSld>
-    <p:spTree>
-      <p:nvGrpSpPr>
-        <p:cNvPr id="1" name=""/>
-        <p:cNvGrpSpPr/>
-        <p:nvPr/>
-      </p:nvGrpSpPr>
-      <p:grpSpPr>
-        <a:xfrm>
-          <a:off x="0" y="0"/>
-          <a:ext cx="0" cy="0"/>
-          <a:chOff x="0" y="0"/>
-          <a:chExt cx="0" cy="0"/>
-        </a:xfrm>
-      </p:grpSpPr>
-      <p:sp>
-        <p:nvSpPr>
-          <p:cNvPr id="2" name="Slide Image Placeholder 1"/>
-          <p:cNvSpPr>
-            <a:spLocks noGrp="1" noRot="1" noChangeAspect="1"/>
-          </p:cNvSpPr>
-          <p:nvPr>
-            <p:ph type="sldImg"/>
-          </p:nvPr>
-        </p:nvSpPr>
-        <p:spPr/>
-      </p:sp>
-      <p:sp>
-        <p:nvSpPr>
-          <p:cNvPr id="3" name="Notes Placeholder 2"/>
-          <p:cNvSpPr>
-            <a:spLocks noGrp="1"/>
-          </p:cNvSpPr>
-          <p:nvPr>
-            <p:ph type="body" idx="1"/>
-          </p:nvPr>
-        </p:nvSpPr>
-        <p:spPr/>
-        <p:txBody>
-          <a:bodyPr/>
-          <a:lstStyle/>
-          <a:p>
-            <a:r>
-              <a:rPr lang="en-US" dirty="0"/>
-              <a:t/>
-            </a:r>
-            <a:endParaRPr lang="en-US" dirty="0"/>
-          </a:p>
-        </p:txBody>
-      </p:sp>
-      <p:sp>
-        <p:nvSpPr>
-          <p:cNvPr id="4" name="Slide Number Placeholder 3"/>
-          <p:cNvSpPr>
-            <a:spLocks noGrp="1"/>
-          </p:cNvSpPr>
-          <p:nvPr>
-            <p:ph type="sldNum" sz="quarter" idx="10"/>
-          </p:nvPr>
-        </p:nvSpPr>
-        <p:spPr/>
-        <p:txBody>
-          <a:bodyPr/>
-          <a:lstStyle/>
-          <a:p>
-            <a:fld id="{F7021451-1387-4CA6-816F-3879F97B5CBC}" type="slidenum">
-              <a:rPr lang="en-US"/>
-              <a:t>33</a:t>
             </a:fld>
             <a:endParaRPr lang="en-US"/>
           </a:p>
@@ -3740,58 +2494,6 @@
           </a:prstGeom>
         </p:spPr>
       </p:pic>
-      <p:pic>
-        <p:nvPicPr>
-          <p:cNvPr id="3" name="Image 1" descr="preencoded.png">
-            <a:hlinkClick r:id="rId3" tooltip="https://github.com/samquansah-algo/nbc-vct/blob/main/brand/NBC_Brand_Guide.pdf"/>
-          </p:cNvPr>
-          <p:cNvPicPr>
-            <a:picLocks noChangeAspect="1"/>
-          </p:cNvPicPr>
-          <p:nvPr/>
-        </p:nvPicPr>
-        <p:blipFill>
-          <a:blip r:embed="rId2"/>
-          <a:stretch>
-            <a:fillRect/>
-          </a:stretch>
-        </p:blipFill>
-        <p:spPr>
-          <a:xfrm>
-            <a:off x="457200" y="4429125"/>
-            <a:ext cx="1104900" cy="142875"/>
-          </a:xfrm>
-          <a:prstGeom prst="rect">
-            <a:avLst/>
-          </a:prstGeom>
-        </p:spPr>
-      </p:pic>
-      <p:pic>
-        <p:nvPicPr>
-          <p:cNvPr id="4" name="Image 2" descr="preencoded.png">
-            <a:hlinkClick r:id="rId5" tooltip="https://github.com/samquansah-algo/nbc-vct/tree/main/weekly-tactics/04-sales/"/>
-          </p:cNvPr>
-          <p:cNvPicPr>
-            <a:picLocks noChangeAspect="1"/>
-          </p:cNvPicPr>
-          <p:nvPr/>
-        </p:nvPicPr>
-        <p:blipFill>
-          <a:blip r:embed="rId4"/>
-          <a:stretch>
-            <a:fillRect/>
-          </a:stretch>
-        </p:blipFill>
-        <p:spPr>
-          <a:xfrm>
-            <a:off x="1704975" y="4429125"/>
-            <a:ext cx="2262187" cy="142875"/>
-          </a:xfrm>
-          <a:prstGeom prst="rect">
-            <a:avLst/>
-          </a:prstGeom>
-        </p:spPr>
-      </p:pic>
     </p:spTree>
   </p:cSld>
   <p:clrMapOvr>
@@ -3844,7 +2546,7 @@
       <p:pic>
         <p:nvPicPr>
           <p:cNvPr id="3" name="Image 1" descr="preencoded.png">
-            <a:hlinkClick r:id="rId3" tooltip="https://github.com/samquansah-algo/nbc-vct/blob/main/weekly-tactics/03-persona-ads/README.md"/>
+            <a:hlinkClick r:id="rId3" tooltip="https://github.com/samquansah-algo/nbc-vct/blob/main/weekly-tactics/04-sales/OUTREACH_KIT.md"/>
           </p:cNvPr>
           <p:cNvPicPr>
             <a:picLocks noChangeAspect="1"/>
@@ -3859,8 +2561,8 @@
         </p:blipFill>
         <p:spPr>
           <a:xfrm>
-            <a:off x="4719638" y="4824412"/>
-            <a:ext cx="376238" cy="109537"/>
+            <a:off x="4781550" y="4824412"/>
+            <a:ext cx="495300" cy="109537"/>
           </a:xfrm>
           <a:prstGeom prst="rect">
             <a:avLst/>
@@ -3885,7 +2587,7 @@
         </p:blipFill>
         <p:spPr>
           <a:xfrm>
-            <a:off x="5157788" y="4824412"/>
+            <a:off x="5338762" y="4824412"/>
             <a:ext cx="642938" cy="109537"/>
           </a:xfrm>
           <a:prstGeom prst="rect">
@@ -3945,7 +2647,7 @@
       <p:pic>
         <p:nvPicPr>
           <p:cNvPr id="3" name="Image 1" descr="preencoded.png">
-            <a:hlinkClick r:id="rId3" tooltip="https://github.com/samquansah-algo/nbc-vct/blob/main/weekly-tactics/03-persona-ads/README.md"/>
+            <a:hlinkClick r:id="rId3" tooltip="https://github.com/samquansah-algo/nbc-vct/blob/main/weekly-tactics/04-sales/OUTREACH_KIT.md"/>
           </p:cNvPr>
           <p:cNvPicPr>
             <a:picLocks noChangeAspect="1"/>
@@ -3960,8 +2662,8 @@
         </p:blipFill>
         <p:spPr>
           <a:xfrm>
-            <a:off x="4719638" y="4824412"/>
-            <a:ext cx="376238" cy="109537"/>
+            <a:off x="4781550" y="4824412"/>
+            <a:ext cx="495300" cy="109537"/>
           </a:xfrm>
           <a:prstGeom prst="rect">
             <a:avLst/>
@@ -3986,7 +2688,7 @@
         </p:blipFill>
         <p:spPr>
           <a:xfrm>
-            <a:off x="5157788" y="4824412"/>
+            <a:off x="5338762" y="4824412"/>
             <a:ext cx="642938" cy="109537"/>
           </a:xfrm>
           <a:prstGeom prst="rect">
@@ -4046,7 +2748,7 @@
       <p:pic>
         <p:nvPicPr>
           <p:cNvPr id="3" name="Image 1" descr="preencoded.png">
-            <a:hlinkClick r:id="rId3" tooltip="https://github.com/samquansah-algo/nbc-vct/blob/main/weekly-tactics/03-persona-ads/README.md"/>
+            <a:hlinkClick r:id="rId3" tooltip="https://github.com/samquansah-algo/nbc-vct/blob/main/weekly-tactics/04-sales/OUTREACH_KIT.md"/>
           </p:cNvPr>
           <p:cNvPicPr>
             <a:picLocks noChangeAspect="1"/>
@@ -4061,8 +2763,8 @@
         </p:blipFill>
         <p:spPr>
           <a:xfrm>
-            <a:off x="4719638" y="4824412"/>
-            <a:ext cx="376238" cy="109537"/>
+            <a:off x="4781550" y="4824412"/>
+            <a:ext cx="495300" cy="109537"/>
           </a:xfrm>
           <a:prstGeom prst="rect">
             <a:avLst/>
@@ -4087,7 +2789,7 @@
         </p:blipFill>
         <p:spPr>
           <a:xfrm>
-            <a:off x="5157788" y="4824412"/>
+            <a:off x="5338762" y="4824412"/>
             <a:ext cx="642938" cy="109537"/>
           </a:xfrm>
           <a:prstGeom prst="rect">
@@ -4147,7 +2849,7 @@
       <p:pic>
         <p:nvPicPr>
           <p:cNvPr id="3" name="Image 1" descr="preencoded.png">
-            <a:hlinkClick r:id="rId3" tooltip="https://github.com/samquansah-algo/nbc-vct/blob/main/brand/NBC_Brand_Guide.pdf"/>
+            <a:hlinkClick r:id="rId3" tooltip="https://github.com/samquansah-algo/nbc-vct/blob/main/weekly-tactics/04-sales/OUTREACH_KIT.md"/>
           </p:cNvPr>
           <p:cNvPicPr>
             <a:picLocks noChangeAspect="1"/>
@@ -4162,7 +2864,33 @@
         </p:blipFill>
         <p:spPr>
           <a:xfrm>
-            <a:off x="4938712" y="4824412"/>
+            <a:off x="4781550" y="4824412"/>
+            <a:ext cx="495300" cy="109537"/>
+          </a:xfrm>
+          <a:prstGeom prst="rect">
+            <a:avLst/>
+          </a:prstGeom>
+        </p:spPr>
+      </p:pic>
+      <p:pic>
+        <p:nvPicPr>
+          <p:cNvPr id="4" name="Image 2" descr="preencoded.png">
+            <a:hlinkClick r:id="rId5" tooltip="https://github.com/samquansah-algo/nbc-vct/blob/main/brand/NBC_Brand_Guide.pdf"/>
+          </p:cNvPr>
+          <p:cNvPicPr>
+            <a:picLocks noChangeAspect="1"/>
+          </p:cNvPicPr>
+          <p:nvPr/>
+        </p:nvPicPr>
+        <p:blipFill>
+          <a:blip r:embed="rId4"/>
+          <a:stretch>
+            <a:fillRect/>
+          </a:stretch>
+        </p:blipFill>
+        <p:spPr>
+          <a:xfrm>
+            <a:off x="5338762" y="4824412"/>
             <a:ext cx="642938" cy="109537"/>
           </a:xfrm>
           <a:prstGeom prst="rect">
@@ -4222,7 +2950,7 @@
       <p:pic>
         <p:nvPicPr>
           <p:cNvPr id="3" name="Image 1" descr="preencoded.png">
-            <a:hlinkClick r:id="rId3" tooltip="https://github.com/samquansah-algo/nbc-vct/blob/main/weekly-tactics/04-sales/lead_list_template.csv"/>
+            <a:hlinkClick r:id="rId3" tooltip="https://github.com/samquansah-algo/nbc-vct/blob/main/marketing/crm/README.md"/>
           </p:cNvPr>
           <p:cNvPicPr>
             <a:picLocks noChangeAspect="1"/>
@@ -4237,8 +2965,8 @@
         </p:blipFill>
         <p:spPr>
           <a:xfrm>
-            <a:off x="5610225" y="3952875"/>
-            <a:ext cx="862012" cy="142875"/>
+            <a:off x="4938712" y="4824412"/>
+            <a:ext cx="180975" cy="109537"/>
           </a:xfrm>
           <a:prstGeom prst="rect">
             <a:avLst/>
@@ -4248,7 +2976,7 @@
       <p:pic>
         <p:nvPicPr>
           <p:cNvPr id="4" name="Image 2" descr="preencoded.png">
-            <a:hlinkClick r:id="rId5" tooltip="https://github.com/samquansah-algo/nbc-vct/blob/main/weekly-tactics/04-sales/lead_list_template.csv"/>
+            <a:hlinkClick r:id="rId5" tooltip="https://github.com/samquansah-algo/nbc-vct/blob/main/brand/NBC_Brand_Guide.pdf"/>
           </p:cNvPr>
           <p:cNvPicPr>
             <a:picLocks noChangeAspect="1"/>
@@ -4263,33 +2991,7 @@
         </p:blipFill>
         <p:spPr>
           <a:xfrm>
-            <a:off x="4555331" y="4824412"/>
-            <a:ext cx="704850" cy="109537"/>
-          </a:xfrm>
-          <a:prstGeom prst="rect">
-            <a:avLst/>
-          </a:prstGeom>
-        </p:spPr>
-      </p:pic>
-      <p:pic>
-        <p:nvPicPr>
-          <p:cNvPr id="5" name="Image 3" descr="preencoded.png">
-            <a:hlinkClick r:id="rId7" tooltip="https://github.com/samquansah-algo/nbc-vct/blob/main/brand/NBC_Brand_Guide.pdf"/>
-          </p:cNvPr>
-          <p:cNvPicPr>
-            <a:picLocks noChangeAspect="1"/>
-          </p:cNvPicPr>
-          <p:nvPr/>
-        </p:nvPicPr>
-        <p:blipFill>
-          <a:blip r:embed="rId6"/>
-          <a:stretch>
-            <a:fillRect/>
-          </a:stretch>
-        </p:blipFill>
-        <p:spPr>
-          <a:xfrm>
-            <a:off x="5322094" y="4824412"/>
+            <a:off x="5181600" y="4824412"/>
             <a:ext cx="642938" cy="109537"/>
           </a:xfrm>
           <a:prstGeom prst="rect">
@@ -4349,7 +3051,7 @@
       <p:pic>
         <p:nvPicPr>
           <p:cNvPr id="3" name="Image 1" descr="preencoded.png">
-            <a:hlinkClick r:id="rId3" tooltip="https://github.com/samquansah-algo/nbc-vct/blob/main/weekly-tactics/04-sales/lead_list_template.csv"/>
+            <a:hlinkClick r:id="rId3" tooltip="https://github.com/samquansah-algo/nbc-vct/blob/main/marketing/crm/README.md"/>
           </p:cNvPr>
           <p:cNvPicPr>
             <a:picLocks noChangeAspect="1"/>
@@ -4364,8 +3066,8 @@
         </p:blipFill>
         <p:spPr>
           <a:xfrm>
-            <a:off x="5610225" y="3952875"/>
-            <a:ext cx="862012" cy="142875"/>
+            <a:off x="4938712" y="4824412"/>
+            <a:ext cx="180975" cy="109537"/>
           </a:xfrm>
           <a:prstGeom prst="rect">
             <a:avLst/>
@@ -4375,7 +3077,7 @@
       <p:pic>
         <p:nvPicPr>
           <p:cNvPr id="4" name="Image 2" descr="preencoded.png">
-            <a:hlinkClick r:id="rId5" tooltip="https://github.com/samquansah-algo/nbc-vct/blob/main/weekly-tactics/04-sales/lead_list_template.csv"/>
+            <a:hlinkClick r:id="rId5" tooltip="https://github.com/samquansah-algo/nbc-vct/blob/main/brand/NBC_Brand_Guide.pdf"/>
           </p:cNvPr>
           <p:cNvPicPr>
             <a:picLocks noChangeAspect="1"/>
@@ -4390,33 +3092,7 @@
         </p:blipFill>
         <p:spPr>
           <a:xfrm>
-            <a:off x="4555331" y="4824412"/>
-            <a:ext cx="704850" cy="109537"/>
-          </a:xfrm>
-          <a:prstGeom prst="rect">
-            <a:avLst/>
-          </a:prstGeom>
-        </p:spPr>
-      </p:pic>
-      <p:pic>
-        <p:nvPicPr>
-          <p:cNvPr id="5" name="Image 3" descr="preencoded.png">
-            <a:hlinkClick r:id="rId7" tooltip="https://github.com/samquansah-algo/nbc-vct/blob/main/brand/NBC_Brand_Guide.pdf"/>
-          </p:cNvPr>
-          <p:cNvPicPr>
-            <a:picLocks noChangeAspect="1"/>
-          </p:cNvPicPr>
-          <p:nvPr/>
-        </p:nvPicPr>
-        <p:blipFill>
-          <a:blip r:embed="rId6"/>
-          <a:stretch>
-            <a:fillRect/>
-          </a:stretch>
-        </p:blipFill>
-        <p:spPr>
-          <a:xfrm>
-            <a:off x="5322094" y="4824412"/>
+            <a:off x="5181600" y="4824412"/>
             <a:ext cx="642938" cy="109537"/>
           </a:xfrm>
           <a:prstGeom prst="rect">
@@ -4476,7 +3152,7 @@
       <p:pic>
         <p:nvPicPr>
           <p:cNvPr id="3" name="Image 1" descr="preencoded.png">
-            <a:hlinkClick r:id="rId3" tooltip="https://github.com/samquansah-algo/nbc-vct/blob/main/weekly-tactics/04-sales/lead_list_template.csv"/>
+            <a:hlinkClick r:id="rId3" tooltip="https://github.com/samquansah-algo/nbc-vct/blob/main/weekly-tactics/04-sales/OUTREACH_KIT.md"/>
           </p:cNvPr>
           <p:cNvPicPr>
             <a:picLocks noChangeAspect="1"/>
@@ -4491,8 +3167,8 @@
         </p:blipFill>
         <p:spPr>
           <a:xfrm>
-            <a:off x="5610225" y="3952875"/>
-            <a:ext cx="862012" cy="142875"/>
+            <a:off x="4781550" y="4824412"/>
+            <a:ext cx="495300" cy="109537"/>
           </a:xfrm>
           <a:prstGeom prst="rect">
             <a:avLst/>
@@ -4502,7 +3178,7 @@
       <p:pic>
         <p:nvPicPr>
           <p:cNvPr id="4" name="Image 2" descr="preencoded.png">
-            <a:hlinkClick r:id="rId5" tooltip="https://github.com/samquansah-algo/nbc-vct/blob/main/weekly-tactics/04-sales/lead_list_template.csv"/>
+            <a:hlinkClick r:id="rId5" tooltip="https://github.com/samquansah-algo/nbc-vct/blob/main/brand/NBC_Brand_Guide.pdf"/>
           </p:cNvPr>
           <p:cNvPicPr>
             <a:picLocks noChangeAspect="1"/>
@@ -4517,33 +3193,7 @@
         </p:blipFill>
         <p:spPr>
           <a:xfrm>
-            <a:off x="4555331" y="4824412"/>
-            <a:ext cx="704850" cy="109537"/>
-          </a:xfrm>
-          <a:prstGeom prst="rect">
-            <a:avLst/>
-          </a:prstGeom>
-        </p:spPr>
-      </p:pic>
-      <p:pic>
-        <p:nvPicPr>
-          <p:cNvPr id="5" name="Image 3" descr="preencoded.png">
-            <a:hlinkClick r:id="rId7" tooltip="https://github.com/samquansah-algo/nbc-vct/blob/main/brand/NBC_Brand_Guide.pdf"/>
-          </p:cNvPr>
-          <p:cNvPicPr>
-            <a:picLocks noChangeAspect="1"/>
-          </p:cNvPicPr>
-          <p:nvPr/>
-        </p:nvPicPr>
-        <p:blipFill>
-          <a:blip r:embed="rId6"/>
-          <a:stretch>
-            <a:fillRect/>
-          </a:stretch>
-        </p:blipFill>
-        <p:spPr>
-          <a:xfrm>
-            <a:off x="5322094" y="4824412"/>
+            <a:off x="5338762" y="4824412"/>
             <a:ext cx="642938" cy="109537"/>
           </a:xfrm>
           <a:prstGeom prst="rect">
@@ -4603,7 +3253,7 @@
       <p:pic>
         <p:nvPicPr>
           <p:cNvPr id="3" name="Image 1" descr="preencoded.png">
-            <a:hlinkClick r:id="rId3" tooltip="https://github.com/samquansah-algo/nbc-vct/blob/main/brand/NBC_Brand_Guide.pdf"/>
+            <a:hlinkClick r:id="rId3" tooltip="https://github.com/samquansah-algo/nbc-vct/blob/main/thesis/v6-capability-layer/THESIS.md"/>
           </p:cNvPr>
           <p:cNvPicPr>
             <a:picLocks noChangeAspect="1"/>
@@ -4618,7 +3268,33 @@
         </p:blipFill>
         <p:spPr>
           <a:xfrm>
-            <a:off x="4938712" y="4824412"/>
+            <a:off x="4850606" y="4824412"/>
+            <a:ext cx="357188" cy="109537"/>
+          </a:xfrm>
+          <a:prstGeom prst="rect">
+            <a:avLst/>
+          </a:prstGeom>
+        </p:spPr>
+      </p:pic>
+      <p:pic>
+        <p:nvPicPr>
+          <p:cNvPr id="4" name="Image 2" descr="preencoded.png">
+            <a:hlinkClick r:id="rId5" tooltip="https://github.com/samquansah-algo/nbc-vct/blob/main/brand/NBC_Brand_Guide.pdf"/>
+          </p:cNvPr>
+          <p:cNvPicPr>
+            <a:picLocks noChangeAspect="1"/>
+          </p:cNvPicPr>
+          <p:nvPr/>
+        </p:nvPicPr>
+        <p:blipFill>
+          <a:blip r:embed="rId4"/>
+          <a:stretch>
+            <a:fillRect/>
+          </a:stretch>
+        </p:blipFill>
+        <p:spPr>
+          <a:xfrm>
+            <a:off x="5269706" y="4824412"/>
             <a:ext cx="642938" cy="109537"/>
           </a:xfrm>
           <a:prstGeom prst="rect">
@@ -4678,7 +3354,7 @@
       <p:pic>
         <p:nvPicPr>
           <p:cNvPr id="3" name="Image 1" descr="preencoded.png">
-            <a:hlinkClick r:id="rId3" tooltip="https://github.com/samquansah-algo/nbc-vct/blob/main/weekly-tactics/04-sales/OUTREACH_KIT.md"/>
+            <a:hlinkClick r:id="rId3" tooltip="https://github.com/samquansah-algo/nbc-vct/blob/main/thesis/v6-capability-layer/THESIS.md"/>
           </p:cNvPr>
           <p:cNvPicPr>
             <a:picLocks noChangeAspect="1"/>
@@ -4693,8 +3369,8 @@
         </p:blipFill>
         <p:spPr>
           <a:xfrm>
-            <a:off x="4660106" y="4824412"/>
-            <a:ext cx="495300" cy="109537"/>
+            <a:off x="4850606" y="4824412"/>
+            <a:ext cx="357188" cy="109537"/>
           </a:xfrm>
           <a:prstGeom prst="rect">
             <a:avLst/>
@@ -4719,7 +3395,7 @@
         </p:blipFill>
         <p:spPr>
           <a:xfrm>
-            <a:off x="5217319" y="4824412"/>
+            <a:off x="5269706" y="4824412"/>
             <a:ext cx="642938" cy="109537"/>
           </a:xfrm>
           <a:prstGeom prst="rect">
@@ -4779,7 +3455,7 @@
       <p:pic>
         <p:nvPicPr>
           <p:cNvPr id="3" name="Image 1" descr="preencoded.png">
-            <a:hlinkClick r:id="rId3" tooltip="https://github.com/samquansah-algo/nbc-vct/blob/main/weekly-tactics/04-sales/OUTREACH_KIT.md"/>
+            <a:hlinkClick r:id="rId3" tooltip="https://github.com/samquansah-algo/nbc-vct/blob/main/thesis/v6-capability-layer/THESIS.md"/>
           </p:cNvPr>
           <p:cNvPicPr>
             <a:picLocks noChangeAspect="1"/>
@@ -4794,8 +3470,8 @@
         </p:blipFill>
         <p:spPr>
           <a:xfrm>
-            <a:off x="4660106" y="4824412"/>
-            <a:ext cx="495300" cy="109537"/>
+            <a:off x="4850606" y="4824412"/>
+            <a:ext cx="357188" cy="109537"/>
           </a:xfrm>
           <a:prstGeom prst="rect">
             <a:avLst/>
@@ -4820,7 +3496,7 @@
         </p:blipFill>
         <p:spPr>
           <a:xfrm>
-            <a:off x="5217319" y="4824412"/>
+            <a:off x="5269706" y="4824412"/>
             <a:ext cx="642938" cy="109537"/>
           </a:xfrm>
           <a:prstGeom prst="rect">
@@ -4895,7 +3571,7 @@
         </p:blipFill>
         <p:spPr>
           <a:xfrm>
-            <a:off x="4752975" y="4824412"/>
+            <a:off x="4874419" y="4824412"/>
             <a:ext cx="357188" cy="109537"/>
           </a:xfrm>
           <a:prstGeom prst="rect">
@@ -4921,939 +3597,7 @@
         </p:blipFill>
         <p:spPr>
           <a:xfrm>
-            <a:off x="5172075" y="4824412"/>
-            <a:ext cx="642938" cy="109537"/>
-          </a:xfrm>
-          <a:prstGeom prst="rect">
-            <a:avLst/>
-          </a:prstGeom>
-        </p:spPr>
-      </p:pic>
-    </p:spTree>
-  </p:cSld>
-  <p:clrMapOvr>
-    <a:masterClrMapping/>
-  </p:clrMapOvr>
-</p:sld>
-</file>
-
-<file path=ppt/slides/slide20.xml><?xml version="1.0" encoding="utf-8"?>
-<p:sld xmlns:a="http://schemas.openxmlformats.org/drawingml/2006/main" xmlns:r="http://schemas.openxmlformats.org/officeDocument/2006/relationships" xmlns:p="http://schemas.openxmlformats.org/presentationml/2006/main">
-  <p:cSld name="Slide 20">
-    <p:spTree>
-      <p:nvGrpSpPr>
-        <p:cNvPr id="1" name=""/>
-        <p:cNvGrpSpPr/>
-        <p:nvPr/>
-      </p:nvGrpSpPr>
-      <p:grpSpPr>
-        <a:xfrm>
-          <a:off x="0" y="0"/>
-          <a:ext cx="0" cy="0"/>
-          <a:chOff x="0" y="0"/>
-          <a:chExt cx="0" cy="0"/>
-        </a:xfrm>
-      </p:grpSpPr>
-      <p:pic>
-        <p:nvPicPr>
-          <p:cNvPr id="2" name="Image 0" descr="NBC sales tactic slide 20">    </p:cNvPr>
-          <p:cNvPicPr>
-            <a:picLocks noChangeAspect="1"/>
-          </p:cNvPicPr>
-          <p:nvPr/>
-        </p:nvPicPr>
-        <p:blipFill>
-          <a:blip r:embed="rId1"/>
-          <a:stretch>
-            <a:fillRect/>
-          </a:stretch>
-        </p:blipFill>
-        <p:spPr>
-          <a:xfrm>
-            <a:off x="0" y="0"/>
-            <a:ext cx="9144000" cy="5143500"/>
-          </a:xfrm>
-          <a:prstGeom prst="rect">
-            <a:avLst/>
-          </a:prstGeom>
-        </p:spPr>
-      </p:pic>
-      <p:pic>
-        <p:nvPicPr>
-          <p:cNvPr id="3" name="Image 1" descr="preencoded.png">
-            <a:hlinkClick r:id="rId3" tooltip="https://github.com/samquansah-algo/nbc-vct/blob/main/weekly-tactics/04-sales/OUTREACH_KIT.md"/>
-          </p:cNvPr>
-          <p:cNvPicPr>
-            <a:picLocks noChangeAspect="1"/>
-          </p:cNvPicPr>
-          <p:nvPr/>
-        </p:nvPicPr>
-        <p:blipFill>
-          <a:blip r:embed="rId2"/>
-          <a:stretch>
-            <a:fillRect/>
-          </a:stretch>
-        </p:blipFill>
-        <p:spPr>
-          <a:xfrm>
-            <a:off x="4660106" y="4824412"/>
-            <a:ext cx="495300" cy="109537"/>
-          </a:xfrm>
-          <a:prstGeom prst="rect">
-            <a:avLst/>
-          </a:prstGeom>
-        </p:spPr>
-      </p:pic>
-      <p:pic>
-        <p:nvPicPr>
-          <p:cNvPr id="4" name="Image 2" descr="preencoded.png">
-            <a:hlinkClick r:id="rId5" tooltip="https://github.com/samquansah-algo/nbc-vct/blob/main/brand/NBC_Brand_Guide.pdf"/>
-          </p:cNvPr>
-          <p:cNvPicPr>
-            <a:picLocks noChangeAspect="1"/>
-          </p:cNvPicPr>
-          <p:nvPr/>
-        </p:nvPicPr>
-        <p:blipFill>
-          <a:blip r:embed="rId4"/>
-          <a:stretch>
-            <a:fillRect/>
-          </a:stretch>
-        </p:blipFill>
-        <p:spPr>
-          <a:xfrm>
-            <a:off x="5217319" y="4824412"/>
-            <a:ext cx="642938" cy="109537"/>
-          </a:xfrm>
-          <a:prstGeom prst="rect">
-            <a:avLst/>
-          </a:prstGeom>
-        </p:spPr>
-      </p:pic>
-    </p:spTree>
-  </p:cSld>
-  <p:clrMapOvr>
-    <a:masterClrMapping/>
-  </p:clrMapOvr>
-</p:sld>
-</file>
-
-<file path=ppt/slides/slide21.xml><?xml version="1.0" encoding="utf-8"?>
-<p:sld xmlns:a="http://schemas.openxmlformats.org/drawingml/2006/main" xmlns:r="http://schemas.openxmlformats.org/officeDocument/2006/relationships" xmlns:p="http://schemas.openxmlformats.org/presentationml/2006/main">
-  <p:cSld name="Slide 21">
-    <p:spTree>
-      <p:nvGrpSpPr>
-        <p:cNvPr id="1" name=""/>
-        <p:cNvGrpSpPr/>
-        <p:nvPr/>
-      </p:nvGrpSpPr>
-      <p:grpSpPr>
-        <a:xfrm>
-          <a:off x="0" y="0"/>
-          <a:ext cx="0" cy="0"/>
-          <a:chOff x="0" y="0"/>
-          <a:chExt cx="0" cy="0"/>
-        </a:xfrm>
-      </p:grpSpPr>
-      <p:pic>
-        <p:nvPicPr>
-          <p:cNvPr id="2" name="Image 0" descr="NBC sales tactic slide 21">    </p:cNvPr>
-          <p:cNvPicPr>
-            <a:picLocks noChangeAspect="1"/>
-          </p:cNvPicPr>
-          <p:nvPr/>
-        </p:nvPicPr>
-        <p:blipFill>
-          <a:blip r:embed="rId1"/>
-          <a:stretch>
-            <a:fillRect/>
-          </a:stretch>
-        </p:blipFill>
-        <p:spPr>
-          <a:xfrm>
-            <a:off x="0" y="0"/>
-            <a:ext cx="9144000" cy="5143500"/>
-          </a:xfrm>
-          <a:prstGeom prst="rect">
-            <a:avLst/>
-          </a:prstGeom>
-        </p:spPr>
-      </p:pic>
-      <p:pic>
-        <p:nvPicPr>
-          <p:cNvPr id="3" name="Image 1" descr="preencoded.png">
-            <a:hlinkClick r:id="rId3" tooltip="https://github.com/samquansah-algo/nbc-vct/blob/main/weekly-tactics/04-sales/OUTREACH_KIT.md"/>
-          </p:cNvPr>
-          <p:cNvPicPr>
-            <a:picLocks noChangeAspect="1"/>
-          </p:cNvPicPr>
-          <p:nvPr/>
-        </p:nvPicPr>
-        <p:blipFill>
-          <a:blip r:embed="rId2"/>
-          <a:stretch>
-            <a:fillRect/>
-          </a:stretch>
-        </p:blipFill>
-        <p:spPr>
-          <a:xfrm>
-            <a:off x="4660106" y="4824412"/>
-            <a:ext cx="495300" cy="109537"/>
-          </a:xfrm>
-          <a:prstGeom prst="rect">
-            <a:avLst/>
-          </a:prstGeom>
-        </p:spPr>
-      </p:pic>
-      <p:pic>
-        <p:nvPicPr>
-          <p:cNvPr id="4" name="Image 2" descr="preencoded.png">
-            <a:hlinkClick r:id="rId5" tooltip="https://github.com/samquansah-algo/nbc-vct/blob/main/brand/NBC_Brand_Guide.pdf"/>
-          </p:cNvPr>
-          <p:cNvPicPr>
-            <a:picLocks noChangeAspect="1"/>
-          </p:cNvPicPr>
-          <p:nvPr/>
-        </p:nvPicPr>
-        <p:blipFill>
-          <a:blip r:embed="rId4"/>
-          <a:stretch>
-            <a:fillRect/>
-          </a:stretch>
-        </p:blipFill>
-        <p:spPr>
-          <a:xfrm>
-            <a:off x="5217319" y="4824412"/>
-            <a:ext cx="642938" cy="109537"/>
-          </a:xfrm>
-          <a:prstGeom prst="rect">
-            <a:avLst/>
-          </a:prstGeom>
-        </p:spPr>
-      </p:pic>
-    </p:spTree>
-  </p:cSld>
-  <p:clrMapOvr>
-    <a:masterClrMapping/>
-  </p:clrMapOvr>
-</p:sld>
-</file>
-
-<file path=ppt/slides/slide22.xml><?xml version="1.0" encoding="utf-8"?>
-<p:sld xmlns:a="http://schemas.openxmlformats.org/drawingml/2006/main" xmlns:r="http://schemas.openxmlformats.org/officeDocument/2006/relationships" xmlns:p="http://schemas.openxmlformats.org/presentationml/2006/main">
-  <p:cSld name="Slide 22">
-    <p:spTree>
-      <p:nvGrpSpPr>
-        <p:cNvPr id="1" name=""/>
-        <p:cNvGrpSpPr/>
-        <p:nvPr/>
-      </p:nvGrpSpPr>
-      <p:grpSpPr>
-        <a:xfrm>
-          <a:off x="0" y="0"/>
-          <a:ext cx="0" cy="0"/>
-          <a:chOff x="0" y="0"/>
-          <a:chExt cx="0" cy="0"/>
-        </a:xfrm>
-      </p:grpSpPr>
-      <p:pic>
-        <p:nvPicPr>
-          <p:cNvPr id="2" name="Image 0" descr="NBC sales tactic slide 22">    </p:cNvPr>
-          <p:cNvPicPr>
-            <a:picLocks noChangeAspect="1"/>
-          </p:cNvPicPr>
-          <p:nvPr/>
-        </p:nvPicPr>
-        <p:blipFill>
-          <a:blip r:embed="rId1"/>
-          <a:stretch>
-            <a:fillRect/>
-          </a:stretch>
-        </p:blipFill>
-        <p:spPr>
-          <a:xfrm>
-            <a:off x="0" y="0"/>
-            <a:ext cx="9144000" cy="5143500"/>
-          </a:xfrm>
-          <a:prstGeom prst="rect">
-            <a:avLst/>
-          </a:prstGeom>
-        </p:spPr>
-      </p:pic>
-      <p:pic>
-        <p:nvPicPr>
-          <p:cNvPr id="3" name="Image 1" descr="preencoded.png">
-            <a:hlinkClick r:id="rId3" tooltip="https://github.com/samquansah-algo/nbc-vct/blob/main/brand/NBC_Brand_Guide.pdf"/>
-          </p:cNvPr>
-          <p:cNvPicPr>
-            <a:picLocks noChangeAspect="1"/>
-          </p:cNvPicPr>
-          <p:nvPr/>
-        </p:nvPicPr>
-        <p:blipFill>
-          <a:blip r:embed="rId2"/>
-          <a:stretch>
-            <a:fillRect/>
-          </a:stretch>
-        </p:blipFill>
-        <p:spPr>
-          <a:xfrm>
-            <a:off x="4938712" y="4824412"/>
-            <a:ext cx="642938" cy="109537"/>
-          </a:xfrm>
-          <a:prstGeom prst="rect">
-            <a:avLst/>
-          </a:prstGeom>
-        </p:spPr>
-      </p:pic>
-    </p:spTree>
-  </p:cSld>
-  <p:clrMapOvr>
-    <a:masterClrMapping/>
-  </p:clrMapOvr>
-</p:sld>
-</file>
-
-<file path=ppt/slides/slide23.xml><?xml version="1.0" encoding="utf-8"?>
-<p:sld xmlns:a="http://schemas.openxmlformats.org/drawingml/2006/main" xmlns:r="http://schemas.openxmlformats.org/officeDocument/2006/relationships" xmlns:p="http://schemas.openxmlformats.org/presentationml/2006/main">
-  <p:cSld name="Slide 23">
-    <p:spTree>
-      <p:nvGrpSpPr>
-        <p:cNvPr id="1" name=""/>
-        <p:cNvGrpSpPr/>
-        <p:nvPr/>
-      </p:nvGrpSpPr>
-      <p:grpSpPr>
-        <a:xfrm>
-          <a:off x="0" y="0"/>
-          <a:ext cx="0" cy="0"/>
-          <a:chOff x="0" y="0"/>
-          <a:chExt cx="0" cy="0"/>
-        </a:xfrm>
-      </p:grpSpPr>
-      <p:pic>
-        <p:nvPicPr>
-          <p:cNvPr id="2" name="Image 0" descr="NBC sales tactic slide 23">    </p:cNvPr>
-          <p:cNvPicPr>
-            <a:picLocks noChangeAspect="1"/>
-          </p:cNvPicPr>
-          <p:nvPr/>
-        </p:nvPicPr>
-        <p:blipFill>
-          <a:blip r:embed="rId1"/>
-          <a:stretch>
-            <a:fillRect/>
-          </a:stretch>
-        </p:blipFill>
-        <p:spPr>
-          <a:xfrm>
-            <a:off x="0" y="0"/>
-            <a:ext cx="9144000" cy="5143500"/>
-          </a:xfrm>
-          <a:prstGeom prst="rect">
-            <a:avLst/>
-          </a:prstGeom>
-        </p:spPr>
-      </p:pic>
-      <p:pic>
-        <p:nvPicPr>
-          <p:cNvPr id="3" name="Image 1" descr="preencoded.png">
-            <a:hlinkClick r:id="rId3" tooltip="https://github.com/samquansah-algo/nbc-vct/blob/main/weekly-tactics/04-sales/OUTREACH_KIT.md"/>
-          </p:cNvPr>
-          <p:cNvPicPr>
-            <a:picLocks noChangeAspect="1"/>
-          </p:cNvPicPr>
-          <p:nvPr/>
-        </p:nvPicPr>
-        <p:blipFill>
-          <a:blip r:embed="rId2"/>
-          <a:stretch>
-            <a:fillRect/>
-          </a:stretch>
-        </p:blipFill>
-        <p:spPr>
-          <a:xfrm>
-            <a:off x="4660106" y="4824412"/>
-            <a:ext cx="495300" cy="109537"/>
-          </a:xfrm>
-          <a:prstGeom prst="rect">
-            <a:avLst/>
-          </a:prstGeom>
-        </p:spPr>
-      </p:pic>
-      <p:pic>
-        <p:nvPicPr>
-          <p:cNvPr id="4" name="Image 2" descr="preencoded.png">
-            <a:hlinkClick r:id="rId5" tooltip="https://github.com/samquansah-algo/nbc-vct/blob/main/brand/NBC_Brand_Guide.pdf"/>
-          </p:cNvPr>
-          <p:cNvPicPr>
-            <a:picLocks noChangeAspect="1"/>
-          </p:cNvPicPr>
-          <p:nvPr/>
-        </p:nvPicPr>
-        <p:blipFill>
-          <a:blip r:embed="rId4"/>
-          <a:stretch>
-            <a:fillRect/>
-          </a:stretch>
-        </p:blipFill>
-        <p:spPr>
-          <a:xfrm>
-            <a:off x="5217319" y="4824412"/>
-            <a:ext cx="642938" cy="109537"/>
-          </a:xfrm>
-          <a:prstGeom prst="rect">
-            <a:avLst/>
-          </a:prstGeom>
-        </p:spPr>
-      </p:pic>
-    </p:spTree>
-  </p:cSld>
-  <p:clrMapOvr>
-    <a:masterClrMapping/>
-  </p:clrMapOvr>
-</p:sld>
-</file>
-
-<file path=ppt/slides/slide24.xml><?xml version="1.0" encoding="utf-8"?>
-<p:sld xmlns:a="http://schemas.openxmlformats.org/drawingml/2006/main" xmlns:r="http://schemas.openxmlformats.org/officeDocument/2006/relationships" xmlns:p="http://schemas.openxmlformats.org/presentationml/2006/main">
-  <p:cSld name="Slide 24">
-    <p:spTree>
-      <p:nvGrpSpPr>
-        <p:cNvPr id="1" name=""/>
-        <p:cNvGrpSpPr/>
-        <p:nvPr/>
-      </p:nvGrpSpPr>
-      <p:grpSpPr>
-        <a:xfrm>
-          <a:off x="0" y="0"/>
-          <a:ext cx="0" cy="0"/>
-          <a:chOff x="0" y="0"/>
-          <a:chExt cx="0" cy="0"/>
-        </a:xfrm>
-      </p:grpSpPr>
-      <p:pic>
-        <p:nvPicPr>
-          <p:cNvPr id="2" name="Image 0" descr="NBC sales tactic slide 24">    </p:cNvPr>
-          <p:cNvPicPr>
-            <a:picLocks noChangeAspect="1"/>
-          </p:cNvPicPr>
-          <p:nvPr/>
-        </p:nvPicPr>
-        <p:blipFill>
-          <a:blip r:embed="rId1"/>
-          <a:stretch>
-            <a:fillRect/>
-          </a:stretch>
-        </p:blipFill>
-        <p:spPr>
-          <a:xfrm>
-            <a:off x="0" y="0"/>
-            <a:ext cx="9144000" cy="5143500"/>
-          </a:xfrm>
-          <a:prstGeom prst="rect">
-            <a:avLst/>
-          </a:prstGeom>
-        </p:spPr>
-      </p:pic>
-      <p:pic>
-        <p:nvPicPr>
-          <p:cNvPr id="3" name="Image 1" descr="preencoded.png">
-            <a:hlinkClick r:id="rId3" tooltip="https://github.com/samquansah-algo/nbc-vct/blob/main/marketing/crm/README.md"/>
-          </p:cNvPr>
-          <p:cNvPicPr>
-            <a:picLocks noChangeAspect="1"/>
-          </p:cNvPicPr>
-          <p:nvPr/>
-        </p:nvPicPr>
-        <p:blipFill>
-          <a:blip r:embed="rId2"/>
-          <a:stretch>
-            <a:fillRect/>
-          </a:stretch>
-        </p:blipFill>
-        <p:spPr>
-          <a:xfrm>
-            <a:off x="4817269" y="4824412"/>
-            <a:ext cx="180975" cy="109537"/>
-          </a:xfrm>
-          <a:prstGeom prst="rect">
-            <a:avLst/>
-          </a:prstGeom>
-        </p:spPr>
-      </p:pic>
-      <p:pic>
-        <p:nvPicPr>
-          <p:cNvPr id="4" name="Image 2" descr="preencoded.png">
-            <a:hlinkClick r:id="rId5" tooltip="https://github.com/samquansah-algo/nbc-vct/blob/main/brand/NBC_Brand_Guide.pdf"/>
-          </p:cNvPr>
-          <p:cNvPicPr>
-            <a:picLocks noChangeAspect="1"/>
-          </p:cNvPicPr>
-          <p:nvPr/>
-        </p:nvPicPr>
-        <p:blipFill>
-          <a:blip r:embed="rId4"/>
-          <a:stretch>
-            <a:fillRect/>
-          </a:stretch>
-        </p:blipFill>
-        <p:spPr>
-          <a:xfrm>
-            <a:off x="5060156" y="4824412"/>
-            <a:ext cx="642938" cy="109537"/>
-          </a:xfrm>
-          <a:prstGeom prst="rect">
-            <a:avLst/>
-          </a:prstGeom>
-        </p:spPr>
-      </p:pic>
-    </p:spTree>
-  </p:cSld>
-  <p:clrMapOvr>
-    <a:masterClrMapping/>
-  </p:clrMapOvr>
-</p:sld>
-</file>
-
-<file path=ppt/slides/slide25.xml><?xml version="1.0" encoding="utf-8"?>
-<p:sld xmlns:a="http://schemas.openxmlformats.org/drawingml/2006/main" xmlns:r="http://schemas.openxmlformats.org/officeDocument/2006/relationships" xmlns:p="http://schemas.openxmlformats.org/presentationml/2006/main">
-  <p:cSld name="Slide 25">
-    <p:spTree>
-      <p:nvGrpSpPr>
-        <p:cNvPr id="1" name=""/>
-        <p:cNvGrpSpPr/>
-        <p:nvPr/>
-      </p:nvGrpSpPr>
-      <p:grpSpPr>
-        <a:xfrm>
-          <a:off x="0" y="0"/>
-          <a:ext cx="0" cy="0"/>
-          <a:chOff x="0" y="0"/>
-          <a:chExt cx="0" cy="0"/>
-        </a:xfrm>
-      </p:grpSpPr>
-      <p:pic>
-        <p:nvPicPr>
-          <p:cNvPr id="2" name="Image 0" descr="NBC sales tactic slide 25">    </p:cNvPr>
-          <p:cNvPicPr>
-            <a:picLocks noChangeAspect="1"/>
-          </p:cNvPicPr>
-          <p:nvPr/>
-        </p:nvPicPr>
-        <p:blipFill>
-          <a:blip r:embed="rId1"/>
-          <a:stretch>
-            <a:fillRect/>
-          </a:stretch>
-        </p:blipFill>
-        <p:spPr>
-          <a:xfrm>
-            <a:off x="0" y="0"/>
-            <a:ext cx="9144000" cy="5143500"/>
-          </a:xfrm>
-          <a:prstGeom prst="rect">
-            <a:avLst/>
-          </a:prstGeom>
-        </p:spPr>
-      </p:pic>
-      <p:pic>
-        <p:nvPicPr>
-          <p:cNvPr id="3" name="Image 1" descr="preencoded.png">
-            <a:hlinkClick r:id="rId3" tooltip="https://github.com/samquansah-algo/nbc-vct/blob/main/marketing/crm/README.md"/>
-          </p:cNvPr>
-          <p:cNvPicPr>
-            <a:picLocks noChangeAspect="1"/>
-          </p:cNvPicPr>
-          <p:nvPr/>
-        </p:nvPicPr>
-        <p:blipFill>
-          <a:blip r:embed="rId2"/>
-          <a:stretch>
-            <a:fillRect/>
-          </a:stretch>
-        </p:blipFill>
-        <p:spPr>
-          <a:xfrm>
-            <a:off x="4817269" y="4824412"/>
-            <a:ext cx="180975" cy="109537"/>
-          </a:xfrm>
-          <a:prstGeom prst="rect">
-            <a:avLst/>
-          </a:prstGeom>
-        </p:spPr>
-      </p:pic>
-      <p:pic>
-        <p:nvPicPr>
-          <p:cNvPr id="4" name="Image 2" descr="preencoded.png">
-            <a:hlinkClick r:id="rId5" tooltip="https://github.com/samquansah-algo/nbc-vct/blob/main/brand/NBC_Brand_Guide.pdf"/>
-          </p:cNvPr>
-          <p:cNvPicPr>
-            <a:picLocks noChangeAspect="1"/>
-          </p:cNvPicPr>
-          <p:nvPr/>
-        </p:nvPicPr>
-        <p:blipFill>
-          <a:blip r:embed="rId4"/>
-          <a:stretch>
-            <a:fillRect/>
-          </a:stretch>
-        </p:blipFill>
-        <p:spPr>
-          <a:xfrm>
-            <a:off x="5060156" y="4824412"/>
-            <a:ext cx="642938" cy="109537"/>
-          </a:xfrm>
-          <a:prstGeom prst="rect">
-            <a:avLst/>
-          </a:prstGeom>
-        </p:spPr>
-      </p:pic>
-    </p:spTree>
-  </p:cSld>
-  <p:clrMapOvr>
-    <a:masterClrMapping/>
-  </p:clrMapOvr>
-</p:sld>
-</file>
-
-<file path=ppt/slides/slide26.xml><?xml version="1.0" encoding="utf-8"?>
-<p:sld xmlns:a="http://schemas.openxmlformats.org/drawingml/2006/main" xmlns:r="http://schemas.openxmlformats.org/officeDocument/2006/relationships" xmlns:p="http://schemas.openxmlformats.org/presentationml/2006/main">
-  <p:cSld name="Slide 26">
-    <p:spTree>
-      <p:nvGrpSpPr>
-        <p:cNvPr id="1" name=""/>
-        <p:cNvGrpSpPr/>
-        <p:nvPr/>
-      </p:nvGrpSpPr>
-      <p:grpSpPr>
-        <a:xfrm>
-          <a:off x="0" y="0"/>
-          <a:ext cx="0" cy="0"/>
-          <a:chOff x="0" y="0"/>
-          <a:chExt cx="0" cy="0"/>
-        </a:xfrm>
-      </p:grpSpPr>
-      <p:pic>
-        <p:nvPicPr>
-          <p:cNvPr id="2" name="Image 0" descr="NBC sales tactic slide 26">    </p:cNvPr>
-          <p:cNvPicPr>
-            <a:picLocks noChangeAspect="1"/>
-          </p:cNvPicPr>
-          <p:nvPr/>
-        </p:nvPicPr>
-        <p:blipFill>
-          <a:blip r:embed="rId1"/>
-          <a:stretch>
-            <a:fillRect/>
-          </a:stretch>
-        </p:blipFill>
-        <p:spPr>
-          <a:xfrm>
-            <a:off x="0" y="0"/>
-            <a:ext cx="9144000" cy="5143500"/>
-          </a:xfrm>
-          <a:prstGeom prst="rect">
-            <a:avLst/>
-          </a:prstGeom>
-        </p:spPr>
-      </p:pic>
-      <p:pic>
-        <p:nvPicPr>
-          <p:cNvPr id="3" name="Image 1" descr="preencoded.png">
-            <a:hlinkClick r:id="rId3" tooltip="https://github.com/samquansah-algo/nbc-vct/blob/main/brand/NBC_Brand_Guide.pdf"/>
-          </p:cNvPr>
-          <p:cNvPicPr>
-            <a:picLocks noChangeAspect="1"/>
-          </p:cNvPicPr>
-          <p:nvPr/>
-        </p:nvPicPr>
-        <p:blipFill>
-          <a:blip r:embed="rId2"/>
-          <a:stretch>
-            <a:fillRect/>
-          </a:stretch>
-        </p:blipFill>
-        <p:spPr>
-          <a:xfrm>
-            <a:off x="4938712" y="4824412"/>
-            <a:ext cx="642938" cy="109537"/>
-          </a:xfrm>
-          <a:prstGeom prst="rect">
-            <a:avLst/>
-          </a:prstGeom>
-        </p:spPr>
-      </p:pic>
-    </p:spTree>
-  </p:cSld>
-  <p:clrMapOvr>
-    <a:masterClrMapping/>
-  </p:clrMapOvr>
-</p:sld>
-</file>
-
-<file path=ppt/slides/slide27.xml><?xml version="1.0" encoding="utf-8"?>
-<p:sld xmlns:a="http://schemas.openxmlformats.org/drawingml/2006/main" xmlns:r="http://schemas.openxmlformats.org/officeDocument/2006/relationships" xmlns:p="http://schemas.openxmlformats.org/presentationml/2006/main">
-  <p:cSld name="Slide 27">
-    <p:spTree>
-      <p:nvGrpSpPr>
-        <p:cNvPr id="1" name=""/>
-        <p:cNvGrpSpPr/>
-        <p:nvPr/>
-      </p:nvGrpSpPr>
-      <p:grpSpPr>
-        <a:xfrm>
-          <a:off x="0" y="0"/>
-          <a:ext cx="0" cy="0"/>
-          <a:chOff x="0" y="0"/>
-          <a:chExt cx="0" cy="0"/>
-        </a:xfrm>
-      </p:grpSpPr>
-      <p:pic>
-        <p:nvPicPr>
-          <p:cNvPr id="2" name="Image 0" descr="NBC sales tactic slide 27">    </p:cNvPr>
-          <p:cNvPicPr>
-            <a:picLocks noChangeAspect="1"/>
-          </p:cNvPicPr>
-          <p:nvPr/>
-        </p:nvPicPr>
-        <p:blipFill>
-          <a:blip r:embed="rId1"/>
-          <a:stretch>
-            <a:fillRect/>
-          </a:stretch>
-        </p:blipFill>
-        <p:spPr>
-          <a:xfrm>
-            <a:off x="0" y="0"/>
-            <a:ext cx="9144000" cy="5143500"/>
-          </a:xfrm>
-          <a:prstGeom prst="rect">
-            <a:avLst/>
-          </a:prstGeom>
-        </p:spPr>
-      </p:pic>
-      <p:pic>
-        <p:nvPicPr>
-          <p:cNvPr id="3" name="Image 1" descr="preencoded.png">
-            <a:hlinkClick r:id="rId3" tooltip="https://github.com/samquansah-algo/nbc-vct/blob/main/weekly-tactics/04-sales/OUTREACH_KIT.md"/>
-          </p:cNvPr>
-          <p:cNvPicPr>
-            <a:picLocks noChangeAspect="1"/>
-          </p:cNvPicPr>
-          <p:nvPr/>
-        </p:nvPicPr>
-        <p:blipFill>
-          <a:blip r:embed="rId2"/>
-          <a:stretch>
-            <a:fillRect/>
-          </a:stretch>
-        </p:blipFill>
-        <p:spPr>
-          <a:xfrm>
-            <a:off x="4660106" y="4824412"/>
-            <a:ext cx="495300" cy="109537"/>
-          </a:xfrm>
-          <a:prstGeom prst="rect">
-            <a:avLst/>
-          </a:prstGeom>
-        </p:spPr>
-      </p:pic>
-      <p:pic>
-        <p:nvPicPr>
-          <p:cNvPr id="4" name="Image 2" descr="preencoded.png">
-            <a:hlinkClick r:id="rId5" tooltip="https://github.com/samquansah-algo/nbc-vct/blob/main/brand/NBC_Brand_Guide.pdf"/>
-          </p:cNvPr>
-          <p:cNvPicPr>
-            <a:picLocks noChangeAspect="1"/>
-          </p:cNvPicPr>
-          <p:nvPr/>
-        </p:nvPicPr>
-        <p:blipFill>
-          <a:blip r:embed="rId4"/>
-          <a:stretch>
-            <a:fillRect/>
-          </a:stretch>
-        </p:blipFill>
-        <p:spPr>
-          <a:xfrm>
-            <a:off x="5217319" y="4824412"/>
-            <a:ext cx="642938" cy="109537"/>
-          </a:xfrm>
-          <a:prstGeom prst="rect">
-            <a:avLst/>
-          </a:prstGeom>
-        </p:spPr>
-      </p:pic>
-    </p:spTree>
-  </p:cSld>
-  <p:clrMapOvr>
-    <a:masterClrMapping/>
-  </p:clrMapOvr>
-</p:sld>
-</file>
-
-<file path=ppt/slides/slide28.xml><?xml version="1.0" encoding="utf-8"?>
-<p:sld xmlns:a="http://schemas.openxmlformats.org/drawingml/2006/main" xmlns:r="http://schemas.openxmlformats.org/officeDocument/2006/relationships" xmlns:p="http://schemas.openxmlformats.org/presentationml/2006/main">
-  <p:cSld name="Slide 28">
-    <p:spTree>
-      <p:nvGrpSpPr>
-        <p:cNvPr id="1" name=""/>
-        <p:cNvGrpSpPr/>
-        <p:nvPr/>
-      </p:nvGrpSpPr>
-      <p:grpSpPr>
-        <a:xfrm>
-          <a:off x="0" y="0"/>
-          <a:ext cx="0" cy="0"/>
-          <a:chOff x="0" y="0"/>
-          <a:chExt cx="0" cy="0"/>
-        </a:xfrm>
-      </p:grpSpPr>
-      <p:pic>
-        <p:nvPicPr>
-          <p:cNvPr id="2" name="Image 0" descr="NBC sales tactic slide 28">    </p:cNvPr>
-          <p:cNvPicPr>
-            <a:picLocks noChangeAspect="1"/>
-          </p:cNvPicPr>
-          <p:nvPr/>
-        </p:nvPicPr>
-        <p:blipFill>
-          <a:blip r:embed="rId1"/>
-          <a:stretch>
-            <a:fillRect/>
-          </a:stretch>
-        </p:blipFill>
-        <p:spPr>
-          <a:xfrm>
-            <a:off x="0" y="0"/>
-            <a:ext cx="9144000" cy="5143500"/>
-          </a:xfrm>
-          <a:prstGeom prst="rect">
-            <a:avLst/>
-          </a:prstGeom>
-        </p:spPr>
-      </p:pic>
-      <p:pic>
-        <p:nvPicPr>
-          <p:cNvPr id="3" name="Image 1" descr="preencoded.png">
-            <a:hlinkClick r:id="rId3" tooltip="https://github.com/samquansah-algo/nbc-vct/blob/main/tactics-milestones/MILESTONES.md"/>
-          </p:cNvPr>
-          <p:cNvPicPr>
-            <a:picLocks noChangeAspect="1"/>
-          </p:cNvPicPr>
-          <p:nvPr/>
-        </p:nvPicPr>
-        <p:blipFill>
-          <a:blip r:embed="rId2"/>
-          <a:stretch>
-            <a:fillRect/>
-          </a:stretch>
-        </p:blipFill>
-        <p:spPr>
-          <a:xfrm>
-            <a:off x="4683919" y="4824412"/>
-            <a:ext cx="447675" cy="109537"/>
-          </a:xfrm>
-          <a:prstGeom prst="rect">
-            <a:avLst/>
-          </a:prstGeom>
-        </p:spPr>
-      </p:pic>
-      <p:pic>
-        <p:nvPicPr>
-          <p:cNvPr id="4" name="Image 2" descr="preencoded.png">
-            <a:hlinkClick r:id="rId5" tooltip="https://github.com/samquansah-algo/nbc-vct/blob/main/brand/NBC_Brand_Guide.pdf"/>
-          </p:cNvPr>
-          <p:cNvPicPr>
-            <a:picLocks noChangeAspect="1"/>
-          </p:cNvPicPr>
-          <p:nvPr/>
-        </p:nvPicPr>
-        <p:blipFill>
-          <a:blip r:embed="rId4"/>
-          <a:stretch>
-            <a:fillRect/>
-          </a:stretch>
-        </p:blipFill>
-        <p:spPr>
-          <a:xfrm>
-            <a:off x="5193506" y="4824412"/>
-            <a:ext cx="642938" cy="109537"/>
-          </a:xfrm>
-          <a:prstGeom prst="rect">
-            <a:avLst/>
-          </a:prstGeom>
-        </p:spPr>
-      </p:pic>
-    </p:spTree>
-  </p:cSld>
-  <p:clrMapOvr>
-    <a:masterClrMapping/>
-  </p:clrMapOvr>
-</p:sld>
-</file>
-
-<file path=ppt/slides/slide29.xml><?xml version="1.0" encoding="utf-8"?>
-<p:sld xmlns:a="http://schemas.openxmlformats.org/drawingml/2006/main" xmlns:r="http://schemas.openxmlformats.org/officeDocument/2006/relationships" xmlns:p="http://schemas.openxmlformats.org/presentationml/2006/main">
-  <p:cSld name="Slide 29">
-    <p:spTree>
-      <p:nvGrpSpPr>
-        <p:cNvPr id="1" name=""/>
-        <p:cNvGrpSpPr/>
-        <p:nvPr/>
-      </p:nvGrpSpPr>
-      <p:grpSpPr>
-        <a:xfrm>
-          <a:off x="0" y="0"/>
-          <a:ext cx="0" cy="0"/>
-          <a:chOff x="0" y="0"/>
-          <a:chExt cx="0" cy="0"/>
-        </a:xfrm>
-      </p:grpSpPr>
-      <p:pic>
-        <p:nvPicPr>
-          <p:cNvPr id="2" name="Image 0" descr="NBC sales tactic slide 29">    </p:cNvPr>
-          <p:cNvPicPr>
-            <a:picLocks noChangeAspect="1"/>
-          </p:cNvPicPr>
-          <p:nvPr/>
-        </p:nvPicPr>
-        <p:blipFill>
-          <a:blip r:embed="rId1"/>
-          <a:stretch>
-            <a:fillRect/>
-          </a:stretch>
-        </p:blipFill>
-        <p:spPr>
-          <a:xfrm>
-            <a:off x="0" y="0"/>
-            <a:ext cx="9144000" cy="5143500"/>
-          </a:xfrm>
-          <a:prstGeom prst="rect">
-            <a:avLst/>
-          </a:prstGeom>
-        </p:spPr>
-      </p:pic>
-      <p:pic>
-        <p:nvPicPr>
-          <p:cNvPr id="3" name="Image 1" descr="preencoded.png">
-            <a:hlinkClick r:id="rId3" tooltip="https://github.com/samquansah-algo/nbc-vct/blob/main/brand/NBC_Brand_Guide.pdf"/>
-          </p:cNvPr>
-          <p:cNvPicPr>
-            <a:picLocks noChangeAspect="1"/>
-          </p:cNvPicPr>
-          <p:nvPr/>
-        </p:nvPicPr>
-        <p:blipFill>
-          <a:blip r:embed="rId2"/>
-          <a:stretch>
-            <a:fillRect/>
-          </a:stretch>
-        </p:blipFill>
-        <p:spPr>
-          <a:xfrm>
-            <a:off x="4938712" y="4824412"/>
+            <a:off x="5293519" y="4824412"/>
             <a:ext cx="642938" cy="109537"/>
           </a:xfrm>
           <a:prstGeom prst="rect">
@@ -5913,7 +3657,7 @@
       <p:pic>
         <p:nvPicPr>
           <p:cNvPr id="3" name="Image 1" descr="preencoded.png">
-            <a:hlinkClick r:id="rId3" tooltip="https://github.com/samquansah-algo/nbc-vct/blob/main/weekly-tactics/01-market-research/README.md"/>
+            <a:hlinkClick r:id="rId3" tooltip="https://github.com/samquansah-algo/nbc-vct/blob/main/weekly-tactics/04-sales/OUTREACH_KIT.md"/>
           </p:cNvPr>
           <p:cNvPicPr>
             <a:picLocks noChangeAspect="1"/>
@@ -5928,8 +3672,8 @@
         </p:blipFill>
         <p:spPr>
           <a:xfrm>
-            <a:off x="4593431" y="4824412"/>
-            <a:ext cx="676275" cy="109537"/>
+            <a:off x="4805363" y="4824412"/>
+            <a:ext cx="495300" cy="109537"/>
           </a:xfrm>
           <a:prstGeom prst="rect">
             <a:avLst/>
@@ -5954,490 +3698,8 @@
         </p:blipFill>
         <p:spPr>
           <a:xfrm>
-            <a:off x="5331619" y="4824412"/>
+            <a:off x="5362575" y="4824412"/>
             <a:ext cx="642938" cy="109537"/>
-          </a:xfrm>
-          <a:prstGeom prst="rect">
-            <a:avLst/>
-          </a:prstGeom>
-        </p:spPr>
-      </p:pic>
-    </p:spTree>
-  </p:cSld>
-  <p:clrMapOvr>
-    <a:masterClrMapping/>
-  </p:clrMapOvr>
-</p:sld>
-</file>
-
-<file path=ppt/slides/slide30.xml><?xml version="1.0" encoding="utf-8"?>
-<p:sld xmlns:a="http://schemas.openxmlformats.org/drawingml/2006/main" xmlns:r="http://schemas.openxmlformats.org/officeDocument/2006/relationships" xmlns:p="http://schemas.openxmlformats.org/presentationml/2006/main">
-  <p:cSld name="Slide 30">
-    <p:spTree>
-      <p:nvGrpSpPr>
-        <p:cNvPr id="1" name=""/>
-        <p:cNvGrpSpPr/>
-        <p:nvPr/>
-      </p:nvGrpSpPr>
-      <p:grpSpPr>
-        <a:xfrm>
-          <a:off x="0" y="0"/>
-          <a:ext cx="0" cy="0"/>
-          <a:chOff x="0" y="0"/>
-          <a:chExt cx="0" cy="0"/>
-        </a:xfrm>
-      </p:grpSpPr>
-      <p:pic>
-        <p:nvPicPr>
-          <p:cNvPr id="2" name="Image 0" descr="NBC sales tactic slide 30">    </p:cNvPr>
-          <p:cNvPicPr>
-            <a:picLocks noChangeAspect="1"/>
-          </p:cNvPicPr>
-          <p:nvPr/>
-        </p:nvPicPr>
-        <p:blipFill>
-          <a:blip r:embed="rId1"/>
-          <a:stretch>
-            <a:fillRect/>
-          </a:stretch>
-        </p:blipFill>
-        <p:spPr>
-          <a:xfrm>
-            <a:off x="0" y="0"/>
-            <a:ext cx="9144000" cy="5143500"/>
-          </a:xfrm>
-          <a:prstGeom prst="rect">
-            <a:avLst/>
-          </a:prstGeom>
-        </p:spPr>
-      </p:pic>
-      <p:pic>
-        <p:nvPicPr>
-          <p:cNvPr id="3" name="Image 1" descr="preencoded.png">
-            <a:hlinkClick r:id="rId3" tooltip="https://github.com/samquansah-algo/nbc-vct/blob/main/thesis/v6-capability-layer/THESIS.md"/>
-          </p:cNvPr>
-          <p:cNvPicPr>
-            <a:picLocks noChangeAspect="1"/>
-          </p:cNvPicPr>
-          <p:nvPr/>
-        </p:nvPicPr>
-        <p:blipFill>
-          <a:blip r:embed="rId2"/>
-          <a:stretch>
-            <a:fillRect/>
-          </a:stretch>
-        </p:blipFill>
-        <p:spPr>
-          <a:xfrm>
-            <a:off x="4729163" y="4824412"/>
-            <a:ext cx="357188" cy="109537"/>
-          </a:xfrm>
-          <a:prstGeom prst="rect">
-            <a:avLst/>
-          </a:prstGeom>
-        </p:spPr>
-      </p:pic>
-      <p:pic>
-        <p:nvPicPr>
-          <p:cNvPr id="4" name="Image 2" descr="preencoded.png">
-            <a:hlinkClick r:id="rId5" tooltip="https://github.com/samquansah-algo/nbc-vct/blob/main/brand/NBC_Brand_Guide.pdf"/>
-          </p:cNvPr>
-          <p:cNvPicPr>
-            <a:picLocks noChangeAspect="1"/>
-          </p:cNvPicPr>
-          <p:nvPr/>
-        </p:nvPicPr>
-        <p:blipFill>
-          <a:blip r:embed="rId4"/>
-          <a:stretch>
-            <a:fillRect/>
-          </a:stretch>
-        </p:blipFill>
-        <p:spPr>
-          <a:xfrm>
-            <a:off x="5148263" y="4824412"/>
-            <a:ext cx="642938" cy="109537"/>
-          </a:xfrm>
-          <a:prstGeom prst="rect">
-            <a:avLst/>
-          </a:prstGeom>
-        </p:spPr>
-      </p:pic>
-    </p:spTree>
-  </p:cSld>
-  <p:clrMapOvr>
-    <a:masterClrMapping/>
-  </p:clrMapOvr>
-</p:sld>
-</file>
-
-<file path=ppt/slides/slide31.xml><?xml version="1.0" encoding="utf-8"?>
-<p:sld xmlns:a="http://schemas.openxmlformats.org/drawingml/2006/main" xmlns:r="http://schemas.openxmlformats.org/officeDocument/2006/relationships" xmlns:p="http://schemas.openxmlformats.org/presentationml/2006/main">
-  <p:cSld name="Slide 31">
-    <p:spTree>
-      <p:nvGrpSpPr>
-        <p:cNvPr id="1" name=""/>
-        <p:cNvGrpSpPr/>
-        <p:nvPr/>
-      </p:nvGrpSpPr>
-      <p:grpSpPr>
-        <a:xfrm>
-          <a:off x="0" y="0"/>
-          <a:ext cx="0" cy="0"/>
-          <a:chOff x="0" y="0"/>
-          <a:chExt cx="0" cy="0"/>
-        </a:xfrm>
-      </p:grpSpPr>
-      <p:pic>
-        <p:nvPicPr>
-          <p:cNvPr id="2" name="Image 0" descr="NBC sales tactic slide 31">    </p:cNvPr>
-          <p:cNvPicPr>
-            <a:picLocks noChangeAspect="1"/>
-          </p:cNvPicPr>
-          <p:nvPr/>
-        </p:nvPicPr>
-        <p:blipFill>
-          <a:blip r:embed="rId1"/>
-          <a:stretch>
-            <a:fillRect/>
-          </a:stretch>
-        </p:blipFill>
-        <p:spPr>
-          <a:xfrm>
-            <a:off x="0" y="0"/>
-            <a:ext cx="9144000" cy="5143500"/>
-          </a:xfrm>
-          <a:prstGeom prst="rect">
-            <a:avLst/>
-          </a:prstGeom>
-        </p:spPr>
-      </p:pic>
-      <p:pic>
-        <p:nvPicPr>
-          <p:cNvPr id="3" name="Image 1" descr="preencoded.png">
-            <a:hlinkClick r:id="rId3" tooltip="https://github.com/samquansah-algo/nbc-vct/blob/main/thesis/v6-capability-layer/THESIS.md"/>
-          </p:cNvPr>
-          <p:cNvPicPr>
-            <a:picLocks noChangeAspect="1"/>
-          </p:cNvPicPr>
-          <p:nvPr/>
-        </p:nvPicPr>
-        <p:blipFill>
-          <a:blip r:embed="rId2"/>
-          <a:stretch>
-            <a:fillRect/>
-          </a:stretch>
-        </p:blipFill>
-        <p:spPr>
-          <a:xfrm>
-            <a:off x="4729163" y="4824412"/>
-            <a:ext cx="357188" cy="109537"/>
-          </a:xfrm>
-          <a:prstGeom prst="rect">
-            <a:avLst/>
-          </a:prstGeom>
-        </p:spPr>
-      </p:pic>
-      <p:pic>
-        <p:nvPicPr>
-          <p:cNvPr id="4" name="Image 2" descr="preencoded.png">
-            <a:hlinkClick r:id="rId5" tooltip="https://github.com/samquansah-algo/nbc-vct/blob/main/brand/NBC_Brand_Guide.pdf"/>
-          </p:cNvPr>
-          <p:cNvPicPr>
-            <a:picLocks noChangeAspect="1"/>
-          </p:cNvPicPr>
-          <p:nvPr/>
-        </p:nvPicPr>
-        <p:blipFill>
-          <a:blip r:embed="rId4"/>
-          <a:stretch>
-            <a:fillRect/>
-          </a:stretch>
-        </p:blipFill>
-        <p:spPr>
-          <a:xfrm>
-            <a:off x="5148263" y="4824412"/>
-            <a:ext cx="642938" cy="109537"/>
-          </a:xfrm>
-          <a:prstGeom prst="rect">
-            <a:avLst/>
-          </a:prstGeom>
-        </p:spPr>
-      </p:pic>
-    </p:spTree>
-  </p:cSld>
-  <p:clrMapOvr>
-    <a:masterClrMapping/>
-  </p:clrMapOvr>
-</p:sld>
-</file>
-
-<file path=ppt/slides/slide32.xml><?xml version="1.0" encoding="utf-8"?>
-<p:sld xmlns:a="http://schemas.openxmlformats.org/drawingml/2006/main" xmlns:r="http://schemas.openxmlformats.org/officeDocument/2006/relationships" xmlns:p="http://schemas.openxmlformats.org/presentationml/2006/main">
-  <p:cSld name="Slide 32">
-    <p:spTree>
-      <p:nvGrpSpPr>
-        <p:cNvPr id="1" name=""/>
-        <p:cNvGrpSpPr/>
-        <p:nvPr/>
-      </p:nvGrpSpPr>
-      <p:grpSpPr>
-        <a:xfrm>
-          <a:off x="0" y="0"/>
-          <a:ext cx="0" cy="0"/>
-          <a:chOff x="0" y="0"/>
-          <a:chExt cx="0" cy="0"/>
-        </a:xfrm>
-      </p:grpSpPr>
-      <p:pic>
-        <p:nvPicPr>
-          <p:cNvPr id="2" name="Image 0" descr="NBC sales tactic slide 32">    </p:cNvPr>
-          <p:cNvPicPr>
-            <a:picLocks noChangeAspect="1"/>
-          </p:cNvPicPr>
-          <p:nvPr/>
-        </p:nvPicPr>
-        <p:blipFill>
-          <a:blip r:embed="rId1"/>
-          <a:stretch>
-            <a:fillRect/>
-          </a:stretch>
-        </p:blipFill>
-        <p:spPr>
-          <a:xfrm>
-            <a:off x="0" y="0"/>
-            <a:ext cx="9144000" cy="5143500"/>
-          </a:xfrm>
-          <a:prstGeom prst="rect">
-            <a:avLst/>
-          </a:prstGeom>
-        </p:spPr>
-      </p:pic>
-      <p:pic>
-        <p:nvPicPr>
-          <p:cNvPr id="3" name="Image 1" descr="preencoded.png">
-            <a:hlinkClick r:id="rId3" tooltip="https://github.com/samquansah-algo/nbc-vct/blob/main/thesis/v6-capability-layer/THESIS.md"/>
-          </p:cNvPr>
-          <p:cNvPicPr>
-            <a:picLocks noChangeAspect="1"/>
-          </p:cNvPicPr>
-          <p:nvPr/>
-        </p:nvPicPr>
-        <p:blipFill>
-          <a:blip r:embed="rId2"/>
-          <a:stretch>
-            <a:fillRect/>
-          </a:stretch>
-        </p:blipFill>
-        <p:spPr>
-          <a:xfrm>
-            <a:off x="4729163" y="4824412"/>
-            <a:ext cx="357188" cy="109537"/>
-          </a:xfrm>
-          <a:prstGeom prst="rect">
-            <a:avLst/>
-          </a:prstGeom>
-        </p:spPr>
-      </p:pic>
-      <p:pic>
-        <p:nvPicPr>
-          <p:cNvPr id="4" name="Image 2" descr="preencoded.png">
-            <a:hlinkClick r:id="rId5" tooltip="https://github.com/samquansah-algo/nbc-vct/blob/main/brand/NBC_Brand_Guide.pdf"/>
-          </p:cNvPr>
-          <p:cNvPicPr>
-            <a:picLocks noChangeAspect="1"/>
-          </p:cNvPicPr>
-          <p:nvPr/>
-        </p:nvPicPr>
-        <p:blipFill>
-          <a:blip r:embed="rId4"/>
-          <a:stretch>
-            <a:fillRect/>
-          </a:stretch>
-        </p:blipFill>
-        <p:spPr>
-          <a:xfrm>
-            <a:off x="5148263" y="4824412"/>
-            <a:ext cx="642938" cy="109537"/>
-          </a:xfrm>
-          <a:prstGeom prst="rect">
-            <a:avLst/>
-          </a:prstGeom>
-        </p:spPr>
-      </p:pic>
-    </p:spTree>
-  </p:cSld>
-  <p:clrMapOvr>
-    <a:masterClrMapping/>
-  </p:clrMapOvr>
-</p:sld>
-</file>
-
-<file path=ppt/slides/slide33.xml><?xml version="1.0" encoding="utf-8"?>
-<p:sld xmlns:a="http://schemas.openxmlformats.org/drawingml/2006/main" xmlns:r="http://schemas.openxmlformats.org/officeDocument/2006/relationships" xmlns:p="http://schemas.openxmlformats.org/presentationml/2006/main">
-  <p:cSld name="Slide 33">
-    <p:spTree>
-      <p:nvGrpSpPr>
-        <p:cNvPr id="1" name=""/>
-        <p:cNvGrpSpPr/>
-        <p:nvPr/>
-      </p:nvGrpSpPr>
-      <p:grpSpPr>
-        <a:xfrm>
-          <a:off x="0" y="0"/>
-          <a:ext cx="0" cy="0"/>
-          <a:chOff x="0" y="0"/>
-          <a:chExt cx="0" cy="0"/>
-        </a:xfrm>
-      </p:grpSpPr>
-      <p:pic>
-        <p:nvPicPr>
-          <p:cNvPr id="2" name="Image 0" descr="NBC sales tactic slide 33">    </p:cNvPr>
-          <p:cNvPicPr>
-            <a:picLocks noChangeAspect="1"/>
-          </p:cNvPicPr>
-          <p:nvPr/>
-        </p:nvPicPr>
-        <p:blipFill>
-          <a:blip r:embed="rId1"/>
-          <a:stretch>
-            <a:fillRect/>
-          </a:stretch>
-        </p:blipFill>
-        <p:spPr>
-          <a:xfrm>
-            <a:off x="0" y="0"/>
-            <a:ext cx="9144000" cy="5143500"/>
-          </a:xfrm>
-          <a:prstGeom prst="rect">
-            <a:avLst/>
-          </a:prstGeom>
-        </p:spPr>
-      </p:pic>
-      <p:pic>
-        <p:nvPicPr>
-          <p:cNvPr id="3" name="Image 1" descr="preencoded.png">
-            <a:hlinkClick r:id="rId3" tooltip="mailto:samquansah@gse.harvard.edu"/>
-          </p:cNvPr>
-          <p:cNvPicPr>
-            <a:picLocks noChangeAspect="1"/>
-          </p:cNvPicPr>
-          <p:nvPr/>
-        </p:nvPicPr>
-        <p:blipFill>
-          <a:blip r:embed="rId2"/>
-          <a:stretch>
-            <a:fillRect/>
-          </a:stretch>
-        </p:blipFill>
-        <p:spPr>
-          <a:xfrm>
-            <a:off x="457200" y="4181475"/>
-            <a:ext cx="1676400" cy="157163"/>
-          </a:xfrm>
-          <a:prstGeom prst="rect">
-            <a:avLst/>
-          </a:prstGeom>
-        </p:spPr>
-      </p:pic>
-      <p:pic>
-        <p:nvPicPr>
-          <p:cNvPr id="4" name="Image 2" descr="preencoded.png">
-            <a:hlinkClick r:id="rId5" tooltip="mailto:samquans@mit.edu"/>
-          </p:cNvPr>
-          <p:cNvPicPr>
-            <a:picLocks noChangeAspect="1"/>
-          </p:cNvPicPr>
-          <p:nvPr/>
-        </p:nvPicPr>
-        <p:blipFill>
-          <a:blip r:embed="rId4"/>
-          <a:stretch>
-            <a:fillRect/>
-          </a:stretch>
-        </p:blipFill>
-        <p:spPr>
-          <a:xfrm>
-            <a:off x="457200" y="4352925"/>
-            <a:ext cx="1076325" cy="157163"/>
-          </a:xfrm>
-          <a:prstGeom prst="rect">
-            <a:avLst/>
-          </a:prstGeom>
-        </p:spPr>
-      </p:pic>
-      <p:pic>
-        <p:nvPicPr>
-          <p:cNvPr id="5" name="Image 3" descr="preencoded.png">
-            <a:hlinkClick r:id="rId7" tooltip="https://github.com/samquansah-algo/nbc-vct/tree/main/weekly-tactics/04-sales/"/>
-          </p:cNvPr>
-          <p:cNvPicPr>
-            <a:picLocks noChangeAspect="1"/>
-          </p:cNvPicPr>
-          <p:nvPr/>
-        </p:nvPicPr>
-        <p:blipFill>
-          <a:blip r:embed="rId6"/>
-          <a:stretch>
-            <a:fillRect/>
-          </a:stretch>
-        </p:blipFill>
-        <p:spPr>
-          <a:xfrm>
-            <a:off x="3648075" y="3805237"/>
-            <a:ext cx="671513" cy="157163"/>
-          </a:xfrm>
-          <a:prstGeom prst="rect">
-            <a:avLst/>
-          </a:prstGeom>
-        </p:spPr>
-      </p:pic>
-      <p:pic>
-        <p:nvPicPr>
-          <p:cNvPr id="6" name="Image 4" descr="preencoded.png">
-            <a:hlinkClick r:id="rId9" tooltip="https://github.com/samquansah-algo/nbc-vct/blob/main/weekly-tactics/04-sales/lead_list_template.csv"/>
-          </p:cNvPr>
-          <p:cNvPicPr>
-            <a:picLocks noChangeAspect="1"/>
-          </p:cNvPicPr>
-          <p:nvPr/>
-        </p:nvPicPr>
-        <p:blipFill>
-          <a:blip r:embed="rId8"/>
-          <a:stretch>
-            <a:fillRect/>
-          </a:stretch>
-        </p:blipFill>
-        <p:spPr>
-          <a:xfrm>
-            <a:off x="3648075" y="3999533"/>
-            <a:ext cx="971550" cy="157163"/>
-          </a:xfrm>
-          <a:prstGeom prst="rect">
-            <a:avLst/>
-          </a:prstGeom>
-        </p:spPr>
-      </p:pic>
-      <p:pic>
-        <p:nvPicPr>
-          <p:cNvPr id="7" name="Image 5" descr="preencoded.png">
-            <a:hlinkClick r:id="rId11" tooltip="https://github.com/samquansah-algo/nbc-vct/blob/main/brand/NBC_Brand_Guide.pdf"/>
-          </p:cNvPr>
-          <p:cNvPicPr>
-            <a:picLocks noChangeAspect="1"/>
-          </p:cNvPicPr>
-          <p:nvPr/>
-        </p:nvPicPr>
-        <p:blipFill>
-          <a:blip r:embed="rId10"/>
-          <a:stretch>
-            <a:fillRect/>
-          </a:stretch>
-        </p:blipFill>
-        <p:spPr>
-          <a:xfrm>
-            <a:off x="3648075" y="4193828"/>
-            <a:ext cx="1185863" cy="157163"/>
           </a:xfrm>
           <a:prstGeom prst="rect">
             <a:avLst/>
@@ -6496,7 +3758,7 @@
       <p:pic>
         <p:nvPicPr>
           <p:cNvPr id="3" name="Image 1" descr="preencoded.png">
-            <a:hlinkClick r:id="rId3" tooltip="https://github.com/samquansah-algo/nbc-vct/blob/main/brand/NBC_Brand_Guide.pdf"/>
+            <a:hlinkClick r:id="rId3" tooltip="https://github.com/samquansah-algo/nbc-vct/blob/main/marketing/watering_holes_v5.md"/>
           </p:cNvPr>
           <p:cNvPicPr>
             <a:picLocks noChangeAspect="1"/>
@@ -6511,7 +3773,33 @@
         </p:blipFill>
         <p:spPr>
           <a:xfrm>
-            <a:off x="4962525" y="4824412"/>
+            <a:off x="4750594" y="4824412"/>
+            <a:ext cx="604837" cy="109537"/>
+          </a:xfrm>
+          <a:prstGeom prst="rect">
+            <a:avLst/>
+          </a:prstGeom>
+        </p:spPr>
+      </p:pic>
+      <p:pic>
+        <p:nvPicPr>
+          <p:cNvPr id="4" name="Image 2" descr="preencoded.png">
+            <a:hlinkClick r:id="rId5" tooltip="https://github.com/samquansah-algo/nbc-vct/blob/main/brand/NBC_Brand_Guide.pdf"/>
+          </p:cNvPr>
+          <p:cNvPicPr>
+            <a:picLocks noChangeAspect="1"/>
+          </p:cNvPicPr>
+          <p:nvPr/>
+        </p:nvPicPr>
+        <p:blipFill>
+          <a:blip r:embed="rId4"/>
+          <a:stretch>
+            <a:fillRect/>
+          </a:stretch>
+        </p:blipFill>
+        <p:spPr>
+          <a:xfrm>
+            <a:off x="5417344" y="4824412"/>
             <a:ext cx="642938" cy="109537"/>
           </a:xfrm>
           <a:prstGeom prst="rect">
@@ -6571,7 +3859,7 @@
       <p:pic>
         <p:nvPicPr>
           <p:cNvPr id="3" name="Image 1" descr="preencoded.png">
-            <a:hlinkClick r:id="rId3" tooltip="https://github.com/samquansah-algo/nbc-vct/blob/main/tactics-milestones/MILESTONES.md"/>
+            <a:hlinkClick r:id="rId3" tooltip="https://github.com/samquansah-algo/nbc-vct/blob/main/weekly-tactics/03-persona-ads/README.md"/>
           </p:cNvPr>
           <p:cNvPicPr>
             <a:picLocks noChangeAspect="1"/>
@@ -6586,8 +3874,8 @@
         </p:blipFill>
         <p:spPr>
           <a:xfrm>
-            <a:off x="4707731" y="4824412"/>
-            <a:ext cx="447675" cy="109537"/>
+            <a:off x="4864894" y="4824412"/>
+            <a:ext cx="376238" cy="109537"/>
           </a:xfrm>
           <a:prstGeom prst="rect">
             <a:avLst/>
@@ -6612,7 +3900,7 @@
         </p:blipFill>
         <p:spPr>
           <a:xfrm>
-            <a:off x="5217319" y="4824412"/>
+            <a:off x="5303044" y="4824412"/>
             <a:ext cx="642938" cy="109537"/>
           </a:xfrm>
           <a:prstGeom prst="rect">
@@ -6672,7 +3960,7 @@
       <p:pic>
         <p:nvPicPr>
           <p:cNvPr id="3" name="Image 1" descr="preencoded.png">
-            <a:hlinkClick r:id="rId3" tooltip="https://github.com/samquansah-algo/nbc-vct/blob/main/thesis/v6-capability-layer/THESIS.md"/>
+            <a:hlinkClick r:id="rId3" tooltip="https://github.com/samquansah-algo/nbc-vct/blob/main/weekly-tactics/04-sales/lead_list_template.csv"/>
           </p:cNvPr>
           <p:cNvPicPr>
             <a:picLocks noChangeAspect="1"/>
@@ -6687,8 +3975,8 @@
         </p:blipFill>
         <p:spPr>
           <a:xfrm>
-            <a:off x="4752975" y="4824412"/>
-            <a:ext cx="357188" cy="109537"/>
+            <a:off x="3886200" y="3952875"/>
+            <a:ext cx="862012" cy="142875"/>
           </a:xfrm>
           <a:prstGeom prst="rect">
             <a:avLst/>
@@ -6698,7 +3986,7 @@
       <p:pic>
         <p:nvPicPr>
           <p:cNvPr id="4" name="Image 2" descr="preencoded.png">
-            <a:hlinkClick r:id="rId5" tooltip="https://github.com/samquansah-algo/nbc-vct/blob/main/brand/NBC_Brand_Guide.pdf"/>
+            <a:hlinkClick r:id="rId5" tooltip="https://github.com/samquansah-algo/nbc-vct/blob/main/weekly-tactics/04-sales/lead_list_template.csv"/>
           </p:cNvPr>
           <p:cNvPicPr>
             <a:picLocks noChangeAspect="1"/>
@@ -6713,7 +4001,33 @@
         </p:blipFill>
         <p:spPr>
           <a:xfrm>
-            <a:off x="5172075" y="4824412"/>
+            <a:off x="4700588" y="4824412"/>
+            <a:ext cx="704850" cy="109537"/>
+          </a:xfrm>
+          <a:prstGeom prst="rect">
+            <a:avLst/>
+          </a:prstGeom>
+        </p:spPr>
+      </p:pic>
+      <p:pic>
+        <p:nvPicPr>
+          <p:cNvPr id="5" name="Image 3" descr="preencoded.png">
+            <a:hlinkClick r:id="rId7" tooltip="https://github.com/samquansah-algo/nbc-vct/blob/main/brand/NBC_Brand_Guide.pdf"/>
+          </p:cNvPr>
+          <p:cNvPicPr>
+            <a:picLocks noChangeAspect="1"/>
+          </p:cNvPicPr>
+          <p:nvPr/>
+        </p:nvPicPr>
+        <p:blipFill>
+          <a:blip r:embed="rId6"/>
+          <a:stretch>
+            <a:fillRect/>
+          </a:stretch>
+        </p:blipFill>
+        <p:spPr>
+          <a:xfrm>
+            <a:off x="5467350" y="4824412"/>
             <a:ext cx="642938" cy="109537"/>
           </a:xfrm>
           <a:prstGeom prst="rect">
@@ -6773,7 +4087,7 @@
       <p:pic>
         <p:nvPicPr>
           <p:cNvPr id="3" name="Image 1" descr="preencoded.png">
-            <a:hlinkClick r:id="rId3" tooltip="https://github.com/samquansah-algo/nbc-vct/blob/main/marketing/crm/README.md"/>
+            <a:hlinkClick r:id="rId3" tooltip="https://github.com/samquansah-algo/nbc-vct/blob/main/weekly-tactics/04-sales/lead_list_template.csv"/>
           </p:cNvPr>
           <p:cNvPicPr>
             <a:picLocks noChangeAspect="1"/>
@@ -6788,8 +4102,8 @@
         </p:blipFill>
         <p:spPr>
           <a:xfrm>
-            <a:off x="4841081" y="4824412"/>
-            <a:ext cx="180975" cy="109537"/>
+            <a:off x="3886200" y="3952875"/>
+            <a:ext cx="862012" cy="142875"/>
           </a:xfrm>
           <a:prstGeom prst="rect">
             <a:avLst/>
@@ -6799,7 +4113,7 @@
       <p:pic>
         <p:nvPicPr>
           <p:cNvPr id="4" name="Image 2" descr="preencoded.png">
-            <a:hlinkClick r:id="rId5" tooltip="https://github.com/samquansah-algo/nbc-vct/blob/main/brand/NBC_Brand_Guide.pdf"/>
+            <a:hlinkClick r:id="rId5" tooltip="https://github.com/samquansah-algo/nbc-vct/blob/main/weekly-tactics/04-sales/lead_list_template.csv"/>
           </p:cNvPr>
           <p:cNvPicPr>
             <a:picLocks noChangeAspect="1"/>
@@ -6814,7 +4128,33 @@
         </p:blipFill>
         <p:spPr>
           <a:xfrm>
-            <a:off x="5083969" y="4824412"/>
+            <a:off x="4700588" y="4824412"/>
+            <a:ext cx="704850" cy="109537"/>
+          </a:xfrm>
+          <a:prstGeom prst="rect">
+            <a:avLst/>
+          </a:prstGeom>
+        </p:spPr>
+      </p:pic>
+      <p:pic>
+        <p:nvPicPr>
+          <p:cNvPr id="5" name="Image 3" descr="preencoded.png">
+            <a:hlinkClick r:id="rId7" tooltip="https://github.com/samquansah-algo/nbc-vct/blob/main/brand/NBC_Brand_Guide.pdf"/>
+          </p:cNvPr>
+          <p:cNvPicPr>
+            <a:picLocks noChangeAspect="1"/>
+          </p:cNvPicPr>
+          <p:nvPr/>
+        </p:nvPicPr>
+        <p:blipFill>
+          <a:blip r:embed="rId6"/>
+          <a:stretch>
+            <a:fillRect/>
+          </a:stretch>
+        </p:blipFill>
+        <p:spPr>
+          <a:xfrm>
+            <a:off x="5467350" y="4824412"/>
             <a:ext cx="642938" cy="109537"/>
           </a:xfrm>
           <a:prstGeom prst="rect">
@@ -6874,7 +4214,7 @@
       <p:pic>
         <p:nvPicPr>
           <p:cNvPr id="3" name="Image 1" descr="preencoded.png">
-            <a:hlinkClick r:id="rId3" tooltip="https://github.com/samquansah-algo/nbc-vct/blob/main/brand/NBC_Brand_Guide.pdf"/>
+            <a:hlinkClick r:id="rId3" tooltip="https://github.com/samquansah-algo/nbc-vct/blob/main/weekly-tactics/04-sales/lead_list_template.csv"/>
           </p:cNvPr>
           <p:cNvPicPr>
             <a:picLocks noChangeAspect="1"/>
@@ -6889,7 +4229,59 @@
         </p:blipFill>
         <p:spPr>
           <a:xfrm>
-            <a:off x="4962525" y="4824412"/>
+            <a:off x="3886200" y="3952875"/>
+            <a:ext cx="862012" cy="142875"/>
+          </a:xfrm>
+          <a:prstGeom prst="rect">
+            <a:avLst/>
+          </a:prstGeom>
+        </p:spPr>
+      </p:pic>
+      <p:pic>
+        <p:nvPicPr>
+          <p:cNvPr id="4" name="Image 2" descr="preencoded.png">
+            <a:hlinkClick r:id="rId5" tooltip="https://github.com/samquansah-algo/nbc-vct/blob/main/weekly-tactics/04-sales/lead_list_template.csv"/>
+          </p:cNvPr>
+          <p:cNvPicPr>
+            <a:picLocks noChangeAspect="1"/>
+          </p:cNvPicPr>
+          <p:nvPr/>
+        </p:nvPicPr>
+        <p:blipFill>
+          <a:blip r:embed="rId4"/>
+          <a:stretch>
+            <a:fillRect/>
+          </a:stretch>
+        </p:blipFill>
+        <p:spPr>
+          <a:xfrm>
+            <a:off x="4700588" y="4824412"/>
+            <a:ext cx="704850" cy="109537"/>
+          </a:xfrm>
+          <a:prstGeom prst="rect">
+            <a:avLst/>
+          </a:prstGeom>
+        </p:spPr>
+      </p:pic>
+      <p:pic>
+        <p:nvPicPr>
+          <p:cNvPr id="5" name="Image 3" descr="preencoded.png">
+            <a:hlinkClick r:id="rId7" tooltip="https://github.com/samquansah-algo/nbc-vct/blob/main/brand/NBC_Brand_Guide.pdf"/>
+          </p:cNvPr>
+          <p:cNvPicPr>
+            <a:picLocks noChangeAspect="1"/>
+          </p:cNvPicPr>
+          <p:nvPr/>
+        </p:nvPicPr>
+        <p:blipFill>
+          <a:blip r:embed="rId6"/>
+          <a:stretch>
+            <a:fillRect/>
+          </a:stretch>
+        </p:blipFill>
+        <p:spPr>
+          <a:xfrm>
+            <a:off x="5467350" y="4824412"/>
             <a:ext cx="642938" cy="109537"/>
           </a:xfrm>
           <a:prstGeom prst="rect">
@@ -6949,7 +4341,7 @@
       <p:pic>
         <p:nvPicPr>
           <p:cNvPr id="3" name="Image 1" descr="preencoded.png">
-            <a:hlinkClick r:id="rId3" tooltip="https://github.com/samquansah-algo/nbc-vct/blob/main/marketing/watering_holes_v5.md"/>
+            <a:hlinkClick r:id="rId3" tooltip="https://github.com/samquansah-algo/nbc-vct/blob/main/weekly-tactics/04-sales/OUTREACH_KIT.md"/>
           </p:cNvPr>
           <p:cNvPicPr>
             <a:picLocks noChangeAspect="1"/>
@@ -6964,8 +4356,8 @@
         </p:blipFill>
         <p:spPr>
           <a:xfrm>
-            <a:off x="4629150" y="4824412"/>
-            <a:ext cx="604837" cy="109537"/>
+            <a:off x="4805363" y="4824412"/>
+            <a:ext cx="495300" cy="109537"/>
           </a:xfrm>
           <a:prstGeom prst="rect">
             <a:avLst/>
@@ -6990,7 +4382,7 @@
         </p:blipFill>
         <p:spPr>
           <a:xfrm>
-            <a:off x="5295900" y="4824412"/>
+            <a:off x="5362575" y="4824412"/>
             <a:ext cx="642938" cy="109537"/>
           </a:xfrm>
           <a:prstGeom prst="rect">

</xml_diff>

<commit_message>
Tactic 4: add 158 checked leads, restore full deck, plain-language edit
Lead lists now show 54 program owners, 53 school leaders and 51 sponsors,
each checked in a web search or marked to confirm. Copy rewritten in
plain language.

Co-Authored-By: Claude Opus 5.5 <noreply@anthropic.com>
Claude-Session: https://claude.ai/code/session_014DwxjU8rHfrSVBV6irvX7Y
</commit_message>
<xml_diff>
--- a/weekly-tactics/04-sales/NBC_Sales_Tactic.pptx
+++ b/weekly-tactics/04-sales/NBC_Sales_Tactic.pptx
@@ -24,9 +24,26 @@
     <p:sldId id="272" r:id="rId18"/>
     <p:sldId id="273" r:id="rId19"/>
     <p:sldId id="274" r:id="rId20"/>
+    <p:sldId id="275" r:id="rId21"/>
+    <p:sldId id="276" r:id="rId22"/>
+    <p:sldId id="277" r:id="rId23"/>
+    <p:sldId id="278" r:id="rId24"/>
+    <p:sldId id="279" r:id="rId25"/>
+    <p:sldId id="280" r:id="rId26"/>
+    <p:sldId id="281" r:id="rId27"/>
+    <p:sldId id="282" r:id="rId28"/>
+    <p:sldId id="283" r:id="rId29"/>
+    <p:sldId id="284" r:id="rId30"/>
+    <p:sldId id="285" r:id="rId31"/>
+    <p:sldId id="286" r:id="rId32"/>
+    <p:sldId id="287" r:id="rId33"/>
+    <p:sldId id="288" r:id="rId34"/>
+    <p:sldId id="289" r:id="rId35"/>
+    <p:sldId id="290" r:id="rId36"/>
+    <p:sldId id="291" r:id="rId37"/>
   </p:sldIdLst>
   <p:notesMasterIdLst>
-    <p:notesMasterId r:id="rId21"/>
+    <p:notesMasterId r:id="rId38"/>
   </p:notesMasterIdLst>
   <p:sldSz cx="9144000" cy="5143500"/>
   <p:notesSz cx="5143500" cy="9144000"/>
@@ -1530,6 +1547,886 @@
 </p:notes>
 </file>
 
+<file path=ppt/notesSlides/notesSlide20.xml><?xml version="1.0" encoding="utf-8"?>
+<p:notes xmlns:a="http://schemas.openxmlformats.org/drawingml/2006/main" xmlns:r="http://schemas.openxmlformats.org/officeDocument/2006/relationships" xmlns:p="http://schemas.openxmlformats.org/presentationml/2006/main">
+  <p:cSld>
+    <p:spTree>
+      <p:nvGrpSpPr>
+        <p:cNvPr id="1" name=""/>
+        <p:cNvGrpSpPr/>
+        <p:nvPr/>
+      </p:nvGrpSpPr>
+      <p:grpSpPr>
+        <a:xfrm>
+          <a:off x="0" y="0"/>
+          <a:ext cx="0" cy="0"/>
+          <a:chOff x="0" y="0"/>
+          <a:chExt cx="0" cy="0"/>
+        </a:xfrm>
+      </p:grpSpPr>
+      <p:sp>
+        <p:nvSpPr>
+          <p:cNvPr id="2" name="Slide Image Placeholder 1"/>
+          <p:cNvSpPr>
+            <a:spLocks noGrp="1" noRot="1" noChangeAspect="1"/>
+          </p:cNvSpPr>
+          <p:nvPr>
+            <p:ph type="sldImg"/>
+          </p:nvPr>
+        </p:nvSpPr>
+        <p:spPr/>
+      </p:sp>
+      <p:sp>
+        <p:nvSpPr>
+          <p:cNvPr id="3" name="Notes Placeholder 2"/>
+          <p:cNvSpPr>
+            <a:spLocks noGrp="1"/>
+          </p:cNvSpPr>
+          <p:nvPr>
+            <p:ph type="body" idx="1"/>
+          </p:nvPr>
+        </p:nvSpPr>
+        <p:spPr/>
+        <p:txBody>
+          <a:bodyPr/>
+          <a:lstStyle/>
+          <a:p>
+            <a:r>
+              <a:rPr lang="en-US" dirty="0"/>
+              <a:t/>
+            </a:r>
+            <a:endParaRPr lang="en-US" dirty="0"/>
+          </a:p>
+        </p:txBody>
+      </p:sp>
+      <p:sp>
+        <p:nvSpPr>
+          <p:cNvPr id="4" name="Slide Number Placeholder 3"/>
+          <p:cNvSpPr>
+            <a:spLocks noGrp="1"/>
+          </p:cNvSpPr>
+          <p:nvPr>
+            <p:ph type="sldNum" sz="quarter" idx="10"/>
+          </p:nvPr>
+        </p:nvSpPr>
+        <p:spPr/>
+        <p:txBody>
+          <a:bodyPr/>
+          <a:lstStyle/>
+          <a:p>
+            <a:fld id="{F7021451-1387-4CA6-816F-3879F97B5CBC}" type="slidenum">
+              <a:rPr lang="en-US"/>
+              <a:t>20</a:t>
+            </a:fld>
+            <a:endParaRPr lang="en-US"/>
+          </a:p>
+        </p:txBody>
+      </p:sp>
+    </p:spTree>
+    <p:extLst>
+      <p:ext uri="{BB962C8B-B14F-4D97-AF65-F5344CB8AC3E}">
+        <p14:creationId xmlns:p14="http://schemas.microsoft.com/office/powerpoint/2010/main" val="1024086991"/>
+      </p:ext>
+    </p:extLst>
+  </p:cSld>
+  <p:clrMapOvr>
+    <a:masterClrMapping/>
+  </p:clrMapOvr>
+</p:notes>
+</file>
+
+<file path=ppt/notesSlides/notesSlide21.xml><?xml version="1.0" encoding="utf-8"?>
+<p:notes xmlns:a="http://schemas.openxmlformats.org/drawingml/2006/main" xmlns:r="http://schemas.openxmlformats.org/officeDocument/2006/relationships" xmlns:p="http://schemas.openxmlformats.org/presentationml/2006/main">
+  <p:cSld>
+    <p:spTree>
+      <p:nvGrpSpPr>
+        <p:cNvPr id="1" name=""/>
+        <p:cNvGrpSpPr/>
+        <p:nvPr/>
+      </p:nvGrpSpPr>
+      <p:grpSpPr>
+        <a:xfrm>
+          <a:off x="0" y="0"/>
+          <a:ext cx="0" cy="0"/>
+          <a:chOff x="0" y="0"/>
+          <a:chExt cx="0" cy="0"/>
+        </a:xfrm>
+      </p:grpSpPr>
+      <p:sp>
+        <p:nvSpPr>
+          <p:cNvPr id="2" name="Slide Image Placeholder 1"/>
+          <p:cNvSpPr>
+            <a:spLocks noGrp="1" noRot="1" noChangeAspect="1"/>
+          </p:cNvSpPr>
+          <p:nvPr>
+            <p:ph type="sldImg"/>
+          </p:nvPr>
+        </p:nvSpPr>
+        <p:spPr/>
+      </p:sp>
+      <p:sp>
+        <p:nvSpPr>
+          <p:cNvPr id="3" name="Notes Placeholder 2"/>
+          <p:cNvSpPr>
+            <a:spLocks noGrp="1"/>
+          </p:cNvSpPr>
+          <p:nvPr>
+            <p:ph type="body" idx="1"/>
+          </p:nvPr>
+        </p:nvSpPr>
+        <p:spPr/>
+        <p:txBody>
+          <a:bodyPr/>
+          <a:lstStyle/>
+          <a:p>
+            <a:r>
+              <a:rPr lang="en-US" dirty="0"/>
+              <a:t/>
+            </a:r>
+            <a:endParaRPr lang="en-US" dirty="0"/>
+          </a:p>
+        </p:txBody>
+      </p:sp>
+      <p:sp>
+        <p:nvSpPr>
+          <p:cNvPr id="4" name="Slide Number Placeholder 3"/>
+          <p:cNvSpPr>
+            <a:spLocks noGrp="1"/>
+          </p:cNvSpPr>
+          <p:nvPr>
+            <p:ph type="sldNum" sz="quarter" idx="10"/>
+          </p:nvPr>
+        </p:nvSpPr>
+        <p:spPr/>
+        <p:txBody>
+          <a:bodyPr/>
+          <a:lstStyle/>
+          <a:p>
+            <a:fld id="{F7021451-1387-4CA6-816F-3879F97B5CBC}" type="slidenum">
+              <a:rPr lang="en-US"/>
+              <a:t>21</a:t>
+            </a:fld>
+            <a:endParaRPr lang="en-US"/>
+          </a:p>
+        </p:txBody>
+      </p:sp>
+    </p:spTree>
+    <p:extLst>
+      <p:ext uri="{BB962C8B-B14F-4D97-AF65-F5344CB8AC3E}">
+        <p14:creationId xmlns:p14="http://schemas.microsoft.com/office/powerpoint/2010/main" val="1024086991"/>
+      </p:ext>
+    </p:extLst>
+  </p:cSld>
+  <p:clrMapOvr>
+    <a:masterClrMapping/>
+  </p:clrMapOvr>
+</p:notes>
+</file>
+
+<file path=ppt/notesSlides/notesSlide22.xml><?xml version="1.0" encoding="utf-8"?>
+<p:notes xmlns:a="http://schemas.openxmlformats.org/drawingml/2006/main" xmlns:r="http://schemas.openxmlformats.org/officeDocument/2006/relationships" xmlns:p="http://schemas.openxmlformats.org/presentationml/2006/main">
+  <p:cSld>
+    <p:spTree>
+      <p:nvGrpSpPr>
+        <p:cNvPr id="1" name=""/>
+        <p:cNvGrpSpPr/>
+        <p:nvPr/>
+      </p:nvGrpSpPr>
+      <p:grpSpPr>
+        <a:xfrm>
+          <a:off x="0" y="0"/>
+          <a:ext cx="0" cy="0"/>
+          <a:chOff x="0" y="0"/>
+          <a:chExt cx="0" cy="0"/>
+        </a:xfrm>
+      </p:grpSpPr>
+      <p:sp>
+        <p:nvSpPr>
+          <p:cNvPr id="2" name="Slide Image Placeholder 1"/>
+          <p:cNvSpPr>
+            <a:spLocks noGrp="1" noRot="1" noChangeAspect="1"/>
+          </p:cNvSpPr>
+          <p:nvPr>
+            <p:ph type="sldImg"/>
+          </p:nvPr>
+        </p:nvSpPr>
+        <p:spPr/>
+      </p:sp>
+      <p:sp>
+        <p:nvSpPr>
+          <p:cNvPr id="3" name="Notes Placeholder 2"/>
+          <p:cNvSpPr>
+            <a:spLocks noGrp="1"/>
+          </p:cNvSpPr>
+          <p:nvPr>
+            <p:ph type="body" idx="1"/>
+          </p:nvPr>
+        </p:nvSpPr>
+        <p:spPr/>
+        <p:txBody>
+          <a:bodyPr/>
+          <a:lstStyle/>
+          <a:p>
+            <a:r>
+              <a:rPr lang="en-US" dirty="0"/>
+              <a:t/>
+            </a:r>
+            <a:endParaRPr lang="en-US" dirty="0"/>
+          </a:p>
+        </p:txBody>
+      </p:sp>
+      <p:sp>
+        <p:nvSpPr>
+          <p:cNvPr id="4" name="Slide Number Placeholder 3"/>
+          <p:cNvSpPr>
+            <a:spLocks noGrp="1"/>
+          </p:cNvSpPr>
+          <p:nvPr>
+            <p:ph type="sldNum" sz="quarter" idx="10"/>
+          </p:nvPr>
+        </p:nvSpPr>
+        <p:spPr/>
+        <p:txBody>
+          <a:bodyPr/>
+          <a:lstStyle/>
+          <a:p>
+            <a:fld id="{F7021451-1387-4CA6-816F-3879F97B5CBC}" type="slidenum">
+              <a:rPr lang="en-US"/>
+              <a:t>22</a:t>
+            </a:fld>
+            <a:endParaRPr lang="en-US"/>
+          </a:p>
+        </p:txBody>
+      </p:sp>
+    </p:spTree>
+    <p:extLst>
+      <p:ext uri="{BB962C8B-B14F-4D97-AF65-F5344CB8AC3E}">
+        <p14:creationId xmlns:p14="http://schemas.microsoft.com/office/powerpoint/2010/main" val="1024086991"/>
+      </p:ext>
+    </p:extLst>
+  </p:cSld>
+  <p:clrMapOvr>
+    <a:masterClrMapping/>
+  </p:clrMapOvr>
+</p:notes>
+</file>
+
+<file path=ppt/notesSlides/notesSlide23.xml><?xml version="1.0" encoding="utf-8"?>
+<p:notes xmlns:a="http://schemas.openxmlformats.org/drawingml/2006/main" xmlns:r="http://schemas.openxmlformats.org/officeDocument/2006/relationships" xmlns:p="http://schemas.openxmlformats.org/presentationml/2006/main">
+  <p:cSld>
+    <p:spTree>
+      <p:nvGrpSpPr>
+        <p:cNvPr id="1" name=""/>
+        <p:cNvGrpSpPr/>
+        <p:nvPr/>
+      </p:nvGrpSpPr>
+      <p:grpSpPr>
+        <a:xfrm>
+          <a:off x="0" y="0"/>
+          <a:ext cx="0" cy="0"/>
+          <a:chOff x="0" y="0"/>
+          <a:chExt cx="0" cy="0"/>
+        </a:xfrm>
+      </p:grpSpPr>
+      <p:sp>
+        <p:nvSpPr>
+          <p:cNvPr id="2" name="Slide Image Placeholder 1"/>
+          <p:cNvSpPr>
+            <a:spLocks noGrp="1" noRot="1" noChangeAspect="1"/>
+          </p:cNvSpPr>
+          <p:nvPr>
+            <p:ph type="sldImg"/>
+          </p:nvPr>
+        </p:nvSpPr>
+        <p:spPr/>
+      </p:sp>
+      <p:sp>
+        <p:nvSpPr>
+          <p:cNvPr id="3" name="Notes Placeholder 2"/>
+          <p:cNvSpPr>
+            <a:spLocks noGrp="1"/>
+          </p:cNvSpPr>
+          <p:nvPr>
+            <p:ph type="body" idx="1"/>
+          </p:nvPr>
+        </p:nvSpPr>
+        <p:spPr/>
+        <p:txBody>
+          <a:bodyPr/>
+          <a:lstStyle/>
+          <a:p>
+            <a:r>
+              <a:rPr lang="en-US" dirty="0"/>
+              <a:t/>
+            </a:r>
+            <a:endParaRPr lang="en-US" dirty="0"/>
+          </a:p>
+        </p:txBody>
+      </p:sp>
+      <p:sp>
+        <p:nvSpPr>
+          <p:cNvPr id="4" name="Slide Number Placeholder 3"/>
+          <p:cNvSpPr>
+            <a:spLocks noGrp="1"/>
+          </p:cNvSpPr>
+          <p:nvPr>
+            <p:ph type="sldNum" sz="quarter" idx="10"/>
+          </p:nvPr>
+        </p:nvSpPr>
+        <p:spPr/>
+        <p:txBody>
+          <a:bodyPr/>
+          <a:lstStyle/>
+          <a:p>
+            <a:fld id="{F7021451-1387-4CA6-816F-3879F97B5CBC}" type="slidenum">
+              <a:rPr lang="en-US"/>
+              <a:t>23</a:t>
+            </a:fld>
+            <a:endParaRPr lang="en-US"/>
+          </a:p>
+        </p:txBody>
+      </p:sp>
+    </p:spTree>
+    <p:extLst>
+      <p:ext uri="{BB962C8B-B14F-4D97-AF65-F5344CB8AC3E}">
+        <p14:creationId xmlns:p14="http://schemas.microsoft.com/office/powerpoint/2010/main" val="1024086991"/>
+      </p:ext>
+    </p:extLst>
+  </p:cSld>
+  <p:clrMapOvr>
+    <a:masterClrMapping/>
+  </p:clrMapOvr>
+</p:notes>
+</file>
+
+<file path=ppt/notesSlides/notesSlide24.xml><?xml version="1.0" encoding="utf-8"?>
+<p:notes xmlns:a="http://schemas.openxmlformats.org/drawingml/2006/main" xmlns:r="http://schemas.openxmlformats.org/officeDocument/2006/relationships" xmlns:p="http://schemas.openxmlformats.org/presentationml/2006/main">
+  <p:cSld>
+    <p:spTree>
+      <p:nvGrpSpPr>
+        <p:cNvPr id="1" name=""/>
+        <p:cNvGrpSpPr/>
+        <p:nvPr/>
+      </p:nvGrpSpPr>
+      <p:grpSpPr>
+        <a:xfrm>
+          <a:off x="0" y="0"/>
+          <a:ext cx="0" cy="0"/>
+          <a:chOff x="0" y="0"/>
+          <a:chExt cx="0" cy="0"/>
+        </a:xfrm>
+      </p:grpSpPr>
+      <p:sp>
+        <p:nvSpPr>
+          <p:cNvPr id="2" name="Slide Image Placeholder 1"/>
+          <p:cNvSpPr>
+            <a:spLocks noGrp="1" noRot="1" noChangeAspect="1"/>
+          </p:cNvSpPr>
+          <p:nvPr>
+            <p:ph type="sldImg"/>
+          </p:nvPr>
+        </p:nvSpPr>
+        <p:spPr/>
+      </p:sp>
+      <p:sp>
+        <p:nvSpPr>
+          <p:cNvPr id="3" name="Notes Placeholder 2"/>
+          <p:cNvSpPr>
+            <a:spLocks noGrp="1"/>
+          </p:cNvSpPr>
+          <p:nvPr>
+            <p:ph type="body" idx="1"/>
+          </p:nvPr>
+        </p:nvSpPr>
+        <p:spPr/>
+        <p:txBody>
+          <a:bodyPr/>
+          <a:lstStyle/>
+          <a:p>
+            <a:r>
+              <a:rPr lang="en-US" dirty="0"/>
+              <a:t/>
+            </a:r>
+            <a:endParaRPr lang="en-US" dirty="0"/>
+          </a:p>
+        </p:txBody>
+      </p:sp>
+      <p:sp>
+        <p:nvSpPr>
+          <p:cNvPr id="4" name="Slide Number Placeholder 3"/>
+          <p:cNvSpPr>
+            <a:spLocks noGrp="1"/>
+          </p:cNvSpPr>
+          <p:nvPr>
+            <p:ph type="sldNum" sz="quarter" idx="10"/>
+          </p:nvPr>
+        </p:nvSpPr>
+        <p:spPr/>
+        <p:txBody>
+          <a:bodyPr/>
+          <a:lstStyle/>
+          <a:p>
+            <a:fld id="{F7021451-1387-4CA6-816F-3879F97B5CBC}" type="slidenum">
+              <a:rPr lang="en-US"/>
+              <a:t>24</a:t>
+            </a:fld>
+            <a:endParaRPr lang="en-US"/>
+          </a:p>
+        </p:txBody>
+      </p:sp>
+    </p:spTree>
+    <p:extLst>
+      <p:ext uri="{BB962C8B-B14F-4D97-AF65-F5344CB8AC3E}">
+        <p14:creationId xmlns:p14="http://schemas.microsoft.com/office/powerpoint/2010/main" val="1024086991"/>
+      </p:ext>
+    </p:extLst>
+  </p:cSld>
+  <p:clrMapOvr>
+    <a:masterClrMapping/>
+  </p:clrMapOvr>
+</p:notes>
+</file>
+
+<file path=ppt/notesSlides/notesSlide25.xml><?xml version="1.0" encoding="utf-8"?>
+<p:notes xmlns:a="http://schemas.openxmlformats.org/drawingml/2006/main" xmlns:r="http://schemas.openxmlformats.org/officeDocument/2006/relationships" xmlns:p="http://schemas.openxmlformats.org/presentationml/2006/main">
+  <p:cSld>
+    <p:spTree>
+      <p:nvGrpSpPr>
+        <p:cNvPr id="1" name=""/>
+        <p:cNvGrpSpPr/>
+        <p:nvPr/>
+      </p:nvGrpSpPr>
+      <p:grpSpPr>
+        <a:xfrm>
+          <a:off x="0" y="0"/>
+          <a:ext cx="0" cy="0"/>
+          <a:chOff x="0" y="0"/>
+          <a:chExt cx="0" cy="0"/>
+        </a:xfrm>
+      </p:grpSpPr>
+      <p:sp>
+        <p:nvSpPr>
+          <p:cNvPr id="2" name="Slide Image Placeholder 1"/>
+          <p:cNvSpPr>
+            <a:spLocks noGrp="1" noRot="1" noChangeAspect="1"/>
+          </p:cNvSpPr>
+          <p:nvPr>
+            <p:ph type="sldImg"/>
+          </p:nvPr>
+        </p:nvSpPr>
+        <p:spPr/>
+      </p:sp>
+      <p:sp>
+        <p:nvSpPr>
+          <p:cNvPr id="3" name="Notes Placeholder 2"/>
+          <p:cNvSpPr>
+            <a:spLocks noGrp="1"/>
+          </p:cNvSpPr>
+          <p:nvPr>
+            <p:ph type="body" idx="1"/>
+          </p:nvPr>
+        </p:nvSpPr>
+        <p:spPr/>
+        <p:txBody>
+          <a:bodyPr/>
+          <a:lstStyle/>
+          <a:p>
+            <a:r>
+              <a:rPr lang="en-US" dirty="0"/>
+              <a:t/>
+            </a:r>
+            <a:endParaRPr lang="en-US" dirty="0"/>
+          </a:p>
+        </p:txBody>
+      </p:sp>
+      <p:sp>
+        <p:nvSpPr>
+          <p:cNvPr id="4" name="Slide Number Placeholder 3"/>
+          <p:cNvSpPr>
+            <a:spLocks noGrp="1"/>
+          </p:cNvSpPr>
+          <p:nvPr>
+            <p:ph type="sldNum" sz="quarter" idx="10"/>
+          </p:nvPr>
+        </p:nvSpPr>
+        <p:spPr/>
+        <p:txBody>
+          <a:bodyPr/>
+          <a:lstStyle/>
+          <a:p>
+            <a:fld id="{F7021451-1387-4CA6-816F-3879F97B5CBC}" type="slidenum">
+              <a:rPr lang="en-US"/>
+              <a:t>25</a:t>
+            </a:fld>
+            <a:endParaRPr lang="en-US"/>
+          </a:p>
+        </p:txBody>
+      </p:sp>
+    </p:spTree>
+    <p:extLst>
+      <p:ext uri="{BB962C8B-B14F-4D97-AF65-F5344CB8AC3E}">
+        <p14:creationId xmlns:p14="http://schemas.microsoft.com/office/powerpoint/2010/main" val="1024086991"/>
+      </p:ext>
+    </p:extLst>
+  </p:cSld>
+  <p:clrMapOvr>
+    <a:masterClrMapping/>
+  </p:clrMapOvr>
+</p:notes>
+</file>
+
+<file path=ppt/notesSlides/notesSlide26.xml><?xml version="1.0" encoding="utf-8"?>
+<p:notes xmlns:a="http://schemas.openxmlformats.org/drawingml/2006/main" xmlns:r="http://schemas.openxmlformats.org/officeDocument/2006/relationships" xmlns:p="http://schemas.openxmlformats.org/presentationml/2006/main">
+  <p:cSld>
+    <p:spTree>
+      <p:nvGrpSpPr>
+        <p:cNvPr id="1" name=""/>
+        <p:cNvGrpSpPr/>
+        <p:nvPr/>
+      </p:nvGrpSpPr>
+      <p:grpSpPr>
+        <a:xfrm>
+          <a:off x="0" y="0"/>
+          <a:ext cx="0" cy="0"/>
+          <a:chOff x="0" y="0"/>
+          <a:chExt cx="0" cy="0"/>
+        </a:xfrm>
+      </p:grpSpPr>
+      <p:sp>
+        <p:nvSpPr>
+          <p:cNvPr id="2" name="Slide Image Placeholder 1"/>
+          <p:cNvSpPr>
+            <a:spLocks noGrp="1" noRot="1" noChangeAspect="1"/>
+          </p:cNvSpPr>
+          <p:nvPr>
+            <p:ph type="sldImg"/>
+          </p:nvPr>
+        </p:nvSpPr>
+        <p:spPr/>
+      </p:sp>
+      <p:sp>
+        <p:nvSpPr>
+          <p:cNvPr id="3" name="Notes Placeholder 2"/>
+          <p:cNvSpPr>
+            <a:spLocks noGrp="1"/>
+          </p:cNvSpPr>
+          <p:nvPr>
+            <p:ph type="body" idx="1"/>
+          </p:nvPr>
+        </p:nvSpPr>
+        <p:spPr/>
+        <p:txBody>
+          <a:bodyPr/>
+          <a:lstStyle/>
+          <a:p>
+            <a:r>
+              <a:rPr lang="en-US" dirty="0"/>
+              <a:t/>
+            </a:r>
+            <a:endParaRPr lang="en-US" dirty="0"/>
+          </a:p>
+        </p:txBody>
+      </p:sp>
+      <p:sp>
+        <p:nvSpPr>
+          <p:cNvPr id="4" name="Slide Number Placeholder 3"/>
+          <p:cNvSpPr>
+            <a:spLocks noGrp="1"/>
+          </p:cNvSpPr>
+          <p:nvPr>
+            <p:ph type="sldNum" sz="quarter" idx="10"/>
+          </p:nvPr>
+        </p:nvSpPr>
+        <p:spPr/>
+        <p:txBody>
+          <a:bodyPr/>
+          <a:lstStyle/>
+          <a:p>
+            <a:fld id="{F7021451-1387-4CA6-816F-3879F97B5CBC}" type="slidenum">
+              <a:rPr lang="en-US"/>
+              <a:t>26</a:t>
+            </a:fld>
+            <a:endParaRPr lang="en-US"/>
+          </a:p>
+        </p:txBody>
+      </p:sp>
+    </p:spTree>
+    <p:extLst>
+      <p:ext uri="{BB962C8B-B14F-4D97-AF65-F5344CB8AC3E}">
+        <p14:creationId xmlns:p14="http://schemas.microsoft.com/office/powerpoint/2010/main" val="1024086991"/>
+      </p:ext>
+    </p:extLst>
+  </p:cSld>
+  <p:clrMapOvr>
+    <a:masterClrMapping/>
+  </p:clrMapOvr>
+</p:notes>
+</file>
+
+<file path=ppt/notesSlides/notesSlide27.xml><?xml version="1.0" encoding="utf-8"?>
+<p:notes xmlns:a="http://schemas.openxmlformats.org/drawingml/2006/main" xmlns:r="http://schemas.openxmlformats.org/officeDocument/2006/relationships" xmlns:p="http://schemas.openxmlformats.org/presentationml/2006/main">
+  <p:cSld>
+    <p:spTree>
+      <p:nvGrpSpPr>
+        <p:cNvPr id="1" name=""/>
+        <p:cNvGrpSpPr/>
+        <p:nvPr/>
+      </p:nvGrpSpPr>
+      <p:grpSpPr>
+        <a:xfrm>
+          <a:off x="0" y="0"/>
+          <a:ext cx="0" cy="0"/>
+          <a:chOff x="0" y="0"/>
+          <a:chExt cx="0" cy="0"/>
+        </a:xfrm>
+      </p:grpSpPr>
+      <p:sp>
+        <p:nvSpPr>
+          <p:cNvPr id="2" name="Slide Image Placeholder 1"/>
+          <p:cNvSpPr>
+            <a:spLocks noGrp="1" noRot="1" noChangeAspect="1"/>
+          </p:cNvSpPr>
+          <p:nvPr>
+            <p:ph type="sldImg"/>
+          </p:nvPr>
+        </p:nvSpPr>
+        <p:spPr/>
+      </p:sp>
+      <p:sp>
+        <p:nvSpPr>
+          <p:cNvPr id="3" name="Notes Placeholder 2"/>
+          <p:cNvSpPr>
+            <a:spLocks noGrp="1"/>
+          </p:cNvSpPr>
+          <p:nvPr>
+            <p:ph type="body" idx="1"/>
+          </p:nvPr>
+        </p:nvSpPr>
+        <p:spPr/>
+        <p:txBody>
+          <a:bodyPr/>
+          <a:lstStyle/>
+          <a:p>
+            <a:r>
+              <a:rPr lang="en-US" dirty="0"/>
+              <a:t/>
+            </a:r>
+            <a:endParaRPr lang="en-US" dirty="0"/>
+          </a:p>
+        </p:txBody>
+      </p:sp>
+      <p:sp>
+        <p:nvSpPr>
+          <p:cNvPr id="4" name="Slide Number Placeholder 3"/>
+          <p:cNvSpPr>
+            <a:spLocks noGrp="1"/>
+          </p:cNvSpPr>
+          <p:nvPr>
+            <p:ph type="sldNum" sz="quarter" idx="10"/>
+          </p:nvPr>
+        </p:nvSpPr>
+        <p:spPr/>
+        <p:txBody>
+          <a:bodyPr/>
+          <a:lstStyle/>
+          <a:p>
+            <a:fld id="{F7021451-1387-4CA6-816F-3879F97B5CBC}" type="slidenum">
+              <a:rPr lang="en-US"/>
+              <a:t>27</a:t>
+            </a:fld>
+            <a:endParaRPr lang="en-US"/>
+          </a:p>
+        </p:txBody>
+      </p:sp>
+    </p:spTree>
+    <p:extLst>
+      <p:ext uri="{BB962C8B-B14F-4D97-AF65-F5344CB8AC3E}">
+        <p14:creationId xmlns:p14="http://schemas.microsoft.com/office/powerpoint/2010/main" val="1024086991"/>
+      </p:ext>
+    </p:extLst>
+  </p:cSld>
+  <p:clrMapOvr>
+    <a:masterClrMapping/>
+  </p:clrMapOvr>
+</p:notes>
+</file>
+
+<file path=ppt/notesSlides/notesSlide28.xml><?xml version="1.0" encoding="utf-8"?>
+<p:notes xmlns:a="http://schemas.openxmlformats.org/drawingml/2006/main" xmlns:r="http://schemas.openxmlformats.org/officeDocument/2006/relationships" xmlns:p="http://schemas.openxmlformats.org/presentationml/2006/main">
+  <p:cSld>
+    <p:spTree>
+      <p:nvGrpSpPr>
+        <p:cNvPr id="1" name=""/>
+        <p:cNvGrpSpPr/>
+        <p:nvPr/>
+      </p:nvGrpSpPr>
+      <p:grpSpPr>
+        <a:xfrm>
+          <a:off x="0" y="0"/>
+          <a:ext cx="0" cy="0"/>
+          <a:chOff x="0" y="0"/>
+          <a:chExt cx="0" cy="0"/>
+        </a:xfrm>
+      </p:grpSpPr>
+      <p:sp>
+        <p:nvSpPr>
+          <p:cNvPr id="2" name="Slide Image Placeholder 1"/>
+          <p:cNvSpPr>
+            <a:spLocks noGrp="1" noRot="1" noChangeAspect="1"/>
+          </p:cNvSpPr>
+          <p:nvPr>
+            <p:ph type="sldImg"/>
+          </p:nvPr>
+        </p:nvSpPr>
+        <p:spPr/>
+      </p:sp>
+      <p:sp>
+        <p:nvSpPr>
+          <p:cNvPr id="3" name="Notes Placeholder 2"/>
+          <p:cNvSpPr>
+            <a:spLocks noGrp="1"/>
+          </p:cNvSpPr>
+          <p:nvPr>
+            <p:ph type="body" idx="1"/>
+          </p:nvPr>
+        </p:nvSpPr>
+        <p:spPr/>
+        <p:txBody>
+          <a:bodyPr/>
+          <a:lstStyle/>
+          <a:p>
+            <a:r>
+              <a:rPr lang="en-US" dirty="0"/>
+              <a:t/>
+            </a:r>
+            <a:endParaRPr lang="en-US" dirty="0"/>
+          </a:p>
+        </p:txBody>
+      </p:sp>
+      <p:sp>
+        <p:nvSpPr>
+          <p:cNvPr id="4" name="Slide Number Placeholder 3"/>
+          <p:cNvSpPr>
+            <a:spLocks noGrp="1"/>
+          </p:cNvSpPr>
+          <p:nvPr>
+            <p:ph type="sldNum" sz="quarter" idx="10"/>
+          </p:nvPr>
+        </p:nvSpPr>
+        <p:spPr/>
+        <p:txBody>
+          <a:bodyPr/>
+          <a:lstStyle/>
+          <a:p>
+            <a:fld id="{F7021451-1387-4CA6-816F-3879F97B5CBC}" type="slidenum">
+              <a:rPr lang="en-US"/>
+              <a:t>28</a:t>
+            </a:fld>
+            <a:endParaRPr lang="en-US"/>
+          </a:p>
+        </p:txBody>
+      </p:sp>
+    </p:spTree>
+    <p:extLst>
+      <p:ext uri="{BB962C8B-B14F-4D97-AF65-F5344CB8AC3E}">
+        <p14:creationId xmlns:p14="http://schemas.microsoft.com/office/powerpoint/2010/main" val="1024086991"/>
+      </p:ext>
+    </p:extLst>
+  </p:cSld>
+  <p:clrMapOvr>
+    <a:masterClrMapping/>
+  </p:clrMapOvr>
+</p:notes>
+</file>
+
+<file path=ppt/notesSlides/notesSlide29.xml><?xml version="1.0" encoding="utf-8"?>
+<p:notes xmlns:a="http://schemas.openxmlformats.org/drawingml/2006/main" xmlns:r="http://schemas.openxmlformats.org/officeDocument/2006/relationships" xmlns:p="http://schemas.openxmlformats.org/presentationml/2006/main">
+  <p:cSld>
+    <p:spTree>
+      <p:nvGrpSpPr>
+        <p:cNvPr id="1" name=""/>
+        <p:cNvGrpSpPr/>
+        <p:nvPr/>
+      </p:nvGrpSpPr>
+      <p:grpSpPr>
+        <a:xfrm>
+          <a:off x="0" y="0"/>
+          <a:ext cx="0" cy="0"/>
+          <a:chOff x="0" y="0"/>
+          <a:chExt cx="0" cy="0"/>
+        </a:xfrm>
+      </p:grpSpPr>
+      <p:sp>
+        <p:nvSpPr>
+          <p:cNvPr id="2" name="Slide Image Placeholder 1"/>
+          <p:cNvSpPr>
+            <a:spLocks noGrp="1" noRot="1" noChangeAspect="1"/>
+          </p:cNvSpPr>
+          <p:nvPr>
+            <p:ph type="sldImg"/>
+          </p:nvPr>
+        </p:nvSpPr>
+        <p:spPr/>
+      </p:sp>
+      <p:sp>
+        <p:nvSpPr>
+          <p:cNvPr id="3" name="Notes Placeholder 2"/>
+          <p:cNvSpPr>
+            <a:spLocks noGrp="1"/>
+          </p:cNvSpPr>
+          <p:nvPr>
+            <p:ph type="body" idx="1"/>
+          </p:nvPr>
+        </p:nvSpPr>
+        <p:spPr/>
+        <p:txBody>
+          <a:bodyPr/>
+          <a:lstStyle/>
+          <a:p>
+            <a:r>
+              <a:rPr lang="en-US" dirty="0"/>
+              <a:t/>
+            </a:r>
+            <a:endParaRPr lang="en-US" dirty="0"/>
+          </a:p>
+        </p:txBody>
+      </p:sp>
+      <p:sp>
+        <p:nvSpPr>
+          <p:cNvPr id="4" name="Slide Number Placeholder 3"/>
+          <p:cNvSpPr>
+            <a:spLocks noGrp="1"/>
+          </p:cNvSpPr>
+          <p:nvPr>
+            <p:ph type="sldNum" sz="quarter" idx="10"/>
+          </p:nvPr>
+        </p:nvSpPr>
+        <p:spPr/>
+        <p:txBody>
+          <a:bodyPr/>
+          <a:lstStyle/>
+          <a:p>
+            <a:fld id="{F7021451-1387-4CA6-816F-3879F97B5CBC}" type="slidenum">
+              <a:rPr lang="en-US"/>
+              <a:t>29</a:t>
+            </a:fld>
+            <a:endParaRPr lang="en-US"/>
+          </a:p>
+        </p:txBody>
+      </p:sp>
+    </p:spTree>
+    <p:extLst>
+      <p:ext uri="{BB962C8B-B14F-4D97-AF65-F5344CB8AC3E}">
+        <p14:creationId xmlns:p14="http://schemas.microsoft.com/office/powerpoint/2010/main" val="1024086991"/>
+      </p:ext>
+    </p:extLst>
+  </p:cSld>
+  <p:clrMapOvr>
+    <a:masterClrMapping/>
+  </p:clrMapOvr>
+</p:notes>
+</file>
+
 <file path=ppt/notesSlides/notesSlide3.xml><?xml version="1.0" encoding="utf-8"?>
 <p:notes xmlns:a="http://schemas.openxmlformats.org/drawingml/2006/main" xmlns:r="http://schemas.openxmlformats.org/officeDocument/2006/relationships" xmlns:p="http://schemas.openxmlformats.org/presentationml/2006/main">
   <p:cSld>
@@ -1600,6 +2497,622 @@
             <a:fld id="{F7021451-1387-4CA6-816F-3879F97B5CBC}" type="slidenum">
               <a:rPr lang="en-US"/>
               <a:t>3</a:t>
+            </a:fld>
+            <a:endParaRPr lang="en-US"/>
+          </a:p>
+        </p:txBody>
+      </p:sp>
+    </p:spTree>
+    <p:extLst>
+      <p:ext uri="{BB962C8B-B14F-4D97-AF65-F5344CB8AC3E}">
+        <p14:creationId xmlns:p14="http://schemas.microsoft.com/office/powerpoint/2010/main" val="1024086991"/>
+      </p:ext>
+    </p:extLst>
+  </p:cSld>
+  <p:clrMapOvr>
+    <a:masterClrMapping/>
+  </p:clrMapOvr>
+</p:notes>
+</file>
+
+<file path=ppt/notesSlides/notesSlide30.xml><?xml version="1.0" encoding="utf-8"?>
+<p:notes xmlns:a="http://schemas.openxmlformats.org/drawingml/2006/main" xmlns:r="http://schemas.openxmlformats.org/officeDocument/2006/relationships" xmlns:p="http://schemas.openxmlformats.org/presentationml/2006/main">
+  <p:cSld>
+    <p:spTree>
+      <p:nvGrpSpPr>
+        <p:cNvPr id="1" name=""/>
+        <p:cNvGrpSpPr/>
+        <p:nvPr/>
+      </p:nvGrpSpPr>
+      <p:grpSpPr>
+        <a:xfrm>
+          <a:off x="0" y="0"/>
+          <a:ext cx="0" cy="0"/>
+          <a:chOff x="0" y="0"/>
+          <a:chExt cx="0" cy="0"/>
+        </a:xfrm>
+      </p:grpSpPr>
+      <p:sp>
+        <p:nvSpPr>
+          <p:cNvPr id="2" name="Slide Image Placeholder 1"/>
+          <p:cNvSpPr>
+            <a:spLocks noGrp="1" noRot="1" noChangeAspect="1"/>
+          </p:cNvSpPr>
+          <p:nvPr>
+            <p:ph type="sldImg"/>
+          </p:nvPr>
+        </p:nvSpPr>
+        <p:spPr/>
+      </p:sp>
+      <p:sp>
+        <p:nvSpPr>
+          <p:cNvPr id="3" name="Notes Placeholder 2"/>
+          <p:cNvSpPr>
+            <a:spLocks noGrp="1"/>
+          </p:cNvSpPr>
+          <p:nvPr>
+            <p:ph type="body" idx="1"/>
+          </p:nvPr>
+        </p:nvSpPr>
+        <p:spPr/>
+        <p:txBody>
+          <a:bodyPr/>
+          <a:lstStyle/>
+          <a:p>
+            <a:r>
+              <a:rPr lang="en-US" dirty="0"/>
+              <a:t/>
+            </a:r>
+            <a:endParaRPr lang="en-US" dirty="0"/>
+          </a:p>
+        </p:txBody>
+      </p:sp>
+      <p:sp>
+        <p:nvSpPr>
+          <p:cNvPr id="4" name="Slide Number Placeholder 3"/>
+          <p:cNvSpPr>
+            <a:spLocks noGrp="1"/>
+          </p:cNvSpPr>
+          <p:nvPr>
+            <p:ph type="sldNum" sz="quarter" idx="10"/>
+          </p:nvPr>
+        </p:nvSpPr>
+        <p:spPr/>
+        <p:txBody>
+          <a:bodyPr/>
+          <a:lstStyle/>
+          <a:p>
+            <a:fld id="{F7021451-1387-4CA6-816F-3879F97B5CBC}" type="slidenum">
+              <a:rPr lang="en-US"/>
+              <a:t>30</a:t>
+            </a:fld>
+            <a:endParaRPr lang="en-US"/>
+          </a:p>
+        </p:txBody>
+      </p:sp>
+    </p:spTree>
+    <p:extLst>
+      <p:ext uri="{BB962C8B-B14F-4D97-AF65-F5344CB8AC3E}">
+        <p14:creationId xmlns:p14="http://schemas.microsoft.com/office/powerpoint/2010/main" val="1024086991"/>
+      </p:ext>
+    </p:extLst>
+  </p:cSld>
+  <p:clrMapOvr>
+    <a:masterClrMapping/>
+  </p:clrMapOvr>
+</p:notes>
+</file>
+
+<file path=ppt/notesSlides/notesSlide31.xml><?xml version="1.0" encoding="utf-8"?>
+<p:notes xmlns:a="http://schemas.openxmlformats.org/drawingml/2006/main" xmlns:r="http://schemas.openxmlformats.org/officeDocument/2006/relationships" xmlns:p="http://schemas.openxmlformats.org/presentationml/2006/main">
+  <p:cSld>
+    <p:spTree>
+      <p:nvGrpSpPr>
+        <p:cNvPr id="1" name=""/>
+        <p:cNvGrpSpPr/>
+        <p:nvPr/>
+      </p:nvGrpSpPr>
+      <p:grpSpPr>
+        <a:xfrm>
+          <a:off x="0" y="0"/>
+          <a:ext cx="0" cy="0"/>
+          <a:chOff x="0" y="0"/>
+          <a:chExt cx="0" cy="0"/>
+        </a:xfrm>
+      </p:grpSpPr>
+      <p:sp>
+        <p:nvSpPr>
+          <p:cNvPr id="2" name="Slide Image Placeholder 1"/>
+          <p:cNvSpPr>
+            <a:spLocks noGrp="1" noRot="1" noChangeAspect="1"/>
+          </p:cNvSpPr>
+          <p:nvPr>
+            <p:ph type="sldImg"/>
+          </p:nvPr>
+        </p:nvSpPr>
+        <p:spPr/>
+      </p:sp>
+      <p:sp>
+        <p:nvSpPr>
+          <p:cNvPr id="3" name="Notes Placeholder 2"/>
+          <p:cNvSpPr>
+            <a:spLocks noGrp="1"/>
+          </p:cNvSpPr>
+          <p:nvPr>
+            <p:ph type="body" idx="1"/>
+          </p:nvPr>
+        </p:nvSpPr>
+        <p:spPr/>
+        <p:txBody>
+          <a:bodyPr/>
+          <a:lstStyle/>
+          <a:p>
+            <a:r>
+              <a:rPr lang="en-US" dirty="0"/>
+              <a:t/>
+            </a:r>
+            <a:endParaRPr lang="en-US" dirty="0"/>
+          </a:p>
+        </p:txBody>
+      </p:sp>
+      <p:sp>
+        <p:nvSpPr>
+          <p:cNvPr id="4" name="Slide Number Placeholder 3"/>
+          <p:cNvSpPr>
+            <a:spLocks noGrp="1"/>
+          </p:cNvSpPr>
+          <p:nvPr>
+            <p:ph type="sldNum" sz="quarter" idx="10"/>
+          </p:nvPr>
+        </p:nvSpPr>
+        <p:spPr/>
+        <p:txBody>
+          <a:bodyPr/>
+          <a:lstStyle/>
+          <a:p>
+            <a:fld id="{F7021451-1387-4CA6-816F-3879F97B5CBC}" type="slidenum">
+              <a:rPr lang="en-US"/>
+              <a:t>31</a:t>
+            </a:fld>
+            <a:endParaRPr lang="en-US"/>
+          </a:p>
+        </p:txBody>
+      </p:sp>
+    </p:spTree>
+    <p:extLst>
+      <p:ext uri="{BB962C8B-B14F-4D97-AF65-F5344CB8AC3E}">
+        <p14:creationId xmlns:p14="http://schemas.microsoft.com/office/powerpoint/2010/main" val="1024086991"/>
+      </p:ext>
+    </p:extLst>
+  </p:cSld>
+  <p:clrMapOvr>
+    <a:masterClrMapping/>
+  </p:clrMapOvr>
+</p:notes>
+</file>
+
+<file path=ppt/notesSlides/notesSlide32.xml><?xml version="1.0" encoding="utf-8"?>
+<p:notes xmlns:a="http://schemas.openxmlformats.org/drawingml/2006/main" xmlns:r="http://schemas.openxmlformats.org/officeDocument/2006/relationships" xmlns:p="http://schemas.openxmlformats.org/presentationml/2006/main">
+  <p:cSld>
+    <p:spTree>
+      <p:nvGrpSpPr>
+        <p:cNvPr id="1" name=""/>
+        <p:cNvGrpSpPr/>
+        <p:nvPr/>
+      </p:nvGrpSpPr>
+      <p:grpSpPr>
+        <a:xfrm>
+          <a:off x="0" y="0"/>
+          <a:ext cx="0" cy="0"/>
+          <a:chOff x="0" y="0"/>
+          <a:chExt cx="0" cy="0"/>
+        </a:xfrm>
+      </p:grpSpPr>
+      <p:sp>
+        <p:nvSpPr>
+          <p:cNvPr id="2" name="Slide Image Placeholder 1"/>
+          <p:cNvSpPr>
+            <a:spLocks noGrp="1" noRot="1" noChangeAspect="1"/>
+          </p:cNvSpPr>
+          <p:nvPr>
+            <p:ph type="sldImg"/>
+          </p:nvPr>
+        </p:nvSpPr>
+        <p:spPr/>
+      </p:sp>
+      <p:sp>
+        <p:nvSpPr>
+          <p:cNvPr id="3" name="Notes Placeholder 2"/>
+          <p:cNvSpPr>
+            <a:spLocks noGrp="1"/>
+          </p:cNvSpPr>
+          <p:nvPr>
+            <p:ph type="body" idx="1"/>
+          </p:nvPr>
+        </p:nvSpPr>
+        <p:spPr/>
+        <p:txBody>
+          <a:bodyPr/>
+          <a:lstStyle/>
+          <a:p>
+            <a:r>
+              <a:rPr lang="en-US" dirty="0"/>
+              <a:t/>
+            </a:r>
+            <a:endParaRPr lang="en-US" dirty="0"/>
+          </a:p>
+        </p:txBody>
+      </p:sp>
+      <p:sp>
+        <p:nvSpPr>
+          <p:cNvPr id="4" name="Slide Number Placeholder 3"/>
+          <p:cNvSpPr>
+            <a:spLocks noGrp="1"/>
+          </p:cNvSpPr>
+          <p:nvPr>
+            <p:ph type="sldNum" sz="quarter" idx="10"/>
+          </p:nvPr>
+        </p:nvSpPr>
+        <p:spPr/>
+        <p:txBody>
+          <a:bodyPr/>
+          <a:lstStyle/>
+          <a:p>
+            <a:fld id="{F7021451-1387-4CA6-816F-3879F97B5CBC}" type="slidenum">
+              <a:rPr lang="en-US"/>
+              <a:t>32</a:t>
+            </a:fld>
+            <a:endParaRPr lang="en-US"/>
+          </a:p>
+        </p:txBody>
+      </p:sp>
+    </p:spTree>
+    <p:extLst>
+      <p:ext uri="{BB962C8B-B14F-4D97-AF65-F5344CB8AC3E}">
+        <p14:creationId xmlns:p14="http://schemas.microsoft.com/office/powerpoint/2010/main" val="1024086991"/>
+      </p:ext>
+    </p:extLst>
+  </p:cSld>
+  <p:clrMapOvr>
+    <a:masterClrMapping/>
+  </p:clrMapOvr>
+</p:notes>
+</file>
+
+<file path=ppt/notesSlides/notesSlide33.xml><?xml version="1.0" encoding="utf-8"?>
+<p:notes xmlns:a="http://schemas.openxmlformats.org/drawingml/2006/main" xmlns:r="http://schemas.openxmlformats.org/officeDocument/2006/relationships" xmlns:p="http://schemas.openxmlformats.org/presentationml/2006/main">
+  <p:cSld>
+    <p:spTree>
+      <p:nvGrpSpPr>
+        <p:cNvPr id="1" name=""/>
+        <p:cNvGrpSpPr/>
+        <p:nvPr/>
+      </p:nvGrpSpPr>
+      <p:grpSpPr>
+        <a:xfrm>
+          <a:off x="0" y="0"/>
+          <a:ext cx="0" cy="0"/>
+          <a:chOff x="0" y="0"/>
+          <a:chExt cx="0" cy="0"/>
+        </a:xfrm>
+      </p:grpSpPr>
+      <p:sp>
+        <p:nvSpPr>
+          <p:cNvPr id="2" name="Slide Image Placeholder 1"/>
+          <p:cNvSpPr>
+            <a:spLocks noGrp="1" noRot="1" noChangeAspect="1"/>
+          </p:cNvSpPr>
+          <p:nvPr>
+            <p:ph type="sldImg"/>
+          </p:nvPr>
+        </p:nvSpPr>
+        <p:spPr/>
+      </p:sp>
+      <p:sp>
+        <p:nvSpPr>
+          <p:cNvPr id="3" name="Notes Placeholder 2"/>
+          <p:cNvSpPr>
+            <a:spLocks noGrp="1"/>
+          </p:cNvSpPr>
+          <p:nvPr>
+            <p:ph type="body" idx="1"/>
+          </p:nvPr>
+        </p:nvSpPr>
+        <p:spPr/>
+        <p:txBody>
+          <a:bodyPr/>
+          <a:lstStyle/>
+          <a:p>
+            <a:r>
+              <a:rPr lang="en-US" dirty="0"/>
+              <a:t/>
+            </a:r>
+            <a:endParaRPr lang="en-US" dirty="0"/>
+          </a:p>
+        </p:txBody>
+      </p:sp>
+      <p:sp>
+        <p:nvSpPr>
+          <p:cNvPr id="4" name="Slide Number Placeholder 3"/>
+          <p:cNvSpPr>
+            <a:spLocks noGrp="1"/>
+          </p:cNvSpPr>
+          <p:nvPr>
+            <p:ph type="sldNum" sz="quarter" idx="10"/>
+          </p:nvPr>
+        </p:nvSpPr>
+        <p:spPr/>
+        <p:txBody>
+          <a:bodyPr/>
+          <a:lstStyle/>
+          <a:p>
+            <a:fld id="{F7021451-1387-4CA6-816F-3879F97B5CBC}" type="slidenum">
+              <a:rPr lang="en-US"/>
+              <a:t>33</a:t>
+            </a:fld>
+            <a:endParaRPr lang="en-US"/>
+          </a:p>
+        </p:txBody>
+      </p:sp>
+    </p:spTree>
+    <p:extLst>
+      <p:ext uri="{BB962C8B-B14F-4D97-AF65-F5344CB8AC3E}">
+        <p14:creationId xmlns:p14="http://schemas.microsoft.com/office/powerpoint/2010/main" val="1024086991"/>
+      </p:ext>
+    </p:extLst>
+  </p:cSld>
+  <p:clrMapOvr>
+    <a:masterClrMapping/>
+  </p:clrMapOvr>
+</p:notes>
+</file>
+
+<file path=ppt/notesSlides/notesSlide34.xml><?xml version="1.0" encoding="utf-8"?>
+<p:notes xmlns:a="http://schemas.openxmlformats.org/drawingml/2006/main" xmlns:r="http://schemas.openxmlformats.org/officeDocument/2006/relationships" xmlns:p="http://schemas.openxmlformats.org/presentationml/2006/main">
+  <p:cSld>
+    <p:spTree>
+      <p:nvGrpSpPr>
+        <p:cNvPr id="1" name=""/>
+        <p:cNvGrpSpPr/>
+        <p:nvPr/>
+      </p:nvGrpSpPr>
+      <p:grpSpPr>
+        <a:xfrm>
+          <a:off x="0" y="0"/>
+          <a:ext cx="0" cy="0"/>
+          <a:chOff x="0" y="0"/>
+          <a:chExt cx="0" cy="0"/>
+        </a:xfrm>
+      </p:grpSpPr>
+      <p:sp>
+        <p:nvSpPr>
+          <p:cNvPr id="2" name="Slide Image Placeholder 1"/>
+          <p:cNvSpPr>
+            <a:spLocks noGrp="1" noRot="1" noChangeAspect="1"/>
+          </p:cNvSpPr>
+          <p:nvPr>
+            <p:ph type="sldImg"/>
+          </p:nvPr>
+        </p:nvSpPr>
+        <p:spPr/>
+      </p:sp>
+      <p:sp>
+        <p:nvSpPr>
+          <p:cNvPr id="3" name="Notes Placeholder 2"/>
+          <p:cNvSpPr>
+            <a:spLocks noGrp="1"/>
+          </p:cNvSpPr>
+          <p:nvPr>
+            <p:ph type="body" idx="1"/>
+          </p:nvPr>
+        </p:nvSpPr>
+        <p:spPr/>
+        <p:txBody>
+          <a:bodyPr/>
+          <a:lstStyle/>
+          <a:p>
+            <a:r>
+              <a:rPr lang="en-US" dirty="0"/>
+              <a:t/>
+            </a:r>
+            <a:endParaRPr lang="en-US" dirty="0"/>
+          </a:p>
+        </p:txBody>
+      </p:sp>
+      <p:sp>
+        <p:nvSpPr>
+          <p:cNvPr id="4" name="Slide Number Placeholder 3"/>
+          <p:cNvSpPr>
+            <a:spLocks noGrp="1"/>
+          </p:cNvSpPr>
+          <p:nvPr>
+            <p:ph type="sldNum" sz="quarter" idx="10"/>
+          </p:nvPr>
+        </p:nvSpPr>
+        <p:spPr/>
+        <p:txBody>
+          <a:bodyPr/>
+          <a:lstStyle/>
+          <a:p>
+            <a:fld id="{F7021451-1387-4CA6-816F-3879F97B5CBC}" type="slidenum">
+              <a:rPr lang="en-US"/>
+              <a:t>34</a:t>
+            </a:fld>
+            <a:endParaRPr lang="en-US"/>
+          </a:p>
+        </p:txBody>
+      </p:sp>
+    </p:spTree>
+    <p:extLst>
+      <p:ext uri="{BB962C8B-B14F-4D97-AF65-F5344CB8AC3E}">
+        <p14:creationId xmlns:p14="http://schemas.microsoft.com/office/powerpoint/2010/main" val="1024086991"/>
+      </p:ext>
+    </p:extLst>
+  </p:cSld>
+  <p:clrMapOvr>
+    <a:masterClrMapping/>
+  </p:clrMapOvr>
+</p:notes>
+</file>
+
+<file path=ppt/notesSlides/notesSlide35.xml><?xml version="1.0" encoding="utf-8"?>
+<p:notes xmlns:a="http://schemas.openxmlformats.org/drawingml/2006/main" xmlns:r="http://schemas.openxmlformats.org/officeDocument/2006/relationships" xmlns:p="http://schemas.openxmlformats.org/presentationml/2006/main">
+  <p:cSld>
+    <p:spTree>
+      <p:nvGrpSpPr>
+        <p:cNvPr id="1" name=""/>
+        <p:cNvGrpSpPr/>
+        <p:nvPr/>
+      </p:nvGrpSpPr>
+      <p:grpSpPr>
+        <a:xfrm>
+          <a:off x="0" y="0"/>
+          <a:ext cx="0" cy="0"/>
+          <a:chOff x="0" y="0"/>
+          <a:chExt cx="0" cy="0"/>
+        </a:xfrm>
+      </p:grpSpPr>
+      <p:sp>
+        <p:nvSpPr>
+          <p:cNvPr id="2" name="Slide Image Placeholder 1"/>
+          <p:cNvSpPr>
+            <a:spLocks noGrp="1" noRot="1" noChangeAspect="1"/>
+          </p:cNvSpPr>
+          <p:nvPr>
+            <p:ph type="sldImg"/>
+          </p:nvPr>
+        </p:nvSpPr>
+        <p:spPr/>
+      </p:sp>
+      <p:sp>
+        <p:nvSpPr>
+          <p:cNvPr id="3" name="Notes Placeholder 2"/>
+          <p:cNvSpPr>
+            <a:spLocks noGrp="1"/>
+          </p:cNvSpPr>
+          <p:nvPr>
+            <p:ph type="body" idx="1"/>
+          </p:nvPr>
+        </p:nvSpPr>
+        <p:spPr/>
+        <p:txBody>
+          <a:bodyPr/>
+          <a:lstStyle/>
+          <a:p>
+            <a:r>
+              <a:rPr lang="en-US" dirty="0"/>
+              <a:t/>
+            </a:r>
+            <a:endParaRPr lang="en-US" dirty="0"/>
+          </a:p>
+        </p:txBody>
+      </p:sp>
+      <p:sp>
+        <p:nvSpPr>
+          <p:cNvPr id="4" name="Slide Number Placeholder 3"/>
+          <p:cNvSpPr>
+            <a:spLocks noGrp="1"/>
+          </p:cNvSpPr>
+          <p:nvPr>
+            <p:ph type="sldNum" sz="quarter" idx="10"/>
+          </p:nvPr>
+        </p:nvSpPr>
+        <p:spPr/>
+        <p:txBody>
+          <a:bodyPr/>
+          <a:lstStyle/>
+          <a:p>
+            <a:fld id="{F7021451-1387-4CA6-816F-3879F97B5CBC}" type="slidenum">
+              <a:rPr lang="en-US"/>
+              <a:t>35</a:t>
+            </a:fld>
+            <a:endParaRPr lang="en-US"/>
+          </a:p>
+        </p:txBody>
+      </p:sp>
+    </p:spTree>
+    <p:extLst>
+      <p:ext uri="{BB962C8B-B14F-4D97-AF65-F5344CB8AC3E}">
+        <p14:creationId xmlns:p14="http://schemas.microsoft.com/office/powerpoint/2010/main" val="1024086991"/>
+      </p:ext>
+    </p:extLst>
+  </p:cSld>
+  <p:clrMapOvr>
+    <a:masterClrMapping/>
+  </p:clrMapOvr>
+</p:notes>
+</file>
+
+<file path=ppt/notesSlides/notesSlide36.xml><?xml version="1.0" encoding="utf-8"?>
+<p:notes xmlns:a="http://schemas.openxmlformats.org/drawingml/2006/main" xmlns:r="http://schemas.openxmlformats.org/officeDocument/2006/relationships" xmlns:p="http://schemas.openxmlformats.org/presentationml/2006/main">
+  <p:cSld>
+    <p:spTree>
+      <p:nvGrpSpPr>
+        <p:cNvPr id="1" name=""/>
+        <p:cNvGrpSpPr/>
+        <p:nvPr/>
+      </p:nvGrpSpPr>
+      <p:grpSpPr>
+        <a:xfrm>
+          <a:off x="0" y="0"/>
+          <a:ext cx="0" cy="0"/>
+          <a:chOff x="0" y="0"/>
+          <a:chExt cx="0" cy="0"/>
+        </a:xfrm>
+      </p:grpSpPr>
+      <p:sp>
+        <p:nvSpPr>
+          <p:cNvPr id="2" name="Slide Image Placeholder 1"/>
+          <p:cNvSpPr>
+            <a:spLocks noGrp="1" noRot="1" noChangeAspect="1"/>
+          </p:cNvSpPr>
+          <p:nvPr>
+            <p:ph type="sldImg"/>
+          </p:nvPr>
+        </p:nvSpPr>
+        <p:spPr/>
+      </p:sp>
+      <p:sp>
+        <p:nvSpPr>
+          <p:cNvPr id="3" name="Notes Placeholder 2"/>
+          <p:cNvSpPr>
+            <a:spLocks noGrp="1"/>
+          </p:cNvSpPr>
+          <p:nvPr>
+            <p:ph type="body" idx="1"/>
+          </p:nvPr>
+        </p:nvSpPr>
+        <p:spPr/>
+        <p:txBody>
+          <a:bodyPr/>
+          <a:lstStyle/>
+          <a:p>
+            <a:r>
+              <a:rPr lang="en-US" dirty="0"/>
+              <a:t/>
+            </a:r>
+            <a:endParaRPr lang="en-US" dirty="0"/>
+          </a:p>
+        </p:txBody>
+      </p:sp>
+      <p:sp>
+        <p:nvSpPr>
+          <p:cNvPr id="4" name="Slide Number Placeholder 3"/>
+          <p:cNvSpPr>
+            <a:spLocks noGrp="1"/>
+          </p:cNvSpPr>
+          <p:nvPr>
+            <p:ph type="sldNum" sz="quarter" idx="10"/>
+          </p:nvPr>
+        </p:nvSpPr>
+        <p:spPr/>
+        <p:txBody>
+          <a:bodyPr/>
+          <a:lstStyle/>
+          <a:p>
+            <a:fld id="{F7021451-1387-4CA6-816F-3879F97B5CBC}" type="slidenum">
+              <a:rPr lang="en-US"/>
+              <a:t>36</a:t>
             </a:fld>
             <a:endParaRPr lang="en-US"/>
           </a:p>
@@ -2494,6 +4007,58 @@
           </a:prstGeom>
         </p:spPr>
       </p:pic>
+      <p:pic>
+        <p:nvPicPr>
+          <p:cNvPr id="3" name="Image 1" descr="preencoded.png">
+            <a:hlinkClick r:id="rId3" tooltip="https://github.com/samquansah-algo/nbc-vct/blob/main/brand/NBC_Brand_Guide.pdf"/>
+          </p:cNvPr>
+          <p:cNvPicPr>
+            <a:picLocks noChangeAspect="1"/>
+          </p:cNvPicPr>
+          <p:nvPr/>
+        </p:nvPicPr>
+        <p:blipFill>
+          <a:blip r:embed="rId2"/>
+          <a:stretch>
+            <a:fillRect/>
+          </a:stretch>
+        </p:blipFill>
+        <p:spPr>
+          <a:xfrm>
+            <a:off x="457200" y="4429125"/>
+            <a:ext cx="1104900" cy="142875"/>
+          </a:xfrm>
+          <a:prstGeom prst="rect">
+            <a:avLst/>
+          </a:prstGeom>
+        </p:spPr>
+      </p:pic>
+      <p:pic>
+        <p:nvPicPr>
+          <p:cNvPr id="4" name="Image 2" descr="preencoded.png">
+            <a:hlinkClick r:id="rId5" tooltip="https://github.com/samquansah-algo/nbc-vct/tree/main/weekly-tactics/04-sales/"/>
+          </p:cNvPr>
+          <p:cNvPicPr>
+            <a:picLocks noChangeAspect="1"/>
+          </p:cNvPicPr>
+          <p:nvPr/>
+        </p:nvPicPr>
+        <p:blipFill>
+          <a:blip r:embed="rId4"/>
+          <a:stretch>
+            <a:fillRect/>
+          </a:stretch>
+        </p:blipFill>
+        <p:spPr>
+          <a:xfrm>
+            <a:off x="1704975" y="4429125"/>
+            <a:ext cx="2262187" cy="142875"/>
+          </a:xfrm>
+          <a:prstGeom prst="rect">
+            <a:avLst/>
+          </a:prstGeom>
+        </p:spPr>
+      </p:pic>
     </p:spTree>
   </p:cSld>
   <p:clrMapOvr>
@@ -2546,7 +4111,7 @@
       <p:pic>
         <p:nvPicPr>
           <p:cNvPr id="3" name="Image 1" descr="preencoded.png">
-            <a:hlinkClick r:id="rId3" tooltip="https://github.com/samquansah-algo/nbc-vct/blob/main/weekly-tactics/04-sales/OUTREACH_KIT.md"/>
+            <a:hlinkClick r:id="rId3" tooltip="https://github.com/samquansah-algo/nbc-vct/blob/main/weekly-tactics/03-persona-ads/README.md"/>
           </p:cNvPr>
           <p:cNvPicPr>
             <a:picLocks noChangeAspect="1"/>
@@ -2561,8 +4126,8 @@
         </p:blipFill>
         <p:spPr>
           <a:xfrm>
-            <a:off x="4781550" y="4824412"/>
-            <a:ext cx="495300" cy="109537"/>
+            <a:off x="4719638" y="4824412"/>
+            <a:ext cx="376238" cy="109537"/>
           </a:xfrm>
           <a:prstGeom prst="rect">
             <a:avLst/>
@@ -2587,7 +4152,7 @@
         </p:blipFill>
         <p:spPr>
           <a:xfrm>
-            <a:off x="5338762" y="4824412"/>
+            <a:off x="5157788" y="4824412"/>
             <a:ext cx="642938" cy="109537"/>
           </a:xfrm>
           <a:prstGeom prst="rect">
@@ -2647,7 +4212,7 @@
       <p:pic>
         <p:nvPicPr>
           <p:cNvPr id="3" name="Image 1" descr="preencoded.png">
-            <a:hlinkClick r:id="rId3" tooltip="https://github.com/samquansah-algo/nbc-vct/blob/main/weekly-tactics/04-sales/OUTREACH_KIT.md"/>
+            <a:hlinkClick r:id="rId3" tooltip="https://github.com/samquansah-algo/nbc-vct/blob/main/weekly-tactics/03-persona-ads/README.md"/>
           </p:cNvPr>
           <p:cNvPicPr>
             <a:picLocks noChangeAspect="1"/>
@@ -2662,8 +4227,8 @@
         </p:blipFill>
         <p:spPr>
           <a:xfrm>
-            <a:off x="4781550" y="4824412"/>
-            <a:ext cx="495300" cy="109537"/>
+            <a:off x="4719638" y="4824412"/>
+            <a:ext cx="376238" cy="109537"/>
           </a:xfrm>
           <a:prstGeom prst="rect">
             <a:avLst/>
@@ -2688,7 +4253,7 @@
         </p:blipFill>
         <p:spPr>
           <a:xfrm>
-            <a:off x="5338762" y="4824412"/>
+            <a:off x="5157788" y="4824412"/>
             <a:ext cx="642938" cy="109537"/>
           </a:xfrm>
           <a:prstGeom prst="rect">
@@ -2748,7 +4313,7 @@
       <p:pic>
         <p:nvPicPr>
           <p:cNvPr id="3" name="Image 1" descr="preencoded.png">
-            <a:hlinkClick r:id="rId3" tooltip="https://github.com/samquansah-algo/nbc-vct/blob/main/weekly-tactics/04-sales/OUTREACH_KIT.md"/>
+            <a:hlinkClick r:id="rId3" tooltip="https://github.com/samquansah-algo/nbc-vct/blob/main/weekly-tactics/03-persona-ads/README.md"/>
           </p:cNvPr>
           <p:cNvPicPr>
             <a:picLocks noChangeAspect="1"/>
@@ -2763,8 +4328,8 @@
         </p:blipFill>
         <p:spPr>
           <a:xfrm>
-            <a:off x="4781550" y="4824412"/>
-            <a:ext cx="495300" cy="109537"/>
+            <a:off x="4719638" y="4824412"/>
+            <a:ext cx="376238" cy="109537"/>
           </a:xfrm>
           <a:prstGeom prst="rect">
             <a:avLst/>
@@ -2789,7 +4354,7 @@
         </p:blipFill>
         <p:spPr>
           <a:xfrm>
-            <a:off x="5338762" y="4824412"/>
+            <a:off x="5157788" y="4824412"/>
             <a:ext cx="642938" cy="109537"/>
           </a:xfrm>
           <a:prstGeom prst="rect">
@@ -2849,7 +4414,7 @@
       <p:pic>
         <p:nvPicPr>
           <p:cNvPr id="3" name="Image 1" descr="preencoded.png">
-            <a:hlinkClick r:id="rId3" tooltip="https://github.com/samquansah-algo/nbc-vct/blob/main/weekly-tactics/04-sales/OUTREACH_KIT.md"/>
+            <a:hlinkClick r:id="rId3" tooltip="https://github.com/samquansah-algo/nbc-vct/blob/main/brand/NBC_Brand_Guide.pdf"/>
           </p:cNvPr>
           <p:cNvPicPr>
             <a:picLocks noChangeAspect="1"/>
@@ -2864,33 +4429,7 @@
         </p:blipFill>
         <p:spPr>
           <a:xfrm>
-            <a:off x="4781550" y="4824412"/>
-            <a:ext cx="495300" cy="109537"/>
-          </a:xfrm>
-          <a:prstGeom prst="rect">
-            <a:avLst/>
-          </a:prstGeom>
-        </p:spPr>
-      </p:pic>
-      <p:pic>
-        <p:nvPicPr>
-          <p:cNvPr id="4" name="Image 2" descr="preencoded.png">
-            <a:hlinkClick r:id="rId5" tooltip="https://github.com/samquansah-algo/nbc-vct/blob/main/brand/NBC_Brand_Guide.pdf"/>
-          </p:cNvPr>
-          <p:cNvPicPr>
-            <a:picLocks noChangeAspect="1"/>
-          </p:cNvPicPr>
-          <p:nvPr/>
-        </p:nvPicPr>
-        <p:blipFill>
-          <a:blip r:embed="rId4"/>
-          <a:stretch>
-            <a:fillRect/>
-          </a:stretch>
-        </p:blipFill>
-        <p:spPr>
-          <a:xfrm>
-            <a:off x="5338762" y="4824412"/>
+            <a:off x="4938712" y="4824412"/>
             <a:ext cx="642938" cy="109537"/>
           </a:xfrm>
           <a:prstGeom prst="rect">
@@ -2950,7 +4489,7 @@
       <p:pic>
         <p:nvPicPr>
           <p:cNvPr id="3" name="Image 1" descr="preencoded.png">
-            <a:hlinkClick r:id="rId3" tooltip="https://github.com/samquansah-algo/nbc-vct/blob/main/marketing/crm/README.md"/>
+            <a:hlinkClick r:id="rId3" tooltip="https://github.com/samquansah-algo/nbc-vct/blob/main/weekly-tactics/04-sales/README.md"/>
           </p:cNvPr>
           <p:cNvPicPr>
             <a:picLocks noChangeAspect="1"/>
@@ -2965,8 +4504,8 @@
         </p:blipFill>
         <p:spPr>
           <a:xfrm>
-            <a:off x="4938712" y="4824412"/>
-            <a:ext cx="180975" cy="109537"/>
+            <a:off x="4748213" y="4824412"/>
+            <a:ext cx="319088" cy="109537"/>
           </a:xfrm>
           <a:prstGeom prst="rect">
             <a:avLst/>
@@ -2991,7 +4530,7 @@
         </p:blipFill>
         <p:spPr>
           <a:xfrm>
-            <a:off x="5181600" y="4824412"/>
+            <a:off x="5129213" y="4824412"/>
             <a:ext cx="642938" cy="109537"/>
           </a:xfrm>
           <a:prstGeom prst="rect">
@@ -3051,7 +4590,7 @@
       <p:pic>
         <p:nvPicPr>
           <p:cNvPr id="3" name="Image 1" descr="preencoded.png">
-            <a:hlinkClick r:id="rId3" tooltip="https://github.com/samquansah-algo/nbc-vct/blob/main/marketing/crm/README.md"/>
+            <a:hlinkClick r:id="rId3" tooltip="https://github.com/samquansah-algo/nbc-vct/blob/main/weekly-tactics/04-sales/README.md"/>
           </p:cNvPr>
           <p:cNvPicPr>
             <a:picLocks noChangeAspect="1"/>
@@ -3066,8 +4605,8 @@
         </p:blipFill>
         <p:spPr>
           <a:xfrm>
-            <a:off x="4938712" y="4824412"/>
-            <a:ext cx="180975" cy="109537"/>
+            <a:off x="4748213" y="4824412"/>
+            <a:ext cx="319088" cy="109537"/>
           </a:xfrm>
           <a:prstGeom prst="rect">
             <a:avLst/>
@@ -3092,7 +4631,7 @@
         </p:blipFill>
         <p:spPr>
           <a:xfrm>
-            <a:off x="5181600" y="4824412"/>
+            <a:off x="5129213" y="4824412"/>
             <a:ext cx="642938" cy="109537"/>
           </a:xfrm>
           <a:prstGeom prst="rect">
@@ -3152,7 +4691,7 @@
       <p:pic>
         <p:nvPicPr>
           <p:cNvPr id="3" name="Image 1" descr="preencoded.png">
-            <a:hlinkClick r:id="rId3" tooltip="https://github.com/samquansah-algo/nbc-vct/blob/main/weekly-tactics/04-sales/OUTREACH_KIT.md"/>
+            <a:hlinkClick r:id="rId3" tooltip="https://github.com/samquansah-algo/nbc-vct/blob/main/weekly-tactics/04-sales/README.md"/>
           </p:cNvPr>
           <p:cNvPicPr>
             <a:picLocks noChangeAspect="1"/>
@@ -3167,8 +4706,8 @@
         </p:blipFill>
         <p:spPr>
           <a:xfrm>
-            <a:off x="4781550" y="4824412"/>
-            <a:ext cx="495300" cy="109537"/>
+            <a:off x="4748213" y="4824412"/>
+            <a:ext cx="319088" cy="109537"/>
           </a:xfrm>
           <a:prstGeom prst="rect">
             <a:avLst/>
@@ -3193,7 +4732,7 @@
         </p:blipFill>
         <p:spPr>
           <a:xfrm>
-            <a:off x="5338762" y="4824412"/>
+            <a:off x="5129213" y="4824412"/>
             <a:ext cx="642938" cy="109537"/>
           </a:xfrm>
           <a:prstGeom prst="rect">
@@ -3253,7 +4792,7 @@
       <p:pic>
         <p:nvPicPr>
           <p:cNvPr id="3" name="Image 1" descr="preencoded.png">
-            <a:hlinkClick r:id="rId3" tooltip="https://github.com/samquansah-algo/nbc-vct/blob/main/thesis/v6-capability-layer/THESIS.md"/>
+            <a:hlinkClick r:id="rId3" tooltip="https://github.com/samquansah-algo/nbc-vct/blob/main/weekly-tactics/04-sales/README.md"/>
           </p:cNvPr>
           <p:cNvPicPr>
             <a:picLocks noChangeAspect="1"/>
@@ -3268,8 +4807,8 @@
         </p:blipFill>
         <p:spPr>
           <a:xfrm>
-            <a:off x="4850606" y="4824412"/>
-            <a:ext cx="357188" cy="109537"/>
+            <a:off x="4748213" y="4824412"/>
+            <a:ext cx="319088" cy="109537"/>
           </a:xfrm>
           <a:prstGeom prst="rect">
             <a:avLst/>
@@ -3294,7 +4833,7 @@
         </p:blipFill>
         <p:spPr>
           <a:xfrm>
-            <a:off x="5269706" y="4824412"/>
+            <a:off x="5129213" y="4824412"/>
             <a:ext cx="642938" cy="109537"/>
           </a:xfrm>
           <a:prstGeom prst="rect">
@@ -3354,7 +4893,7 @@
       <p:pic>
         <p:nvPicPr>
           <p:cNvPr id="3" name="Image 1" descr="preencoded.png">
-            <a:hlinkClick r:id="rId3" tooltip="https://github.com/samquansah-algo/nbc-vct/blob/main/thesis/v6-capability-layer/THESIS.md"/>
+            <a:hlinkClick r:id="rId3" tooltip="https://github.com/samquansah-algo/nbc-vct/blob/main/weekly-tactics/04-sales/README.md"/>
           </p:cNvPr>
           <p:cNvPicPr>
             <a:picLocks noChangeAspect="1"/>
@@ -3369,8 +4908,8 @@
         </p:blipFill>
         <p:spPr>
           <a:xfrm>
-            <a:off x="4850606" y="4824412"/>
-            <a:ext cx="357188" cy="109537"/>
+            <a:off x="4748213" y="4824412"/>
+            <a:ext cx="319088" cy="109537"/>
           </a:xfrm>
           <a:prstGeom prst="rect">
             <a:avLst/>
@@ -3395,7 +4934,7 @@
         </p:blipFill>
         <p:spPr>
           <a:xfrm>
-            <a:off x="5269706" y="4824412"/>
+            <a:off x="5129213" y="4824412"/>
             <a:ext cx="642938" cy="109537"/>
           </a:xfrm>
           <a:prstGeom prst="rect">
@@ -3455,7 +4994,7 @@
       <p:pic>
         <p:nvPicPr>
           <p:cNvPr id="3" name="Image 1" descr="preencoded.png">
-            <a:hlinkClick r:id="rId3" tooltip="https://github.com/samquansah-algo/nbc-vct/blob/main/thesis/v6-capability-layer/THESIS.md"/>
+            <a:hlinkClick r:id="rId3" tooltip="https://github.com/samquansah-algo/nbc-vct/blob/main/weekly-tactics/04-sales/README.md"/>
           </p:cNvPr>
           <p:cNvPicPr>
             <a:picLocks noChangeAspect="1"/>
@@ -3470,8 +5009,8 @@
         </p:blipFill>
         <p:spPr>
           <a:xfrm>
-            <a:off x="4850606" y="4824412"/>
-            <a:ext cx="357188" cy="109537"/>
+            <a:off x="4748213" y="4824412"/>
+            <a:ext cx="319088" cy="109537"/>
           </a:xfrm>
           <a:prstGeom prst="rect">
             <a:avLst/>
@@ -3496,7 +5035,7 @@
         </p:blipFill>
         <p:spPr>
           <a:xfrm>
-            <a:off x="5269706" y="4824412"/>
+            <a:off x="5129213" y="4824412"/>
             <a:ext cx="642938" cy="109537"/>
           </a:xfrm>
           <a:prstGeom prst="rect">
@@ -3571,7 +5110,7 @@
         </p:blipFill>
         <p:spPr>
           <a:xfrm>
-            <a:off x="4874419" y="4824412"/>
+            <a:off x="4752975" y="4824412"/>
             <a:ext cx="357188" cy="109537"/>
           </a:xfrm>
           <a:prstGeom prst="rect">
@@ -3597,7 +5136,939 @@
         </p:blipFill>
         <p:spPr>
           <a:xfrm>
-            <a:off x="5293519" y="4824412"/>
+            <a:off x="5172075" y="4824412"/>
+            <a:ext cx="642938" cy="109537"/>
+          </a:xfrm>
+          <a:prstGeom prst="rect">
+            <a:avLst/>
+          </a:prstGeom>
+        </p:spPr>
+      </p:pic>
+    </p:spTree>
+  </p:cSld>
+  <p:clrMapOvr>
+    <a:masterClrMapping/>
+  </p:clrMapOvr>
+</p:sld>
+</file>
+
+<file path=ppt/slides/slide20.xml><?xml version="1.0" encoding="utf-8"?>
+<p:sld xmlns:a="http://schemas.openxmlformats.org/drawingml/2006/main" xmlns:r="http://schemas.openxmlformats.org/officeDocument/2006/relationships" xmlns:p="http://schemas.openxmlformats.org/presentationml/2006/main">
+  <p:cSld name="Slide 20">
+    <p:spTree>
+      <p:nvGrpSpPr>
+        <p:cNvPr id="1" name=""/>
+        <p:cNvGrpSpPr/>
+        <p:nvPr/>
+      </p:nvGrpSpPr>
+      <p:grpSpPr>
+        <a:xfrm>
+          <a:off x="0" y="0"/>
+          <a:ext cx="0" cy="0"/>
+          <a:chOff x="0" y="0"/>
+          <a:chExt cx="0" cy="0"/>
+        </a:xfrm>
+      </p:grpSpPr>
+      <p:pic>
+        <p:nvPicPr>
+          <p:cNvPr id="2" name="Image 0" descr="NBC sales tactic slide 20">    </p:cNvPr>
+          <p:cNvPicPr>
+            <a:picLocks noChangeAspect="1"/>
+          </p:cNvPicPr>
+          <p:nvPr/>
+        </p:nvPicPr>
+        <p:blipFill>
+          <a:blip r:embed="rId1"/>
+          <a:stretch>
+            <a:fillRect/>
+          </a:stretch>
+        </p:blipFill>
+        <p:spPr>
+          <a:xfrm>
+            <a:off x="0" y="0"/>
+            <a:ext cx="9144000" cy="5143500"/>
+          </a:xfrm>
+          <a:prstGeom prst="rect">
+            <a:avLst/>
+          </a:prstGeom>
+        </p:spPr>
+      </p:pic>
+      <p:pic>
+        <p:nvPicPr>
+          <p:cNvPr id="3" name="Image 1" descr="preencoded.png">
+            <a:hlinkClick r:id="rId3" tooltip="https://github.com/samquansah-algo/nbc-vct/blob/main/brand/NBC_Brand_Guide.pdf"/>
+          </p:cNvPr>
+          <p:cNvPicPr>
+            <a:picLocks noChangeAspect="1"/>
+          </p:cNvPicPr>
+          <p:nvPr/>
+        </p:nvPicPr>
+        <p:blipFill>
+          <a:blip r:embed="rId2"/>
+          <a:stretch>
+            <a:fillRect/>
+          </a:stretch>
+        </p:blipFill>
+        <p:spPr>
+          <a:xfrm>
+            <a:off x="4938712" y="4824412"/>
+            <a:ext cx="642938" cy="109537"/>
+          </a:xfrm>
+          <a:prstGeom prst="rect">
+            <a:avLst/>
+          </a:prstGeom>
+        </p:spPr>
+      </p:pic>
+    </p:spTree>
+  </p:cSld>
+  <p:clrMapOvr>
+    <a:masterClrMapping/>
+  </p:clrMapOvr>
+</p:sld>
+</file>
+
+<file path=ppt/slides/slide21.xml><?xml version="1.0" encoding="utf-8"?>
+<p:sld xmlns:a="http://schemas.openxmlformats.org/drawingml/2006/main" xmlns:r="http://schemas.openxmlformats.org/officeDocument/2006/relationships" xmlns:p="http://schemas.openxmlformats.org/presentationml/2006/main">
+  <p:cSld name="Slide 21">
+    <p:spTree>
+      <p:nvGrpSpPr>
+        <p:cNvPr id="1" name=""/>
+        <p:cNvGrpSpPr/>
+        <p:nvPr/>
+      </p:nvGrpSpPr>
+      <p:grpSpPr>
+        <a:xfrm>
+          <a:off x="0" y="0"/>
+          <a:ext cx="0" cy="0"/>
+          <a:chOff x="0" y="0"/>
+          <a:chExt cx="0" cy="0"/>
+        </a:xfrm>
+      </p:grpSpPr>
+      <p:pic>
+        <p:nvPicPr>
+          <p:cNvPr id="2" name="Image 0" descr="NBC sales tactic slide 21">    </p:cNvPr>
+          <p:cNvPicPr>
+            <a:picLocks noChangeAspect="1"/>
+          </p:cNvPicPr>
+          <p:nvPr/>
+        </p:nvPicPr>
+        <p:blipFill>
+          <a:blip r:embed="rId1"/>
+          <a:stretch>
+            <a:fillRect/>
+          </a:stretch>
+        </p:blipFill>
+        <p:spPr>
+          <a:xfrm>
+            <a:off x="0" y="0"/>
+            <a:ext cx="9144000" cy="5143500"/>
+          </a:xfrm>
+          <a:prstGeom prst="rect">
+            <a:avLst/>
+          </a:prstGeom>
+        </p:spPr>
+      </p:pic>
+      <p:pic>
+        <p:nvPicPr>
+          <p:cNvPr id="3" name="Image 1" descr="preencoded.png">
+            <a:hlinkClick r:id="rId3" tooltip="https://github.com/samquansah-algo/nbc-vct/blob/main/weekly-tactics/04-sales/OUTREACH_KIT.md"/>
+          </p:cNvPr>
+          <p:cNvPicPr>
+            <a:picLocks noChangeAspect="1"/>
+          </p:cNvPicPr>
+          <p:nvPr/>
+        </p:nvPicPr>
+        <p:blipFill>
+          <a:blip r:embed="rId2"/>
+          <a:stretch>
+            <a:fillRect/>
+          </a:stretch>
+        </p:blipFill>
+        <p:spPr>
+          <a:xfrm>
+            <a:off x="4660106" y="4824412"/>
+            <a:ext cx="495300" cy="109537"/>
+          </a:xfrm>
+          <a:prstGeom prst="rect">
+            <a:avLst/>
+          </a:prstGeom>
+        </p:spPr>
+      </p:pic>
+      <p:pic>
+        <p:nvPicPr>
+          <p:cNvPr id="4" name="Image 2" descr="preencoded.png">
+            <a:hlinkClick r:id="rId5" tooltip="https://github.com/samquansah-algo/nbc-vct/blob/main/brand/NBC_Brand_Guide.pdf"/>
+          </p:cNvPr>
+          <p:cNvPicPr>
+            <a:picLocks noChangeAspect="1"/>
+          </p:cNvPicPr>
+          <p:nvPr/>
+        </p:nvPicPr>
+        <p:blipFill>
+          <a:blip r:embed="rId4"/>
+          <a:stretch>
+            <a:fillRect/>
+          </a:stretch>
+        </p:blipFill>
+        <p:spPr>
+          <a:xfrm>
+            <a:off x="5217319" y="4824412"/>
+            <a:ext cx="642938" cy="109537"/>
+          </a:xfrm>
+          <a:prstGeom prst="rect">
+            <a:avLst/>
+          </a:prstGeom>
+        </p:spPr>
+      </p:pic>
+    </p:spTree>
+  </p:cSld>
+  <p:clrMapOvr>
+    <a:masterClrMapping/>
+  </p:clrMapOvr>
+</p:sld>
+</file>
+
+<file path=ppt/slides/slide22.xml><?xml version="1.0" encoding="utf-8"?>
+<p:sld xmlns:a="http://schemas.openxmlformats.org/drawingml/2006/main" xmlns:r="http://schemas.openxmlformats.org/officeDocument/2006/relationships" xmlns:p="http://schemas.openxmlformats.org/presentationml/2006/main">
+  <p:cSld name="Slide 22">
+    <p:spTree>
+      <p:nvGrpSpPr>
+        <p:cNvPr id="1" name=""/>
+        <p:cNvGrpSpPr/>
+        <p:nvPr/>
+      </p:nvGrpSpPr>
+      <p:grpSpPr>
+        <a:xfrm>
+          <a:off x="0" y="0"/>
+          <a:ext cx="0" cy="0"/>
+          <a:chOff x="0" y="0"/>
+          <a:chExt cx="0" cy="0"/>
+        </a:xfrm>
+      </p:grpSpPr>
+      <p:pic>
+        <p:nvPicPr>
+          <p:cNvPr id="2" name="Image 0" descr="NBC sales tactic slide 22">    </p:cNvPr>
+          <p:cNvPicPr>
+            <a:picLocks noChangeAspect="1"/>
+          </p:cNvPicPr>
+          <p:nvPr/>
+        </p:nvPicPr>
+        <p:blipFill>
+          <a:blip r:embed="rId1"/>
+          <a:stretch>
+            <a:fillRect/>
+          </a:stretch>
+        </p:blipFill>
+        <p:spPr>
+          <a:xfrm>
+            <a:off x="0" y="0"/>
+            <a:ext cx="9144000" cy="5143500"/>
+          </a:xfrm>
+          <a:prstGeom prst="rect">
+            <a:avLst/>
+          </a:prstGeom>
+        </p:spPr>
+      </p:pic>
+      <p:pic>
+        <p:nvPicPr>
+          <p:cNvPr id="3" name="Image 1" descr="preencoded.png">
+            <a:hlinkClick r:id="rId3" tooltip="https://github.com/samquansah-algo/nbc-vct/blob/main/weekly-tactics/04-sales/OUTREACH_KIT.md"/>
+          </p:cNvPr>
+          <p:cNvPicPr>
+            <a:picLocks noChangeAspect="1"/>
+          </p:cNvPicPr>
+          <p:nvPr/>
+        </p:nvPicPr>
+        <p:blipFill>
+          <a:blip r:embed="rId2"/>
+          <a:stretch>
+            <a:fillRect/>
+          </a:stretch>
+        </p:blipFill>
+        <p:spPr>
+          <a:xfrm>
+            <a:off x="4660106" y="4824412"/>
+            <a:ext cx="495300" cy="109537"/>
+          </a:xfrm>
+          <a:prstGeom prst="rect">
+            <a:avLst/>
+          </a:prstGeom>
+        </p:spPr>
+      </p:pic>
+      <p:pic>
+        <p:nvPicPr>
+          <p:cNvPr id="4" name="Image 2" descr="preencoded.png">
+            <a:hlinkClick r:id="rId5" tooltip="https://github.com/samquansah-algo/nbc-vct/blob/main/brand/NBC_Brand_Guide.pdf"/>
+          </p:cNvPr>
+          <p:cNvPicPr>
+            <a:picLocks noChangeAspect="1"/>
+          </p:cNvPicPr>
+          <p:nvPr/>
+        </p:nvPicPr>
+        <p:blipFill>
+          <a:blip r:embed="rId4"/>
+          <a:stretch>
+            <a:fillRect/>
+          </a:stretch>
+        </p:blipFill>
+        <p:spPr>
+          <a:xfrm>
+            <a:off x="5217319" y="4824412"/>
+            <a:ext cx="642938" cy="109537"/>
+          </a:xfrm>
+          <a:prstGeom prst="rect">
+            <a:avLst/>
+          </a:prstGeom>
+        </p:spPr>
+      </p:pic>
+    </p:spTree>
+  </p:cSld>
+  <p:clrMapOvr>
+    <a:masterClrMapping/>
+  </p:clrMapOvr>
+</p:sld>
+</file>
+
+<file path=ppt/slides/slide23.xml><?xml version="1.0" encoding="utf-8"?>
+<p:sld xmlns:a="http://schemas.openxmlformats.org/drawingml/2006/main" xmlns:r="http://schemas.openxmlformats.org/officeDocument/2006/relationships" xmlns:p="http://schemas.openxmlformats.org/presentationml/2006/main">
+  <p:cSld name="Slide 23">
+    <p:spTree>
+      <p:nvGrpSpPr>
+        <p:cNvPr id="1" name=""/>
+        <p:cNvGrpSpPr/>
+        <p:nvPr/>
+      </p:nvGrpSpPr>
+      <p:grpSpPr>
+        <a:xfrm>
+          <a:off x="0" y="0"/>
+          <a:ext cx="0" cy="0"/>
+          <a:chOff x="0" y="0"/>
+          <a:chExt cx="0" cy="0"/>
+        </a:xfrm>
+      </p:grpSpPr>
+      <p:pic>
+        <p:nvPicPr>
+          <p:cNvPr id="2" name="Image 0" descr="NBC sales tactic slide 23">    </p:cNvPr>
+          <p:cNvPicPr>
+            <a:picLocks noChangeAspect="1"/>
+          </p:cNvPicPr>
+          <p:nvPr/>
+        </p:nvPicPr>
+        <p:blipFill>
+          <a:blip r:embed="rId1"/>
+          <a:stretch>
+            <a:fillRect/>
+          </a:stretch>
+        </p:blipFill>
+        <p:spPr>
+          <a:xfrm>
+            <a:off x="0" y="0"/>
+            <a:ext cx="9144000" cy="5143500"/>
+          </a:xfrm>
+          <a:prstGeom prst="rect">
+            <a:avLst/>
+          </a:prstGeom>
+        </p:spPr>
+      </p:pic>
+      <p:pic>
+        <p:nvPicPr>
+          <p:cNvPr id="3" name="Image 1" descr="preencoded.png">
+            <a:hlinkClick r:id="rId3" tooltip="https://github.com/samquansah-algo/nbc-vct/blob/main/weekly-tactics/04-sales/OUTREACH_KIT.md"/>
+          </p:cNvPr>
+          <p:cNvPicPr>
+            <a:picLocks noChangeAspect="1"/>
+          </p:cNvPicPr>
+          <p:nvPr/>
+        </p:nvPicPr>
+        <p:blipFill>
+          <a:blip r:embed="rId2"/>
+          <a:stretch>
+            <a:fillRect/>
+          </a:stretch>
+        </p:blipFill>
+        <p:spPr>
+          <a:xfrm>
+            <a:off x="4660106" y="4824412"/>
+            <a:ext cx="495300" cy="109537"/>
+          </a:xfrm>
+          <a:prstGeom prst="rect">
+            <a:avLst/>
+          </a:prstGeom>
+        </p:spPr>
+      </p:pic>
+      <p:pic>
+        <p:nvPicPr>
+          <p:cNvPr id="4" name="Image 2" descr="preencoded.png">
+            <a:hlinkClick r:id="rId5" tooltip="https://github.com/samquansah-algo/nbc-vct/blob/main/brand/NBC_Brand_Guide.pdf"/>
+          </p:cNvPr>
+          <p:cNvPicPr>
+            <a:picLocks noChangeAspect="1"/>
+          </p:cNvPicPr>
+          <p:nvPr/>
+        </p:nvPicPr>
+        <p:blipFill>
+          <a:blip r:embed="rId4"/>
+          <a:stretch>
+            <a:fillRect/>
+          </a:stretch>
+        </p:blipFill>
+        <p:spPr>
+          <a:xfrm>
+            <a:off x="5217319" y="4824412"/>
+            <a:ext cx="642938" cy="109537"/>
+          </a:xfrm>
+          <a:prstGeom prst="rect">
+            <a:avLst/>
+          </a:prstGeom>
+        </p:spPr>
+      </p:pic>
+    </p:spTree>
+  </p:cSld>
+  <p:clrMapOvr>
+    <a:masterClrMapping/>
+  </p:clrMapOvr>
+</p:sld>
+</file>
+
+<file path=ppt/slides/slide24.xml><?xml version="1.0" encoding="utf-8"?>
+<p:sld xmlns:a="http://schemas.openxmlformats.org/drawingml/2006/main" xmlns:r="http://schemas.openxmlformats.org/officeDocument/2006/relationships" xmlns:p="http://schemas.openxmlformats.org/presentationml/2006/main">
+  <p:cSld name="Slide 24">
+    <p:spTree>
+      <p:nvGrpSpPr>
+        <p:cNvPr id="1" name=""/>
+        <p:cNvGrpSpPr/>
+        <p:nvPr/>
+      </p:nvGrpSpPr>
+      <p:grpSpPr>
+        <a:xfrm>
+          <a:off x="0" y="0"/>
+          <a:ext cx="0" cy="0"/>
+          <a:chOff x="0" y="0"/>
+          <a:chExt cx="0" cy="0"/>
+        </a:xfrm>
+      </p:grpSpPr>
+      <p:pic>
+        <p:nvPicPr>
+          <p:cNvPr id="2" name="Image 0" descr="NBC sales tactic slide 24">    </p:cNvPr>
+          <p:cNvPicPr>
+            <a:picLocks noChangeAspect="1"/>
+          </p:cNvPicPr>
+          <p:nvPr/>
+        </p:nvPicPr>
+        <p:blipFill>
+          <a:blip r:embed="rId1"/>
+          <a:stretch>
+            <a:fillRect/>
+          </a:stretch>
+        </p:blipFill>
+        <p:spPr>
+          <a:xfrm>
+            <a:off x="0" y="0"/>
+            <a:ext cx="9144000" cy="5143500"/>
+          </a:xfrm>
+          <a:prstGeom prst="rect">
+            <a:avLst/>
+          </a:prstGeom>
+        </p:spPr>
+      </p:pic>
+      <p:pic>
+        <p:nvPicPr>
+          <p:cNvPr id="3" name="Image 1" descr="preencoded.png">
+            <a:hlinkClick r:id="rId3" tooltip="https://github.com/samquansah-algo/nbc-vct/blob/main/weekly-tactics/04-sales/OUTREACH_KIT.md"/>
+          </p:cNvPr>
+          <p:cNvPicPr>
+            <a:picLocks noChangeAspect="1"/>
+          </p:cNvPicPr>
+          <p:nvPr/>
+        </p:nvPicPr>
+        <p:blipFill>
+          <a:blip r:embed="rId2"/>
+          <a:stretch>
+            <a:fillRect/>
+          </a:stretch>
+        </p:blipFill>
+        <p:spPr>
+          <a:xfrm>
+            <a:off x="4660106" y="4824412"/>
+            <a:ext cx="495300" cy="109537"/>
+          </a:xfrm>
+          <a:prstGeom prst="rect">
+            <a:avLst/>
+          </a:prstGeom>
+        </p:spPr>
+      </p:pic>
+      <p:pic>
+        <p:nvPicPr>
+          <p:cNvPr id="4" name="Image 2" descr="preencoded.png">
+            <a:hlinkClick r:id="rId5" tooltip="https://github.com/samquansah-algo/nbc-vct/blob/main/brand/NBC_Brand_Guide.pdf"/>
+          </p:cNvPr>
+          <p:cNvPicPr>
+            <a:picLocks noChangeAspect="1"/>
+          </p:cNvPicPr>
+          <p:nvPr/>
+        </p:nvPicPr>
+        <p:blipFill>
+          <a:blip r:embed="rId4"/>
+          <a:stretch>
+            <a:fillRect/>
+          </a:stretch>
+        </p:blipFill>
+        <p:spPr>
+          <a:xfrm>
+            <a:off x="5217319" y="4824412"/>
+            <a:ext cx="642938" cy="109537"/>
+          </a:xfrm>
+          <a:prstGeom prst="rect">
+            <a:avLst/>
+          </a:prstGeom>
+        </p:spPr>
+      </p:pic>
+    </p:spTree>
+  </p:cSld>
+  <p:clrMapOvr>
+    <a:masterClrMapping/>
+  </p:clrMapOvr>
+</p:sld>
+</file>
+
+<file path=ppt/slides/slide25.xml><?xml version="1.0" encoding="utf-8"?>
+<p:sld xmlns:a="http://schemas.openxmlformats.org/drawingml/2006/main" xmlns:r="http://schemas.openxmlformats.org/officeDocument/2006/relationships" xmlns:p="http://schemas.openxmlformats.org/presentationml/2006/main">
+  <p:cSld name="Slide 25">
+    <p:spTree>
+      <p:nvGrpSpPr>
+        <p:cNvPr id="1" name=""/>
+        <p:cNvGrpSpPr/>
+        <p:nvPr/>
+      </p:nvGrpSpPr>
+      <p:grpSpPr>
+        <a:xfrm>
+          <a:off x="0" y="0"/>
+          <a:ext cx="0" cy="0"/>
+          <a:chOff x="0" y="0"/>
+          <a:chExt cx="0" cy="0"/>
+        </a:xfrm>
+      </p:grpSpPr>
+      <p:pic>
+        <p:nvPicPr>
+          <p:cNvPr id="2" name="Image 0" descr="NBC sales tactic slide 25">    </p:cNvPr>
+          <p:cNvPicPr>
+            <a:picLocks noChangeAspect="1"/>
+          </p:cNvPicPr>
+          <p:nvPr/>
+        </p:nvPicPr>
+        <p:blipFill>
+          <a:blip r:embed="rId1"/>
+          <a:stretch>
+            <a:fillRect/>
+          </a:stretch>
+        </p:blipFill>
+        <p:spPr>
+          <a:xfrm>
+            <a:off x="0" y="0"/>
+            <a:ext cx="9144000" cy="5143500"/>
+          </a:xfrm>
+          <a:prstGeom prst="rect">
+            <a:avLst/>
+          </a:prstGeom>
+        </p:spPr>
+      </p:pic>
+      <p:pic>
+        <p:nvPicPr>
+          <p:cNvPr id="3" name="Image 1" descr="preencoded.png">
+            <a:hlinkClick r:id="rId3" tooltip="https://github.com/samquansah-algo/nbc-vct/blob/main/brand/NBC_Brand_Guide.pdf"/>
+          </p:cNvPr>
+          <p:cNvPicPr>
+            <a:picLocks noChangeAspect="1"/>
+          </p:cNvPicPr>
+          <p:nvPr/>
+        </p:nvPicPr>
+        <p:blipFill>
+          <a:blip r:embed="rId2"/>
+          <a:stretch>
+            <a:fillRect/>
+          </a:stretch>
+        </p:blipFill>
+        <p:spPr>
+          <a:xfrm>
+            <a:off x="4938712" y="4824412"/>
+            <a:ext cx="642938" cy="109537"/>
+          </a:xfrm>
+          <a:prstGeom prst="rect">
+            <a:avLst/>
+          </a:prstGeom>
+        </p:spPr>
+      </p:pic>
+    </p:spTree>
+  </p:cSld>
+  <p:clrMapOvr>
+    <a:masterClrMapping/>
+  </p:clrMapOvr>
+</p:sld>
+</file>
+
+<file path=ppt/slides/slide26.xml><?xml version="1.0" encoding="utf-8"?>
+<p:sld xmlns:a="http://schemas.openxmlformats.org/drawingml/2006/main" xmlns:r="http://schemas.openxmlformats.org/officeDocument/2006/relationships" xmlns:p="http://schemas.openxmlformats.org/presentationml/2006/main">
+  <p:cSld name="Slide 26">
+    <p:spTree>
+      <p:nvGrpSpPr>
+        <p:cNvPr id="1" name=""/>
+        <p:cNvGrpSpPr/>
+        <p:nvPr/>
+      </p:nvGrpSpPr>
+      <p:grpSpPr>
+        <a:xfrm>
+          <a:off x="0" y="0"/>
+          <a:ext cx="0" cy="0"/>
+          <a:chOff x="0" y="0"/>
+          <a:chExt cx="0" cy="0"/>
+        </a:xfrm>
+      </p:grpSpPr>
+      <p:pic>
+        <p:nvPicPr>
+          <p:cNvPr id="2" name="Image 0" descr="NBC sales tactic slide 26">    </p:cNvPr>
+          <p:cNvPicPr>
+            <a:picLocks noChangeAspect="1"/>
+          </p:cNvPicPr>
+          <p:nvPr/>
+        </p:nvPicPr>
+        <p:blipFill>
+          <a:blip r:embed="rId1"/>
+          <a:stretch>
+            <a:fillRect/>
+          </a:stretch>
+        </p:blipFill>
+        <p:spPr>
+          <a:xfrm>
+            <a:off x="0" y="0"/>
+            <a:ext cx="9144000" cy="5143500"/>
+          </a:xfrm>
+          <a:prstGeom prst="rect">
+            <a:avLst/>
+          </a:prstGeom>
+        </p:spPr>
+      </p:pic>
+      <p:pic>
+        <p:nvPicPr>
+          <p:cNvPr id="3" name="Image 1" descr="preencoded.png">
+            <a:hlinkClick r:id="rId3" tooltip="https://github.com/samquansah-algo/nbc-vct/blob/main/weekly-tactics/04-sales/OUTREACH_KIT.md"/>
+          </p:cNvPr>
+          <p:cNvPicPr>
+            <a:picLocks noChangeAspect="1"/>
+          </p:cNvPicPr>
+          <p:nvPr/>
+        </p:nvPicPr>
+        <p:blipFill>
+          <a:blip r:embed="rId2"/>
+          <a:stretch>
+            <a:fillRect/>
+          </a:stretch>
+        </p:blipFill>
+        <p:spPr>
+          <a:xfrm>
+            <a:off x="4660106" y="4824412"/>
+            <a:ext cx="495300" cy="109537"/>
+          </a:xfrm>
+          <a:prstGeom prst="rect">
+            <a:avLst/>
+          </a:prstGeom>
+        </p:spPr>
+      </p:pic>
+      <p:pic>
+        <p:nvPicPr>
+          <p:cNvPr id="4" name="Image 2" descr="preencoded.png">
+            <a:hlinkClick r:id="rId5" tooltip="https://github.com/samquansah-algo/nbc-vct/blob/main/brand/NBC_Brand_Guide.pdf"/>
+          </p:cNvPr>
+          <p:cNvPicPr>
+            <a:picLocks noChangeAspect="1"/>
+          </p:cNvPicPr>
+          <p:nvPr/>
+        </p:nvPicPr>
+        <p:blipFill>
+          <a:blip r:embed="rId4"/>
+          <a:stretch>
+            <a:fillRect/>
+          </a:stretch>
+        </p:blipFill>
+        <p:spPr>
+          <a:xfrm>
+            <a:off x="5217319" y="4824412"/>
+            <a:ext cx="642938" cy="109537"/>
+          </a:xfrm>
+          <a:prstGeom prst="rect">
+            <a:avLst/>
+          </a:prstGeom>
+        </p:spPr>
+      </p:pic>
+    </p:spTree>
+  </p:cSld>
+  <p:clrMapOvr>
+    <a:masterClrMapping/>
+  </p:clrMapOvr>
+</p:sld>
+</file>
+
+<file path=ppt/slides/slide27.xml><?xml version="1.0" encoding="utf-8"?>
+<p:sld xmlns:a="http://schemas.openxmlformats.org/drawingml/2006/main" xmlns:r="http://schemas.openxmlformats.org/officeDocument/2006/relationships" xmlns:p="http://schemas.openxmlformats.org/presentationml/2006/main">
+  <p:cSld name="Slide 27">
+    <p:spTree>
+      <p:nvGrpSpPr>
+        <p:cNvPr id="1" name=""/>
+        <p:cNvGrpSpPr/>
+        <p:nvPr/>
+      </p:nvGrpSpPr>
+      <p:grpSpPr>
+        <a:xfrm>
+          <a:off x="0" y="0"/>
+          <a:ext cx="0" cy="0"/>
+          <a:chOff x="0" y="0"/>
+          <a:chExt cx="0" cy="0"/>
+        </a:xfrm>
+      </p:grpSpPr>
+      <p:pic>
+        <p:nvPicPr>
+          <p:cNvPr id="2" name="Image 0" descr="NBC sales tactic slide 27">    </p:cNvPr>
+          <p:cNvPicPr>
+            <a:picLocks noChangeAspect="1"/>
+          </p:cNvPicPr>
+          <p:nvPr/>
+        </p:nvPicPr>
+        <p:blipFill>
+          <a:blip r:embed="rId1"/>
+          <a:stretch>
+            <a:fillRect/>
+          </a:stretch>
+        </p:blipFill>
+        <p:spPr>
+          <a:xfrm>
+            <a:off x="0" y="0"/>
+            <a:ext cx="9144000" cy="5143500"/>
+          </a:xfrm>
+          <a:prstGeom prst="rect">
+            <a:avLst/>
+          </a:prstGeom>
+        </p:spPr>
+      </p:pic>
+      <p:pic>
+        <p:nvPicPr>
+          <p:cNvPr id="3" name="Image 1" descr="preencoded.png">
+            <a:hlinkClick r:id="rId3" tooltip="https://github.com/samquansah-algo/nbc-vct/blob/main/marketing/crm/README.md"/>
+          </p:cNvPr>
+          <p:cNvPicPr>
+            <a:picLocks noChangeAspect="1"/>
+          </p:cNvPicPr>
+          <p:nvPr/>
+        </p:nvPicPr>
+        <p:blipFill>
+          <a:blip r:embed="rId2"/>
+          <a:stretch>
+            <a:fillRect/>
+          </a:stretch>
+        </p:blipFill>
+        <p:spPr>
+          <a:xfrm>
+            <a:off x="4817269" y="4824412"/>
+            <a:ext cx="180975" cy="109537"/>
+          </a:xfrm>
+          <a:prstGeom prst="rect">
+            <a:avLst/>
+          </a:prstGeom>
+        </p:spPr>
+      </p:pic>
+      <p:pic>
+        <p:nvPicPr>
+          <p:cNvPr id="4" name="Image 2" descr="preencoded.png">
+            <a:hlinkClick r:id="rId5" tooltip="https://github.com/samquansah-algo/nbc-vct/blob/main/brand/NBC_Brand_Guide.pdf"/>
+          </p:cNvPr>
+          <p:cNvPicPr>
+            <a:picLocks noChangeAspect="1"/>
+          </p:cNvPicPr>
+          <p:nvPr/>
+        </p:nvPicPr>
+        <p:blipFill>
+          <a:blip r:embed="rId4"/>
+          <a:stretch>
+            <a:fillRect/>
+          </a:stretch>
+        </p:blipFill>
+        <p:spPr>
+          <a:xfrm>
+            <a:off x="5060156" y="4824412"/>
+            <a:ext cx="642938" cy="109537"/>
+          </a:xfrm>
+          <a:prstGeom prst="rect">
+            <a:avLst/>
+          </a:prstGeom>
+        </p:spPr>
+      </p:pic>
+    </p:spTree>
+  </p:cSld>
+  <p:clrMapOvr>
+    <a:masterClrMapping/>
+  </p:clrMapOvr>
+</p:sld>
+</file>
+
+<file path=ppt/slides/slide28.xml><?xml version="1.0" encoding="utf-8"?>
+<p:sld xmlns:a="http://schemas.openxmlformats.org/drawingml/2006/main" xmlns:r="http://schemas.openxmlformats.org/officeDocument/2006/relationships" xmlns:p="http://schemas.openxmlformats.org/presentationml/2006/main">
+  <p:cSld name="Slide 28">
+    <p:spTree>
+      <p:nvGrpSpPr>
+        <p:cNvPr id="1" name=""/>
+        <p:cNvGrpSpPr/>
+        <p:nvPr/>
+      </p:nvGrpSpPr>
+      <p:grpSpPr>
+        <a:xfrm>
+          <a:off x="0" y="0"/>
+          <a:ext cx="0" cy="0"/>
+          <a:chOff x="0" y="0"/>
+          <a:chExt cx="0" cy="0"/>
+        </a:xfrm>
+      </p:grpSpPr>
+      <p:pic>
+        <p:nvPicPr>
+          <p:cNvPr id="2" name="Image 0" descr="NBC sales tactic slide 28">    </p:cNvPr>
+          <p:cNvPicPr>
+            <a:picLocks noChangeAspect="1"/>
+          </p:cNvPicPr>
+          <p:nvPr/>
+        </p:nvPicPr>
+        <p:blipFill>
+          <a:blip r:embed="rId1"/>
+          <a:stretch>
+            <a:fillRect/>
+          </a:stretch>
+        </p:blipFill>
+        <p:spPr>
+          <a:xfrm>
+            <a:off x="0" y="0"/>
+            <a:ext cx="9144000" cy="5143500"/>
+          </a:xfrm>
+          <a:prstGeom prst="rect">
+            <a:avLst/>
+          </a:prstGeom>
+        </p:spPr>
+      </p:pic>
+      <p:pic>
+        <p:nvPicPr>
+          <p:cNvPr id="3" name="Image 1" descr="preencoded.png">
+            <a:hlinkClick r:id="rId3" tooltip="https://github.com/samquansah-algo/nbc-vct/blob/main/marketing/crm/README.md"/>
+          </p:cNvPr>
+          <p:cNvPicPr>
+            <a:picLocks noChangeAspect="1"/>
+          </p:cNvPicPr>
+          <p:nvPr/>
+        </p:nvPicPr>
+        <p:blipFill>
+          <a:blip r:embed="rId2"/>
+          <a:stretch>
+            <a:fillRect/>
+          </a:stretch>
+        </p:blipFill>
+        <p:spPr>
+          <a:xfrm>
+            <a:off x="4817269" y="4824412"/>
+            <a:ext cx="180975" cy="109537"/>
+          </a:xfrm>
+          <a:prstGeom prst="rect">
+            <a:avLst/>
+          </a:prstGeom>
+        </p:spPr>
+      </p:pic>
+      <p:pic>
+        <p:nvPicPr>
+          <p:cNvPr id="4" name="Image 2" descr="preencoded.png">
+            <a:hlinkClick r:id="rId5" tooltip="https://github.com/samquansah-algo/nbc-vct/blob/main/brand/NBC_Brand_Guide.pdf"/>
+          </p:cNvPr>
+          <p:cNvPicPr>
+            <a:picLocks noChangeAspect="1"/>
+          </p:cNvPicPr>
+          <p:nvPr/>
+        </p:nvPicPr>
+        <p:blipFill>
+          <a:blip r:embed="rId4"/>
+          <a:stretch>
+            <a:fillRect/>
+          </a:stretch>
+        </p:blipFill>
+        <p:spPr>
+          <a:xfrm>
+            <a:off x="5060156" y="4824412"/>
+            <a:ext cx="642938" cy="109537"/>
+          </a:xfrm>
+          <a:prstGeom prst="rect">
+            <a:avLst/>
+          </a:prstGeom>
+        </p:spPr>
+      </p:pic>
+    </p:spTree>
+  </p:cSld>
+  <p:clrMapOvr>
+    <a:masterClrMapping/>
+  </p:clrMapOvr>
+</p:sld>
+</file>
+
+<file path=ppt/slides/slide29.xml><?xml version="1.0" encoding="utf-8"?>
+<p:sld xmlns:a="http://schemas.openxmlformats.org/drawingml/2006/main" xmlns:r="http://schemas.openxmlformats.org/officeDocument/2006/relationships" xmlns:p="http://schemas.openxmlformats.org/presentationml/2006/main">
+  <p:cSld name="Slide 29">
+    <p:spTree>
+      <p:nvGrpSpPr>
+        <p:cNvPr id="1" name=""/>
+        <p:cNvGrpSpPr/>
+        <p:nvPr/>
+      </p:nvGrpSpPr>
+      <p:grpSpPr>
+        <a:xfrm>
+          <a:off x="0" y="0"/>
+          <a:ext cx="0" cy="0"/>
+          <a:chOff x="0" y="0"/>
+          <a:chExt cx="0" cy="0"/>
+        </a:xfrm>
+      </p:grpSpPr>
+      <p:pic>
+        <p:nvPicPr>
+          <p:cNvPr id="2" name="Image 0" descr="NBC sales tactic slide 29">    </p:cNvPr>
+          <p:cNvPicPr>
+            <a:picLocks noChangeAspect="1"/>
+          </p:cNvPicPr>
+          <p:nvPr/>
+        </p:nvPicPr>
+        <p:blipFill>
+          <a:blip r:embed="rId1"/>
+          <a:stretch>
+            <a:fillRect/>
+          </a:stretch>
+        </p:blipFill>
+        <p:spPr>
+          <a:xfrm>
+            <a:off x="0" y="0"/>
+            <a:ext cx="9144000" cy="5143500"/>
+          </a:xfrm>
+          <a:prstGeom prst="rect">
+            <a:avLst/>
+          </a:prstGeom>
+        </p:spPr>
+      </p:pic>
+      <p:pic>
+        <p:nvPicPr>
+          <p:cNvPr id="3" name="Image 1" descr="preencoded.png">
+            <a:hlinkClick r:id="rId3" tooltip="https://github.com/samquansah-algo/nbc-vct/blob/main/brand/NBC_Brand_Guide.pdf"/>
+          </p:cNvPr>
+          <p:cNvPicPr>
+            <a:picLocks noChangeAspect="1"/>
+          </p:cNvPicPr>
+          <p:nvPr/>
+        </p:nvPicPr>
+        <p:blipFill>
+          <a:blip r:embed="rId2"/>
+          <a:stretch>
+            <a:fillRect/>
+          </a:stretch>
+        </p:blipFill>
+        <p:spPr>
+          <a:xfrm>
+            <a:off x="4938712" y="4824412"/>
             <a:ext cx="642938" cy="109537"/>
           </a:xfrm>
           <a:prstGeom prst="rect">
@@ -3657,7 +6128,7 @@
       <p:pic>
         <p:nvPicPr>
           <p:cNvPr id="3" name="Image 1" descr="preencoded.png">
-            <a:hlinkClick r:id="rId3" tooltip="https://github.com/samquansah-algo/nbc-vct/blob/main/weekly-tactics/04-sales/OUTREACH_KIT.md"/>
+            <a:hlinkClick r:id="rId3" tooltip="https://github.com/samquansah-algo/nbc-vct/blob/main/weekly-tactics/01-market-research/README.md"/>
           </p:cNvPr>
           <p:cNvPicPr>
             <a:picLocks noChangeAspect="1"/>
@@ -3672,8 +6143,8 @@
         </p:blipFill>
         <p:spPr>
           <a:xfrm>
-            <a:off x="4805363" y="4824412"/>
-            <a:ext cx="495300" cy="109537"/>
+            <a:off x="4593431" y="4824412"/>
+            <a:ext cx="676275" cy="109537"/>
           </a:xfrm>
           <a:prstGeom prst="rect">
             <a:avLst/>
@@ -3698,8 +6169,767 @@
         </p:blipFill>
         <p:spPr>
           <a:xfrm>
-            <a:off x="5362575" y="4824412"/>
+            <a:off x="5331619" y="4824412"/>
             <a:ext cx="642938" cy="109537"/>
+          </a:xfrm>
+          <a:prstGeom prst="rect">
+            <a:avLst/>
+          </a:prstGeom>
+        </p:spPr>
+      </p:pic>
+    </p:spTree>
+  </p:cSld>
+  <p:clrMapOvr>
+    <a:masterClrMapping/>
+  </p:clrMapOvr>
+</p:sld>
+</file>
+
+<file path=ppt/slides/slide30.xml><?xml version="1.0" encoding="utf-8"?>
+<p:sld xmlns:a="http://schemas.openxmlformats.org/drawingml/2006/main" xmlns:r="http://schemas.openxmlformats.org/officeDocument/2006/relationships" xmlns:p="http://schemas.openxmlformats.org/presentationml/2006/main">
+  <p:cSld name="Slide 30">
+    <p:spTree>
+      <p:nvGrpSpPr>
+        <p:cNvPr id="1" name=""/>
+        <p:cNvGrpSpPr/>
+        <p:nvPr/>
+      </p:nvGrpSpPr>
+      <p:grpSpPr>
+        <a:xfrm>
+          <a:off x="0" y="0"/>
+          <a:ext cx="0" cy="0"/>
+          <a:chOff x="0" y="0"/>
+          <a:chExt cx="0" cy="0"/>
+        </a:xfrm>
+      </p:grpSpPr>
+      <p:pic>
+        <p:nvPicPr>
+          <p:cNvPr id="2" name="Image 0" descr="NBC sales tactic slide 30">    </p:cNvPr>
+          <p:cNvPicPr>
+            <a:picLocks noChangeAspect="1"/>
+          </p:cNvPicPr>
+          <p:nvPr/>
+        </p:nvPicPr>
+        <p:blipFill>
+          <a:blip r:embed="rId1"/>
+          <a:stretch>
+            <a:fillRect/>
+          </a:stretch>
+        </p:blipFill>
+        <p:spPr>
+          <a:xfrm>
+            <a:off x="0" y="0"/>
+            <a:ext cx="9144000" cy="5143500"/>
+          </a:xfrm>
+          <a:prstGeom prst="rect">
+            <a:avLst/>
+          </a:prstGeom>
+        </p:spPr>
+      </p:pic>
+      <p:pic>
+        <p:nvPicPr>
+          <p:cNvPr id="3" name="Image 1" descr="preencoded.png">
+            <a:hlinkClick r:id="rId3" tooltip="https://github.com/samquansah-algo/nbc-vct/blob/main/weekly-tactics/04-sales/OUTREACH_KIT.md"/>
+          </p:cNvPr>
+          <p:cNvPicPr>
+            <a:picLocks noChangeAspect="1"/>
+          </p:cNvPicPr>
+          <p:nvPr/>
+        </p:nvPicPr>
+        <p:blipFill>
+          <a:blip r:embed="rId2"/>
+          <a:stretch>
+            <a:fillRect/>
+          </a:stretch>
+        </p:blipFill>
+        <p:spPr>
+          <a:xfrm>
+            <a:off x="4660106" y="4824412"/>
+            <a:ext cx="495300" cy="109537"/>
+          </a:xfrm>
+          <a:prstGeom prst="rect">
+            <a:avLst/>
+          </a:prstGeom>
+        </p:spPr>
+      </p:pic>
+      <p:pic>
+        <p:nvPicPr>
+          <p:cNvPr id="4" name="Image 2" descr="preencoded.png">
+            <a:hlinkClick r:id="rId5" tooltip="https://github.com/samquansah-algo/nbc-vct/blob/main/brand/NBC_Brand_Guide.pdf"/>
+          </p:cNvPr>
+          <p:cNvPicPr>
+            <a:picLocks noChangeAspect="1"/>
+          </p:cNvPicPr>
+          <p:nvPr/>
+        </p:nvPicPr>
+        <p:blipFill>
+          <a:blip r:embed="rId4"/>
+          <a:stretch>
+            <a:fillRect/>
+          </a:stretch>
+        </p:blipFill>
+        <p:spPr>
+          <a:xfrm>
+            <a:off x="5217319" y="4824412"/>
+            <a:ext cx="642938" cy="109537"/>
+          </a:xfrm>
+          <a:prstGeom prst="rect">
+            <a:avLst/>
+          </a:prstGeom>
+        </p:spPr>
+      </p:pic>
+    </p:spTree>
+  </p:cSld>
+  <p:clrMapOvr>
+    <a:masterClrMapping/>
+  </p:clrMapOvr>
+</p:sld>
+</file>
+
+<file path=ppt/slides/slide31.xml><?xml version="1.0" encoding="utf-8"?>
+<p:sld xmlns:a="http://schemas.openxmlformats.org/drawingml/2006/main" xmlns:r="http://schemas.openxmlformats.org/officeDocument/2006/relationships" xmlns:p="http://schemas.openxmlformats.org/presentationml/2006/main">
+  <p:cSld name="Slide 31">
+    <p:spTree>
+      <p:nvGrpSpPr>
+        <p:cNvPr id="1" name=""/>
+        <p:cNvGrpSpPr/>
+        <p:nvPr/>
+      </p:nvGrpSpPr>
+      <p:grpSpPr>
+        <a:xfrm>
+          <a:off x="0" y="0"/>
+          <a:ext cx="0" cy="0"/>
+          <a:chOff x="0" y="0"/>
+          <a:chExt cx="0" cy="0"/>
+        </a:xfrm>
+      </p:grpSpPr>
+      <p:pic>
+        <p:nvPicPr>
+          <p:cNvPr id="2" name="Image 0" descr="NBC sales tactic slide 31">    </p:cNvPr>
+          <p:cNvPicPr>
+            <a:picLocks noChangeAspect="1"/>
+          </p:cNvPicPr>
+          <p:nvPr/>
+        </p:nvPicPr>
+        <p:blipFill>
+          <a:blip r:embed="rId1"/>
+          <a:stretch>
+            <a:fillRect/>
+          </a:stretch>
+        </p:blipFill>
+        <p:spPr>
+          <a:xfrm>
+            <a:off x="0" y="0"/>
+            <a:ext cx="9144000" cy="5143500"/>
+          </a:xfrm>
+          <a:prstGeom prst="rect">
+            <a:avLst/>
+          </a:prstGeom>
+        </p:spPr>
+      </p:pic>
+      <p:pic>
+        <p:nvPicPr>
+          <p:cNvPr id="3" name="Image 1" descr="preencoded.png">
+            <a:hlinkClick r:id="rId3" tooltip="https://github.com/samquansah-algo/nbc-vct/blob/main/tactics-milestones/MILESTONES.md"/>
+          </p:cNvPr>
+          <p:cNvPicPr>
+            <a:picLocks noChangeAspect="1"/>
+          </p:cNvPicPr>
+          <p:nvPr/>
+        </p:nvPicPr>
+        <p:blipFill>
+          <a:blip r:embed="rId2"/>
+          <a:stretch>
+            <a:fillRect/>
+          </a:stretch>
+        </p:blipFill>
+        <p:spPr>
+          <a:xfrm>
+            <a:off x="4683919" y="4824412"/>
+            <a:ext cx="447675" cy="109537"/>
+          </a:xfrm>
+          <a:prstGeom prst="rect">
+            <a:avLst/>
+          </a:prstGeom>
+        </p:spPr>
+      </p:pic>
+      <p:pic>
+        <p:nvPicPr>
+          <p:cNvPr id="4" name="Image 2" descr="preencoded.png">
+            <a:hlinkClick r:id="rId5" tooltip="https://github.com/samquansah-algo/nbc-vct/blob/main/brand/NBC_Brand_Guide.pdf"/>
+          </p:cNvPr>
+          <p:cNvPicPr>
+            <a:picLocks noChangeAspect="1"/>
+          </p:cNvPicPr>
+          <p:nvPr/>
+        </p:nvPicPr>
+        <p:blipFill>
+          <a:blip r:embed="rId4"/>
+          <a:stretch>
+            <a:fillRect/>
+          </a:stretch>
+        </p:blipFill>
+        <p:spPr>
+          <a:xfrm>
+            <a:off x="5193506" y="4824412"/>
+            <a:ext cx="642938" cy="109537"/>
+          </a:xfrm>
+          <a:prstGeom prst="rect">
+            <a:avLst/>
+          </a:prstGeom>
+        </p:spPr>
+      </p:pic>
+    </p:spTree>
+  </p:cSld>
+  <p:clrMapOvr>
+    <a:masterClrMapping/>
+  </p:clrMapOvr>
+</p:sld>
+</file>
+
+<file path=ppt/slides/slide32.xml><?xml version="1.0" encoding="utf-8"?>
+<p:sld xmlns:a="http://schemas.openxmlformats.org/drawingml/2006/main" xmlns:r="http://schemas.openxmlformats.org/officeDocument/2006/relationships" xmlns:p="http://schemas.openxmlformats.org/presentationml/2006/main">
+  <p:cSld name="Slide 32">
+    <p:spTree>
+      <p:nvGrpSpPr>
+        <p:cNvPr id="1" name=""/>
+        <p:cNvGrpSpPr/>
+        <p:nvPr/>
+      </p:nvGrpSpPr>
+      <p:grpSpPr>
+        <a:xfrm>
+          <a:off x="0" y="0"/>
+          <a:ext cx="0" cy="0"/>
+          <a:chOff x="0" y="0"/>
+          <a:chExt cx="0" cy="0"/>
+        </a:xfrm>
+      </p:grpSpPr>
+      <p:pic>
+        <p:nvPicPr>
+          <p:cNvPr id="2" name="Image 0" descr="NBC sales tactic slide 32">    </p:cNvPr>
+          <p:cNvPicPr>
+            <a:picLocks noChangeAspect="1"/>
+          </p:cNvPicPr>
+          <p:nvPr/>
+        </p:nvPicPr>
+        <p:blipFill>
+          <a:blip r:embed="rId1"/>
+          <a:stretch>
+            <a:fillRect/>
+          </a:stretch>
+        </p:blipFill>
+        <p:spPr>
+          <a:xfrm>
+            <a:off x="0" y="0"/>
+            <a:ext cx="9144000" cy="5143500"/>
+          </a:xfrm>
+          <a:prstGeom prst="rect">
+            <a:avLst/>
+          </a:prstGeom>
+        </p:spPr>
+      </p:pic>
+      <p:pic>
+        <p:nvPicPr>
+          <p:cNvPr id="3" name="Image 1" descr="preencoded.png">
+            <a:hlinkClick r:id="rId3" tooltip="https://github.com/samquansah-algo/nbc-vct/blob/main/brand/NBC_Brand_Guide.pdf"/>
+          </p:cNvPr>
+          <p:cNvPicPr>
+            <a:picLocks noChangeAspect="1"/>
+          </p:cNvPicPr>
+          <p:nvPr/>
+        </p:nvPicPr>
+        <p:blipFill>
+          <a:blip r:embed="rId2"/>
+          <a:stretch>
+            <a:fillRect/>
+          </a:stretch>
+        </p:blipFill>
+        <p:spPr>
+          <a:xfrm>
+            <a:off x="4938712" y="4824412"/>
+            <a:ext cx="642938" cy="109537"/>
+          </a:xfrm>
+          <a:prstGeom prst="rect">
+            <a:avLst/>
+          </a:prstGeom>
+        </p:spPr>
+      </p:pic>
+    </p:spTree>
+  </p:cSld>
+  <p:clrMapOvr>
+    <a:masterClrMapping/>
+  </p:clrMapOvr>
+</p:sld>
+</file>
+
+<file path=ppt/slides/slide33.xml><?xml version="1.0" encoding="utf-8"?>
+<p:sld xmlns:a="http://schemas.openxmlformats.org/drawingml/2006/main" xmlns:r="http://schemas.openxmlformats.org/officeDocument/2006/relationships" xmlns:p="http://schemas.openxmlformats.org/presentationml/2006/main">
+  <p:cSld name="Slide 33">
+    <p:spTree>
+      <p:nvGrpSpPr>
+        <p:cNvPr id="1" name=""/>
+        <p:cNvGrpSpPr/>
+        <p:nvPr/>
+      </p:nvGrpSpPr>
+      <p:grpSpPr>
+        <a:xfrm>
+          <a:off x="0" y="0"/>
+          <a:ext cx="0" cy="0"/>
+          <a:chOff x="0" y="0"/>
+          <a:chExt cx="0" cy="0"/>
+        </a:xfrm>
+      </p:grpSpPr>
+      <p:pic>
+        <p:nvPicPr>
+          <p:cNvPr id="2" name="Image 0" descr="NBC sales tactic slide 33">    </p:cNvPr>
+          <p:cNvPicPr>
+            <a:picLocks noChangeAspect="1"/>
+          </p:cNvPicPr>
+          <p:nvPr/>
+        </p:nvPicPr>
+        <p:blipFill>
+          <a:blip r:embed="rId1"/>
+          <a:stretch>
+            <a:fillRect/>
+          </a:stretch>
+        </p:blipFill>
+        <p:spPr>
+          <a:xfrm>
+            <a:off x="0" y="0"/>
+            <a:ext cx="9144000" cy="5143500"/>
+          </a:xfrm>
+          <a:prstGeom prst="rect">
+            <a:avLst/>
+          </a:prstGeom>
+        </p:spPr>
+      </p:pic>
+      <p:pic>
+        <p:nvPicPr>
+          <p:cNvPr id="3" name="Image 1" descr="preencoded.png">
+            <a:hlinkClick r:id="rId3" tooltip="https://github.com/samquansah-algo/nbc-vct/blob/main/thesis/v6-capability-layer/THESIS.md"/>
+          </p:cNvPr>
+          <p:cNvPicPr>
+            <a:picLocks noChangeAspect="1"/>
+          </p:cNvPicPr>
+          <p:nvPr/>
+        </p:nvPicPr>
+        <p:blipFill>
+          <a:blip r:embed="rId2"/>
+          <a:stretch>
+            <a:fillRect/>
+          </a:stretch>
+        </p:blipFill>
+        <p:spPr>
+          <a:xfrm>
+            <a:off x="4729163" y="4824412"/>
+            <a:ext cx="357188" cy="109537"/>
+          </a:xfrm>
+          <a:prstGeom prst="rect">
+            <a:avLst/>
+          </a:prstGeom>
+        </p:spPr>
+      </p:pic>
+      <p:pic>
+        <p:nvPicPr>
+          <p:cNvPr id="4" name="Image 2" descr="preencoded.png">
+            <a:hlinkClick r:id="rId5" tooltip="https://github.com/samquansah-algo/nbc-vct/blob/main/brand/NBC_Brand_Guide.pdf"/>
+          </p:cNvPr>
+          <p:cNvPicPr>
+            <a:picLocks noChangeAspect="1"/>
+          </p:cNvPicPr>
+          <p:nvPr/>
+        </p:nvPicPr>
+        <p:blipFill>
+          <a:blip r:embed="rId4"/>
+          <a:stretch>
+            <a:fillRect/>
+          </a:stretch>
+        </p:blipFill>
+        <p:spPr>
+          <a:xfrm>
+            <a:off x="5148263" y="4824412"/>
+            <a:ext cx="642938" cy="109537"/>
+          </a:xfrm>
+          <a:prstGeom prst="rect">
+            <a:avLst/>
+          </a:prstGeom>
+        </p:spPr>
+      </p:pic>
+    </p:spTree>
+  </p:cSld>
+  <p:clrMapOvr>
+    <a:masterClrMapping/>
+  </p:clrMapOvr>
+</p:sld>
+</file>
+
+<file path=ppt/slides/slide34.xml><?xml version="1.0" encoding="utf-8"?>
+<p:sld xmlns:a="http://schemas.openxmlformats.org/drawingml/2006/main" xmlns:r="http://schemas.openxmlformats.org/officeDocument/2006/relationships" xmlns:p="http://schemas.openxmlformats.org/presentationml/2006/main">
+  <p:cSld name="Slide 34">
+    <p:spTree>
+      <p:nvGrpSpPr>
+        <p:cNvPr id="1" name=""/>
+        <p:cNvGrpSpPr/>
+        <p:nvPr/>
+      </p:nvGrpSpPr>
+      <p:grpSpPr>
+        <a:xfrm>
+          <a:off x="0" y="0"/>
+          <a:ext cx="0" cy="0"/>
+          <a:chOff x="0" y="0"/>
+          <a:chExt cx="0" cy="0"/>
+        </a:xfrm>
+      </p:grpSpPr>
+      <p:pic>
+        <p:nvPicPr>
+          <p:cNvPr id="2" name="Image 0" descr="NBC sales tactic slide 34">    </p:cNvPr>
+          <p:cNvPicPr>
+            <a:picLocks noChangeAspect="1"/>
+          </p:cNvPicPr>
+          <p:nvPr/>
+        </p:nvPicPr>
+        <p:blipFill>
+          <a:blip r:embed="rId1"/>
+          <a:stretch>
+            <a:fillRect/>
+          </a:stretch>
+        </p:blipFill>
+        <p:spPr>
+          <a:xfrm>
+            <a:off x="0" y="0"/>
+            <a:ext cx="9144000" cy="5143500"/>
+          </a:xfrm>
+          <a:prstGeom prst="rect">
+            <a:avLst/>
+          </a:prstGeom>
+        </p:spPr>
+      </p:pic>
+      <p:pic>
+        <p:nvPicPr>
+          <p:cNvPr id="3" name="Image 1" descr="preencoded.png">
+            <a:hlinkClick r:id="rId3" tooltip="https://github.com/samquansah-algo/nbc-vct/blob/main/thesis/v6-capability-layer/THESIS.md"/>
+          </p:cNvPr>
+          <p:cNvPicPr>
+            <a:picLocks noChangeAspect="1"/>
+          </p:cNvPicPr>
+          <p:nvPr/>
+        </p:nvPicPr>
+        <p:blipFill>
+          <a:blip r:embed="rId2"/>
+          <a:stretch>
+            <a:fillRect/>
+          </a:stretch>
+        </p:blipFill>
+        <p:spPr>
+          <a:xfrm>
+            <a:off x="4729163" y="4824412"/>
+            <a:ext cx="357188" cy="109537"/>
+          </a:xfrm>
+          <a:prstGeom prst="rect">
+            <a:avLst/>
+          </a:prstGeom>
+        </p:spPr>
+      </p:pic>
+      <p:pic>
+        <p:nvPicPr>
+          <p:cNvPr id="4" name="Image 2" descr="preencoded.png">
+            <a:hlinkClick r:id="rId5" tooltip="https://github.com/samquansah-algo/nbc-vct/blob/main/brand/NBC_Brand_Guide.pdf"/>
+          </p:cNvPr>
+          <p:cNvPicPr>
+            <a:picLocks noChangeAspect="1"/>
+          </p:cNvPicPr>
+          <p:nvPr/>
+        </p:nvPicPr>
+        <p:blipFill>
+          <a:blip r:embed="rId4"/>
+          <a:stretch>
+            <a:fillRect/>
+          </a:stretch>
+        </p:blipFill>
+        <p:spPr>
+          <a:xfrm>
+            <a:off x="5148263" y="4824412"/>
+            <a:ext cx="642938" cy="109537"/>
+          </a:xfrm>
+          <a:prstGeom prst="rect">
+            <a:avLst/>
+          </a:prstGeom>
+        </p:spPr>
+      </p:pic>
+    </p:spTree>
+  </p:cSld>
+  <p:clrMapOvr>
+    <a:masterClrMapping/>
+  </p:clrMapOvr>
+</p:sld>
+</file>
+
+<file path=ppt/slides/slide35.xml><?xml version="1.0" encoding="utf-8"?>
+<p:sld xmlns:a="http://schemas.openxmlformats.org/drawingml/2006/main" xmlns:r="http://schemas.openxmlformats.org/officeDocument/2006/relationships" xmlns:p="http://schemas.openxmlformats.org/presentationml/2006/main">
+  <p:cSld name="Slide 35">
+    <p:spTree>
+      <p:nvGrpSpPr>
+        <p:cNvPr id="1" name=""/>
+        <p:cNvGrpSpPr/>
+        <p:nvPr/>
+      </p:nvGrpSpPr>
+      <p:grpSpPr>
+        <a:xfrm>
+          <a:off x="0" y="0"/>
+          <a:ext cx="0" cy="0"/>
+          <a:chOff x="0" y="0"/>
+          <a:chExt cx="0" cy="0"/>
+        </a:xfrm>
+      </p:grpSpPr>
+      <p:pic>
+        <p:nvPicPr>
+          <p:cNvPr id="2" name="Image 0" descr="NBC sales tactic slide 35">    </p:cNvPr>
+          <p:cNvPicPr>
+            <a:picLocks noChangeAspect="1"/>
+          </p:cNvPicPr>
+          <p:nvPr/>
+        </p:nvPicPr>
+        <p:blipFill>
+          <a:blip r:embed="rId1"/>
+          <a:stretch>
+            <a:fillRect/>
+          </a:stretch>
+        </p:blipFill>
+        <p:spPr>
+          <a:xfrm>
+            <a:off x="0" y="0"/>
+            <a:ext cx="9144000" cy="5143500"/>
+          </a:xfrm>
+          <a:prstGeom prst="rect">
+            <a:avLst/>
+          </a:prstGeom>
+        </p:spPr>
+      </p:pic>
+      <p:pic>
+        <p:nvPicPr>
+          <p:cNvPr id="3" name="Image 1" descr="preencoded.png">
+            <a:hlinkClick r:id="rId3" tooltip="https://github.com/samquansah-algo/nbc-vct/blob/main/thesis/v6-capability-layer/THESIS.md"/>
+          </p:cNvPr>
+          <p:cNvPicPr>
+            <a:picLocks noChangeAspect="1"/>
+          </p:cNvPicPr>
+          <p:nvPr/>
+        </p:nvPicPr>
+        <p:blipFill>
+          <a:blip r:embed="rId2"/>
+          <a:stretch>
+            <a:fillRect/>
+          </a:stretch>
+        </p:blipFill>
+        <p:spPr>
+          <a:xfrm>
+            <a:off x="4729163" y="4824412"/>
+            <a:ext cx="357188" cy="109537"/>
+          </a:xfrm>
+          <a:prstGeom prst="rect">
+            <a:avLst/>
+          </a:prstGeom>
+        </p:spPr>
+      </p:pic>
+      <p:pic>
+        <p:nvPicPr>
+          <p:cNvPr id="4" name="Image 2" descr="preencoded.png">
+            <a:hlinkClick r:id="rId5" tooltip="https://github.com/samquansah-algo/nbc-vct/blob/main/brand/NBC_Brand_Guide.pdf"/>
+          </p:cNvPr>
+          <p:cNvPicPr>
+            <a:picLocks noChangeAspect="1"/>
+          </p:cNvPicPr>
+          <p:nvPr/>
+        </p:nvPicPr>
+        <p:blipFill>
+          <a:blip r:embed="rId4"/>
+          <a:stretch>
+            <a:fillRect/>
+          </a:stretch>
+        </p:blipFill>
+        <p:spPr>
+          <a:xfrm>
+            <a:off x="5148263" y="4824412"/>
+            <a:ext cx="642938" cy="109537"/>
+          </a:xfrm>
+          <a:prstGeom prst="rect">
+            <a:avLst/>
+          </a:prstGeom>
+        </p:spPr>
+      </p:pic>
+    </p:spTree>
+  </p:cSld>
+  <p:clrMapOvr>
+    <a:masterClrMapping/>
+  </p:clrMapOvr>
+</p:sld>
+</file>
+
+<file path=ppt/slides/slide36.xml><?xml version="1.0" encoding="utf-8"?>
+<p:sld xmlns:a="http://schemas.openxmlformats.org/drawingml/2006/main" xmlns:r="http://schemas.openxmlformats.org/officeDocument/2006/relationships" xmlns:p="http://schemas.openxmlformats.org/presentationml/2006/main">
+  <p:cSld name="Slide 36">
+    <p:spTree>
+      <p:nvGrpSpPr>
+        <p:cNvPr id="1" name=""/>
+        <p:cNvGrpSpPr/>
+        <p:nvPr/>
+      </p:nvGrpSpPr>
+      <p:grpSpPr>
+        <a:xfrm>
+          <a:off x="0" y="0"/>
+          <a:ext cx="0" cy="0"/>
+          <a:chOff x="0" y="0"/>
+          <a:chExt cx="0" cy="0"/>
+        </a:xfrm>
+      </p:grpSpPr>
+      <p:pic>
+        <p:nvPicPr>
+          <p:cNvPr id="2" name="Image 0" descr="NBC sales tactic slide 36">    </p:cNvPr>
+          <p:cNvPicPr>
+            <a:picLocks noChangeAspect="1"/>
+          </p:cNvPicPr>
+          <p:nvPr/>
+        </p:nvPicPr>
+        <p:blipFill>
+          <a:blip r:embed="rId1"/>
+          <a:stretch>
+            <a:fillRect/>
+          </a:stretch>
+        </p:blipFill>
+        <p:spPr>
+          <a:xfrm>
+            <a:off x="0" y="0"/>
+            <a:ext cx="9144000" cy="5143500"/>
+          </a:xfrm>
+          <a:prstGeom prst="rect">
+            <a:avLst/>
+          </a:prstGeom>
+        </p:spPr>
+      </p:pic>
+      <p:pic>
+        <p:nvPicPr>
+          <p:cNvPr id="3" name="Image 1" descr="preencoded.png">
+            <a:hlinkClick r:id="rId3" tooltip="mailto:samquansah@gse.harvard.edu"/>
+          </p:cNvPr>
+          <p:cNvPicPr>
+            <a:picLocks noChangeAspect="1"/>
+          </p:cNvPicPr>
+          <p:nvPr/>
+        </p:nvPicPr>
+        <p:blipFill>
+          <a:blip r:embed="rId2"/>
+          <a:stretch>
+            <a:fillRect/>
+          </a:stretch>
+        </p:blipFill>
+        <p:spPr>
+          <a:xfrm>
+            <a:off x="457200" y="4181475"/>
+            <a:ext cx="1676400" cy="157163"/>
+          </a:xfrm>
+          <a:prstGeom prst="rect">
+            <a:avLst/>
+          </a:prstGeom>
+        </p:spPr>
+      </p:pic>
+      <p:pic>
+        <p:nvPicPr>
+          <p:cNvPr id="4" name="Image 2" descr="preencoded.png">
+            <a:hlinkClick r:id="rId5" tooltip="mailto:samquans@mit.edu"/>
+          </p:cNvPr>
+          <p:cNvPicPr>
+            <a:picLocks noChangeAspect="1"/>
+          </p:cNvPicPr>
+          <p:nvPr/>
+        </p:nvPicPr>
+        <p:blipFill>
+          <a:blip r:embed="rId4"/>
+          <a:stretch>
+            <a:fillRect/>
+          </a:stretch>
+        </p:blipFill>
+        <p:spPr>
+          <a:xfrm>
+            <a:off x="457200" y="4352925"/>
+            <a:ext cx="1076325" cy="157163"/>
+          </a:xfrm>
+          <a:prstGeom prst="rect">
+            <a:avLst/>
+          </a:prstGeom>
+        </p:spPr>
+      </p:pic>
+      <p:pic>
+        <p:nvPicPr>
+          <p:cNvPr id="5" name="Image 3" descr="preencoded.png">
+            <a:hlinkClick r:id="rId7" tooltip="https://github.com/samquansah-algo/nbc-vct/tree/main/weekly-tactics/04-sales/"/>
+          </p:cNvPr>
+          <p:cNvPicPr>
+            <a:picLocks noChangeAspect="1"/>
+          </p:cNvPicPr>
+          <p:nvPr/>
+        </p:nvPicPr>
+        <p:blipFill>
+          <a:blip r:embed="rId6"/>
+          <a:stretch>
+            <a:fillRect/>
+          </a:stretch>
+        </p:blipFill>
+        <p:spPr>
+          <a:xfrm>
+            <a:off x="3648075" y="3805237"/>
+            <a:ext cx="671513" cy="157163"/>
+          </a:xfrm>
+          <a:prstGeom prst="rect">
+            <a:avLst/>
+          </a:prstGeom>
+        </p:spPr>
+      </p:pic>
+      <p:pic>
+        <p:nvPicPr>
+          <p:cNvPr id="6" name="Image 4" descr="preencoded.png">
+            <a:hlinkClick r:id="rId9" tooltip="https://github.com/samquansah-algo/nbc-vct/blob/main/weekly-tactics/04-sales/lead_list_template.csv"/>
+          </p:cNvPr>
+          <p:cNvPicPr>
+            <a:picLocks noChangeAspect="1"/>
+          </p:cNvPicPr>
+          <p:nvPr/>
+        </p:nvPicPr>
+        <p:blipFill>
+          <a:blip r:embed="rId8"/>
+          <a:stretch>
+            <a:fillRect/>
+          </a:stretch>
+        </p:blipFill>
+        <p:spPr>
+          <a:xfrm>
+            <a:off x="3648075" y="3999533"/>
+            <a:ext cx="971550" cy="157163"/>
+          </a:xfrm>
+          <a:prstGeom prst="rect">
+            <a:avLst/>
+          </a:prstGeom>
+        </p:spPr>
+      </p:pic>
+      <p:pic>
+        <p:nvPicPr>
+          <p:cNvPr id="7" name="Image 5" descr="preencoded.png">
+            <a:hlinkClick r:id="rId11" tooltip="https://github.com/samquansah-algo/nbc-vct/blob/main/brand/NBC_Brand_Guide.pdf"/>
+          </p:cNvPr>
+          <p:cNvPicPr>
+            <a:picLocks noChangeAspect="1"/>
+          </p:cNvPicPr>
+          <p:nvPr/>
+        </p:nvPicPr>
+        <p:blipFill>
+          <a:blip r:embed="rId10"/>
+          <a:stretch>
+            <a:fillRect/>
+          </a:stretch>
+        </p:blipFill>
+        <p:spPr>
+          <a:xfrm>
+            <a:off x="3648075" y="4193828"/>
+            <a:ext cx="1185863" cy="157163"/>
           </a:xfrm>
           <a:prstGeom prst="rect">
             <a:avLst/>
@@ -3758,7 +6988,7 @@
       <p:pic>
         <p:nvPicPr>
           <p:cNvPr id="3" name="Image 1" descr="preencoded.png">
-            <a:hlinkClick r:id="rId3" tooltip="https://github.com/samquansah-algo/nbc-vct/blob/main/marketing/watering_holes_v5.md"/>
+            <a:hlinkClick r:id="rId3" tooltip="https://github.com/samquansah-algo/nbc-vct/blob/main/brand/NBC_Brand_Guide.pdf"/>
           </p:cNvPr>
           <p:cNvPicPr>
             <a:picLocks noChangeAspect="1"/>
@@ -3773,33 +7003,7 @@
         </p:blipFill>
         <p:spPr>
           <a:xfrm>
-            <a:off x="4750594" y="4824412"/>
-            <a:ext cx="604837" cy="109537"/>
-          </a:xfrm>
-          <a:prstGeom prst="rect">
-            <a:avLst/>
-          </a:prstGeom>
-        </p:spPr>
-      </p:pic>
-      <p:pic>
-        <p:nvPicPr>
-          <p:cNvPr id="4" name="Image 2" descr="preencoded.png">
-            <a:hlinkClick r:id="rId5" tooltip="https://github.com/samquansah-algo/nbc-vct/blob/main/brand/NBC_Brand_Guide.pdf"/>
-          </p:cNvPr>
-          <p:cNvPicPr>
-            <a:picLocks noChangeAspect="1"/>
-          </p:cNvPicPr>
-          <p:nvPr/>
-        </p:nvPicPr>
-        <p:blipFill>
-          <a:blip r:embed="rId4"/>
-          <a:stretch>
-            <a:fillRect/>
-          </a:stretch>
-        </p:blipFill>
-        <p:spPr>
-          <a:xfrm>
-            <a:off x="5417344" y="4824412"/>
+            <a:off x="4962525" y="4824412"/>
             <a:ext cx="642938" cy="109537"/>
           </a:xfrm>
           <a:prstGeom prst="rect">
@@ -3859,7 +7063,7 @@
       <p:pic>
         <p:nvPicPr>
           <p:cNvPr id="3" name="Image 1" descr="preencoded.png">
-            <a:hlinkClick r:id="rId3" tooltip="https://github.com/samquansah-algo/nbc-vct/blob/main/weekly-tactics/03-persona-ads/README.md"/>
+            <a:hlinkClick r:id="rId3" tooltip="https://github.com/samquansah-algo/nbc-vct/blob/main/tactics-milestones/MILESTONES.md"/>
           </p:cNvPr>
           <p:cNvPicPr>
             <a:picLocks noChangeAspect="1"/>
@@ -3874,8 +7078,8 @@
         </p:blipFill>
         <p:spPr>
           <a:xfrm>
-            <a:off x="4864894" y="4824412"/>
-            <a:ext cx="376238" cy="109537"/>
+            <a:off x="4707731" y="4824412"/>
+            <a:ext cx="447675" cy="109537"/>
           </a:xfrm>
           <a:prstGeom prst="rect">
             <a:avLst/>
@@ -3900,7 +7104,7 @@
         </p:blipFill>
         <p:spPr>
           <a:xfrm>
-            <a:off x="5303044" y="4824412"/>
+            <a:off x="5217319" y="4824412"/>
             <a:ext cx="642938" cy="109537"/>
           </a:xfrm>
           <a:prstGeom prst="rect">
@@ -3960,7 +7164,7 @@
       <p:pic>
         <p:nvPicPr>
           <p:cNvPr id="3" name="Image 1" descr="preencoded.png">
-            <a:hlinkClick r:id="rId3" tooltip="https://github.com/samquansah-algo/nbc-vct/blob/main/weekly-tactics/04-sales/lead_list_template.csv"/>
+            <a:hlinkClick r:id="rId3" tooltip="https://github.com/samquansah-algo/nbc-vct/blob/main/thesis/v6-capability-layer/THESIS.md"/>
           </p:cNvPr>
           <p:cNvPicPr>
             <a:picLocks noChangeAspect="1"/>
@@ -3975,8 +7179,8 @@
         </p:blipFill>
         <p:spPr>
           <a:xfrm>
-            <a:off x="3886200" y="3952875"/>
-            <a:ext cx="862012" cy="142875"/>
+            <a:off x="4752975" y="4824412"/>
+            <a:ext cx="357188" cy="109537"/>
           </a:xfrm>
           <a:prstGeom prst="rect">
             <a:avLst/>
@@ -3986,7 +7190,7 @@
       <p:pic>
         <p:nvPicPr>
           <p:cNvPr id="4" name="Image 2" descr="preencoded.png">
-            <a:hlinkClick r:id="rId5" tooltip="https://github.com/samquansah-algo/nbc-vct/blob/main/weekly-tactics/04-sales/lead_list_template.csv"/>
+            <a:hlinkClick r:id="rId5" tooltip="https://github.com/samquansah-algo/nbc-vct/blob/main/brand/NBC_Brand_Guide.pdf"/>
           </p:cNvPr>
           <p:cNvPicPr>
             <a:picLocks noChangeAspect="1"/>
@@ -4001,33 +7205,7 @@
         </p:blipFill>
         <p:spPr>
           <a:xfrm>
-            <a:off x="4700588" y="4824412"/>
-            <a:ext cx="704850" cy="109537"/>
-          </a:xfrm>
-          <a:prstGeom prst="rect">
-            <a:avLst/>
-          </a:prstGeom>
-        </p:spPr>
-      </p:pic>
-      <p:pic>
-        <p:nvPicPr>
-          <p:cNvPr id="5" name="Image 3" descr="preencoded.png">
-            <a:hlinkClick r:id="rId7" tooltip="https://github.com/samquansah-algo/nbc-vct/blob/main/brand/NBC_Brand_Guide.pdf"/>
-          </p:cNvPr>
-          <p:cNvPicPr>
-            <a:picLocks noChangeAspect="1"/>
-          </p:cNvPicPr>
-          <p:nvPr/>
-        </p:nvPicPr>
-        <p:blipFill>
-          <a:blip r:embed="rId6"/>
-          <a:stretch>
-            <a:fillRect/>
-          </a:stretch>
-        </p:blipFill>
-        <p:spPr>
-          <a:xfrm>
-            <a:off x="5467350" y="4824412"/>
+            <a:off x="5172075" y="4824412"/>
             <a:ext cx="642938" cy="109537"/>
           </a:xfrm>
           <a:prstGeom prst="rect">
@@ -4087,7 +7265,7 @@
       <p:pic>
         <p:nvPicPr>
           <p:cNvPr id="3" name="Image 1" descr="preencoded.png">
-            <a:hlinkClick r:id="rId3" tooltip="https://github.com/samquansah-algo/nbc-vct/blob/main/weekly-tactics/04-sales/lead_list_template.csv"/>
+            <a:hlinkClick r:id="rId3" tooltip="https://github.com/samquansah-algo/nbc-vct/blob/main/marketing/crm/README.md"/>
           </p:cNvPr>
           <p:cNvPicPr>
             <a:picLocks noChangeAspect="1"/>
@@ -4102,8 +7280,8 @@
         </p:blipFill>
         <p:spPr>
           <a:xfrm>
-            <a:off x="3886200" y="3952875"/>
-            <a:ext cx="862012" cy="142875"/>
+            <a:off x="4841081" y="4824412"/>
+            <a:ext cx="180975" cy="109537"/>
           </a:xfrm>
           <a:prstGeom prst="rect">
             <a:avLst/>
@@ -4113,7 +7291,7 @@
       <p:pic>
         <p:nvPicPr>
           <p:cNvPr id="4" name="Image 2" descr="preencoded.png">
-            <a:hlinkClick r:id="rId5" tooltip="https://github.com/samquansah-algo/nbc-vct/blob/main/weekly-tactics/04-sales/lead_list_template.csv"/>
+            <a:hlinkClick r:id="rId5" tooltip="https://github.com/samquansah-algo/nbc-vct/blob/main/brand/NBC_Brand_Guide.pdf"/>
           </p:cNvPr>
           <p:cNvPicPr>
             <a:picLocks noChangeAspect="1"/>
@@ -4128,33 +7306,7 @@
         </p:blipFill>
         <p:spPr>
           <a:xfrm>
-            <a:off x="4700588" y="4824412"/>
-            <a:ext cx="704850" cy="109537"/>
-          </a:xfrm>
-          <a:prstGeom prst="rect">
-            <a:avLst/>
-          </a:prstGeom>
-        </p:spPr>
-      </p:pic>
-      <p:pic>
-        <p:nvPicPr>
-          <p:cNvPr id="5" name="Image 3" descr="preencoded.png">
-            <a:hlinkClick r:id="rId7" tooltip="https://github.com/samquansah-algo/nbc-vct/blob/main/brand/NBC_Brand_Guide.pdf"/>
-          </p:cNvPr>
-          <p:cNvPicPr>
-            <a:picLocks noChangeAspect="1"/>
-          </p:cNvPicPr>
-          <p:nvPr/>
-        </p:nvPicPr>
-        <p:blipFill>
-          <a:blip r:embed="rId6"/>
-          <a:stretch>
-            <a:fillRect/>
-          </a:stretch>
-        </p:blipFill>
-        <p:spPr>
-          <a:xfrm>
-            <a:off x="5467350" y="4824412"/>
+            <a:off x="5083969" y="4824412"/>
             <a:ext cx="642938" cy="109537"/>
           </a:xfrm>
           <a:prstGeom prst="rect">
@@ -4214,7 +7366,7 @@
       <p:pic>
         <p:nvPicPr>
           <p:cNvPr id="3" name="Image 1" descr="preencoded.png">
-            <a:hlinkClick r:id="rId3" tooltip="https://github.com/samquansah-algo/nbc-vct/blob/main/weekly-tactics/04-sales/lead_list_template.csv"/>
+            <a:hlinkClick r:id="rId3" tooltip="https://github.com/samquansah-algo/nbc-vct/blob/main/brand/NBC_Brand_Guide.pdf"/>
           </p:cNvPr>
           <p:cNvPicPr>
             <a:picLocks noChangeAspect="1"/>
@@ -4229,59 +7381,7 @@
         </p:blipFill>
         <p:spPr>
           <a:xfrm>
-            <a:off x="3886200" y="3952875"/>
-            <a:ext cx="862012" cy="142875"/>
-          </a:xfrm>
-          <a:prstGeom prst="rect">
-            <a:avLst/>
-          </a:prstGeom>
-        </p:spPr>
-      </p:pic>
-      <p:pic>
-        <p:nvPicPr>
-          <p:cNvPr id="4" name="Image 2" descr="preencoded.png">
-            <a:hlinkClick r:id="rId5" tooltip="https://github.com/samquansah-algo/nbc-vct/blob/main/weekly-tactics/04-sales/lead_list_template.csv"/>
-          </p:cNvPr>
-          <p:cNvPicPr>
-            <a:picLocks noChangeAspect="1"/>
-          </p:cNvPicPr>
-          <p:nvPr/>
-        </p:nvPicPr>
-        <p:blipFill>
-          <a:blip r:embed="rId4"/>
-          <a:stretch>
-            <a:fillRect/>
-          </a:stretch>
-        </p:blipFill>
-        <p:spPr>
-          <a:xfrm>
-            <a:off x="4700588" y="4824412"/>
-            <a:ext cx="704850" cy="109537"/>
-          </a:xfrm>
-          <a:prstGeom prst="rect">
-            <a:avLst/>
-          </a:prstGeom>
-        </p:spPr>
-      </p:pic>
-      <p:pic>
-        <p:nvPicPr>
-          <p:cNvPr id="5" name="Image 3" descr="preencoded.png">
-            <a:hlinkClick r:id="rId7" tooltip="https://github.com/samquansah-algo/nbc-vct/blob/main/brand/NBC_Brand_Guide.pdf"/>
-          </p:cNvPr>
-          <p:cNvPicPr>
-            <a:picLocks noChangeAspect="1"/>
-          </p:cNvPicPr>
-          <p:nvPr/>
-        </p:nvPicPr>
-        <p:blipFill>
-          <a:blip r:embed="rId6"/>
-          <a:stretch>
-            <a:fillRect/>
-          </a:stretch>
-        </p:blipFill>
-        <p:spPr>
-          <a:xfrm>
-            <a:off x="5467350" y="4824412"/>
+            <a:off x="4962525" y="4824412"/>
             <a:ext cx="642938" cy="109537"/>
           </a:xfrm>
           <a:prstGeom prst="rect">
@@ -4341,7 +7441,7 @@
       <p:pic>
         <p:nvPicPr>
           <p:cNvPr id="3" name="Image 1" descr="preencoded.png">
-            <a:hlinkClick r:id="rId3" tooltip="https://github.com/samquansah-algo/nbc-vct/blob/main/weekly-tactics/04-sales/OUTREACH_KIT.md"/>
+            <a:hlinkClick r:id="rId3" tooltip="https://github.com/samquansah-algo/nbc-vct/blob/main/marketing/watering_holes_v5.md"/>
           </p:cNvPr>
           <p:cNvPicPr>
             <a:picLocks noChangeAspect="1"/>
@@ -4356,8 +7456,8 @@
         </p:blipFill>
         <p:spPr>
           <a:xfrm>
-            <a:off x="4805363" y="4824412"/>
-            <a:ext cx="495300" cy="109537"/>
+            <a:off x="4629150" y="4824412"/>
+            <a:ext cx="604837" cy="109537"/>
           </a:xfrm>
           <a:prstGeom prst="rect">
             <a:avLst/>
@@ -4382,7 +7482,7 @@
         </p:blipFill>
         <p:spPr>
           <a:xfrm>
-            <a:off x="5362575" y="4824412"/>
+            <a:off x="5295900" y="4824412"/>
             <a:ext cx="642938" cy="109537"/>
           </a:xfrm>
           <a:prstGeom prst="rect">

</xml_diff>

<commit_message>
Tactic 4: note that messages, replies and results are updated on GitHub
Co-Authored-By: Claude Opus 5.5 <noreply@anthropic.com>
Claude-Session: https://claude.ai/code/session_014DwxjU8rHfrSVBV6irvX7Y
</commit_message>
<xml_diff>
--- a/weekly-tactics/04-sales/NBC_Sales_Tactic.pptx
+++ b/weekly-tactics/04-sales/NBC_Sales_Tactic.pptx
@@ -4489,7 +4489,7 @@
       <p:pic>
         <p:nvPicPr>
           <p:cNvPr id="3" name="Image 1" descr="preencoded.png">
-            <a:hlinkClick r:id="rId3" tooltip="https://github.com/samquansah-algo/nbc-vct/blob/main/weekly-tactics/04-sales/README.md"/>
+            <a:hlinkClick r:id="rId3" tooltip="https://github.com/samquansah-algo/nbc-vct/tree/main/weekly-tactics/04-sales/"/>
           </p:cNvPr>
           <p:cNvPicPr>
             <a:picLocks noChangeAspect="1"/>
@@ -4498,6 +4498,32 @@
         </p:nvPicPr>
         <p:blipFill>
           <a:blip r:embed="rId2"/>
+          <a:stretch>
+            <a:fillRect/>
+          </a:stretch>
+        </p:blipFill>
+        <p:spPr>
+          <a:xfrm>
+            <a:off x="6462713" y="4610100"/>
+            <a:ext cx="233362" cy="95250"/>
+          </a:xfrm>
+          <a:prstGeom prst="rect">
+            <a:avLst/>
+          </a:prstGeom>
+        </p:spPr>
+      </p:pic>
+      <p:pic>
+        <p:nvPicPr>
+          <p:cNvPr id="4" name="Image 2" descr="preencoded.png">
+            <a:hlinkClick r:id="rId5" tooltip="https://github.com/samquansah-algo/nbc-vct/blob/main/weekly-tactics/04-sales/README.md"/>
+          </p:cNvPr>
+          <p:cNvPicPr>
+            <a:picLocks noChangeAspect="1"/>
+          </p:cNvPicPr>
+          <p:nvPr/>
+        </p:nvPicPr>
+        <p:blipFill>
+          <a:blip r:embed="rId4"/>
           <a:stretch>
             <a:fillRect/>
           </a:stretch>
@@ -4514,8 +4540,8 @@
       </p:pic>
       <p:pic>
         <p:nvPicPr>
-          <p:cNvPr id="4" name="Image 2" descr="preencoded.png">
-            <a:hlinkClick r:id="rId5" tooltip="https://github.com/samquansah-algo/nbc-vct/blob/main/brand/NBC_Brand_Guide.pdf"/>
+          <p:cNvPr id="5" name="Image 3" descr="preencoded.png">
+            <a:hlinkClick r:id="rId7" tooltip="https://github.com/samquansah-algo/nbc-vct/blob/main/brand/NBC_Brand_Guide.pdf"/>
           </p:cNvPr>
           <p:cNvPicPr>
             <a:picLocks noChangeAspect="1"/>
@@ -4523,7 +4549,7 @@
           <p:nvPr/>
         </p:nvPicPr>
         <p:blipFill>
-          <a:blip r:embed="rId4"/>
+          <a:blip r:embed="rId6"/>
           <a:stretch>
             <a:fillRect/>
           </a:stretch>
@@ -4590,7 +4616,7 @@
       <p:pic>
         <p:nvPicPr>
           <p:cNvPr id="3" name="Image 1" descr="preencoded.png">
-            <a:hlinkClick r:id="rId3" tooltip="https://github.com/samquansah-algo/nbc-vct/blob/main/weekly-tactics/04-sales/README.md"/>
+            <a:hlinkClick r:id="rId3" tooltip="https://github.com/samquansah-algo/nbc-vct/tree/main/weekly-tactics/04-sales/"/>
           </p:cNvPr>
           <p:cNvPicPr>
             <a:picLocks noChangeAspect="1"/>
@@ -4599,6 +4625,32 @@
         </p:nvPicPr>
         <p:blipFill>
           <a:blip r:embed="rId2"/>
+          <a:stretch>
+            <a:fillRect/>
+          </a:stretch>
+        </p:blipFill>
+        <p:spPr>
+          <a:xfrm>
+            <a:off x="6462713" y="4610100"/>
+            <a:ext cx="233362" cy="95250"/>
+          </a:xfrm>
+          <a:prstGeom prst="rect">
+            <a:avLst/>
+          </a:prstGeom>
+        </p:spPr>
+      </p:pic>
+      <p:pic>
+        <p:nvPicPr>
+          <p:cNvPr id="4" name="Image 2" descr="preencoded.png">
+            <a:hlinkClick r:id="rId5" tooltip="https://github.com/samquansah-algo/nbc-vct/blob/main/weekly-tactics/04-sales/README.md"/>
+          </p:cNvPr>
+          <p:cNvPicPr>
+            <a:picLocks noChangeAspect="1"/>
+          </p:cNvPicPr>
+          <p:nvPr/>
+        </p:nvPicPr>
+        <p:blipFill>
+          <a:blip r:embed="rId4"/>
           <a:stretch>
             <a:fillRect/>
           </a:stretch>
@@ -4615,8 +4667,8 @@
       </p:pic>
       <p:pic>
         <p:nvPicPr>
-          <p:cNvPr id="4" name="Image 2" descr="preencoded.png">
-            <a:hlinkClick r:id="rId5" tooltip="https://github.com/samquansah-algo/nbc-vct/blob/main/brand/NBC_Brand_Guide.pdf"/>
+          <p:cNvPr id="5" name="Image 3" descr="preencoded.png">
+            <a:hlinkClick r:id="rId7" tooltip="https://github.com/samquansah-algo/nbc-vct/blob/main/brand/NBC_Brand_Guide.pdf"/>
           </p:cNvPr>
           <p:cNvPicPr>
             <a:picLocks noChangeAspect="1"/>
@@ -4624,7 +4676,7 @@
           <p:nvPr/>
         </p:nvPicPr>
         <p:blipFill>
-          <a:blip r:embed="rId4"/>
+          <a:blip r:embed="rId6"/>
           <a:stretch>
             <a:fillRect/>
           </a:stretch>
@@ -4691,7 +4743,7 @@
       <p:pic>
         <p:nvPicPr>
           <p:cNvPr id="3" name="Image 1" descr="preencoded.png">
-            <a:hlinkClick r:id="rId3" tooltip="https://github.com/samquansah-algo/nbc-vct/blob/main/weekly-tactics/04-sales/README.md"/>
+            <a:hlinkClick r:id="rId3" tooltip="https://github.com/samquansah-algo/nbc-vct/tree/main/weekly-tactics/04-sales/"/>
           </p:cNvPr>
           <p:cNvPicPr>
             <a:picLocks noChangeAspect="1"/>
@@ -4700,6 +4752,32 @@
         </p:nvPicPr>
         <p:blipFill>
           <a:blip r:embed="rId2"/>
+          <a:stretch>
+            <a:fillRect/>
+          </a:stretch>
+        </p:blipFill>
+        <p:spPr>
+          <a:xfrm>
+            <a:off x="6462713" y="4610100"/>
+            <a:ext cx="233362" cy="95250"/>
+          </a:xfrm>
+          <a:prstGeom prst="rect">
+            <a:avLst/>
+          </a:prstGeom>
+        </p:spPr>
+      </p:pic>
+      <p:pic>
+        <p:nvPicPr>
+          <p:cNvPr id="4" name="Image 2" descr="preencoded.png">
+            <a:hlinkClick r:id="rId5" tooltip="https://github.com/samquansah-algo/nbc-vct/blob/main/weekly-tactics/04-sales/README.md"/>
+          </p:cNvPr>
+          <p:cNvPicPr>
+            <a:picLocks noChangeAspect="1"/>
+          </p:cNvPicPr>
+          <p:nvPr/>
+        </p:nvPicPr>
+        <p:blipFill>
+          <a:blip r:embed="rId4"/>
           <a:stretch>
             <a:fillRect/>
           </a:stretch>
@@ -4716,8 +4794,8 @@
       </p:pic>
       <p:pic>
         <p:nvPicPr>
-          <p:cNvPr id="4" name="Image 2" descr="preencoded.png">
-            <a:hlinkClick r:id="rId5" tooltip="https://github.com/samquansah-algo/nbc-vct/blob/main/brand/NBC_Brand_Guide.pdf"/>
+          <p:cNvPr id="5" name="Image 3" descr="preencoded.png">
+            <a:hlinkClick r:id="rId7" tooltip="https://github.com/samquansah-algo/nbc-vct/blob/main/brand/NBC_Brand_Guide.pdf"/>
           </p:cNvPr>
           <p:cNvPicPr>
             <a:picLocks noChangeAspect="1"/>
@@ -4725,7 +4803,7 @@
           <p:nvPr/>
         </p:nvPicPr>
         <p:blipFill>
-          <a:blip r:embed="rId4"/>
+          <a:blip r:embed="rId6"/>
           <a:stretch>
             <a:fillRect/>
           </a:stretch>
@@ -4792,7 +4870,7 @@
       <p:pic>
         <p:nvPicPr>
           <p:cNvPr id="3" name="Image 1" descr="preencoded.png">
-            <a:hlinkClick r:id="rId3" tooltip="https://github.com/samquansah-algo/nbc-vct/blob/main/weekly-tactics/04-sales/README.md"/>
+            <a:hlinkClick r:id="rId3" tooltip="https://github.com/samquansah-algo/nbc-vct/tree/main/weekly-tactics/04-sales/"/>
           </p:cNvPr>
           <p:cNvPicPr>
             <a:picLocks noChangeAspect="1"/>
@@ -4801,6 +4879,32 @@
         </p:nvPicPr>
         <p:blipFill>
           <a:blip r:embed="rId2"/>
+          <a:stretch>
+            <a:fillRect/>
+          </a:stretch>
+        </p:blipFill>
+        <p:spPr>
+          <a:xfrm>
+            <a:off x="6462713" y="4610100"/>
+            <a:ext cx="233362" cy="95250"/>
+          </a:xfrm>
+          <a:prstGeom prst="rect">
+            <a:avLst/>
+          </a:prstGeom>
+        </p:spPr>
+      </p:pic>
+      <p:pic>
+        <p:nvPicPr>
+          <p:cNvPr id="4" name="Image 2" descr="preencoded.png">
+            <a:hlinkClick r:id="rId5" tooltip="https://github.com/samquansah-algo/nbc-vct/blob/main/weekly-tactics/04-sales/README.md"/>
+          </p:cNvPr>
+          <p:cNvPicPr>
+            <a:picLocks noChangeAspect="1"/>
+          </p:cNvPicPr>
+          <p:nvPr/>
+        </p:nvPicPr>
+        <p:blipFill>
+          <a:blip r:embed="rId4"/>
           <a:stretch>
             <a:fillRect/>
           </a:stretch>
@@ -4817,8 +4921,8 @@
       </p:pic>
       <p:pic>
         <p:nvPicPr>
-          <p:cNvPr id="4" name="Image 2" descr="preencoded.png">
-            <a:hlinkClick r:id="rId5" tooltip="https://github.com/samquansah-algo/nbc-vct/blob/main/brand/NBC_Brand_Guide.pdf"/>
+          <p:cNvPr id="5" name="Image 3" descr="preencoded.png">
+            <a:hlinkClick r:id="rId7" tooltip="https://github.com/samquansah-algo/nbc-vct/blob/main/brand/NBC_Brand_Guide.pdf"/>
           </p:cNvPr>
           <p:cNvPicPr>
             <a:picLocks noChangeAspect="1"/>
@@ -4826,7 +4930,7 @@
           <p:nvPr/>
         </p:nvPicPr>
         <p:blipFill>
-          <a:blip r:embed="rId4"/>
+          <a:blip r:embed="rId6"/>
           <a:stretch>
             <a:fillRect/>
           </a:stretch>
@@ -4893,7 +4997,7 @@
       <p:pic>
         <p:nvPicPr>
           <p:cNvPr id="3" name="Image 1" descr="preencoded.png">
-            <a:hlinkClick r:id="rId3" tooltip="https://github.com/samquansah-algo/nbc-vct/blob/main/weekly-tactics/04-sales/README.md"/>
+            <a:hlinkClick r:id="rId3" tooltip="https://github.com/samquansah-algo/nbc-vct/tree/main/weekly-tactics/04-sales/"/>
           </p:cNvPr>
           <p:cNvPicPr>
             <a:picLocks noChangeAspect="1"/>
@@ -4902,6 +5006,32 @@
         </p:nvPicPr>
         <p:blipFill>
           <a:blip r:embed="rId2"/>
+          <a:stretch>
+            <a:fillRect/>
+          </a:stretch>
+        </p:blipFill>
+        <p:spPr>
+          <a:xfrm>
+            <a:off x="6462713" y="4610100"/>
+            <a:ext cx="233362" cy="95250"/>
+          </a:xfrm>
+          <a:prstGeom prst="rect">
+            <a:avLst/>
+          </a:prstGeom>
+        </p:spPr>
+      </p:pic>
+      <p:pic>
+        <p:nvPicPr>
+          <p:cNvPr id="4" name="Image 2" descr="preencoded.png">
+            <a:hlinkClick r:id="rId5" tooltip="https://github.com/samquansah-algo/nbc-vct/blob/main/weekly-tactics/04-sales/README.md"/>
+          </p:cNvPr>
+          <p:cNvPicPr>
+            <a:picLocks noChangeAspect="1"/>
+          </p:cNvPicPr>
+          <p:nvPr/>
+        </p:nvPicPr>
+        <p:blipFill>
+          <a:blip r:embed="rId4"/>
           <a:stretch>
             <a:fillRect/>
           </a:stretch>
@@ -4918,8 +5048,8 @@
       </p:pic>
       <p:pic>
         <p:nvPicPr>
-          <p:cNvPr id="4" name="Image 2" descr="preencoded.png">
-            <a:hlinkClick r:id="rId5" tooltip="https://github.com/samquansah-algo/nbc-vct/blob/main/brand/NBC_Brand_Guide.pdf"/>
+          <p:cNvPr id="5" name="Image 3" descr="preencoded.png">
+            <a:hlinkClick r:id="rId7" tooltip="https://github.com/samquansah-algo/nbc-vct/blob/main/brand/NBC_Brand_Guide.pdf"/>
           </p:cNvPr>
           <p:cNvPicPr>
             <a:picLocks noChangeAspect="1"/>
@@ -4927,7 +5057,7 @@
           <p:nvPr/>
         </p:nvPicPr>
         <p:blipFill>
-          <a:blip r:embed="rId4"/>
+          <a:blip r:embed="rId6"/>
           <a:stretch>
             <a:fillRect/>
           </a:stretch>
@@ -4994,7 +5124,7 @@
       <p:pic>
         <p:nvPicPr>
           <p:cNvPr id="3" name="Image 1" descr="preencoded.png">
-            <a:hlinkClick r:id="rId3" tooltip="https://github.com/samquansah-algo/nbc-vct/blob/main/weekly-tactics/04-sales/README.md"/>
+            <a:hlinkClick r:id="rId3" tooltip="https://github.com/samquansah-algo/nbc-vct/tree/main/weekly-tactics/04-sales/"/>
           </p:cNvPr>
           <p:cNvPicPr>
             <a:picLocks noChangeAspect="1"/>
@@ -5003,6 +5133,32 @@
         </p:nvPicPr>
         <p:blipFill>
           <a:blip r:embed="rId2"/>
+          <a:stretch>
+            <a:fillRect/>
+          </a:stretch>
+        </p:blipFill>
+        <p:spPr>
+          <a:xfrm>
+            <a:off x="6462713" y="4610100"/>
+            <a:ext cx="233362" cy="95250"/>
+          </a:xfrm>
+          <a:prstGeom prst="rect">
+            <a:avLst/>
+          </a:prstGeom>
+        </p:spPr>
+      </p:pic>
+      <p:pic>
+        <p:nvPicPr>
+          <p:cNvPr id="4" name="Image 2" descr="preencoded.png">
+            <a:hlinkClick r:id="rId5" tooltip="https://github.com/samquansah-algo/nbc-vct/blob/main/weekly-tactics/04-sales/README.md"/>
+          </p:cNvPr>
+          <p:cNvPicPr>
+            <a:picLocks noChangeAspect="1"/>
+          </p:cNvPicPr>
+          <p:nvPr/>
+        </p:nvPicPr>
+        <p:blipFill>
+          <a:blip r:embed="rId4"/>
           <a:stretch>
             <a:fillRect/>
           </a:stretch>
@@ -5019,8 +5175,8 @@
       </p:pic>
       <p:pic>
         <p:nvPicPr>
-          <p:cNvPr id="4" name="Image 2" descr="preencoded.png">
-            <a:hlinkClick r:id="rId5" tooltip="https://github.com/samquansah-algo/nbc-vct/blob/main/brand/NBC_Brand_Guide.pdf"/>
+          <p:cNvPr id="5" name="Image 3" descr="preencoded.png">
+            <a:hlinkClick r:id="rId7" tooltip="https://github.com/samquansah-algo/nbc-vct/blob/main/brand/NBC_Brand_Guide.pdf"/>
           </p:cNvPr>
           <p:cNvPicPr>
             <a:picLocks noChangeAspect="1"/>
@@ -5028,7 +5184,7 @@
           <p:nvPr/>
         </p:nvPicPr>
         <p:blipFill>
-          <a:blip r:embed="rId4"/>
+          <a:blip r:embed="rId6"/>
           <a:stretch>
             <a:fillRect/>
           </a:stretch>
@@ -5750,7 +5906,7 @@
       <p:pic>
         <p:nvPicPr>
           <p:cNvPr id="3" name="Image 1" descr="preencoded.png">
-            <a:hlinkClick r:id="rId3" tooltip="https://github.com/samquansah-algo/nbc-vct/blob/main/weekly-tactics/04-sales/OUTREACH_KIT.md"/>
+            <a:hlinkClick r:id="rId3" tooltip="https://github.com/samquansah-algo/nbc-vct/tree/main/weekly-tactics/04-sales/"/>
           </p:cNvPr>
           <p:cNvPicPr>
             <a:picLocks noChangeAspect="1"/>
@@ -5759,6 +5915,32 @@
         </p:nvPicPr>
         <p:blipFill>
           <a:blip r:embed="rId2"/>
+          <a:stretch>
+            <a:fillRect/>
+          </a:stretch>
+        </p:blipFill>
+        <p:spPr>
+          <a:xfrm>
+            <a:off x="7539037" y="2760166"/>
+            <a:ext cx="352425" cy="142875"/>
+          </a:xfrm>
+          <a:prstGeom prst="rect">
+            <a:avLst/>
+          </a:prstGeom>
+        </p:spPr>
+      </p:pic>
+      <p:pic>
+        <p:nvPicPr>
+          <p:cNvPr id="4" name="Image 2" descr="preencoded.png">
+            <a:hlinkClick r:id="rId5" tooltip="https://github.com/samquansah-algo/nbc-vct/blob/main/weekly-tactics/04-sales/OUTREACH_KIT.md"/>
+          </p:cNvPr>
+          <p:cNvPicPr>
+            <a:picLocks noChangeAspect="1"/>
+          </p:cNvPicPr>
+          <p:nvPr/>
+        </p:nvPicPr>
+        <p:blipFill>
+          <a:blip r:embed="rId4"/>
           <a:stretch>
             <a:fillRect/>
           </a:stretch>
@@ -5775,8 +5957,8 @@
       </p:pic>
       <p:pic>
         <p:nvPicPr>
-          <p:cNvPr id="4" name="Image 2" descr="preencoded.png">
-            <a:hlinkClick r:id="rId5" tooltip="https://github.com/samquansah-algo/nbc-vct/blob/main/brand/NBC_Brand_Guide.pdf"/>
+          <p:cNvPr id="5" name="Image 3" descr="preencoded.png">
+            <a:hlinkClick r:id="rId7" tooltip="https://github.com/samquansah-algo/nbc-vct/blob/main/brand/NBC_Brand_Guide.pdf"/>
           </p:cNvPr>
           <p:cNvPicPr>
             <a:picLocks noChangeAspect="1"/>
@@ -5784,7 +5966,7 @@
           <p:nvPr/>
         </p:nvPicPr>
         <p:blipFill>
-          <a:blip r:embed="rId4"/>
+          <a:blip r:embed="rId6"/>
           <a:stretch>
             <a:fillRect/>
           </a:stretch>
@@ -5851,7 +6033,7 @@
       <p:pic>
         <p:nvPicPr>
           <p:cNvPr id="3" name="Image 1" descr="preencoded.png">
-            <a:hlinkClick r:id="rId3" tooltip="https://github.com/samquansah-algo/nbc-vct/blob/main/marketing/crm/README.md"/>
+            <a:hlinkClick r:id="rId3" tooltip="https://github.com/samquansah-algo/nbc-vct/tree/main/weekly-tactics/04-sales/"/>
           </p:cNvPr>
           <p:cNvPicPr>
             <a:picLocks noChangeAspect="1"/>
@@ -5860,6 +6042,32 @@
         </p:nvPicPr>
         <p:blipFill>
           <a:blip r:embed="rId2"/>
+          <a:stretch>
+            <a:fillRect/>
+          </a:stretch>
+        </p:blipFill>
+        <p:spPr>
+          <a:xfrm>
+            <a:off x="1500188" y="3810000"/>
+            <a:ext cx="352425" cy="142875"/>
+          </a:xfrm>
+          <a:prstGeom prst="rect">
+            <a:avLst/>
+          </a:prstGeom>
+        </p:spPr>
+      </p:pic>
+      <p:pic>
+        <p:nvPicPr>
+          <p:cNvPr id="4" name="Image 2" descr="preencoded.png">
+            <a:hlinkClick r:id="rId5" tooltip="https://github.com/samquansah-algo/nbc-vct/blob/main/marketing/crm/README.md"/>
+          </p:cNvPr>
+          <p:cNvPicPr>
+            <a:picLocks noChangeAspect="1"/>
+          </p:cNvPicPr>
+          <p:nvPr/>
+        </p:nvPicPr>
+        <p:blipFill>
+          <a:blip r:embed="rId4"/>
           <a:stretch>
             <a:fillRect/>
           </a:stretch>
@@ -5876,8 +6084,8 @@
       </p:pic>
       <p:pic>
         <p:nvPicPr>
-          <p:cNvPr id="4" name="Image 2" descr="preencoded.png">
-            <a:hlinkClick r:id="rId5" tooltip="https://github.com/samquansah-algo/nbc-vct/blob/main/brand/NBC_Brand_Guide.pdf"/>
+          <p:cNvPr id="5" name="Image 3" descr="preencoded.png">
+            <a:hlinkClick r:id="rId7" tooltip="https://github.com/samquansah-algo/nbc-vct/blob/main/brand/NBC_Brand_Guide.pdf"/>
           </p:cNvPr>
           <p:cNvPicPr>
             <a:picLocks noChangeAspect="1"/>
@@ -5885,7 +6093,7 @@
           <p:nvPr/>
         </p:nvPicPr>
         <p:blipFill>
-          <a:blip r:embed="rId4"/>
+          <a:blip r:embed="rId6"/>
           <a:stretch>
             <a:fillRect/>
           </a:stretch>
@@ -5952,7 +6160,7 @@
       <p:pic>
         <p:nvPicPr>
           <p:cNvPr id="3" name="Image 1" descr="preencoded.png">
-            <a:hlinkClick r:id="rId3" tooltip="https://github.com/samquansah-algo/nbc-vct/blob/main/marketing/crm/README.md"/>
+            <a:hlinkClick r:id="rId3" tooltip="https://github.com/samquansah-algo/nbc-vct/tree/main/weekly-tactics/04-sales/"/>
           </p:cNvPr>
           <p:cNvPicPr>
             <a:picLocks noChangeAspect="1"/>
@@ -5961,6 +6169,32 @@
         </p:nvPicPr>
         <p:blipFill>
           <a:blip r:embed="rId2"/>
+          <a:stretch>
+            <a:fillRect/>
+          </a:stretch>
+        </p:blipFill>
+        <p:spPr>
+          <a:xfrm>
+            <a:off x="1071563" y="3952875"/>
+            <a:ext cx="352425" cy="142875"/>
+          </a:xfrm>
+          <a:prstGeom prst="rect">
+            <a:avLst/>
+          </a:prstGeom>
+        </p:spPr>
+      </p:pic>
+      <p:pic>
+        <p:nvPicPr>
+          <p:cNvPr id="4" name="Image 2" descr="preencoded.png">
+            <a:hlinkClick r:id="rId5" tooltip="https://github.com/samquansah-algo/nbc-vct/blob/main/marketing/crm/README.md"/>
+          </p:cNvPr>
+          <p:cNvPicPr>
+            <a:picLocks noChangeAspect="1"/>
+          </p:cNvPicPr>
+          <p:nvPr/>
+        </p:nvPicPr>
+        <p:blipFill>
+          <a:blip r:embed="rId4"/>
           <a:stretch>
             <a:fillRect/>
           </a:stretch>
@@ -5977,8 +6211,8 @@
       </p:pic>
       <p:pic>
         <p:nvPicPr>
-          <p:cNvPr id="4" name="Image 2" descr="preencoded.png">
-            <a:hlinkClick r:id="rId5" tooltip="https://github.com/samquansah-algo/nbc-vct/blob/main/brand/NBC_Brand_Guide.pdf"/>
+          <p:cNvPr id="5" name="Image 3" descr="preencoded.png">
+            <a:hlinkClick r:id="rId7" tooltip="https://github.com/samquansah-algo/nbc-vct/blob/main/brand/NBC_Brand_Guide.pdf"/>
           </p:cNvPr>
           <p:cNvPicPr>
             <a:picLocks noChangeAspect="1"/>
@@ -5986,7 +6220,7 @@
           <p:nvPr/>
         </p:nvPicPr>
         <p:blipFill>
-          <a:blip r:embed="rId4"/>
+          <a:blip r:embed="rId6"/>
           <a:stretch>
             <a:fillRect/>
           </a:stretch>

</xml_diff>

<commit_message>
Tactic 4: client-facing lead lists; website marked in development
Co-Authored-By: Claude Opus 5.5 <noreply@anthropic.com>
Claude-Session: https://claude.ai/code/session_014DwxjU8rHfrSVBV6irvX7Y
</commit_message>
<xml_diff>
--- a/weekly-tactics/04-sales/NBC_Sales_Tactic.pptx
+++ b/weekly-tactics/04-sales/NBC_Sales_Tactic.pptx
@@ -4504,7 +4504,7 @@
         </p:blipFill>
         <p:spPr>
           <a:xfrm>
-            <a:off x="6462713" y="4610100"/>
+            <a:off x="3971925" y="4610100"/>
             <a:ext cx="233362" cy="95250"/>
           </a:xfrm>
           <a:prstGeom prst="rect">
@@ -4631,7 +4631,7 @@
         </p:blipFill>
         <p:spPr>
           <a:xfrm>
-            <a:off x="6462713" y="4610100"/>
+            <a:off x="3971925" y="4610100"/>
             <a:ext cx="233362" cy="95250"/>
           </a:xfrm>
           <a:prstGeom prst="rect">
@@ -4758,7 +4758,7 @@
         </p:blipFill>
         <p:spPr>
           <a:xfrm>
-            <a:off x="6462713" y="4610100"/>
+            <a:off x="3971925" y="4610100"/>
             <a:ext cx="233362" cy="95250"/>
           </a:xfrm>
           <a:prstGeom prst="rect">
@@ -4885,7 +4885,7 @@
         </p:blipFill>
         <p:spPr>
           <a:xfrm>
-            <a:off x="6462713" y="4610100"/>
+            <a:off x="3971925" y="4610100"/>
             <a:ext cx="233362" cy="95250"/>
           </a:xfrm>
           <a:prstGeom prst="rect">
@@ -5012,7 +5012,7 @@
         </p:blipFill>
         <p:spPr>
           <a:xfrm>
-            <a:off x="6462713" y="4610100"/>
+            <a:off x="3971925" y="4610100"/>
             <a:ext cx="233362" cy="95250"/>
           </a:xfrm>
           <a:prstGeom prst="rect">
@@ -5139,7 +5139,7 @@
         </p:blipFill>
         <p:spPr>
           <a:xfrm>
-            <a:off x="6462713" y="4610100"/>
+            <a:off x="3971925" y="4610100"/>
             <a:ext cx="233362" cy="95250"/>
           </a:xfrm>
           <a:prstGeom prst="rect">

</xml_diff>

<commit_message>
Tactic 4: layout fixes (headline spacing, fixed table columns, no overflow)
Co-Authored-By: Claude Opus 5.5 <noreply@anthropic.com>
Claude-Session: https://claude.ai/code/session_014DwxjU8rHfrSVBV6irvX7Y
</commit_message>
<xml_diff>
--- a/weekly-tactics/04-sales/NBC_Sales_Tactic.pptx
+++ b/weekly-tactics/04-sales/NBC_Sales_Tactic.pptx
@@ -43,9 +43,10 @@
     <p:sldId id="291" r:id="rId37"/>
     <p:sldId id="292" r:id="rId38"/>
     <p:sldId id="293" r:id="rId39"/>
+    <p:sldId id="294" r:id="rId40"/>
   </p:sldIdLst>
   <p:notesMasterIdLst>
-    <p:notesMasterId r:id="rId40"/>
+    <p:notesMasterId r:id="rId41"/>
   </p:notesMasterIdLst>
   <p:sldSz cx="9144000" cy="5143500"/>
   <p:notesSz cx="5143500" cy="9144000"/>
@@ -3309,6 +3310,94 @@
 </p:notes>
 </file>
 
+<file path=ppt/notesSlides/notesSlide39.xml><?xml version="1.0" encoding="utf-8"?>
+<p:notes xmlns:a="http://schemas.openxmlformats.org/drawingml/2006/main" xmlns:r="http://schemas.openxmlformats.org/officeDocument/2006/relationships" xmlns:p="http://schemas.openxmlformats.org/presentationml/2006/main">
+  <p:cSld>
+    <p:spTree>
+      <p:nvGrpSpPr>
+        <p:cNvPr id="1" name=""/>
+        <p:cNvGrpSpPr/>
+        <p:nvPr/>
+      </p:nvGrpSpPr>
+      <p:grpSpPr>
+        <a:xfrm>
+          <a:off x="0" y="0"/>
+          <a:ext cx="0" cy="0"/>
+          <a:chOff x="0" y="0"/>
+          <a:chExt cx="0" cy="0"/>
+        </a:xfrm>
+      </p:grpSpPr>
+      <p:sp>
+        <p:nvSpPr>
+          <p:cNvPr id="2" name="Slide Image Placeholder 1"/>
+          <p:cNvSpPr>
+            <a:spLocks noGrp="1" noRot="1" noChangeAspect="1"/>
+          </p:cNvSpPr>
+          <p:nvPr>
+            <p:ph type="sldImg"/>
+          </p:nvPr>
+        </p:nvSpPr>
+        <p:spPr/>
+      </p:sp>
+      <p:sp>
+        <p:nvSpPr>
+          <p:cNvPr id="3" name="Notes Placeholder 2"/>
+          <p:cNvSpPr>
+            <a:spLocks noGrp="1"/>
+          </p:cNvSpPr>
+          <p:nvPr>
+            <p:ph type="body" idx="1"/>
+          </p:nvPr>
+        </p:nvSpPr>
+        <p:spPr/>
+        <p:txBody>
+          <a:bodyPr/>
+          <a:lstStyle/>
+          <a:p>
+            <a:r>
+              <a:rPr lang="en-US" dirty="0"/>
+              <a:t/>
+            </a:r>
+            <a:endParaRPr lang="en-US" dirty="0"/>
+          </a:p>
+        </p:txBody>
+      </p:sp>
+      <p:sp>
+        <p:nvSpPr>
+          <p:cNvPr id="4" name="Slide Number Placeholder 3"/>
+          <p:cNvSpPr>
+            <a:spLocks noGrp="1"/>
+          </p:cNvSpPr>
+          <p:nvPr>
+            <p:ph type="sldNum" sz="quarter" idx="10"/>
+          </p:nvPr>
+        </p:nvSpPr>
+        <p:spPr/>
+        <p:txBody>
+          <a:bodyPr/>
+          <a:lstStyle/>
+          <a:p>
+            <a:fld id="{F7021451-1387-4CA6-816F-3879F97B5CBC}" type="slidenum">
+              <a:rPr lang="en-US"/>
+              <a:t>39</a:t>
+            </a:fld>
+            <a:endParaRPr lang="en-US"/>
+          </a:p>
+        </p:txBody>
+      </p:sp>
+    </p:spTree>
+    <p:extLst>
+      <p:ext uri="{BB962C8B-B14F-4D97-AF65-F5344CB8AC3E}">
+        <p14:creationId xmlns:p14="http://schemas.microsoft.com/office/powerpoint/2010/main" val="1024086991"/>
+      </p:ext>
+    </p:extLst>
+  </p:cSld>
+  <p:clrMapOvr>
+    <a:masterClrMapping/>
+  </p:clrMapOvr>
+</p:notes>
+</file>
+
 <file path=ppt/notesSlides/notesSlide4.xml><?xml version="1.0" encoding="utf-8"?>
 <p:notes xmlns:a="http://schemas.openxmlformats.org/drawingml/2006/main" xmlns:r="http://schemas.openxmlformats.org/officeDocument/2006/relationships" xmlns:p="http://schemas.openxmlformats.org/presentationml/2006/main">
   <p:cSld>
@@ -4682,7 +4771,7 @@
         </p:blipFill>
         <p:spPr>
           <a:xfrm>
-            <a:off x="6782842" y="1304627"/>
+            <a:off x="6429375" y="1322040"/>
             <a:ext cx="633412" cy="95250"/>
           </a:xfrm>
           <a:prstGeom prst="rect">
@@ -4708,7 +4797,7 @@
         </p:blipFill>
         <p:spPr>
           <a:xfrm>
-            <a:off x="6782842" y="1420118"/>
+            <a:off x="6429375" y="1460153"/>
             <a:ext cx="661987" cy="95250"/>
           </a:xfrm>
           <a:prstGeom prst="rect">
@@ -4734,7 +4823,7 @@
         </p:blipFill>
         <p:spPr>
           <a:xfrm>
-            <a:off x="6782842" y="1535609"/>
+            <a:off x="6429375" y="1598265"/>
             <a:ext cx="585788" cy="95250"/>
           </a:xfrm>
           <a:prstGeom prst="rect">
@@ -4760,7 +4849,7 @@
         </p:blipFill>
         <p:spPr>
           <a:xfrm>
-            <a:off x="6782842" y="1651099"/>
+            <a:off x="6429375" y="1736378"/>
             <a:ext cx="571500" cy="95250"/>
           </a:xfrm>
           <a:prstGeom prst="rect">
@@ -4786,7 +4875,7 @@
         </p:blipFill>
         <p:spPr>
           <a:xfrm>
-            <a:off x="6782842" y="1766590"/>
+            <a:off x="6429375" y="1874490"/>
             <a:ext cx="552450" cy="95250"/>
           </a:xfrm>
           <a:prstGeom prst="rect">
@@ -4812,7 +4901,7 @@
         </p:blipFill>
         <p:spPr>
           <a:xfrm>
-            <a:off x="6782842" y="1882080"/>
+            <a:off x="6429375" y="2012603"/>
             <a:ext cx="881063" cy="95250"/>
           </a:xfrm>
           <a:prstGeom prst="rect">
@@ -4838,7 +4927,7 @@
         </p:blipFill>
         <p:spPr>
           <a:xfrm>
-            <a:off x="6782842" y="1997571"/>
+            <a:off x="6429375" y="2150715"/>
             <a:ext cx="1109662" cy="95250"/>
           </a:xfrm>
           <a:prstGeom prst="rect">
@@ -4864,7 +4953,7 @@
         </p:blipFill>
         <p:spPr>
           <a:xfrm>
-            <a:off x="6782842" y="2113062"/>
+            <a:off x="6429375" y="2288828"/>
             <a:ext cx="995362" cy="95250"/>
           </a:xfrm>
           <a:prstGeom prst="rect">
@@ -4890,7 +4979,7 @@
         </p:blipFill>
         <p:spPr>
           <a:xfrm>
-            <a:off x="6782842" y="2228552"/>
+            <a:off x="6429375" y="2426940"/>
             <a:ext cx="995362" cy="95250"/>
           </a:xfrm>
           <a:prstGeom prst="rect">
@@ -4916,7 +5005,7 @@
         </p:blipFill>
         <p:spPr>
           <a:xfrm>
-            <a:off x="6782842" y="2344043"/>
+            <a:off x="6429375" y="2565053"/>
             <a:ext cx="704850" cy="95250"/>
           </a:xfrm>
           <a:prstGeom prst="rect">
@@ -4942,7 +5031,7 @@
         </p:blipFill>
         <p:spPr>
           <a:xfrm>
-            <a:off x="6782842" y="2459534"/>
+            <a:off x="6429375" y="2703165"/>
             <a:ext cx="871538" cy="95250"/>
           </a:xfrm>
           <a:prstGeom prst="rect">
@@ -4968,7 +5057,7 @@
         </p:blipFill>
         <p:spPr>
           <a:xfrm>
-            <a:off x="6782842" y="2575024"/>
+            <a:off x="6429375" y="2841278"/>
             <a:ext cx="995362" cy="95250"/>
           </a:xfrm>
           <a:prstGeom prst="rect">
@@ -4994,7 +5083,7 @@
         </p:blipFill>
         <p:spPr>
           <a:xfrm>
-            <a:off x="6782842" y="2690515"/>
+            <a:off x="6429375" y="2979390"/>
             <a:ext cx="552450" cy="95250"/>
           </a:xfrm>
           <a:prstGeom prst="rect">
@@ -5020,7 +5109,7 @@
         </p:blipFill>
         <p:spPr>
           <a:xfrm>
-            <a:off x="6782842" y="2806005"/>
+            <a:off x="6429375" y="3117503"/>
             <a:ext cx="557213" cy="95250"/>
           </a:xfrm>
           <a:prstGeom prst="rect">
@@ -5046,7 +5135,7 @@
         </p:blipFill>
         <p:spPr>
           <a:xfrm>
-            <a:off x="6782842" y="2921496"/>
+            <a:off x="6429375" y="3255615"/>
             <a:ext cx="552450" cy="95250"/>
           </a:xfrm>
           <a:prstGeom prst="rect">
@@ -5072,7 +5161,7 @@
         </p:blipFill>
         <p:spPr>
           <a:xfrm>
-            <a:off x="6782842" y="3036987"/>
+            <a:off x="6429375" y="3393728"/>
             <a:ext cx="881063" cy="95250"/>
           </a:xfrm>
           <a:prstGeom prst="rect">
@@ -5098,7 +5187,7 @@
         </p:blipFill>
         <p:spPr>
           <a:xfrm>
-            <a:off x="6782842" y="3152477"/>
+            <a:off x="6429375" y="3531840"/>
             <a:ext cx="919162" cy="95250"/>
           </a:xfrm>
           <a:prstGeom prst="rect">
@@ -5124,7 +5213,7 @@
         </p:blipFill>
         <p:spPr>
           <a:xfrm>
-            <a:off x="6782842" y="3267968"/>
+            <a:off x="6429375" y="3669953"/>
             <a:ext cx="614363" cy="95250"/>
           </a:xfrm>
           <a:prstGeom prst="rect">
@@ -5150,7 +5239,7 @@
         </p:blipFill>
         <p:spPr>
           <a:xfrm>
-            <a:off x="6782842" y="3383459"/>
+            <a:off x="6429375" y="3808065"/>
             <a:ext cx="661987" cy="95250"/>
           </a:xfrm>
           <a:prstGeom prst="rect">
@@ -5176,7 +5265,7 @@
         </p:blipFill>
         <p:spPr>
           <a:xfrm>
-            <a:off x="6782842" y="3498949"/>
+            <a:off x="6429375" y="3946178"/>
             <a:ext cx="1285875" cy="95250"/>
           </a:xfrm>
           <a:prstGeom prst="rect">
@@ -5202,7 +5291,7 @@
         </p:blipFill>
         <p:spPr>
           <a:xfrm>
-            <a:off x="6782842" y="3614440"/>
+            <a:off x="6429375" y="4084290"/>
             <a:ext cx="447675" cy="95250"/>
           </a:xfrm>
           <a:prstGeom prst="rect">
@@ -5228,7 +5317,7 @@
         </p:blipFill>
         <p:spPr>
           <a:xfrm>
-            <a:off x="6782842" y="3729930"/>
+            <a:off x="6429375" y="4222403"/>
             <a:ext cx="919162" cy="95250"/>
           </a:xfrm>
           <a:prstGeom prst="rect">
@@ -5381,7 +5470,7 @@
         </p:blipFill>
         <p:spPr>
           <a:xfrm>
-            <a:off x="7046714" y="1304627"/>
+            <a:off x="6429375" y="1322040"/>
             <a:ext cx="733425" cy="95250"/>
           </a:xfrm>
           <a:prstGeom prst="rect">
@@ -5407,7 +5496,7 @@
         </p:blipFill>
         <p:spPr>
           <a:xfrm>
-            <a:off x="7046714" y="1420118"/>
+            <a:off x="6429375" y="1460153"/>
             <a:ext cx="447675" cy="95250"/>
           </a:xfrm>
           <a:prstGeom prst="rect">
@@ -5433,7 +5522,7 @@
         </p:blipFill>
         <p:spPr>
           <a:xfrm>
-            <a:off x="7046714" y="1535609"/>
+            <a:off x="6429375" y="1598265"/>
             <a:ext cx="823913" cy="95250"/>
           </a:xfrm>
           <a:prstGeom prst="rect">
@@ -5459,7 +5548,7 @@
         </p:blipFill>
         <p:spPr>
           <a:xfrm>
-            <a:off x="7046714" y="1651099"/>
+            <a:off x="6429375" y="1736378"/>
             <a:ext cx="400050" cy="95250"/>
           </a:xfrm>
           <a:prstGeom prst="rect">
@@ -5485,7 +5574,7 @@
         </p:blipFill>
         <p:spPr>
           <a:xfrm>
-            <a:off x="7046714" y="1766590"/>
+            <a:off x="6429375" y="1874490"/>
             <a:ext cx="447675" cy="95250"/>
           </a:xfrm>
           <a:prstGeom prst="rect">
@@ -5511,7 +5600,7 @@
         </p:blipFill>
         <p:spPr>
           <a:xfrm>
-            <a:off x="7046714" y="1882080"/>
+            <a:off x="6429375" y="2012603"/>
             <a:ext cx="490537" cy="95250"/>
           </a:xfrm>
           <a:prstGeom prst="rect">
@@ -5537,7 +5626,7 @@
         </p:blipFill>
         <p:spPr>
           <a:xfrm>
-            <a:off x="7046714" y="1997571"/>
+            <a:off x="6429375" y="2150715"/>
             <a:ext cx="1023937" cy="95250"/>
           </a:xfrm>
           <a:prstGeom prst="rect">
@@ -5563,7 +5652,7 @@
         </p:blipFill>
         <p:spPr>
           <a:xfrm>
-            <a:off x="7046714" y="2113062"/>
+            <a:off x="6429375" y="2288828"/>
             <a:ext cx="509587" cy="95250"/>
           </a:xfrm>
           <a:prstGeom prst="rect">
@@ -5589,7 +5678,7 @@
         </p:blipFill>
         <p:spPr>
           <a:xfrm>
-            <a:off x="7046714" y="2228552"/>
+            <a:off x="6429375" y="2426940"/>
             <a:ext cx="781050" cy="95250"/>
           </a:xfrm>
           <a:prstGeom prst="rect">
@@ -5615,7 +5704,7 @@
         </p:blipFill>
         <p:spPr>
           <a:xfrm>
-            <a:off x="7046714" y="2344043"/>
+            <a:off x="6429375" y="2565053"/>
             <a:ext cx="838200" cy="95250"/>
           </a:xfrm>
           <a:prstGeom prst="rect">
@@ -5641,7 +5730,7 @@
         </p:blipFill>
         <p:spPr>
           <a:xfrm>
-            <a:off x="7046714" y="2459534"/>
+            <a:off x="6429375" y="2703165"/>
             <a:ext cx="666750" cy="95250"/>
           </a:xfrm>
           <a:prstGeom prst="rect">
@@ -5667,7 +5756,7 @@
         </p:blipFill>
         <p:spPr>
           <a:xfrm>
-            <a:off x="7046714" y="2575024"/>
+            <a:off x="6429375" y="2841278"/>
             <a:ext cx="542925" cy="95250"/>
           </a:xfrm>
           <a:prstGeom prst="rect">
@@ -5693,7 +5782,7 @@
         </p:blipFill>
         <p:spPr>
           <a:xfrm>
-            <a:off x="7046714" y="2690515"/>
+            <a:off x="6429375" y="2979390"/>
             <a:ext cx="552450" cy="95250"/>
           </a:xfrm>
           <a:prstGeom prst="rect">
@@ -5719,7 +5808,7 @@
         </p:blipFill>
         <p:spPr>
           <a:xfrm>
-            <a:off x="7046714" y="2806005"/>
+            <a:off x="6429375" y="3117503"/>
             <a:ext cx="509587" cy="95250"/>
           </a:xfrm>
           <a:prstGeom prst="rect">
@@ -5745,7 +5834,7 @@
         </p:blipFill>
         <p:spPr>
           <a:xfrm>
-            <a:off x="7046714" y="2921496"/>
+            <a:off x="6429375" y="3255615"/>
             <a:ext cx="723900" cy="95250"/>
           </a:xfrm>
           <a:prstGeom prst="rect">
@@ -5771,7 +5860,7 @@
         </p:blipFill>
         <p:spPr>
           <a:xfrm>
-            <a:off x="7046714" y="3036987"/>
+            <a:off x="6429375" y="3393728"/>
             <a:ext cx="428625" cy="95250"/>
           </a:xfrm>
           <a:prstGeom prst="rect">
@@ -5797,7 +5886,7 @@
         </p:blipFill>
         <p:spPr>
           <a:xfrm>
-            <a:off x="7046714" y="3152477"/>
+            <a:off x="6429375" y="3531840"/>
             <a:ext cx="495300" cy="95250"/>
           </a:xfrm>
           <a:prstGeom prst="rect">
@@ -5823,7 +5912,7 @@
         </p:blipFill>
         <p:spPr>
           <a:xfrm>
-            <a:off x="7046714" y="3267968"/>
+            <a:off x="6429375" y="3669953"/>
             <a:ext cx="604837" cy="95250"/>
           </a:xfrm>
           <a:prstGeom prst="rect">
@@ -5849,7 +5938,7 @@
         </p:blipFill>
         <p:spPr>
           <a:xfrm>
-            <a:off x="7046714" y="3383459"/>
+            <a:off x="6429375" y="3808065"/>
             <a:ext cx="633412" cy="95250"/>
           </a:xfrm>
           <a:prstGeom prst="rect">
@@ -5875,7 +5964,7 @@
         </p:blipFill>
         <p:spPr>
           <a:xfrm>
-            <a:off x="7046714" y="3498949"/>
+            <a:off x="6429375" y="3946178"/>
             <a:ext cx="514350" cy="95250"/>
           </a:xfrm>
           <a:prstGeom prst="rect">
@@ -5901,7 +5990,7 @@
         </p:blipFill>
         <p:spPr>
           <a:xfrm>
-            <a:off x="7046714" y="3614440"/>
+            <a:off x="6429375" y="4084290"/>
             <a:ext cx="785813" cy="95250"/>
           </a:xfrm>
           <a:prstGeom prst="rect">
@@ -5927,7 +6016,7 @@
         </p:blipFill>
         <p:spPr>
           <a:xfrm>
-            <a:off x="7046714" y="3729930"/>
+            <a:off x="6429375" y="4222403"/>
             <a:ext cx="500063" cy="95250"/>
           </a:xfrm>
           <a:prstGeom prst="rect">
@@ -6080,7 +6169,7 @@
         </p:blipFill>
         <p:spPr>
           <a:xfrm>
-            <a:off x="6815584" y="1304627"/>
+            <a:off x="6429375" y="1322040"/>
             <a:ext cx="533400" cy="95250"/>
           </a:xfrm>
           <a:prstGeom prst="rect">
@@ -6106,7 +6195,7 @@
         </p:blipFill>
         <p:spPr>
           <a:xfrm>
-            <a:off x="6815584" y="1420118"/>
+            <a:off x="6429375" y="1460153"/>
             <a:ext cx="290513" cy="95250"/>
           </a:xfrm>
           <a:prstGeom prst="rect">
@@ -6132,7 +6221,7 @@
         </p:blipFill>
         <p:spPr>
           <a:xfrm>
-            <a:off x="6815584" y="1535609"/>
+            <a:off x="6429375" y="1598265"/>
             <a:ext cx="452437" cy="95250"/>
           </a:xfrm>
           <a:prstGeom prst="rect">
@@ -6158,7 +6247,7 @@
         </p:blipFill>
         <p:spPr>
           <a:xfrm>
-            <a:off x="6815584" y="1651099"/>
+            <a:off x="6429375" y="1736378"/>
             <a:ext cx="590550" cy="95250"/>
           </a:xfrm>
           <a:prstGeom prst="rect">
@@ -6184,7 +6273,7 @@
         </p:blipFill>
         <p:spPr>
           <a:xfrm>
-            <a:off x="6815584" y="1766590"/>
+            <a:off x="6429375" y="1874490"/>
             <a:ext cx="642938" cy="95250"/>
           </a:xfrm>
           <a:prstGeom prst="rect">
@@ -6210,7 +6299,7 @@
         </p:blipFill>
         <p:spPr>
           <a:xfrm>
-            <a:off x="6815584" y="1882080"/>
+            <a:off x="6429375" y="2012603"/>
             <a:ext cx="561975" cy="95250"/>
           </a:xfrm>
           <a:prstGeom prst="rect">
@@ -6236,7 +6325,7 @@
         </p:blipFill>
         <p:spPr>
           <a:xfrm>
-            <a:off x="6815584" y="1997571"/>
+            <a:off x="6429375" y="2150715"/>
             <a:ext cx="623888" cy="95250"/>
           </a:xfrm>
           <a:prstGeom prst="rect">
@@ -6262,7 +6351,7 @@
         </p:blipFill>
         <p:spPr>
           <a:xfrm>
-            <a:off x="6815584" y="2113062"/>
+            <a:off x="6429375" y="2288828"/>
             <a:ext cx="652463" cy="95250"/>
           </a:xfrm>
           <a:prstGeom prst="rect">
@@ -6288,7 +6377,7 @@
         </p:blipFill>
         <p:spPr>
           <a:xfrm>
-            <a:off x="6815584" y="2228552"/>
+            <a:off x="6429375" y="2426940"/>
             <a:ext cx="361950" cy="95250"/>
           </a:xfrm>
           <a:prstGeom prst="rect">
@@ -6314,7 +6403,7 @@
         </p:blipFill>
         <p:spPr>
           <a:xfrm>
-            <a:off x="6815584" y="2344043"/>
+            <a:off x="6429375" y="2565053"/>
             <a:ext cx="519112" cy="95250"/>
           </a:xfrm>
           <a:prstGeom prst="rect">
@@ -6340,7 +6429,7 @@
         </p:blipFill>
         <p:spPr>
           <a:xfrm>
-            <a:off x="6815584" y="2459534"/>
+            <a:off x="6429375" y="2703165"/>
             <a:ext cx="785813" cy="95250"/>
           </a:xfrm>
           <a:prstGeom prst="rect">
@@ -6366,7 +6455,7 @@
         </p:blipFill>
         <p:spPr>
           <a:xfrm>
-            <a:off x="6815584" y="2575024"/>
+            <a:off x="6429375" y="2841278"/>
             <a:ext cx="1057275" cy="95250"/>
           </a:xfrm>
           <a:prstGeom prst="rect">
@@ -6392,7 +6481,7 @@
         </p:blipFill>
         <p:spPr>
           <a:xfrm>
-            <a:off x="6815584" y="2690515"/>
+            <a:off x="6429375" y="2979390"/>
             <a:ext cx="976312" cy="95250"/>
           </a:xfrm>
           <a:prstGeom prst="rect">
@@ -6418,7 +6507,7 @@
         </p:blipFill>
         <p:spPr>
           <a:xfrm>
-            <a:off x="6815584" y="2806005"/>
+            <a:off x="6429375" y="3117503"/>
             <a:ext cx="704850" cy="95250"/>
           </a:xfrm>
           <a:prstGeom prst="rect">
@@ -6444,7 +6533,7 @@
         </p:blipFill>
         <p:spPr>
           <a:xfrm>
-            <a:off x="6815584" y="2921496"/>
+            <a:off x="6429375" y="3255615"/>
             <a:ext cx="857250" cy="95250"/>
           </a:xfrm>
           <a:prstGeom prst="rect">
@@ -6470,7 +6559,7 @@
         </p:blipFill>
         <p:spPr>
           <a:xfrm>
-            <a:off x="6815584" y="3036987"/>
+            <a:off x="6429375" y="3393728"/>
             <a:ext cx="681038" cy="95250"/>
           </a:xfrm>
           <a:prstGeom prst="rect">
@@ -6496,7 +6585,7 @@
         </p:blipFill>
         <p:spPr>
           <a:xfrm>
-            <a:off x="6815584" y="3152477"/>
+            <a:off x="6429375" y="3531840"/>
             <a:ext cx="814388" cy="95250"/>
           </a:xfrm>
           <a:prstGeom prst="rect">
@@ -6522,7 +6611,7 @@
         </p:blipFill>
         <p:spPr>
           <a:xfrm>
-            <a:off x="6815584" y="3267968"/>
+            <a:off x="6429375" y="3669953"/>
             <a:ext cx="633412" cy="95250"/>
           </a:xfrm>
           <a:prstGeom prst="rect">
@@ -6548,7 +6637,7 @@
         </p:blipFill>
         <p:spPr>
           <a:xfrm>
-            <a:off x="6815584" y="3383459"/>
+            <a:off x="6429375" y="3808065"/>
             <a:ext cx="895350" cy="95250"/>
           </a:xfrm>
           <a:prstGeom prst="rect">
@@ -6574,7 +6663,7 @@
         </p:blipFill>
         <p:spPr>
           <a:xfrm>
-            <a:off x="6815584" y="3498949"/>
+            <a:off x="6429375" y="3946178"/>
             <a:ext cx="995362" cy="95250"/>
           </a:xfrm>
           <a:prstGeom prst="rect">
@@ -6600,7 +6689,7 @@
         </p:blipFill>
         <p:spPr>
           <a:xfrm>
-            <a:off x="6815584" y="3614440"/>
+            <a:off x="6429375" y="4084290"/>
             <a:ext cx="681038" cy="95250"/>
           </a:xfrm>
           <a:prstGeom prst="rect">
@@ -6626,7 +6715,7 @@
         </p:blipFill>
         <p:spPr>
           <a:xfrm>
-            <a:off x="6815584" y="3729930"/>
+            <a:off x="6429375" y="4222403"/>
             <a:ext cx="885825" cy="95250"/>
           </a:xfrm>
           <a:prstGeom prst="rect">
@@ -6779,7 +6868,7 @@
         </p:blipFill>
         <p:spPr>
           <a:xfrm>
-            <a:off x="7040687" y="1304627"/>
+            <a:off x="6429375" y="1322040"/>
             <a:ext cx="919162" cy="95250"/>
           </a:xfrm>
           <a:prstGeom prst="rect">
@@ -6805,7 +6894,7 @@
         </p:blipFill>
         <p:spPr>
           <a:xfrm>
-            <a:off x="7040687" y="1420118"/>
+            <a:off x="6429375" y="1460153"/>
             <a:ext cx="790575" cy="95250"/>
           </a:xfrm>
           <a:prstGeom prst="rect">
@@ -6831,7 +6920,7 @@
         </p:blipFill>
         <p:spPr>
           <a:xfrm>
-            <a:off x="7040687" y="1535609"/>
+            <a:off x="6429375" y="1598265"/>
             <a:ext cx="790575" cy="95250"/>
           </a:xfrm>
           <a:prstGeom prst="rect">
@@ -6857,7 +6946,7 @@
         </p:blipFill>
         <p:spPr>
           <a:xfrm>
-            <a:off x="7040687" y="1651099"/>
+            <a:off x="6429375" y="1736378"/>
             <a:ext cx="790575" cy="95250"/>
           </a:xfrm>
           <a:prstGeom prst="rect">
@@ -6883,7 +6972,7 @@
         </p:blipFill>
         <p:spPr>
           <a:xfrm>
-            <a:off x="7040687" y="1766590"/>
+            <a:off x="6429375" y="1874490"/>
             <a:ext cx="828675" cy="95250"/>
           </a:xfrm>
           <a:prstGeom prst="rect">
@@ -6909,7 +6998,7 @@
         </p:blipFill>
         <p:spPr>
           <a:xfrm>
-            <a:off x="7040687" y="1882080"/>
+            <a:off x="6429375" y="2012603"/>
             <a:ext cx="828675" cy="95250"/>
           </a:xfrm>
           <a:prstGeom prst="rect">
@@ -6935,7 +7024,7 @@
         </p:blipFill>
         <p:spPr>
           <a:xfrm>
-            <a:off x="7040687" y="1997571"/>
+            <a:off x="6429375" y="2150715"/>
             <a:ext cx="828675" cy="95250"/>
           </a:xfrm>
           <a:prstGeom prst="rect">
@@ -6961,7 +7050,7 @@
         </p:blipFill>
         <p:spPr>
           <a:xfrm>
-            <a:off x="7040687" y="2113062"/>
+            <a:off x="6429375" y="2288828"/>
             <a:ext cx="828675" cy="95250"/>
           </a:xfrm>
           <a:prstGeom prst="rect">
@@ -6987,7 +7076,7 @@
         </p:blipFill>
         <p:spPr>
           <a:xfrm>
-            <a:off x="7040687" y="2228552"/>
+            <a:off x="6429375" y="2426940"/>
             <a:ext cx="828675" cy="95250"/>
           </a:xfrm>
           <a:prstGeom prst="rect">
@@ -7013,7 +7102,7 @@
         </p:blipFill>
         <p:spPr>
           <a:xfrm>
-            <a:off x="7040687" y="2344043"/>
+            <a:off x="6429375" y="2565053"/>
             <a:ext cx="828675" cy="95250"/>
           </a:xfrm>
           <a:prstGeom prst="rect">
@@ -7039,7 +7128,7 @@
         </p:blipFill>
         <p:spPr>
           <a:xfrm>
-            <a:off x="7040687" y="2459534"/>
+            <a:off x="6429375" y="2703165"/>
             <a:ext cx="828675" cy="95250"/>
           </a:xfrm>
           <a:prstGeom prst="rect">
@@ -7065,7 +7154,7 @@
         </p:blipFill>
         <p:spPr>
           <a:xfrm>
-            <a:off x="7040687" y="2575024"/>
+            <a:off x="6429375" y="2841278"/>
             <a:ext cx="828675" cy="95250"/>
           </a:xfrm>
           <a:prstGeom prst="rect">
@@ -7091,7 +7180,7 @@
         </p:blipFill>
         <p:spPr>
           <a:xfrm>
-            <a:off x="7040687" y="2690515"/>
+            <a:off x="6429375" y="2979390"/>
             <a:ext cx="642938" cy="95250"/>
           </a:xfrm>
           <a:prstGeom prst="rect">
@@ -7117,7 +7206,7 @@
         </p:blipFill>
         <p:spPr>
           <a:xfrm>
-            <a:off x="7040687" y="2806005"/>
+            <a:off x="6429375" y="3117503"/>
             <a:ext cx="666750" cy="95250"/>
           </a:xfrm>
           <a:prstGeom prst="rect">
@@ -7143,7 +7232,7 @@
         </p:blipFill>
         <p:spPr>
           <a:xfrm>
-            <a:off x="7040687" y="2921496"/>
+            <a:off x="6429375" y="3255615"/>
             <a:ext cx="666750" cy="95250"/>
           </a:xfrm>
           <a:prstGeom prst="rect">
@@ -7169,7 +7258,7 @@
         </p:blipFill>
         <p:spPr>
           <a:xfrm>
-            <a:off x="7040687" y="3036987"/>
+            <a:off x="6429375" y="3393728"/>
             <a:ext cx="666750" cy="95250"/>
           </a:xfrm>
           <a:prstGeom prst="rect">
@@ -7195,7 +7284,7 @@
         </p:blipFill>
         <p:spPr>
           <a:xfrm>
-            <a:off x="7040687" y="3152477"/>
+            <a:off x="6429375" y="3531840"/>
             <a:ext cx="557213" cy="95250"/>
           </a:xfrm>
           <a:prstGeom prst="rect">
@@ -7221,7 +7310,7 @@
         </p:blipFill>
         <p:spPr>
           <a:xfrm>
-            <a:off x="7040687" y="3267968"/>
+            <a:off x="6429375" y="3669953"/>
             <a:ext cx="666750" cy="95250"/>
           </a:xfrm>
           <a:prstGeom prst="rect">
@@ -7374,7 +7463,7 @@
         </p:blipFill>
         <p:spPr>
           <a:xfrm>
-            <a:off x="6873032" y="1304627"/>
+            <a:off x="6429375" y="1322040"/>
             <a:ext cx="552450" cy="95250"/>
           </a:xfrm>
           <a:prstGeom prst="rect">
@@ -7400,7 +7489,7 @@
         </p:blipFill>
         <p:spPr>
           <a:xfrm>
-            <a:off x="6873032" y="1420118"/>
+            <a:off x="6429375" y="1460153"/>
             <a:ext cx="552450" cy="95250"/>
           </a:xfrm>
           <a:prstGeom prst="rect">
@@ -7426,7 +7515,7 @@
         </p:blipFill>
         <p:spPr>
           <a:xfrm>
-            <a:off x="6873032" y="1535609"/>
+            <a:off x="6429375" y="1598265"/>
             <a:ext cx="557213" cy="95250"/>
           </a:xfrm>
           <a:prstGeom prst="rect">
@@ -7452,7 +7541,7 @@
         </p:blipFill>
         <p:spPr>
           <a:xfrm>
-            <a:off x="6873032" y="1651099"/>
+            <a:off x="6429375" y="1736378"/>
             <a:ext cx="552450" cy="95250"/>
           </a:xfrm>
           <a:prstGeom prst="rect">
@@ -7478,7 +7567,7 @@
         </p:blipFill>
         <p:spPr>
           <a:xfrm>
-            <a:off x="6873032" y="1766590"/>
+            <a:off x="6429375" y="1874490"/>
             <a:ext cx="552450" cy="95250"/>
           </a:xfrm>
           <a:prstGeom prst="rect">
@@ -7504,7 +7593,7 @@
         </p:blipFill>
         <p:spPr>
           <a:xfrm>
-            <a:off x="6873032" y="1882080"/>
+            <a:off x="6429375" y="2012603"/>
             <a:ext cx="557213" cy="95250"/>
           </a:xfrm>
           <a:prstGeom prst="rect">
@@ -7530,7 +7619,7 @@
         </p:blipFill>
         <p:spPr>
           <a:xfrm>
-            <a:off x="6873032" y="1997571"/>
+            <a:off x="6429375" y="2150715"/>
             <a:ext cx="790575" cy="95250"/>
           </a:xfrm>
           <a:prstGeom prst="rect">
@@ -7556,7 +7645,7 @@
         </p:blipFill>
         <p:spPr>
           <a:xfrm>
-            <a:off x="6873032" y="2113062"/>
+            <a:off x="6429375" y="2288828"/>
             <a:ext cx="790575" cy="95250"/>
           </a:xfrm>
           <a:prstGeom prst="rect">
@@ -7582,7 +7671,7 @@
         </p:blipFill>
         <p:spPr>
           <a:xfrm>
-            <a:off x="6873032" y="2228552"/>
+            <a:off x="6429375" y="2426940"/>
             <a:ext cx="790575" cy="95250"/>
           </a:xfrm>
           <a:prstGeom prst="rect">
@@ -7608,7 +7697,7 @@
         </p:blipFill>
         <p:spPr>
           <a:xfrm>
-            <a:off x="6873032" y="2344043"/>
+            <a:off x="6429375" y="2565053"/>
             <a:ext cx="790575" cy="95250"/>
           </a:xfrm>
           <a:prstGeom prst="rect">
@@ -7634,7 +7723,7 @@
         </p:blipFill>
         <p:spPr>
           <a:xfrm>
-            <a:off x="6873032" y="2459534"/>
+            <a:off x="6429375" y="2703165"/>
             <a:ext cx="790575" cy="95250"/>
           </a:xfrm>
           <a:prstGeom prst="rect">
@@ -7660,7 +7749,7 @@
         </p:blipFill>
         <p:spPr>
           <a:xfrm>
-            <a:off x="6873032" y="2575024"/>
+            <a:off x="6429375" y="2841278"/>
             <a:ext cx="790575" cy="95250"/>
           </a:xfrm>
           <a:prstGeom prst="rect">
@@ -7686,7 +7775,7 @@
         </p:blipFill>
         <p:spPr>
           <a:xfrm>
-            <a:off x="6873032" y="2690515"/>
+            <a:off x="6429375" y="2979390"/>
             <a:ext cx="790575" cy="95250"/>
           </a:xfrm>
           <a:prstGeom prst="rect">
@@ -7712,7 +7801,7 @@
         </p:blipFill>
         <p:spPr>
           <a:xfrm>
-            <a:off x="6873032" y="2806005"/>
+            <a:off x="6429375" y="3117503"/>
             <a:ext cx="838200" cy="95250"/>
           </a:xfrm>
           <a:prstGeom prst="rect">
@@ -7738,7 +7827,7 @@
         </p:blipFill>
         <p:spPr>
           <a:xfrm>
-            <a:off x="6873032" y="2921496"/>
+            <a:off x="6429375" y="3255615"/>
             <a:ext cx="557213" cy="95250"/>
           </a:xfrm>
           <a:prstGeom prst="rect">
@@ -7764,7 +7853,7 @@
         </p:blipFill>
         <p:spPr>
           <a:xfrm>
-            <a:off x="6873032" y="3036987"/>
+            <a:off x="6429375" y="3393728"/>
             <a:ext cx="1057275" cy="95250"/>
           </a:xfrm>
           <a:prstGeom prst="rect">
@@ -7790,7 +7879,7 @@
         </p:blipFill>
         <p:spPr>
           <a:xfrm>
-            <a:off x="6873032" y="3152477"/>
+            <a:off x="6429375" y="3531840"/>
             <a:ext cx="1057275" cy="95250"/>
           </a:xfrm>
           <a:prstGeom prst="rect">
@@ -7816,7 +7905,7 @@
         </p:blipFill>
         <p:spPr>
           <a:xfrm>
-            <a:off x="6873032" y="3267968"/>
+            <a:off x="6429375" y="3669953"/>
             <a:ext cx="1057275" cy="95250"/>
           </a:xfrm>
           <a:prstGeom prst="rect">
@@ -7969,7 +8058,7 @@
         </p:blipFill>
         <p:spPr>
           <a:xfrm>
-            <a:off x="6682680" y="1304627"/>
+            <a:off x="6429375" y="1322040"/>
             <a:ext cx="1057275" cy="95250"/>
           </a:xfrm>
           <a:prstGeom prst="rect">
@@ -7995,7 +8084,7 @@
         </p:blipFill>
         <p:spPr>
           <a:xfrm>
-            <a:off x="6682680" y="1420118"/>
+            <a:off x="6429375" y="1460153"/>
             <a:ext cx="1057275" cy="95250"/>
           </a:xfrm>
           <a:prstGeom prst="rect">
@@ -8021,7 +8110,7 @@
         </p:blipFill>
         <p:spPr>
           <a:xfrm>
-            <a:off x="6682680" y="1535609"/>
+            <a:off x="6429375" y="1598265"/>
             <a:ext cx="790575" cy="95250"/>
           </a:xfrm>
           <a:prstGeom prst="rect">
@@ -8047,7 +8136,7 @@
         </p:blipFill>
         <p:spPr>
           <a:xfrm>
-            <a:off x="6682680" y="1651099"/>
+            <a:off x="6429375" y="1736378"/>
             <a:ext cx="790575" cy="95250"/>
           </a:xfrm>
           <a:prstGeom prst="rect">
@@ -8073,7 +8162,7 @@
         </p:blipFill>
         <p:spPr>
           <a:xfrm>
-            <a:off x="6682680" y="1766590"/>
+            <a:off x="6429375" y="1874490"/>
             <a:ext cx="581025" cy="95250"/>
           </a:xfrm>
           <a:prstGeom prst="rect">
@@ -8099,7 +8188,7 @@
         </p:blipFill>
         <p:spPr>
           <a:xfrm>
-            <a:off x="6682680" y="1882080"/>
+            <a:off x="6429375" y="2012603"/>
             <a:ext cx="666750" cy="95250"/>
           </a:xfrm>
           <a:prstGeom prst="rect">
@@ -8125,7 +8214,7 @@
         </p:blipFill>
         <p:spPr>
           <a:xfrm>
-            <a:off x="6682680" y="1997571"/>
+            <a:off x="6429375" y="2150715"/>
             <a:ext cx="666750" cy="95250"/>
           </a:xfrm>
           <a:prstGeom prst="rect">
@@ -8151,7 +8240,7 @@
         </p:blipFill>
         <p:spPr>
           <a:xfrm>
-            <a:off x="6682680" y="2113062"/>
+            <a:off x="6429375" y="2288828"/>
             <a:ext cx="666750" cy="95250"/>
           </a:xfrm>
           <a:prstGeom prst="rect">
@@ -8177,7 +8266,7 @@
         </p:blipFill>
         <p:spPr>
           <a:xfrm>
-            <a:off x="6682680" y="2228552"/>
+            <a:off x="6429375" y="2426940"/>
             <a:ext cx="666750" cy="95250"/>
           </a:xfrm>
           <a:prstGeom prst="rect">
@@ -8203,7 +8292,7 @@
         </p:blipFill>
         <p:spPr>
           <a:xfrm>
-            <a:off x="6682680" y="2344043"/>
+            <a:off x="6429375" y="2565053"/>
             <a:ext cx="666750" cy="95250"/>
           </a:xfrm>
           <a:prstGeom prst="rect">
@@ -8229,7 +8318,7 @@
         </p:blipFill>
         <p:spPr>
           <a:xfrm>
-            <a:off x="6682680" y="2459534"/>
+            <a:off x="6429375" y="2703165"/>
             <a:ext cx="666750" cy="95250"/>
           </a:xfrm>
           <a:prstGeom prst="rect">
@@ -8255,7 +8344,7 @@
         </p:blipFill>
         <p:spPr>
           <a:xfrm>
-            <a:off x="6682680" y="2575024"/>
+            <a:off x="6429375" y="2841278"/>
             <a:ext cx="557213" cy="95250"/>
           </a:xfrm>
           <a:prstGeom prst="rect">
@@ -8281,7 +8370,7 @@
         </p:blipFill>
         <p:spPr>
           <a:xfrm>
-            <a:off x="6682680" y="2690515"/>
+            <a:off x="6429375" y="2979390"/>
             <a:ext cx="1171575" cy="95250"/>
           </a:xfrm>
           <a:prstGeom prst="rect">
@@ -8307,7 +8396,7 @@
         </p:blipFill>
         <p:spPr>
           <a:xfrm>
-            <a:off x="6682680" y="2806005"/>
+            <a:off x="6429375" y="3117503"/>
             <a:ext cx="1171575" cy="95250"/>
           </a:xfrm>
           <a:prstGeom prst="rect">
@@ -8333,7 +8422,7 @@
         </p:blipFill>
         <p:spPr>
           <a:xfrm>
-            <a:off x="6682680" y="2921496"/>
+            <a:off x="6429375" y="3255615"/>
             <a:ext cx="557213" cy="95250"/>
           </a:xfrm>
           <a:prstGeom prst="rect">
@@ -8359,7 +8448,7 @@
         </p:blipFill>
         <p:spPr>
           <a:xfrm>
-            <a:off x="6682680" y="3036987"/>
+            <a:off x="6429375" y="3393728"/>
             <a:ext cx="771525" cy="95250"/>
           </a:xfrm>
           <a:prstGeom prst="rect">
@@ -8385,7 +8474,7 @@
         </p:blipFill>
         <p:spPr>
           <a:xfrm>
-            <a:off x="6682680" y="3152477"/>
+            <a:off x="6429375" y="3531840"/>
             <a:ext cx="557213" cy="95250"/>
           </a:xfrm>
           <a:prstGeom prst="rect">
@@ -8639,7 +8728,7 @@
         </p:blipFill>
         <p:spPr>
           <a:xfrm>
-            <a:off x="7301285" y="1304627"/>
+            <a:off x="6429375" y="1322040"/>
             <a:ext cx="828675" cy="95250"/>
           </a:xfrm>
           <a:prstGeom prst="rect">
@@ -8665,7 +8754,7 @@
         </p:blipFill>
         <p:spPr>
           <a:xfrm>
-            <a:off x="7301285" y="1420118"/>
+            <a:off x="6429375" y="1460153"/>
             <a:ext cx="866775" cy="95250"/>
           </a:xfrm>
           <a:prstGeom prst="rect">
@@ -8691,7 +8780,7 @@
         </p:blipFill>
         <p:spPr>
           <a:xfrm>
-            <a:off x="7301285" y="1535609"/>
+            <a:off x="6429375" y="1598265"/>
             <a:ext cx="714375" cy="95250"/>
           </a:xfrm>
           <a:prstGeom prst="rect">
@@ -8717,7 +8806,7 @@
         </p:blipFill>
         <p:spPr>
           <a:xfrm>
-            <a:off x="7301285" y="1651099"/>
+            <a:off x="6429375" y="1736378"/>
             <a:ext cx="457200" cy="95250"/>
           </a:xfrm>
           <a:prstGeom prst="rect">
@@ -8743,7 +8832,7 @@
         </p:blipFill>
         <p:spPr>
           <a:xfrm>
-            <a:off x="7301285" y="1766590"/>
+            <a:off x="6429375" y="1874490"/>
             <a:ext cx="747712" cy="95250"/>
           </a:xfrm>
           <a:prstGeom prst="rect">
@@ -8769,7 +8858,7 @@
         </p:blipFill>
         <p:spPr>
           <a:xfrm>
-            <a:off x="7301285" y="1882080"/>
+            <a:off x="6429375" y="2012603"/>
             <a:ext cx="838200" cy="95250"/>
           </a:xfrm>
           <a:prstGeom prst="rect">
@@ -8795,7 +8884,7 @@
         </p:blipFill>
         <p:spPr>
           <a:xfrm>
-            <a:off x="7301285" y="1997571"/>
+            <a:off x="6429375" y="2150715"/>
             <a:ext cx="557213" cy="95250"/>
           </a:xfrm>
           <a:prstGeom prst="rect">
@@ -8821,7 +8910,7 @@
         </p:blipFill>
         <p:spPr>
           <a:xfrm>
-            <a:off x="7301285" y="2113062"/>
+            <a:off x="6429375" y="2288828"/>
             <a:ext cx="719137" cy="95250"/>
           </a:xfrm>
           <a:prstGeom prst="rect">
@@ -8847,7 +8936,7 @@
         </p:blipFill>
         <p:spPr>
           <a:xfrm>
-            <a:off x="7301285" y="2228552"/>
+            <a:off x="6429375" y="2426940"/>
             <a:ext cx="485775" cy="95250"/>
           </a:xfrm>
           <a:prstGeom prst="rect">
@@ -8873,7 +8962,7 @@
         </p:blipFill>
         <p:spPr>
           <a:xfrm>
-            <a:off x="7301285" y="2344043"/>
+            <a:off x="6429375" y="2565053"/>
             <a:ext cx="852488" cy="95250"/>
           </a:xfrm>
           <a:prstGeom prst="rect">
@@ -8899,7 +8988,7 @@
         </p:blipFill>
         <p:spPr>
           <a:xfrm>
-            <a:off x="7301285" y="2459534"/>
+            <a:off x="6429375" y="2703165"/>
             <a:ext cx="614363" cy="95250"/>
           </a:xfrm>
           <a:prstGeom prst="rect">
@@ -8925,7 +9014,7 @@
         </p:blipFill>
         <p:spPr>
           <a:xfrm>
-            <a:off x="7301285" y="2575024"/>
+            <a:off x="6429375" y="2841278"/>
             <a:ext cx="904875" cy="95250"/>
           </a:xfrm>
           <a:prstGeom prst="rect">
@@ -8951,7 +9040,7 @@
         </p:blipFill>
         <p:spPr>
           <a:xfrm>
-            <a:off x="7301285" y="2690515"/>
+            <a:off x="6429375" y="2979390"/>
             <a:ext cx="904875" cy="95250"/>
           </a:xfrm>
           <a:prstGeom prst="rect">
@@ -8977,7 +9066,7 @@
         </p:blipFill>
         <p:spPr>
           <a:xfrm>
-            <a:off x="7301285" y="2806005"/>
+            <a:off x="6429375" y="3117503"/>
             <a:ext cx="809625" cy="95250"/>
           </a:xfrm>
           <a:prstGeom prst="rect">
@@ -9003,7 +9092,7 @@
         </p:blipFill>
         <p:spPr>
           <a:xfrm>
-            <a:off x="7301285" y="2921496"/>
+            <a:off x="6429375" y="3255615"/>
             <a:ext cx="481012" cy="95250"/>
           </a:xfrm>
           <a:prstGeom prst="rect">
@@ -9029,7 +9118,7 @@
         </p:blipFill>
         <p:spPr>
           <a:xfrm>
-            <a:off x="7301285" y="3036987"/>
+            <a:off x="6429375" y="3393728"/>
             <a:ext cx="666750" cy="95250"/>
           </a:xfrm>
           <a:prstGeom prst="rect">
@@ -9055,7 +9144,7 @@
         </p:blipFill>
         <p:spPr>
           <a:xfrm>
-            <a:off x="7301285" y="3152477"/>
+            <a:off x="6429375" y="3531840"/>
             <a:ext cx="423862" cy="95250"/>
           </a:xfrm>
           <a:prstGeom prst="rect">
@@ -9066,7 +9155,7 @@
       <p:pic>
         <p:nvPicPr>
           <p:cNvPr id="20" name="Image 18" descr="preencoded.png">
-            <a:hlinkClick r:id="rId37" tooltip="https://asanteafrica.org/"/>
+            <a:hlinkClick r:id="rId37" tooltip="https://github.com/samquansah-algo/nbc-vct/tree/main/weekly-tactics/04-sales/"/>
           </p:cNvPr>
           <p:cNvPicPr>
             <a:picLocks noChangeAspect="1"/>
@@ -9075,240 +9164,6 @@
         </p:nvPicPr>
         <p:blipFill>
           <a:blip r:embed="rId36"/>
-          <a:stretch>
-            <a:fillRect/>
-          </a:stretch>
-        </p:blipFill>
-        <p:spPr>
-          <a:xfrm>
-            <a:off x="7301285" y="3267968"/>
-            <a:ext cx="528638" cy="95250"/>
-          </a:xfrm>
-          <a:prstGeom prst="rect">
-            <a:avLst/>
-          </a:prstGeom>
-        </p:spPr>
-      </p:pic>
-      <p:pic>
-        <p:nvPicPr>
-          <p:cNvPr id="21" name="Image 19" descr="preencoded.png">
-            <a:hlinkClick r:id="rId39" tooltip="https://digitalskillsafrica.org/"/>
-          </p:cNvPr>
-          <p:cNvPicPr>
-            <a:picLocks noChangeAspect="1"/>
-          </p:cNvPicPr>
-          <p:nvPr/>
-        </p:nvPicPr>
-        <p:blipFill>
-          <a:blip r:embed="rId38"/>
-          <a:stretch>
-            <a:fillRect/>
-          </a:stretch>
-        </p:blipFill>
-        <p:spPr>
-          <a:xfrm>
-            <a:off x="7301285" y="3383459"/>
-            <a:ext cx="681038" cy="95250"/>
-          </a:xfrm>
-          <a:prstGeom prst="rect">
-            <a:avLst/>
-          </a:prstGeom>
-        </p:spPr>
-      </p:pic>
-      <p:pic>
-        <p:nvPicPr>
-          <p:cNvPr id="22" name="Image 20" descr="preencoded.png">
-            <a:hlinkClick r:id="rId41" tooltip="https://bstemghana.com/"/>
-          </p:cNvPr>
-          <p:cNvPicPr>
-            <a:picLocks noChangeAspect="1"/>
-          </p:cNvPicPr>
-          <p:nvPr/>
-        </p:nvPicPr>
-        <p:blipFill>
-          <a:blip r:embed="rId40"/>
-          <a:stretch>
-            <a:fillRect/>
-          </a:stretch>
-        </p:blipFill>
-        <p:spPr>
-          <a:xfrm>
-            <a:off x="7301285" y="3498949"/>
-            <a:ext cx="571500" cy="95250"/>
-          </a:xfrm>
-          <a:prstGeom prst="rect">
-            <a:avLst/>
-          </a:prstGeom>
-        </p:spPr>
-      </p:pic>
-      <p:pic>
-        <p:nvPicPr>
-          <p:cNvPr id="23" name="Image 21" descr="preencoded.png">
-            <a:hlinkClick r:id="rId43" tooltip="https://learningthroughplay.com/"/>
-          </p:cNvPr>
-          <p:cNvPicPr>
-            <a:picLocks noChangeAspect="1"/>
-          </p:cNvPicPr>
-          <p:nvPr/>
-        </p:nvPicPr>
-        <p:blipFill>
-          <a:blip r:embed="rId42"/>
-          <a:stretch>
-            <a:fillRect/>
-          </a:stretch>
-        </p:blipFill>
-        <p:spPr>
-          <a:xfrm>
-            <a:off x="7301285" y="3614440"/>
-            <a:ext cx="833437" cy="95250"/>
-          </a:xfrm>
-          <a:prstGeom prst="rect">
-            <a:avLst/>
-          </a:prstGeom>
-        </p:spPr>
-      </p:pic>
-      <p:pic>
-        <p:nvPicPr>
-          <p:cNvPr id="24" name="Image 22" descr="preencoded.png">
-            <a:hlinkClick r:id="rId45" tooltip="https://oakfnd.org/"/>
-          </p:cNvPr>
-          <p:cNvPicPr>
-            <a:picLocks noChangeAspect="1"/>
-          </p:cNvPicPr>
-          <p:nvPr/>
-        </p:nvPicPr>
-        <p:blipFill>
-          <a:blip r:embed="rId44"/>
-          <a:stretch>
-            <a:fillRect/>
-          </a:stretch>
-        </p:blipFill>
-        <p:spPr>
-          <a:xfrm>
-            <a:off x="7301285" y="3729930"/>
-            <a:ext cx="361950" cy="95250"/>
-          </a:xfrm>
-          <a:prstGeom prst="rect">
-            <a:avLst/>
-          </a:prstGeom>
-        </p:spPr>
-      </p:pic>
-      <p:pic>
-        <p:nvPicPr>
-          <p:cNvPr id="25" name="Image 23" descr="preencoded.png">
-            <a:hlinkClick r:id="rId47" tooltip="https://gatesfoundation.org/"/>
-          </p:cNvPr>
-          <p:cNvPicPr>
-            <a:picLocks noChangeAspect="1"/>
-          </p:cNvPicPr>
-          <p:nvPr/>
-        </p:nvPicPr>
-        <p:blipFill>
-          <a:blip r:embed="rId46"/>
-          <a:stretch>
-            <a:fillRect/>
-          </a:stretch>
-        </p:blipFill>
-        <p:spPr>
-          <a:xfrm>
-            <a:off x="7301285" y="3845421"/>
-            <a:ext cx="671513" cy="95250"/>
-          </a:xfrm>
-          <a:prstGeom prst="rect">
-            <a:avLst/>
-          </a:prstGeom>
-        </p:spPr>
-      </p:pic>
-      <p:pic>
-        <p:nvPicPr>
-          <p:cNvPr id="26" name="Image 24" descr="preencoded.png">
-            <a:hlinkClick r:id="rId49" tooltip="https://hewlett.org/"/>
-          </p:cNvPr>
-          <p:cNvPicPr>
-            <a:picLocks noChangeAspect="1"/>
-          </p:cNvPicPr>
-          <p:nvPr/>
-        </p:nvPicPr>
-        <p:blipFill>
-          <a:blip r:embed="rId48"/>
-          <a:stretch>
-            <a:fillRect/>
-          </a:stretch>
-        </p:blipFill>
-        <p:spPr>
-          <a:xfrm>
-            <a:off x="7301285" y="3960912"/>
-            <a:ext cx="376238" cy="95250"/>
-          </a:xfrm>
-          <a:prstGeom prst="rect">
-            <a:avLst/>
-          </a:prstGeom>
-        </p:spPr>
-      </p:pic>
-      <p:pic>
-        <p:nvPicPr>
-          <p:cNvPr id="27" name="Image 25" descr="preencoded.png">
-            <a:hlinkClick r:id="rId51" tooltip="https://imaginablefutures.com/"/>
-          </p:cNvPr>
-          <p:cNvPicPr>
-            <a:picLocks noChangeAspect="1"/>
-          </p:cNvPicPr>
-          <p:nvPr/>
-        </p:nvPicPr>
-        <p:blipFill>
-          <a:blip r:embed="rId50"/>
-          <a:stretch>
-            <a:fillRect/>
-          </a:stretch>
-        </p:blipFill>
-        <p:spPr>
-          <a:xfrm>
-            <a:off x="7301285" y="4076402"/>
-            <a:ext cx="762000" cy="95250"/>
-          </a:xfrm>
-          <a:prstGeom prst="rect">
-            <a:avLst/>
-          </a:prstGeom>
-        </p:spPr>
-      </p:pic>
-      <p:pic>
-        <p:nvPicPr>
-          <p:cNvPr id="28" name="Image 26" descr="preencoded.png">
-            <a:hlinkClick r:id="rId53" tooltip="https://fordfoundation.org/"/>
-          </p:cNvPr>
-          <p:cNvPicPr>
-            <a:picLocks noChangeAspect="1"/>
-          </p:cNvPicPr>
-          <p:nvPr/>
-        </p:nvPicPr>
-        <p:blipFill>
-          <a:blip r:embed="rId52"/>
-          <a:stretch>
-            <a:fillRect/>
-          </a:stretch>
-        </p:blipFill>
-        <p:spPr>
-          <a:xfrm>
-            <a:off x="7301285" y="4191893"/>
-            <a:ext cx="633412" cy="95250"/>
-          </a:xfrm>
-          <a:prstGeom prst="rect">
-            <a:avLst/>
-          </a:prstGeom>
-        </p:spPr>
-      </p:pic>
-      <p:pic>
-        <p:nvPicPr>
-          <p:cNvPr id="29" name="Image 27" descr="preencoded.png">
-            <a:hlinkClick r:id="rId55" tooltip="https://github.com/samquansah-algo/nbc-vct/tree/main/weekly-tactics/04-sales/"/>
-          </p:cNvPr>
-          <p:cNvPicPr>
-            <a:picLocks noChangeAspect="1"/>
-          </p:cNvPicPr>
-          <p:nvPr/>
-        </p:nvPicPr>
-        <p:blipFill>
-          <a:blip r:embed="rId54"/>
           <a:stretch>
             <a:fillRect/>
           </a:stretch>
@@ -9325,16 +9180,16 @@
       </p:pic>
       <p:pic>
         <p:nvPicPr>
-          <p:cNvPr id="30" name="Image 28" descr="preencoded.png">
-            <a:hlinkClick r:id="rId57" tooltip="https://github.com/samquansah-algo/nbc-vct/blob/main/weekly-tactics/04-sales/README.md"/>
-          </p:cNvPr>
-          <p:cNvPicPr>
-            <a:picLocks noChangeAspect="1"/>
-          </p:cNvPicPr>
-          <p:nvPr/>
-        </p:nvPicPr>
-        <p:blipFill>
-          <a:blip r:embed="rId56"/>
+          <p:cNvPr id="21" name="Image 19" descr="preencoded.png">
+            <a:hlinkClick r:id="rId39" tooltip="https://github.com/samquansah-algo/nbc-vct/blob/main/weekly-tactics/04-sales/README.md"/>
+          </p:cNvPr>
+          <p:cNvPicPr>
+            <a:picLocks noChangeAspect="1"/>
+          </p:cNvPicPr>
+          <p:nvPr/>
+        </p:nvPicPr>
+        <p:blipFill>
+          <a:blip r:embed="rId38"/>
           <a:stretch>
             <a:fillRect/>
           </a:stretch>
@@ -9351,16 +9206,16 @@
       </p:pic>
       <p:pic>
         <p:nvPicPr>
-          <p:cNvPr id="31" name="Image 29" descr="preencoded.png">
-            <a:hlinkClick r:id="rId59" tooltip="https://github.com/samquansah-algo/nbc-vct/blob/main/brand/NBC_Brand_Guide.pdf"/>
-          </p:cNvPr>
-          <p:cNvPicPr>
-            <a:picLocks noChangeAspect="1"/>
-          </p:cNvPicPr>
-          <p:nvPr/>
-        </p:nvPicPr>
-        <p:blipFill>
-          <a:blip r:embed="rId58"/>
+          <p:cNvPr id="22" name="Image 20" descr="preencoded.png">
+            <a:hlinkClick r:id="rId41" tooltip="https://github.com/samquansah-algo/nbc-vct/blob/main/brand/NBC_Brand_Guide.pdf"/>
+          </p:cNvPr>
+          <p:cNvPicPr>
+            <a:picLocks noChangeAspect="1"/>
+          </p:cNvPicPr>
+          <p:nvPr/>
+        </p:nvPicPr>
+        <p:blipFill>
+          <a:blip r:embed="rId40"/>
           <a:stretch>
             <a:fillRect/>
           </a:stretch>
@@ -9427,7 +9282,7 @@
       <p:pic>
         <p:nvPicPr>
           <p:cNvPr id="3" name="Image 1" descr="preencoded.png">
-            <a:hlinkClick r:id="rId3" tooltip="https://unicef.org/ghana"/>
+            <a:hlinkClick r:id="rId3" tooltip="https://asanteafrica.org/"/>
           </p:cNvPr>
           <p:cNvPicPr>
             <a:picLocks noChangeAspect="1"/>
@@ -9442,7 +9297,241 @@
         </p:blipFill>
         <p:spPr>
           <a:xfrm>
-            <a:off x="7088386" y="1304627"/>
+            <a:off x="6429375" y="1322040"/>
+            <a:ext cx="528638" cy="95250"/>
+          </a:xfrm>
+          <a:prstGeom prst="rect">
+            <a:avLst/>
+          </a:prstGeom>
+        </p:spPr>
+      </p:pic>
+      <p:pic>
+        <p:nvPicPr>
+          <p:cNvPr id="4" name="Image 2" descr="preencoded.png">
+            <a:hlinkClick r:id="rId5" tooltip="https://digitalskillsafrica.org/"/>
+          </p:cNvPr>
+          <p:cNvPicPr>
+            <a:picLocks noChangeAspect="1"/>
+          </p:cNvPicPr>
+          <p:nvPr/>
+        </p:nvPicPr>
+        <p:blipFill>
+          <a:blip r:embed="rId4"/>
+          <a:stretch>
+            <a:fillRect/>
+          </a:stretch>
+        </p:blipFill>
+        <p:spPr>
+          <a:xfrm>
+            <a:off x="6429375" y="1460153"/>
+            <a:ext cx="681038" cy="95250"/>
+          </a:xfrm>
+          <a:prstGeom prst="rect">
+            <a:avLst/>
+          </a:prstGeom>
+        </p:spPr>
+      </p:pic>
+      <p:pic>
+        <p:nvPicPr>
+          <p:cNvPr id="5" name="Image 3" descr="preencoded.png">
+            <a:hlinkClick r:id="rId7" tooltip="https://bstemghana.com/"/>
+          </p:cNvPr>
+          <p:cNvPicPr>
+            <a:picLocks noChangeAspect="1"/>
+          </p:cNvPicPr>
+          <p:nvPr/>
+        </p:nvPicPr>
+        <p:blipFill>
+          <a:blip r:embed="rId6"/>
+          <a:stretch>
+            <a:fillRect/>
+          </a:stretch>
+        </p:blipFill>
+        <p:spPr>
+          <a:xfrm>
+            <a:off x="6429375" y="1598265"/>
+            <a:ext cx="571500" cy="95250"/>
+          </a:xfrm>
+          <a:prstGeom prst="rect">
+            <a:avLst/>
+          </a:prstGeom>
+        </p:spPr>
+      </p:pic>
+      <p:pic>
+        <p:nvPicPr>
+          <p:cNvPr id="6" name="Image 4" descr="preencoded.png">
+            <a:hlinkClick r:id="rId9" tooltip="https://learningthroughplay.com/"/>
+          </p:cNvPr>
+          <p:cNvPicPr>
+            <a:picLocks noChangeAspect="1"/>
+          </p:cNvPicPr>
+          <p:nvPr/>
+        </p:nvPicPr>
+        <p:blipFill>
+          <a:blip r:embed="rId8"/>
+          <a:stretch>
+            <a:fillRect/>
+          </a:stretch>
+        </p:blipFill>
+        <p:spPr>
+          <a:xfrm>
+            <a:off x="6429375" y="1736378"/>
+            <a:ext cx="833437" cy="95250"/>
+          </a:xfrm>
+          <a:prstGeom prst="rect">
+            <a:avLst/>
+          </a:prstGeom>
+        </p:spPr>
+      </p:pic>
+      <p:pic>
+        <p:nvPicPr>
+          <p:cNvPr id="7" name="Image 5" descr="preencoded.png">
+            <a:hlinkClick r:id="rId11" tooltip="https://oakfnd.org/"/>
+          </p:cNvPr>
+          <p:cNvPicPr>
+            <a:picLocks noChangeAspect="1"/>
+          </p:cNvPicPr>
+          <p:nvPr/>
+        </p:nvPicPr>
+        <p:blipFill>
+          <a:blip r:embed="rId10"/>
+          <a:stretch>
+            <a:fillRect/>
+          </a:stretch>
+        </p:blipFill>
+        <p:spPr>
+          <a:xfrm>
+            <a:off x="6429375" y="1874490"/>
+            <a:ext cx="361950" cy="95250"/>
+          </a:xfrm>
+          <a:prstGeom prst="rect">
+            <a:avLst/>
+          </a:prstGeom>
+        </p:spPr>
+      </p:pic>
+      <p:pic>
+        <p:nvPicPr>
+          <p:cNvPr id="8" name="Image 6" descr="preencoded.png">
+            <a:hlinkClick r:id="rId13" tooltip="https://gatesfoundation.org/"/>
+          </p:cNvPr>
+          <p:cNvPicPr>
+            <a:picLocks noChangeAspect="1"/>
+          </p:cNvPicPr>
+          <p:nvPr/>
+        </p:nvPicPr>
+        <p:blipFill>
+          <a:blip r:embed="rId12"/>
+          <a:stretch>
+            <a:fillRect/>
+          </a:stretch>
+        </p:blipFill>
+        <p:spPr>
+          <a:xfrm>
+            <a:off x="6429375" y="2012603"/>
+            <a:ext cx="671513" cy="95250"/>
+          </a:xfrm>
+          <a:prstGeom prst="rect">
+            <a:avLst/>
+          </a:prstGeom>
+        </p:spPr>
+      </p:pic>
+      <p:pic>
+        <p:nvPicPr>
+          <p:cNvPr id="9" name="Image 7" descr="preencoded.png">
+            <a:hlinkClick r:id="rId15" tooltip="https://hewlett.org/"/>
+          </p:cNvPr>
+          <p:cNvPicPr>
+            <a:picLocks noChangeAspect="1"/>
+          </p:cNvPicPr>
+          <p:nvPr/>
+        </p:nvPicPr>
+        <p:blipFill>
+          <a:blip r:embed="rId14"/>
+          <a:stretch>
+            <a:fillRect/>
+          </a:stretch>
+        </p:blipFill>
+        <p:spPr>
+          <a:xfrm>
+            <a:off x="6429375" y="2150715"/>
+            <a:ext cx="376238" cy="95250"/>
+          </a:xfrm>
+          <a:prstGeom prst="rect">
+            <a:avLst/>
+          </a:prstGeom>
+        </p:spPr>
+      </p:pic>
+      <p:pic>
+        <p:nvPicPr>
+          <p:cNvPr id="10" name="Image 8" descr="preencoded.png">
+            <a:hlinkClick r:id="rId17" tooltip="https://imaginablefutures.com/"/>
+          </p:cNvPr>
+          <p:cNvPicPr>
+            <a:picLocks noChangeAspect="1"/>
+          </p:cNvPicPr>
+          <p:nvPr/>
+        </p:nvPicPr>
+        <p:blipFill>
+          <a:blip r:embed="rId16"/>
+          <a:stretch>
+            <a:fillRect/>
+          </a:stretch>
+        </p:blipFill>
+        <p:spPr>
+          <a:xfrm>
+            <a:off x="6429375" y="2288828"/>
+            <a:ext cx="762000" cy="95250"/>
+          </a:xfrm>
+          <a:prstGeom prst="rect">
+            <a:avLst/>
+          </a:prstGeom>
+        </p:spPr>
+      </p:pic>
+      <p:pic>
+        <p:nvPicPr>
+          <p:cNvPr id="11" name="Image 9" descr="preencoded.png">
+            <a:hlinkClick r:id="rId19" tooltip="https://fordfoundation.org/"/>
+          </p:cNvPr>
+          <p:cNvPicPr>
+            <a:picLocks noChangeAspect="1"/>
+          </p:cNvPicPr>
+          <p:nvPr/>
+        </p:nvPicPr>
+        <p:blipFill>
+          <a:blip r:embed="rId18"/>
+          <a:stretch>
+            <a:fillRect/>
+          </a:stretch>
+        </p:blipFill>
+        <p:spPr>
+          <a:xfrm>
+            <a:off x="6429375" y="2426940"/>
+            <a:ext cx="633412" cy="95250"/>
+          </a:xfrm>
+          <a:prstGeom prst="rect">
+            <a:avLst/>
+          </a:prstGeom>
+        </p:spPr>
+      </p:pic>
+      <p:pic>
+        <p:nvPicPr>
+          <p:cNvPr id="12" name="Image 10" descr="preencoded.png">
+            <a:hlinkClick r:id="rId21" tooltip="https://unicef.org/ghana"/>
+          </p:cNvPr>
+          <p:cNvPicPr>
+            <a:picLocks noChangeAspect="1"/>
+          </p:cNvPicPr>
+          <p:nvPr/>
+        </p:nvPicPr>
+        <p:blipFill>
+          <a:blip r:embed="rId20"/>
+          <a:stretch>
+            <a:fillRect/>
+          </a:stretch>
+        </p:blipFill>
+        <p:spPr>
+          <a:xfrm>
+            <a:off x="6429375" y="2565053"/>
             <a:ext cx="566738" cy="95250"/>
           </a:xfrm>
           <a:prstGeom prst="rect">
@@ -9452,23 +9541,23 @@
       </p:pic>
       <p:pic>
         <p:nvPicPr>
-          <p:cNvPr id="4" name="Image 2" descr="preencoded.png">
-            <a:hlinkClick r:id="rId5" tooltip="https://gov.uk/fcdo"/>
-          </p:cNvPr>
-          <p:cNvPicPr>
-            <a:picLocks noChangeAspect="1"/>
-          </p:cNvPicPr>
-          <p:nvPr/>
-        </p:nvPicPr>
-        <p:blipFill>
-          <a:blip r:embed="rId4"/>
-          <a:stretch>
-            <a:fillRect/>
-          </a:stretch>
-        </p:blipFill>
-        <p:spPr>
-          <a:xfrm>
-            <a:off x="7088386" y="1420118"/>
+          <p:cNvPr id="13" name="Image 11" descr="preencoded.png">
+            <a:hlinkClick r:id="rId23" tooltip="https://gov.uk/fcdo"/>
+          </p:cNvPr>
+          <p:cNvPicPr>
+            <a:picLocks noChangeAspect="1"/>
+          </p:cNvPicPr>
+          <p:nvPr/>
+        </p:nvPicPr>
+        <p:blipFill>
+          <a:blip r:embed="rId22"/>
+          <a:stretch>
+            <a:fillRect/>
+          </a:stretch>
+        </p:blipFill>
+        <p:spPr>
+          <a:xfrm>
+            <a:off x="6429375" y="2703165"/>
             <a:ext cx="390525" cy="95250"/>
           </a:xfrm>
           <a:prstGeom prst="rect">
@@ -9478,23 +9567,23 @@
       </p:pic>
       <p:pic>
         <p:nvPicPr>
-          <p:cNvPr id="5" name="Image 3" descr="preencoded.png">
-            <a:hlinkClick r:id="rId7" tooltip="https://international.gc.ca/"/>
-          </p:cNvPr>
-          <p:cNvPicPr>
-            <a:picLocks noChangeAspect="1"/>
-          </p:cNvPicPr>
-          <p:nvPr/>
-        </p:nvPicPr>
-        <p:blipFill>
-          <a:blip r:embed="rId6"/>
-          <a:stretch>
-            <a:fillRect/>
-          </a:stretch>
-        </p:blipFill>
-        <p:spPr>
-          <a:xfrm>
-            <a:off x="7088386" y="1535609"/>
+          <p:cNvPr id="14" name="Image 12" descr="preencoded.png">
+            <a:hlinkClick r:id="rId25" tooltip="https://international.gc.ca/"/>
+          </p:cNvPr>
+          <p:cNvPicPr>
+            <a:picLocks noChangeAspect="1"/>
+          </p:cNvPicPr>
+          <p:nvPr/>
+        </p:nvPicPr>
+        <p:blipFill>
+          <a:blip r:embed="rId24"/>
+          <a:stretch>
+            <a:fillRect/>
+          </a:stretch>
+        </p:blipFill>
+        <p:spPr>
+          <a:xfrm>
+            <a:off x="6429375" y="2841278"/>
             <a:ext cx="604837" cy="95250"/>
           </a:xfrm>
           <a:prstGeom prst="rect">
@@ -9504,23 +9593,23 @@
       </p:pic>
       <p:pic>
         <p:nvPicPr>
-          <p:cNvPr id="6" name="Image 4" descr="preencoded.png">
-            <a:hlinkClick r:id="rId9" tooltip="https://koica.go.kr/"/>
-          </p:cNvPr>
-          <p:cNvPicPr>
-            <a:picLocks noChangeAspect="1"/>
-          </p:cNvPicPr>
-          <p:nvPr/>
-        </p:nvPicPr>
-        <p:blipFill>
-          <a:blip r:embed="rId8"/>
-          <a:stretch>
-            <a:fillRect/>
-          </a:stretch>
-        </p:blipFill>
-        <p:spPr>
-          <a:xfrm>
-            <a:off x="7088386" y="1651099"/>
+          <p:cNvPr id="15" name="Image 13" descr="preencoded.png">
+            <a:hlinkClick r:id="rId27" tooltip="https://koica.go.kr/"/>
+          </p:cNvPr>
+          <p:cNvPicPr>
+            <a:picLocks noChangeAspect="1"/>
+          </p:cNvPicPr>
+          <p:nvPr/>
+        </p:nvPicPr>
+        <p:blipFill>
+          <a:blip r:embed="rId26"/>
+          <a:stretch>
+            <a:fillRect/>
+          </a:stretch>
+        </p:blipFill>
+        <p:spPr>
+          <a:xfrm>
+            <a:off x="6429375" y="2979390"/>
             <a:ext cx="361950" cy="95250"/>
           </a:xfrm>
           <a:prstGeom prst="rect">
@@ -9530,23 +9619,23 @@
       </p:pic>
       <p:pic>
         <p:nvPicPr>
-          <p:cNvPr id="7" name="Image 5" descr="preencoded.png">
-            <a:hlinkClick r:id="rId11" tooltip="https://jica.go.jp/"/>
-          </p:cNvPr>
-          <p:cNvPicPr>
-            <a:picLocks noChangeAspect="1"/>
-          </p:cNvPicPr>
-          <p:nvPr/>
-        </p:nvPicPr>
-        <p:blipFill>
-          <a:blip r:embed="rId10"/>
-          <a:stretch>
-            <a:fillRect/>
-          </a:stretch>
-        </p:blipFill>
-        <p:spPr>
-          <a:xfrm>
-            <a:off x="7088386" y="1766590"/>
+          <p:cNvPr id="16" name="Image 14" descr="preencoded.png">
+            <a:hlinkClick r:id="rId29" tooltip="https://jica.go.jp/"/>
+          </p:cNvPr>
+          <p:cNvPicPr>
+            <a:picLocks noChangeAspect="1"/>
+          </p:cNvPicPr>
+          <p:nvPr/>
+        </p:nvPicPr>
+        <p:blipFill>
+          <a:blip r:embed="rId28"/>
+          <a:stretch>
+            <a:fillRect/>
+          </a:stretch>
+        </p:blipFill>
+        <p:spPr>
+          <a:xfrm>
+            <a:off x="6429375" y="3117503"/>
             <a:ext cx="295275" cy="95250"/>
           </a:xfrm>
           <a:prstGeom prst="rect">
@@ -9556,23 +9645,23 @@
       </p:pic>
       <p:pic>
         <p:nvPicPr>
-          <p:cNvPr id="8" name="Image 6" descr="preencoded.png">
-            <a:hlinkClick r:id="rId13" tooltip="https://giz.de/"/>
-          </p:cNvPr>
-          <p:cNvPicPr>
-            <a:picLocks noChangeAspect="1"/>
-          </p:cNvPicPr>
-          <p:nvPr/>
-        </p:nvPicPr>
-        <p:blipFill>
-          <a:blip r:embed="rId12"/>
-          <a:stretch>
-            <a:fillRect/>
-          </a:stretch>
-        </p:blipFill>
-        <p:spPr>
-          <a:xfrm>
-            <a:off x="7088386" y="1882080"/>
+          <p:cNvPr id="17" name="Image 15" descr="preencoded.png">
+            <a:hlinkClick r:id="rId31" tooltip="https://giz.de/"/>
+          </p:cNvPr>
+          <p:cNvPicPr>
+            <a:picLocks noChangeAspect="1"/>
+          </p:cNvPicPr>
+          <p:nvPr/>
+        </p:nvPicPr>
+        <p:blipFill>
+          <a:blip r:embed="rId30"/>
+          <a:stretch>
+            <a:fillRect/>
+          </a:stretch>
+        </p:blipFill>
+        <p:spPr>
+          <a:xfrm>
+            <a:off x="6429375" y="3255615"/>
             <a:ext cx="195263" cy="95250"/>
           </a:xfrm>
           <a:prstGeom prst="rect">
@@ -9582,23 +9671,23 @@
       </p:pic>
       <p:pic>
         <p:nvPicPr>
-          <p:cNvPr id="9" name="Image 7" descr="preencoded.png">
-            <a:hlinkClick r:id="rId15" tooltip="https://google.org/"/>
-          </p:cNvPr>
-          <p:cNvPicPr>
-            <a:picLocks noChangeAspect="1"/>
-          </p:cNvPicPr>
-          <p:nvPr/>
-        </p:nvPicPr>
-        <p:blipFill>
-          <a:blip r:embed="rId14"/>
-          <a:stretch>
-            <a:fillRect/>
-          </a:stretch>
-        </p:blipFill>
-        <p:spPr>
-          <a:xfrm>
-            <a:off x="7088386" y="1997571"/>
+          <p:cNvPr id="18" name="Image 16" descr="preencoded.png">
+            <a:hlinkClick r:id="rId33" tooltip="https://google.org/"/>
+          </p:cNvPr>
+          <p:cNvPicPr>
+            <a:picLocks noChangeAspect="1"/>
+          </p:cNvPicPr>
+          <p:nvPr/>
+        </p:nvPicPr>
+        <p:blipFill>
+          <a:blip r:embed="rId32"/>
+          <a:stretch>
+            <a:fillRect/>
+          </a:stretch>
+        </p:blipFill>
+        <p:spPr>
+          <a:xfrm>
+            <a:off x="6429375" y="3393728"/>
             <a:ext cx="361950" cy="95250"/>
           </a:xfrm>
           <a:prstGeom prst="rect">
@@ -9608,23 +9697,23 @@
       </p:pic>
       <p:pic>
         <p:nvPicPr>
-          <p:cNvPr id="10" name="Image 8" descr="preencoded.png">
-            <a:hlinkClick r:id="rId17" tooltip="https://about.meta.com/"/>
-          </p:cNvPr>
-          <p:cNvPicPr>
-            <a:picLocks noChangeAspect="1"/>
-          </p:cNvPicPr>
-          <p:nvPr/>
-        </p:nvPicPr>
-        <p:blipFill>
-          <a:blip r:embed="rId16"/>
-          <a:stretch>
-            <a:fillRect/>
-          </a:stretch>
-        </p:blipFill>
-        <p:spPr>
-          <a:xfrm>
-            <a:off x="7088386" y="2113062"/>
+          <p:cNvPr id="19" name="Image 17" descr="preencoded.png">
+            <a:hlinkClick r:id="rId35" tooltip="https://about.meta.com/"/>
+          </p:cNvPr>
+          <p:cNvPicPr>
+            <a:picLocks noChangeAspect="1"/>
+          </p:cNvPicPr>
+          <p:nvPr/>
+        </p:nvPicPr>
+        <p:blipFill>
+          <a:blip r:embed="rId34"/>
+          <a:stretch>
+            <a:fillRect/>
+          </a:stretch>
+        </p:blipFill>
+        <p:spPr>
+          <a:xfrm>
+            <a:off x="6429375" y="3531840"/>
             <a:ext cx="538163" cy="95250"/>
           </a:xfrm>
           <a:prstGeom prst="rect">
@@ -9634,242 +9723,8 @@
       </p:pic>
       <p:pic>
         <p:nvPicPr>
-          <p:cNvPr id="11" name="Image 9" descr="preencoded.png">
-            <a:hlinkClick r:id="rId19" tooltip="https://huawei.com/"/>
-          </p:cNvPr>
-          <p:cNvPicPr>
-            <a:picLocks noChangeAspect="1"/>
-          </p:cNvPicPr>
-          <p:nvPr/>
-        </p:nvPicPr>
-        <p:blipFill>
-          <a:blip r:embed="rId18"/>
-          <a:stretch>
-            <a:fillRect/>
-          </a:stretch>
-        </p:blipFill>
-        <p:spPr>
-          <a:xfrm>
-            <a:off x="7088386" y="2228552"/>
-            <a:ext cx="400050" cy="95250"/>
-          </a:xfrm>
-          <a:prstGeom prst="rect">
-            <a:avLst/>
-          </a:prstGeom>
-        </p:spPr>
-      </p:pic>
-      <p:pic>
-        <p:nvPicPr>
-          <p:cNvPr id="12" name="Image 10" descr="preencoded.png">
-            <a:hlinkClick r:id="rId21" tooltip="https://samsung.com/"/>
-          </p:cNvPr>
-          <p:cNvPicPr>
-            <a:picLocks noChangeAspect="1"/>
-          </p:cNvPicPr>
-          <p:nvPr/>
-        </p:nvPicPr>
-        <p:blipFill>
-          <a:blip r:embed="rId20"/>
-          <a:stretch>
-            <a:fillRect/>
-          </a:stretch>
-        </p:blipFill>
-        <p:spPr>
-          <a:xfrm>
-            <a:off x="7088386" y="2344043"/>
-            <a:ext cx="461962" cy="95250"/>
-          </a:xfrm>
-          <a:prstGeom prst="rect">
-            <a:avLst/>
-          </a:prstGeom>
-        </p:spPr>
-      </p:pic>
-      <p:pic>
-        <p:nvPicPr>
-          <p:cNvPr id="13" name="Image 11" descr="preencoded.png">
-            <a:hlinkClick r:id="rId23" tooltip="https://arm.com/resources/education"/>
-          </p:cNvPr>
-          <p:cNvPicPr>
-            <a:picLocks noChangeAspect="1"/>
-          </p:cNvPicPr>
-          <p:nvPr/>
-        </p:nvPicPr>
-        <p:blipFill>
-          <a:blip r:embed="rId22"/>
-          <a:stretch>
-            <a:fillRect/>
-          </a:stretch>
-        </p:blipFill>
-        <p:spPr>
-          <a:xfrm>
-            <a:off x="7088386" y="2459534"/>
-            <a:ext cx="995362" cy="95250"/>
-          </a:xfrm>
-          <a:prstGeom prst="rect">
-            <a:avLst/>
-          </a:prstGeom>
-        </p:spPr>
-      </p:pic>
-      <p:pic>
-        <p:nvPicPr>
-          <p:cNvPr id="14" name="Image 12" descr="preencoded.png">
-            <a:hlinkClick r:id="rId25" tooltip="https://netacad.com/"/>
-          </p:cNvPr>
-          <p:cNvPicPr>
-            <a:picLocks noChangeAspect="1"/>
-          </p:cNvPicPr>
-          <p:nvPr/>
-        </p:nvPicPr>
-        <p:blipFill>
-          <a:blip r:embed="rId24"/>
-          <a:stretch>
-            <a:fillRect/>
-          </a:stretch>
-        </p:blipFill>
-        <p:spPr>
-          <a:xfrm>
-            <a:off x="7088386" y="2575024"/>
-            <a:ext cx="419100" cy="95250"/>
-          </a:xfrm>
-          <a:prstGeom prst="rect">
-            <a:avLst/>
-          </a:prstGeom>
-        </p:spPr>
-      </p:pic>
-      <p:pic>
-        <p:nvPicPr>
-          <p:cNvPr id="15" name="Image 13" descr="preencoded.png">
-            <a:hlinkClick r:id="rId27" tooltip="https://fondationorange.com/"/>
-          </p:cNvPr>
-          <p:cNvPicPr>
-            <a:picLocks noChangeAspect="1"/>
-          </p:cNvPicPr>
-          <p:nvPr/>
-        </p:nvPicPr>
-        <p:blipFill>
-          <a:blip r:embed="rId26"/>
-          <a:stretch>
-            <a:fillRect/>
-          </a:stretch>
-        </p:blipFill>
-        <p:spPr>
-          <a:xfrm>
-            <a:off x="7088386" y="2690515"/>
-            <a:ext cx="714375" cy="95250"/>
-          </a:xfrm>
-          <a:prstGeom prst="rect">
-            <a:avLst/>
-          </a:prstGeom>
-        </p:spPr>
-      </p:pic>
-      <p:pic>
-        <p:nvPicPr>
-          <p:cNvPr id="16" name="Image 14" descr="preencoded.png">
-            <a:hlinkClick r:id="rId29" tooltip="https://vodafone.com/foundation"/>
-          </p:cNvPr>
-          <p:cNvPicPr>
-            <a:picLocks noChangeAspect="1"/>
-          </p:cNvPicPr>
-          <p:nvPr/>
-        </p:nvPicPr>
-        <p:blipFill>
-          <a:blip r:embed="rId28"/>
-          <a:stretch>
-            <a:fillRect/>
-          </a:stretch>
-        </p:blipFill>
-        <p:spPr>
-          <a:xfrm>
-            <a:off x="7088386" y="2806005"/>
-            <a:ext cx="862012" cy="95250"/>
-          </a:xfrm>
-          <a:prstGeom prst="rect">
-            <a:avLst/>
-          </a:prstGeom>
-        </p:spPr>
-      </p:pic>
-      <p:pic>
-        <p:nvPicPr>
-          <p:cNvPr id="17" name="Image 15" descr="preencoded.png">
-            <a:hlinkClick r:id="rId31" tooltip="https://airtel.africa/"/>
-          </p:cNvPr>
-          <p:cNvPicPr>
-            <a:picLocks noChangeAspect="1"/>
-          </p:cNvPicPr>
-          <p:nvPr/>
-        </p:nvPicPr>
-        <p:blipFill>
-          <a:blip r:embed="rId30"/>
-          <a:stretch>
-            <a:fillRect/>
-          </a:stretch>
-        </p:blipFill>
-        <p:spPr>
-          <a:xfrm>
-            <a:off x="7088386" y="2921496"/>
-            <a:ext cx="366712" cy="95250"/>
-          </a:xfrm>
-          <a:prstGeom prst="rect">
-            <a:avLst/>
-          </a:prstGeom>
-        </p:spPr>
-      </p:pic>
-      <p:pic>
-        <p:nvPicPr>
-          <p:cNvPr id="18" name="Image 16" descr="preencoded.png">
-            <a:hlinkClick r:id="rId33" tooltip="https://newmont.com/"/>
-          </p:cNvPr>
-          <p:cNvPicPr>
-            <a:picLocks noChangeAspect="1"/>
-          </p:cNvPicPr>
-          <p:nvPr/>
-        </p:nvPicPr>
-        <p:blipFill>
-          <a:blip r:embed="rId32"/>
-          <a:stretch>
-            <a:fillRect/>
-          </a:stretch>
-        </p:blipFill>
-        <p:spPr>
-          <a:xfrm>
-            <a:off x="7088386" y="3036987"/>
-            <a:ext cx="476250" cy="95250"/>
-          </a:xfrm>
-          <a:prstGeom prst="rect">
-            <a:avLst/>
-          </a:prstGeom>
-        </p:spPr>
-      </p:pic>
-      <p:pic>
-        <p:nvPicPr>
-          <p:cNvPr id="19" name="Image 17" descr="preencoded.png">
-            <a:hlinkClick r:id="rId35" tooltip="https://anglogoldashanti.com/"/>
-          </p:cNvPr>
-          <p:cNvPicPr>
-            <a:picLocks noChangeAspect="1"/>
-          </p:cNvPicPr>
-          <p:nvPr/>
-        </p:nvPicPr>
-        <p:blipFill>
-          <a:blip r:embed="rId34"/>
-          <a:stretch>
-            <a:fillRect/>
-          </a:stretch>
-        </p:blipFill>
-        <p:spPr>
-          <a:xfrm>
-            <a:off x="7088386" y="3152477"/>
-            <a:ext cx="733425" cy="95250"/>
-          </a:xfrm>
-          <a:prstGeom prst="rect">
-            <a:avLst/>
-          </a:prstGeom>
-        </p:spPr>
-      </p:pic>
-      <p:pic>
-        <p:nvPicPr>
           <p:cNvPr id="20" name="Image 18" descr="preencoded.png">
-            <a:hlinkClick r:id="rId37" tooltip="https://kosmosenergy.com/"/>
+            <a:hlinkClick r:id="rId37" tooltip="https://github.com/samquansah-algo/nbc-vct/tree/main/weekly-tactics/04-sales/"/>
           </p:cNvPr>
           <p:cNvPicPr>
             <a:picLocks noChangeAspect="1"/>
@@ -9878,214 +9733,6 @@
         </p:nvPicPr>
         <p:blipFill>
           <a:blip r:embed="rId36"/>
-          <a:stretch>
-            <a:fillRect/>
-          </a:stretch>
-        </p:blipFill>
-        <p:spPr>
-          <a:xfrm>
-            <a:off x="7088386" y="3267968"/>
-            <a:ext cx="642938" cy="95250"/>
-          </a:xfrm>
-          <a:prstGeom prst="rect">
-            <a:avLst/>
-          </a:prstGeom>
-        </p:spPr>
-      </p:pic>
-      <p:pic>
-        <p:nvPicPr>
-          <p:cNvPr id="21" name="Image 19" descr="preencoded.png">
-            <a:hlinkClick r:id="rId39" tooltip="https://tullowoil.com/"/>
-          </p:cNvPr>
-          <p:cNvPicPr>
-            <a:picLocks noChangeAspect="1"/>
-          </p:cNvPicPr>
-          <p:nvPr/>
-        </p:nvPicPr>
-        <p:blipFill>
-          <a:blip r:embed="rId38"/>
-          <a:stretch>
-            <a:fillRect/>
-          </a:stretch>
-        </p:blipFill>
-        <p:spPr>
-          <a:xfrm>
-            <a:off x="7088386" y="3383459"/>
-            <a:ext cx="447675" cy="95250"/>
-          </a:xfrm>
-          <a:prstGeom prst="rect">
-            <a:avLst/>
-          </a:prstGeom>
-        </p:spPr>
-      </p:pic>
-      <p:pic>
-        <p:nvPicPr>
-          <p:cNvPr id="22" name="Image 20" descr="preencoded.png">
-            <a:hlinkClick r:id="rId41" tooltip="https://gnpcghana.com/"/>
-          </p:cNvPr>
-          <p:cNvPicPr>
-            <a:picLocks noChangeAspect="1"/>
-          </p:cNvPicPr>
-          <p:nvPr/>
-        </p:nvPicPr>
-        <p:blipFill>
-          <a:blip r:embed="rId40"/>
-          <a:stretch>
-            <a:fillRect/>
-          </a:stretch>
-        </p:blipFill>
-        <p:spPr>
-          <a:xfrm>
-            <a:off x="7088386" y="3498949"/>
-            <a:ext cx="528638" cy="95250"/>
-          </a:xfrm>
-          <a:prstGeom prst="rect">
-            <a:avLst/>
-          </a:prstGeom>
-        </p:spPr>
-      </p:pic>
-      <p:pic>
-        <p:nvPicPr>
-          <p:cNvPr id="23" name="Image 21" descr="preencoded.png">
-            <a:hlinkClick r:id="rId43" tooltip="https://absa.com.gh/"/>
-          </p:cNvPr>
-          <p:cNvPicPr>
-            <a:picLocks noChangeAspect="1"/>
-          </p:cNvPicPr>
-          <p:nvPr/>
-        </p:nvPicPr>
-        <p:blipFill>
-          <a:blip r:embed="rId42"/>
-          <a:stretch>
-            <a:fillRect/>
-          </a:stretch>
-        </p:blipFill>
-        <p:spPr>
-          <a:xfrm>
-            <a:off x="7088386" y="3614440"/>
-            <a:ext cx="419100" cy="95250"/>
-          </a:xfrm>
-          <a:prstGeom prst="rect">
-            <a:avLst/>
-          </a:prstGeom>
-        </p:spPr>
-      </p:pic>
-      <p:pic>
-        <p:nvPicPr>
-          <p:cNvPr id="24" name="Image 22" descr="preencoded.png">
-            <a:hlinkClick r:id="rId45" tooltip="https://stanbicbank.com.gh/"/>
-          </p:cNvPr>
-          <p:cNvPicPr>
-            <a:picLocks noChangeAspect="1"/>
-          </p:cNvPicPr>
-          <p:nvPr/>
-        </p:nvPicPr>
-        <p:blipFill>
-          <a:blip r:embed="rId44"/>
-          <a:stretch>
-            <a:fillRect/>
-          </a:stretch>
-        </p:blipFill>
-        <p:spPr>
-          <a:xfrm>
-            <a:off x="7088386" y="3729930"/>
-            <a:ext cx="661987" cy="95250"/>
-          </a:xfrm>
-          <a:prstGeom prst="rect">
-            <a:avLst/>
-          </a:prstGeom>
-        </p:spPr>
-      </p:pic>
-      <p:pic>
-        <p:nvPicPr>
-          <p:cNvPr id="25" name="Image 23" descr="preencoded.png">
-            <a:hlinkClick r:id="rId47" tooltip="https://gcbbank.com.gh/"/>
-          </p:cNvPr>
-          <p:cNvPicPr>
-            <a:picLocks noChangeAspect="1"/>
-          </p:cNvPicPr>
-          <p:nvPr/>
-        </p:nvPicPr>
-        <p:blipFill>
-          <a:blip r:embed="rId46"/>
-          <a:stretch>
-            <a:fillRect/>
-          </a:stretch>
-        </p:blipFill>
-        <p:spPr>
-          <a:xfrm>
-            <a:off x="7088386" y="3845421"/>
-            <a:ext cx="547687" cy="95250"/>
-          </a:xfrm>
-          <a:prstGeom prst="rect">
-            <a:avLst/>
-          </a:prstGeom>
-        </p:spPr>
-      </p:pic>
-      <p:pic>
-        <p:nvPicPr>
-          <p:cNvPr id="26" name="Image 24" descr="preencoded.png">
-            <a:hlinkClick r:id="rId49" tooltip="https://fidelitybank.com.gh/"/>
-          </p:cNvPr>
-          <p:cNvPicPr>
-            <a:picLocks noChangeAspect="1"/>
-          </p:cNvPicPr>
-          <p:nvPr/>
-        </p:nvPicPr>
-        <p:blipFill>
-          <a:blip r:embed="rId48"/>
-          <a:stretch>
-            <a:fillRect/>
-          </a:stretch>
-        </p:blipFill>
-        <p:spPr>
-          <a:xfrm>
-            <a:off x="7088386" y="3960912"/>
-            <a:ext cx="652463" cy="95250"/>
-          </a:xfrm>
-          <a:prstGeom prst="rect">
-            <a:avLst/>
-          </a:prstGeom>
-        </p:spPr>
-      </p:pic>
-      <p:pic>
-        <p:nvPicPr>
-          <p:cNvPr id="27" name="Image 25" descr="preencoded.png">
-            <a:hlinkClick r:id="rId51" tooltip="https://raspberrypi.org/"/>
-          </p:cNvPr>
-          <p:cNvPicPr>
-            <a:picLocks noChangeAspect="1"/>
-          </p:cNvPicPr>
-          <p:nvPr/>
-        </p:nvPicPr>
-        <p:blipFill>
-          <a:blip r:embed="rId50"/>
-          <a:stretch>
-            <a:fillRect/>
-          </a:stretch>
-        </p:blipFill>
-        <p:spPr>
-          <a:xfrm>
-            <a:off x="7088386" y="4076402"/>
-            <a:ext cx="514350" cy="95250"/>
-          </a:xfrm>
-          <a:prstGeom prst="rect">
-            <a:avLst/>
-          </a:prstGeom>
-        </p:spPr>
-      </p:pic>
-      <p:pic>
-        <p:nvPicPr>
-          <p:cNvPr id="28" name="Image 26" descr="preencoded.png">
-            <a:hlinkClick r:id="rId53" tooltip="https://github.com/samquansah-algo/nbc-vct/tree/main/weekly-tactics/04-sales/"/>
-          </p:cNvPr>
-          <p:cNvPicPr>
-            <a:picLocks noChangeAspect="1"/>
-          </p:cNvPicPr>
-          <p:nvPr/>
-        </p:nvPicPr>
-        <p:blipFill>
-          <a:blip r:embed="rId52"/>
           <a:stretch>
             <a:fillRect/>
           </a:stretch>
@@ -10102,16 +9749,16 @@
       </p:pic>
       <p:pic>
         <p:nvPicPr>
-          <p:cNvPr id="29" name="Image 27" descr="preencoded.png">
-            <a:hlinkClick r:id="rId55" tooltip="https://github.com/samquansah-algo/nbc-vct/blob/main/weekly-tactics/04-sales/README.md"/>
-          </p:cNvPr>
-          <p:cNvPicPr>
-            <a:picLocks noChangeAspect="1"/>
-          </p:cNvPicPr>
-          <p:nvPr/>
-        </p:nvPicPr>
-        <p:blipFill>
-          <a:blip r:embed="rId54"/>
+          <p:cNvPr id="21" name="Image 19" descr="preencoded.png">
+            <a:hlinkClick r:id="rId39" tooltip="https://github.com/samquansah-algo/nbc-vct/blob/main/weekly-tactics/04-sales/README.md"/>
+          </p:cNvPr>
+          <p:cNvPicPr>
+            <a:picLocks noChangeAspect="1"/>
+          </p:cNvPicPr>
+          <p:nvPr/>
+        </p:nvPicPr>
+        <p:blipFill>
+          <a:blip r:embed="rId38"/>
           <a:stretch>
             <a:fillRect/>
           </a:stretch>
@@ -10128,16 +9775,16 @@
       </p:pic>
       <p:pic>
         <p:nvPicPr>
-          <p:cNvPr id="30" name="Image 28" descr="preencoded.png">
-            <a:hlinkClick r:id="rId57" tooltip="https://github.com/samquansah-algo/nbc-vct/blob/main/brand/NBC_Brand_Guide.pdf"/>
-          </p:cNvPr>
-          <p:cNvPicPr>
-            <a:picLocks noChangeAspect="1"/>
-          </p:cNvPicPr>
-          <p:nvPr/>
-        </p:nvPicPr>
-        <p:blipFill>
-          <a:blip r:embed="rId56"/>
+          <p:cNvPr id="22" name="Image 20" descr="preencoded.png">
+            <a:hlinkClick r:id="rId41" tooltip="https://github.com/samquansah-algo/nbc-vct/blob/main/brand/NBC_Brand_Guide.pdf"/>
+          </p:cNvPr>
+          <p:cNvPicPr>
+            <a:picLocks noChangeAspect="1"/>
+          </p:cNvPicPr>
+          <p:nvPr/>
+        </p:nvPicPr>
+        <p:blipFill>
+          <a:blip r:embed="rId40"/>
           <a:stretch>
             <a:fillRect/>
           </a:stretch>
@@ -10204,7 +9851,7 @@
       <p:pic>
         <p:nvPicPr>
           <p:cNvPr id="3" name="Image 1" descr="preencoded.png">
-            <a:hlinkClick r:id="rId3" tooltip="https://github.com/samquansah-algo/nbc-vct/blob/main/brand/NBC_Brand_Guide.pdf"/>
+            <a:hlinkClick r:id="rId3" tooltip="https://huawei.com/"/>
           </p:cNvPr>
           <p:cNvPicPr>
             <a:picLocks noChangeAspect="1"/>
@@ -10219,7 +9866,501 @@
         </p:blipFill>
         <p:spPr>
           <a:xfrm>
-            <a:off x="4938712" y="4824412"/>
+            <a:off x="6429375" y="1322040"/>
+            <a:ext cx="400050" cy="95250"/>
+          </a:xfrm>
+          <a:prstGeom prst="rect">
+            <a:avLst/>
+          </a:prstGeom>
+        </p:spPr>
+      </p:pic>
+      <p:pic>
+        <p:nvPicPr>
+          <p:cNvPr id="4" name="Image 2" descr="preencoded.png">
+            <a:hlinkClick r:id="rId5" tooltip="https://samsung.com/"/>
+          </p:cNvPr>
+          <p:cNvPicPr>
+            <a:picLocks noChangeAspect="1"/>
+          </p:cNvPicPr>
+          <p:nvPr/>
+        </p:nvPicPr>
+        <p:blipFill>
+          <a:blip r:embed="rId4"/>
+          <a:stretch>
+            <a:fillRect/>
+          </a:stretch>
+        </p:blipFill>
+        <p:spPr>
+          <a:xfrm>
+            <a:off x="6429375" y="1460153"/>
+            <a:ext cx="461962" cy="95250"/>
+          </a:xfrm>
+          <a:prstGeom prst="rect">
+            <a:avLst/>
+          </a:prstGeom>
+        </p:spPr>
+      </p:pic>
+      <p:pic>
+        <p:nvPicPr>
+          <p:cNvPr id="5" name="Image 3" descr="preencoded.png">
+            <a:hlinkClick r:id="rId7" tooltip="https://arm.com/resources/education"/>
+          </p:cNvPr>
+          <p:cNvPicPr>
+            <a:picLocks noChangeAspect="1"/>
+          </p:cNvPicPr>
+          <p:nvPr/>
+        </p:nvPicPr>
+        <p:blipFill>
+          <a:blip r:embed="rId6"/>
+          <a:stretch>
+            <a:fillRect/>
+          </a:stretch>
+        </p:blipFill>
+        <p:spPr>
+          <a:xfrm>
+            <a:off x="6429375" y="1598265"/>
+            <a:ext cx="995362" cy="95250"/>
+          </a:xfrm>
+          <a:prstGeom prst="rect">
+            <a:avLst/>
+          </a:prstGeom>
+        </p:spPr>
+      </p:pic>
+      <p:pic>
+        <p:nvPicPr>
+          <p:cNvPr id="6" name="Image 4" descr="preencoded.png">
+            <a:hlinkClick r:id="rId9" tooltip="https://netacad.com/"/>
+          </p:cNvPr>
+          <p:cNvPicPr>
+            <a:picLocks noChangeAspect="1"/>
+          </p:cNvPicPr>
+          <p:nvPr/>
+        </p:nvPicPr>
+        <p:blipFill>
+          <a:blip r:embed="rId8"/>
+          <a:stretch>
+            <a:fillRect/>
+          </a:stretch>
+        </p:blipFill>
+        <p:spPr>
+          <a:xfrm>
+            <a:off x="6429375" y="1736378"/>
+            <a:ext cx="419100" cy="95250"/>
+          </a:xfrm>
+          <a:prstGeom prst="rect">
+            <a:avLst/>
+          </a:prstGeom>
+        </p:spPr>
+      </p:pic>
+      <p:pic>
+        <p:nvPicPr>
+          <p:cNvPr id="7" name="Image 5" descr="preencoded.png">
+            <a:hlinkClick r:id="rId11" tooltip="https://fondationorange.com/"/>
+          </p:cNvPr>
+          <p:cNvPicPr>
+            <a:picLocks noChangeAspect="1"/>
+          </p:cNvPicPr>
+          <p:nvPr/>
+        </p:nvPicPr>
+        <p:blipFill>
+          <a:blip r:embed="rId10"/>
+          <a:stretch>
+            <a:fillRect/>
+          </a:stretch>
+        </p:blipFill>
+        <p:spPr>
+          <a:xfrm>
+            <a:off x="6429375" y="1874490"/>
+            <a:ext cx="714375" cy="95250"/>
+          </a:xfrm>
+          <a:prstGeom prst="rect">
+            <a:avLst/>
+          </a:prstGeom>
+        </p:spPr>
+      </p:pic>
+      <p:pic>
+        <p:nvPicPr>
+          <p:cNvPr id="8" name="Image 6" descr="preencoded.png">
+            <a:hlinkClick r:id="rId13" tooltip="https://vodafone.com/foundation"/>
+          </p:cNvPr>
+          <p:cNvPicPr>
+            <a:picLocks noChangeAspect="1"/>
+          </p:cNvPicPr>
+          <p:nvPr/>
+        </p:nvPicPr>
+        <p:blipFill>
+          <a:blip r:embed="rId12"/>
+          <a:stretch>
+            <a:fillRect/>
+          </a:stretch>
+        </p:blipFill>
+        <p:spPr>
+          <a:xfrm>
+            <a:off x="6429375" y="2012603"/>
+            <a:ext cx="862012" cy="95250"/>
+          </a:xfrm>
+          <a:prstGeom prst="rect">
+            <a:avLst/>
+          </a:prstGeom>
+        </p:spPr>
+      </p:pic>
+      <p:pic>
+        <p:nvPicPr>
+          <p:cNvPr id="9" name="Image 7" descr="preencoded.png">
+            <a:hlinkClick r:id="rId15" tooltip="https://airtel.africa/"/>
+          </p:cNvPr>
+          <p:cNvPicPr>
+            <a:picLocks noChangeAspect="1"/>
+          </p:cNvPicPr>
+          <p:nvPr/>
+        </p:nvPicPr>
+        <p:blipFill>
+          <a:blip r:embed="rId14"/>
+          <a:stretch>
+            <a:fillRect/>
+          </a:stretch>
+        </p:blipFill>
+        <p:spPr>
+          <a:xfrm>
+            <a:off x="6429375" y="2150715"/>
+            <a:ext cx="366712" cy="95250"/>
+          </a:xfrm>
+          <a:prstGeom prst="rect">
+            <a:avLst/>
+          </a:prstGeom>
+        </p:spPr>
+      </p:pic>
+      <p:pic>
+        <p:nvPicPr>
+          <p:cNvPr id="10" name="Image 8" descr="preencoded.png">
+            <a:hlinkClick r:id="rId17" tooltip="https://newmont.com/"/>
+          </p:cNvPr>
+          <p:cNvPicPr>
+            <a:picLocks noChangeAspect="1"/>
+          </p:cNvPicPr>
+          <p:nvPr/>
+        </p:nvPicPr>
+        <p:blipFill>
+          <a:blip r:embed="rId16"/>
+          <a:stretch>
+            <a:fillRect/>
+          </a:stretch>
+        </p:blipFill>
+        <p:spPr>
+          <a:xfrm>
+            <a:off x="6429375" y="2288828"/>
+            <a:ext cx="476250" cy="95250"/>
+          </a:xfrm>
+          <a:prstGeom prst="rect">
+            <a:avLst/>
+          </a:prstGeom>
+        </p:spPr>
+      </p:pic>
+      <p:pic>
+        <p:nvPicPr>
+          <p:cNvPr id="11" name="Image 9" descr="preencoded.png">
+            <a:hlinkClick r:id="rId19" tooltip="https://anglogoldashanti.com/"/>
+          </p:cNvPr>
+          <p:cNvPicPr>
+            <a:picLocks noChangeAspect="1"/>
+          </p:cNvPicPr>
+          <p:nvPr/>
+        </p:nvPicPr>
+        <p:blipFill>
+          <a:blip r:embed="rId18"/>
+          <a:stretch>
+            <a:fillRect/>
+          </a:stretch>
+        </p:blipFill>
+        <p:spPr>
+          <a:xfrm>
+            <a:off x="6429375" y="2426940"/>
+            <a:ext cx="733425" cy="95250"/>
+          </a:xfrm>
+          <a:prstGeom prst="rect">
+            <a:avLst/>
+          </a:prstGeom>
+        </p:spPr>
+      </p:pic>
+      <p:pic>
+        <p:nvPicPr>
+          <p:cNvPr id="12" name="Image 10" descr="preencoded.png">
+            <a:hlinkClick r:id="rId21" tooltip="https://kosmosenergy.com/"/>
+          </p:cNvPr>
+          <p:cNvPicPr>
+            <a:picLocks noChangeAspect="1"/>
+          </p:cNvPicPr>
+          <p:nvPr/>
+        </p:nvPicPr>
+        <p:blipFill>
+          <a:blip r:embed="rId20"/>
+          <a:stretch>
+            <a:fillRect/>
+          </a:stretch>
+        </p:blipFill>
+        <p:spPr>
+          <a:xfrm>
+            <a:off x="6429375" y="2565053"/>
+            <a:ext cx="642938" cy="95250"/>
+          </a:xfrm>
+          <a:prstGeom prst="rect">
+            <a:avLst/>
+          </a:prstGeom>
+        </p:spPr>
+      </p:pic>
+      <p:pic>
+        <p:nvPicPr>
+          <p:cNvPr id="13" name="Image 11" descr="preencoded.png">
+            <a:hlinkClick r:id="rId23" tooltip="https://tullowoil.com/"/>
+          </p:cNvPr>
+          <p:cNvPicPr>
+            <a:picLocks noChangeAspect="1"/>
+          </p:cNvPicPr>
+          <p:nvPr/>
+        </p:nvPicPr>
+        <p:blipFill>
+          <a:blip r:embed="rId22"/>
+          <a:stretch>
+            <a:fillRect/>
+          </a:stretch>
+        </p:blipFill>
+        <p:spPr>
+          <a:xfrm>
+            <a:off x="6429375" y="2703165"/>
+            <a:ext cx="447675" cy="95250"/>
+          </a:xfrm>
+          <a:prstGeom prst="rect">
+            <a:avLst/>
+          </a:prstGeom>
+        </p:spPr>
+      </p:pic>
+      <p:pic>
+        <p:nvPicPr>
+          <p:cNvPr id="14" name="Image 12" descr="preencoded.png">
+            <a:hlinkClick r:id="rId25" tooltip="https://gnpcghana.com/"/>
+          </p:cNvPr>
+          <p:cNvPicPr>
+            <a:picLocks noChangeAspect="1"/>
+          </p:cNvPicPr>
+          <p:nvPr/>
+        </p:nvPicPr>
+        <p:blipFill>
+          <a:blip r:embed="rId24"/>
+          <a:stretch>
+            <a:fillRect/>
+          </a:stretch>
+        </p:blipFill>
+        <p:spPr>
+          <a:xfrm>
+            <a:off x="6429375" y="2841278"/>
+            <a:ext cx="528638" cy="95250"/>
+          </a:xfrm>
+          <a:prstGeom prst="rect">
+            <a:avLst/>
+          </a:prstGeom>
+        </p:spPr>
+      </p:pic>
+      <p:pic>
+        <p:nvPicPr>
+          <p:cNvPr id="15" name="Image 13" descr="preencoded.png">
+            <a:hlinkClick r:id="rId27" tooltip="https://absa.com.gh/"/>
+          </p:cNvPr>
+          <p:cNvPicPr>
+            <a:picLocks noChangeAspect="1"/>
+          </p:cNvPicPr>
+          <p:nvPr/>
+        </p:nvPicPr>
+        <p:blipFill>
+          <a:blip r:embed="rId26"/>
+          <a:stretch>
+            <a:fillRect/>
+          </a:stretch>
+        </p:blipFill>
+        <p:spPr>
+          <a:xfrm>
+            <a:off x="6429375" y="2979390"/>
+            <a:ext cx="419100" cy="95250"/>
+          </a:xfrm>
+          <a:prstGeom prst="rect">
+            <a:avLst/>
+          </a:prstGeom>
+        </p:spPr>
+      </p:pic>
+      <p:pic>
+        <p:nvPicPr>
+          <p:cNvPr id="16" name="Image 14" descr="preencoded.png">
+            <a:hlinkClick r:id="rId29" tooltip="https://stanbicbank.com.gh/"/>
+          </p:cNvPr>
+          <p:cNvPicPr>
+            <a:picLocks noChangeAspect="1"/>
+          </p:cNvPicPr>
+          <p:nvPr/>
+        </p:nvPicPr>
+        <p:blipFill>
+          <a:blip r:embed="rId28"/>
+          <a:stretch>
+            <a:fillRect/>
+          </a:stretch>
+        </p:blipFill>
+        <p:spPr>
+          <a:xfrm>
+            <a:off x="6429375" y="3117503"/>
+            <a:ext cx="661987" cy="95250"/>
+          </a:xfrm>
+          <a:prstGeom prst="rect">
+            <a:avLst/>
+          </a:prstGeom>
+        </p:spPr>
+      </p:pic>
+      <p:pic>
+        <p:nvPicPr>
+          <p:cNvPr id="17" name="Image 15" descr="preencoded.png">
+            <a:hlinkClick r:id="rId31" tooltip="https://gcbbank.com.gh/"/>
+          </p:cNvPr>
+          <p:cNvPicPr>
+            <a:picLocks noChangeAspect="1"/>
+          </p:cNvPicPr>
+          <p:nvPr/>
+        </p:nvPicPr>
+        <p:blipFill>
+          <a:blip r:embed="rId30"/>
+          <a:stretch>
+            <a:fillRect/>
+          </a:stretch>
+        </p:blipFill>
+        <p:spPr>
+          <a:xfrm>
+            <a:off x="6429375" y="3255615"/>
+            <a:ext cx="547687" cy="95250"/>
+          </a:xfrm>
+          <a:prstGeom prst="rect">
+            <a:avLst/>
+          </a:prstGeom>
+        </p:spPr>
+      </p:pic>
+      <p:pic>
+        <p:nvPicPr>
+          <p:cNvPr id="18" name="Image 16" descr="preencoded.png">
+            <a:hlinkClick r:id="rId33" tooltip="https://fidelitybank.com.gh/"/>
+          </p:cNvPr>
+          <p:cNvPicPr>
+            <a:picLocks noChangeAspect="1"/>
+          </p:cNvPicPr>
+          <p:nvPr/>
+        </p:nvPicPr>
+        <p:blipFill>
+          <a:blip r:embed="rId32"/>
+          <a:stretch>
+            <a:fillRect/>
+          </a:stretch>
+        </p:blipFill>
+        <p:spPr>
+          <a:xfrm>
+            <a:off x="6429375" y="3393728"/>
+            <a:ext cx="652463" cy="95250"/>
+          </a:xfrm>
+          <a:prstGeom prst="rect">
+            <a:avLst/>
+          </a:prstGeom>
+        </p:spPr>
+      </p:pic>
+      <p:pic>
+        <p:nvPicPr>
+          <p:cNvPr id="19" name="Image 17" descr="preencoded.png">
+            <a:hlinkClick r:id="rId35" tooltip="https://raspberrypi.org/"/>
+          </p:cNvPr>
+          <p:cNvPicPr>
+            <a:picLocks noChangeAspect="1"/>
+          </p:cNvPicPr>
+          <p:nvPr/>
+        </p:nvPicPr>
+        <p:blipFill>
+          <a:blip r:embed="rId34"/>
+          <a:stretch>
+            <a:fillRect/>
+          </a:stretch>
+        </p:blipFill>
+        <p:spPr>
+          <a:xfrm>
+            <a:off x="6429375" y="3531840"/>
+            <a:ext cx="514350" cy="95250"/>
+          </a:xfrm>
+          <a:prstGeom prst="rect">
+            <a:avLst/>
+          </a:prstGeom>
+        </p:spPr>
+      </p:pic>
+      <p:pic>
+        <p:nvPicPr>
+          <p:cNvPr id="20" name="Image 18" descr="preencoded.png">
+            <a:hlinkClick r:id="rId37" tooltip="https://github.com/samquansah-algo/nbc-vct/tree/main/weekly-tactics/04-sales/"/>
+          </p:cNvPr>
+          <p:cNvPicPr>
+            <a:picLocks noChangeAspect="1"/>
+          </p:cNvPicPr>
+          <p:nvPr/>
+        </p:nvPicPr>
+        <p:blipFill>
+          <a:blip r:embed="rId36"/>
+          <a:stretch>
+            <a:fillRect/>
+          </a:stretch>
+        </p:blipFill>
+        <p:spPr>
+          <a:xfrm>
+            <a:off x="3971925" y="4610100"/>
+            <a:ext cx="233362" cy="95250"/>
+          </a:xfrm>
+          <a:prstGeom prst="rect">
+            <a:avLst/>
+          </a:prstGeom>
+        </p:spPr>
+      </p:pic>
+      <p:pic>
+        <p:nvPicPr>
+          <p:cNvPr id="21" name="Image 19" descr="preencoded.png">
+            <a:hlinkClick r:id="rId39" tooltip="https://github.com/samquansah-algo/nbc-vct/blob/main/weekly-tactics/04-sales/README.md"/>
+          </p:cNvPr>
+          <p:cNvPicPr>
+            <a:picLocks noChangeAspect="1"/>
+          </p:cNvPicPr>
+          <p:nvPr/>
+        </p:nvPicPr>
+        <p:blipFill>
+          <a:blip r:embed="rId38"/>
+          <a:stretch>
+            <a:fillRect/>
+          </a:stretch>
+        </p:blipFill>
+        <p:spPr>
+          <a:xfrm>
+            <a:off x="4748213" y="4824412"/>
+            <a:ext cx="319088" cy="109537"/>
+          </a:xfrm>
+          <a:prstGeom prst="rect">
+            <a:avLst/>
+          </a:prstGeom>
+        </p:spPr>
+      </p:pic>
+      <p:pic>
+        <p:nvPicPr>
+          <p:cNvPr id="22" name="Image 20" descr="preencoded.png">
+            <a:hlinkClick r:id="rId41" tooltip="https://github.com/samquansah-algo/nbc-vct/blob/main/brand/NBC_Brand_Guide.pdf"/>
+          </p:cNvPr>
+          <p:cNvPicPr>
+            <a:picLocks noChangeAspect="1"/>
+          </p:cNvPicPr>
+          <p:nvPr/>
+        </p:nvPicPr>
+        <p:blipFill>
+          <a:blip r:embed="rId40"/>
+          <a:stretch>
+            <a:fillRect/>
+          </a:stretch>
+        </p:blipFill>
+        <p:spPr>
+          <a:xfrm>
+            <a:off x="5129213" y="4824412"/>
             <a:ext cx="642938" cy="109537"/>
           </a:xfrm>
           <a:prstGeom prst="rect">
@@ -10279,7 +10420,7 @@
       <p:pic>
         <p:nvPicPr>
           <p:cNvPr id="3" name="Image 1" descr="preencoded.png">
-            <a:hlinkClick r:id="rId3" tooltip="https://github.com/samquansah-algo/nbc-vct/blob/main/weekly-tactics/04-sales/OUTREACH_KIT.md"/>
+            <a:hlinkClick r:id="rId3" tooltip="https://github.com/samquansah-algo/nbc-vct/blob/main/brand/NBC_Brand_Guide.pdf"/>
           </p:cNvPr>
           <p:cNvPicPr>
             <a:picLocks noChangeAspect="1"/>
@@ -10294,33 +10435,7 @@
         </p:blipFill>
         <p:spPr>
           <a:xfrm>
-            <a:off x="4660106" y="4824412"/>
-            <a:ext cx="495300" cy="109537"/>
-          </a:xfrm>
-          <a:prstGeom prst="rect">
-            <a:avLst/>
-          </a:prstGeom>
-        </p:spPr>
-      </p:pic>
-      <p:pic>
-        <p:nvPicPr>
-          <p:cNvPr id="4" name="Image 2" descr="preencoded.png">
-            <a:hlinkClick r:id="rId5" tooltip="https://github.com/samquansah-algo/nbc-vct/blob/main/brand/NBC_Brand_Guide.pdf"/>
-          </p:cNvPr>
-          <p:cNvPicPr>
-            <a:picLocks noChangeAspect="1"/>
-          </p:cNvPicPr>
-          <p:nvPr/>
-        </p:nvPicPr>
-        <p:blipFill>
-          <a:blip r:embed="rId4"/>
-          <a:stretch>
-            <a:fillRect/>
-          </a:stretch>
-        </p:blipFill>
-        <p:spPr>
-          <a:xfrm>
-            <a:off x="5217319" y="4824412"/>
+            <a:off x="4938712" y="4824412"/>
             <a:ext cx="642938" cy="109537"/>
           </a:xfrm>
           <a:prstGeom prst="rect">
@@ -10683,7 +10798,7 @@
       <p:pic>
         <p:nvPicPr>
           <p:cNvPr id="3" name="Image 1" descr="preencoded.png">
-            <a:hlinkClick r:id="rId3" tooltip="https://github.com/samquansah-algo/nbc-vct/blob/main/brand/NBC_Brand_Guide.pdf"/>
+            <a:hlinkClick r:id="rId3" tooltip="https://github.com/samquansah-algo/nbc-vct/blob/main/weekly-tactics/04-sales/OUTREACH_KIT.md"/>
           </p:cNvPr>
           <p:cNvPicPr>
             <a:picLocks noChangeAspect="1"/>
@@ -10698,7 +10813,33 @@
         </p:blipFill>
         <p:spPr>
           <a:xfrm>
-            <a:off x="4938712" y="4824412"/>
+            <a:off x="4660106" y="4824412"/>
+            <a:ext cx="495300" cy="109537"/>
+          </a:xfrm>
+          <a:prstGeom prst="rect">
+            <a:avLst/>
+          </a:prstGeom>
+        </p:spPr>
+      </p:pic>
+      <p:pic>
+        <p:nvPicPr>
+          <p:cNvPr id="4" name="Image 2" descr="preencoded.png">
+            <a:hlinkClick r:id="rId5" tooltip="https://github.com/samquansah-algo/nbc-vct/blob/main/brand/NBC_Brand_Guide.pdf"/>
+          </p:cNvPr>
+          <p:cNvPicPr>
+            <a:picLocks noChangeAspect="1"/>
+          </p:cNvPicPr>
+          <p:nvPr/>
+        </p:nvPicPr>
+        <p:blipFill>
+          <a:blip r:embed="rId4"/>
+          <a:stretch>
+            <a:fillRect/>
+          </a:stretch>
+        </p:blipFill>
+        <p:spPr>
+          <a:xfrm>
+            <a:off x="5217319" y="4824412"/>
             <a:ext cx="642938" cy="109537"/>
           </a:xfrm>
           <a:prstGeom prst="rect">
@@ -10758,7 +10899,7 @@
       <p:pic>
         <p:nvPicPr>
           <p:cNvPr id="3" name="Image 1" descr="preencoded.png">
-            <a:hlinkClick r:id="rId3" tooltip="https://github.com/samquansah-algo/nbc-vct/tree/main/weekly-tactics/04-sales/"/>
+            <a:hlinkClick r:id="rId3" tooltip="https://github.com/samquansah-algo/nbc-vct/blob/main/brand/NBC_Brand_Guide.pdf"/>
           </p:cNvPr>
           <p:cNvPicPr>
             <a:picLocks noChangeAspect="1"/>
@@ -10773,59 +10914,7 @@
         </p:blipFill>
         <p:spPr>
           <a:xfrm>
-            <a:off x="7539037" y="2760166"/>
-            <a:ext cx="352425" cy="142875"/>
-          </a:xfrm>
-          <a:prstGeom prst="rect">
-            <a:avLst/>
-          </a:prstGeom>
-        </p:spPr>
-      </p:pic>
-      <p:pic>
-        <p:nvPicPr>
-          <p:cNvPr id="4" name="Image 2" descr="preencoded.png">
-            <a:hlinkClick r:id="rId5" tooltip="https://github.com/samquansah-algo/nbc-vct/blob/main/weekly-tactics/04-sales/OUTREACH_KIT.md"/>
-          </p:cNvPr>
-          <p:cNvPicPr>
-            <a:picLocks noChangeAspect="1"/>
-          </p:cNvPicPr>
-          <p:nvPr/>
-        </p:nvPicPr>
-        <p:blipFill>
-          <a:blip r:embed="rId4"/>
-          <a:stretch>
-            <a:fillRect/>
-          </a:stretch>
-        </p:blipFill>
-        <p:spPr>
-          <a:xfrm>
-            <a:off x="4660106" y="4824412"/>
-            <a:ext cx="495300" cy="109537"/>
-          </a:xfrm>
-          <a:prstGeom prst="rect">
-            <a:avLst/>
-          </a:prstGeom>
-        </p:spPr>
-      </p:pic>
-      <p:pic>
-        <p:nvPicPr>
-          <p:cNvPr id="5" name="Image 3" descr="preencoded.png">
-            <a:hlinkClick r:id="rId7" tooltip="https://github.com/samquansah-algo/nbc-vct/blob/main/brand/NBC_Brand_Guide.pdf"/>
-          </p:cNvPr>
-          <p:cNvPicPr>
-            <a:picLocks noChangeAspect="1"/>
-          </p:cNvPicPr>
-          <p:nvPr/>
-        </p:nvPicPr>
-        <p:blipFill>
-          <a:blip r:embed="rId6"/>
-          <a:stretch>
-            <a:fillRect/>
-          </a:stretch>
-        </p:blipFill>
-        <p:spPr>
-          <a:xfrm>
-            <a:off x="5217319" y="4824412"/>
+            <a:off x="4938712" y="4824412"/>
             <a:ext cx="642938" cy="109537"/>
           </a:xfrm>
           <a:prstGeom prst="rect">
@@ -10900,7 +10989,7 @@
         </p:blipFill>
         <p:spPr>
           <a:xfrm>
-            <a:off x="1500188" y="3810000"/>
+            <a:off x="7539037" y="2760166"/>
             <a:ext cx="352425" cy="142875"/>
           </a:xfrm>
           <a:prstGeom prst="rect">
@@ -10911,7 +11000,7 @@
       <p:pic>
         <p:nvPicPr>
           <p:cNvPr id="4" name="Image 2" descr="preencoded.png">
-            <a:hlinkClick r:id="rId5" tooltip="https://github.com/samquansah-algo/nbc-vct/blob/main/marketing/crm/README.md"/>
+            <a:hlinkClick r:id="rId5" tooltip="https://github.com/samquansah-algo/nbc-vct/blob/main/weekly-tactics/04-sales/OUTREACH_KIT.md"/>
           </p:cNvPr>
           <p:cNvPicPr>
             <a:picLocks noChangeAspect="1"/>
@@ -10926,8 +11015,8 @@
         </p:blipFill>
         <p:spPr>
           <a:xfrm>
-            <a:off x="4817269" y="4824412"/>
-            <a:ext cx="180975" cy="109537"/>
+            <a:off x="4660106" y="4824412"/>
+            <a:ext cx="495300" cy="109537"/>
           </a:xfrm>
           <a:prstGeom prst="rect">
             <a:avLst/>
@@ -10952,7 +11041,7 @@
         </p:blipFill>
         <p:spPr>
           <a:xfrm>
-            <a:off x="5060156" y="4824412"/>
+            <a:off x="5217319" y="4824412"/>
             <a:ext cx="642938" cy="109537"/>
           </a:xfrm>
           <a:prstGeom prst="rect">
@@ -11128,7 +11217,7 @@
         </p:blipFill>
         <p:spPr>
           <a:xfrm>
-            <a:off x="1071563" y="3952875"/>
+            <a:off x="1500188" y="3810000"/>
             <a:ext cx="352425" cy="142875"/>
           </a:xfrm>
           <a:prstGeom prst="rect">
@@ -11240,7 +11329,7 @@
       <p:pic>
         <p:nvPicPr>
           <p:cNvPr id="3" name="Image 1" descr="preencoded.png">
-            <a:hlinkClick r:id="rId3" tooltip="https://github.com/samquansah-algo/nbc-vct/blob/main/brand/NBC_Brand_Guide.pdf"/>
+            <a:hlinkClick r:id="rId3" tooltip="https://github.com/samquansah-algo/nbc-vct/tree/main/weekly-tactics/04-sales/"/>
           </p:cNvPr>
           <p:cNvPicPr>
             <a:picLocks noChangeAspect="1"/>
@@ -11255,7 +11344,59 @@
         </p:blipFill>
         <p:spPr>
           <a:xfrm>
-            <a:off x="4938712" y="4824412"/>
+            <a:off x="1071563" y="3952875"/>
+            <a:ext cx="352425" cy="142875"/>
+          </a:xfrm>
+          <a:prstGeom prst="rect">
+            <a:avLst/>
+          </a:prstGeom>
+        </p:spPr>
+      </p:pic>
+      <p:pic>
+        <p:nvPicPr>
+          <p:cNvPr id="4" name="Image 2" descr="preencoded.png">
+            <a:hlinkClick r:id="rId5" tooltip="https://github.com/samquansah-algo/nbc-vct/blob/main/marketing/crm/README.md"/>
+          </p:cNvPr>
+          <p:cNvPicPr>
+            <a:picLocks noChangeAspect="1"/>
+          </p:cNvPicPr>
+          <p:nvPr/>
+        </p:nvPicPr>
+        <p:blipFill>
+          <a:blip r:embed="rId4"/>
+          <a:stretch>
+            <a:fillRect/>
+          </a:stretch>
+        </p:blipFill>
+        <p:spPr>
+          <a:xfrm>
+            <a:off x="4817269" y="4824412"/>
+            <a:ext cx="180975" cy="109537"/>
+          </a:xfrm>
+          <a:prstGeom prst="rect">
+            <a:avLst/>
+          </a:prstGeom>
+        </p:spPr>
+      </p:pic>
+      <p:pic>
+        <p:nvPicPr>
+          <p:cNvPr id="5" name="Image 3" descr="preencoded.png">
+            <a:hlinkClick r:id="rId7" tooltip="https://github.com/samquansah-algo/nbc-vct/blob/main/brand/NBC_Brand_Guide.pdf"/>
+          </p:cNvPr>
+          <p:cNvPicPr>
+            <a:picLocks noChangeAspect="1"/>
+          </p:cNvPicPr>
+          <p:nvPr/>
+        </p:nvPicPr>
+        <p:blipFill>
+          <a:blip r:embed="rId6"/>
+          <a:stretch>
+            <a:fillRect/>
+          </a:stretch>
+        </p:blipFill>
+        <p:spPr>
+          <a:xfrm>
+            <a:off x="5060156" y="4824412"/>
             <a:ext cx="642938" cy="109537"/>
           </a:xfrm>
           <a:prstGeom prst="rect">
@@ -11315,7 +11456,7 @@
       <p:pic>
         <p:nvPicPr>
           <p:cNvPr id="3" name="Image 1" descr="preencoded.png">
-            <a:hlinkClick r:id="rId3" tooltip="https://github.com/samquansah-algo/nbc-vct/blob/main/weekly-tactics/04-sales/OUTREACH_KIT.md"/>
+            <a:hlinkClick r:id="rId3" tooltip="https://github.com/samquansah-algo/nbc-vct/blob/main/brand/NBC_Brand_Guide.pdf"/>
           </p:cNvPr>
           <p:cNvPicPr>
             <a:picLocks noChangeAspect="1"/>
@@ -11330,33 +11471,7 @@
         </p:blipFill>
         <p:spPr>
           <a:xfrm>
-            <a:off x="4660106" y="4824412"/>
-            <a:ext cx="495300" cy="109537"/>
-          </a:xfrm>
-          <a:prstGeom prst="rect">
-            <a:avLst/>
-          </a:prstGeom>
-        </p:spPr>
-      </p:pic>
-      <p:pic>
-        <p:nvPicPr>
-          <p:cNvPr id="4" name="Image 2" descr="preencoded.png">
-            <a:hlinkClick r:id="rId5" tooltip="https://github.com/samquansah-algo/nbc-vct/blob/main/brand/NBC_Brand_Guide.pdf"/>
-          </p:cNvPr>
-          <p:cNvPicPr>
-            <a:picLocks noChangeAspect="1"/>
-          </p:cNvPicPr>
-          <p:nvPr/>
-        </p:nvPicPr>
-        <p:blipFill>
-          <a:blip r:embed="rId4"/>
-          <a:stretch>
-            <a:fillRect/>
-          </a:stretch>
-        </p:blipFill>
-        <p:spPr>
-          <a:xfrm>
-            <a:off x="5217319" y="4824412"/>
+            <a:off x="4938712" y="4824412"/>
             <a:ext cx="642938" cy="109537"/>
           </a:xfrm>
           <a:prstGeom prst="rect">
@@ -11416,7 +11531,7 @@
       <p:pic>
         <p:nvPicPr>
           <p:cNvPr id="3" name="Image 1" descr="preencoded.png">
-            <a:hlinkClick r:id="rId3" tooltip="https://github.com/samquansah-algo/nbc-vct/blob/main/tactics-milestones/MILESTONES.md"/>
+            <a:hlinkClick r:id="rId3" tooltip="https://github.com/samquansah-algo/nbc-vct/blob/main/weekly-tactics/04-sales/OUTREACH_KIT.md"/>
           </p:cNvPr>
           <p:cNvPicPr>
             <a:picLocks noChangeAspect="1"/>
@@ -11431,8 +11546,8 @@
         </p:blipFill>
         <p:spPr>
           <a:xfrm>
-            <a:off x="4683919" y="4824412"/>
-            <a:ext cx="447675" cy="109537"/>
+            <a:off x="4660106" y="4824412"/>
+            <a:ext cx="495300" cy="109537"/>
           </a:xfrm>
           <a:prstGeom prst="rect">
             <a:avLst/>
@@ -11457,7 +11572,7 @@
         </p:blipFill>
         <p:spPr>
           <a:xfrm>
-            <a:off x="5193506" y="4824412"/>
+            <a:off x="5217319" y="4824412"/>
             <a:ext cx="642938" cy="109537"/>
           </a:xfrm>
           <a:prstGeom prst="rect">
@@ -11517,7 +11632,7 @@
       <p:pic>
         <p:nvPicPr>
           <p:cNvPr id="3" name="Image 1" descr="preencoded.png">
-            <a:hlinkClick r:id="rId3" tooltip="https://github.com/samquansah-algo/nbc-vct/blob/main/brand/NBC_Brand_Guide.pdf"/>
+            <a:hlinkClick r:id="rId3" tooltip="https://github.com/samquansah-algo/nbc-vct/blob/main/tactics-milestones/MILESTONES.md"/>
           </p:cNvPr>
           <p:cNvPicPr>
             <a:picLocks noChangeAspect="1"/>
@@ -11532,7 +11647,33 @@
         </p:blipFill>
         <p:spPr>
           <a:xfrm>
-            <a:off x="4938712" y="4824412"/>
+            <a:off x="4683919" y="4824412"/>
+            <a:ext cx="447675" cy="109537"/>
+          </a:xfrm>
+          <a:prstGeom prst="rect">
+            <a:avLst/>
+          </a:prstGeom>
+        </p:spPr>
+      </p:pic>
+      <p:pic>
+        <p:nvPicPr>
+          <p:cNvPr id="4" name="Image 2" descr="preencoded.png">
+            <a:hlinkClick r:id="rId5" tooltip="https://github.com/samquansah-algo/nbc-vct/blob/main/brand/NBC_Brand_Guide.pdf"/>
+          </p:cNvPr>
+          <p:cNvPicPr>
+            <a:picLocks noChangeAspect="1"/>
+          </p:cNvPicPr>
+          <p:nvPr/>
+        </p:nvPicPr>
+        <p:blipFill>
+          <a:blip r:embed="rId4"/>
+          <a:stretch>
+            <a:fillRect/>
+          </a:stretch>
+        </p:blipFill>
+        <p:spPr>
+          <a:xfrm>
+            <a:off x="5193506" y="4824412"/>
             <a:ext cx="642938" cy="109537"/>
           </a:xfrm>
           <a:prstGeom prst="rect">
@@ -11592,7 +11733,7 @@
       <p:pic>
         <p:nvPicPr>
           <p:cNvPr id="3" name="Image 1" descr="preencoded.png">
-            <a:hlinkClick r:id="rId3" tooltip="https://github.com/samquansah-algo/nbc-vct/blob/main/thesis/v6-capability-layer/THESIS.md"/>
+            <a:hlinkClick r:id="rId3" tooltip="https://github.com/samquansah-algo/nbc-vct/blob/main/brand/NBC_Brand_Guide.pdf"/>
           </p:cNvPr>
           <p:cNvPicPr>
             <a:picLocks noChangeAspect="1"/>
@@ -11607,33 +11748,7 @@
         </p:blipFill>
         <p:spPr>
           <a:xfrm>
-            <a:off x="4729163" y="4824412"/>
-            <a:ext cx="357188" cy="109537"/>
-          </a:xfrm>
-          <a:prstGeom prst="rect">
-            <a:avLst/>
-          </a:prstGeom>
-        </p:spPr>
-      </p:pic>
-      <p:pic>
-        <p:nvPicPr>
-          <p:cNvPr id="4" name="Image 2" descr="preencoded.png">
-            <a:hlinkClick r:id="rId5" tooltip="https://github.com/samquansah-algo/nbc-vct/blob/main/brand/NBC_Brand_Guide.pdf"/>
-          </p:cNvPr>
-          <p:cNvPicPr>
-            <a:picLocks noChangeAspect="1"/>
-          </p:cNvPicPr>
-          <p:nvPr/>
-        </p:nvPicPr>
-        <p:blipFill>
-          <a:blip r:embed="rId4"/>
-          <a:stretch>
-            <a:fillRect/>
-          </a:stretch>
-        </p:blipFill>
-        <p:spPr>
-          <a:xfrm>
-            <a:off x="5148263" y="4824412"/>
+            <a:off x="4938712" y="4824412"/>
             <a:ext cx="642938" cy="109537"/>
           </a:xfrm>
           <a:prstGeom prst="rect">
@@ -11871,6 +11986,107 @@
       <p:pic>
         <p:nvPicPr>
           <p:cNvPr id="2" name="Image 0" descr="NBC sales tactic slide 38">    </p:cNvPr>
+          <p:cNvPicPr>
+            <a:picLocks noChangeAspect="1"/>
+          </p:cNvPicPr>
+          <p:nvPr/>
+        </p:nvPicPr>
+        <p:blipFill>
+          <a:blip r:embed="rId1"/>
+          <a:stretch>
+            <a:fillRect/>
+          </a:stretch>
+        </p:blipFill>
+        <p:spPr>
+          <a:xfrm>
+            <a:off x="0" y="0"/>
+            <a:ext cx="9144000" cy="5143500"/>
+          </a:xfrm>
+          <a:prstGeom prst="rect">
+            <a:avLst/>
+          </a:prstGeom>
+        </p:spPr>
+      </p:pic>
+      <p:pic>
+        <p:nvPicPr>
+          <p:cNvPr id="3" name="Image 1" descr="preencoded.png">
+            <a:hlinkClick r:id="rId3" tooltip="https://github.com/samquansah-algo/nbc-vct/blob/main/thesis/v6-capability-layer/THESIS.md"/>
+          </p:cNvPr>
+          <p:cNvPicPr>
+            <a:picLocks noChangeAspect="1"/>
+          </p:cNvPicPr>
+          <p:nvPr/>
+        </p:nvPicPr>
+        <p:blipFill>
+          <a:blip r:embed="rId2"/>
+          <a:stretch>
+            <a:fillRect/>
+          </a:stretch>
+        </p:blipFill>
+        <p:spPr>
+          <a:xfrm>
+            <a:off x="4729163" y="4824412"/>
+            <a:ext cx="357188" cy="109537"/>
+          </a:xfrm>
+          <a:prstGeom prst="rect">
+            <a:avLst/>
+          </a:prstGeom>
+        </p:spPr>
+      </p:pic>
+      <p:pic>
+        <p:nvPicPr>
+          <p:cNvPr id="4" name="Image 2" descr="preencoded.png">
+            <a:hlinkClick r:id="rId5" tooltip="https://github.com/samquansah-algo/nbc-vct/blob/main/brand/NBC_Brand_Guide.pdf"/>
+          </p:cNvPr>
+          <p:cNvPicPr>
+            <a:picLocks noChangeAspect="1"/>
+          </p:cNvPicPr>
+          <p:nvPr/>
+        </p:nvPicPr>
+        <p:blipFill>
+          <a:blip r:embed="rId4"/>
+          <a:stretch>
+            <a:fillRect/>
+          </a:stretch>
+        </p:blipFill>
+        <p:spPr>
+          <a:xfrm>
+            <a:off x="5148263" y="4824412"/>
+            <a:ext cx="642938" cy="109537"/>
+          </a:xfrm>
+          <a:prstGeom prst="rect">
+            <a:avLst/>
+          </a:prstGeom>
+        </p:spPr>
+      </p:pic>
+    </p:spTree>
+  </p:cSld>
+  <p:clrMapOvr>
+    <a:masterClrMapping/>
+  </p:clrMapOvr>
+</p:sld>
+</file>
+
+<file path=ppt/slides/slide39.xml><?xml version="1.0" encoding="utf-8"?>
+<p:sld xmlns:a="http://schemas.openxmlformats.org/drawingml/2006/main" xmlns:r="http://schemas.openxmlformats.org/officeDocument/2006/relationships" xmlns:p="http://schemas.openxmlformats.org/presentationml/2006/main">
+  <p:cSld name="Slide 39">
+    <p:spTree>
+      <p:nvGrpSpPr>
+        <p:cNvPr id="1" name=""/>
+        <p:cNvGrpSpPr/>
+        <p:nvPr/>
+      </p:nvGrpSpPr>
+      <p:grpSpPr>
+        <a:xfrm>
+          <a:off x="0" y="0"/>
+          <a:ext cx="0" cy="0"/>
+          <a:chOff x="0" y="0"/>
+          <a:chExt cx="0" cy="0"/>
+        </a:xfrm>
+      </p:grpSpPr>
+      <p:pic>
+        <p:nvPicPr>
+          <p:cNvPr id="2" name="Image 0" descr="NBC sales tactic slide 39">    </p:cNvPr>
           <p:cNvPicPr>
             <a:picLocks noChangeAspect="1"/>
           </p:cNvPicPr>

</xml_diff>